<commit_message>
Document: logo Academica, naam gelijkgetrokken op Koersplan
Co-Authored-By: Claude Opus 5.5 <noreply@anthropic.com>
Claude-Session: https://claude.ai/code/session_011t24oNqE5E2i7wh7JuX2xs
</commit_message>
<xml_diff>
--- a/Design/Concepts/document/eduface-document-bewerkbaar.pptx
+++ b/Design/Concepts/document/eduface-document-bewerkbaar.pptx
@@ -5454,9 +5454,33 @@
           </a:p>
         </p:txBody>
       </p:sp>
-      <p:sp>
-        <p:nvSpPr>
-          <p:cNvPr id="58" name="TextBox 57"/>
+      <p:pic>
+        <p:nvPicPr>
+          <p:cNvPr id="58" name="Picture 57" descr="academica.png"/>
+          <p:cNvPicPr>
+            <a:picLocks noChangeAspect="1"/>
+          </p:cNvPicPr>
+          <p:nvPr/>
+        </p:nvPicPr>
+        <p:blipFill>
+          <a:blip r:embed="rId2"/>
+          <a:stretch>
+            <a:fillRect/>
+          </a:stretch>
+        </p:blipFill>
+        <p:spPr>
+          <a:xfrm>
+            <a:off x="723900" y="381000"/>
+            <a:ext cx="1569720" cy="304800"/>
+          </a:xfrm>
+          <a:prstGeom prst="rect">
+            <a:avLst/>
+          </a:prstGeom>
+        </p:spPr>
+      </p:pic>
+      <p:sp>
+        <p:nvSpPr>
+          <p:cNvPr id="59" name="TextBox 58"/>
           <p:cNvSpPr txBox="1"/>
           <p:nvPr/>
         </p:nvSpPr>
@@ -6117,9 +6141,33 @@
           </a:p>
         </p:txBody>
       </p:sp>
-      <p:sp>
-        <p:nvSpPr>
-          <p:cNvPr id="17" name="TextBox 16"/>
+      <p:pic>
+        <p:nvPicPr>
+          <p:cNvPr id="17" name="Picture 16" descr="academica.png"/>
+          <p:cNvPicPr>
+            <a:picLocks noChangeAspect="1"/>
+          </p:cNvPicPr>
+          <p:nvPr/>
+        </p:nvPicPr>
+        <p:blipFill>
+          <a:blip r:embed="rId2"/>
+          <a:stretch>
+            <a:fillRect/>
+          </a:stretch>
+        </p:blipFill>
+        <p:spPr>
+          <a:xfrm>
+            <a:off x="723900" y="10182225"/>
+            <a:ext cx="784860" cy="152400"/>
+          </a:xfrm>
+          <a:prstGeom prst="rect">
+            <a:avLst/>
+          </a:prstGeom>
+        </p:spPr>
+      </p:pic>
+      <p:sp>
+        <p:nvSpPr>
+          <p:cNvPr id="18" name="TextBox 17"/>
           <p:cNvSpPr txBox="1"/>
           <p:nvPr/>
         </p:nvSpPr>
@@ -7932,9 +7980,33 @@
           </a:p>
         </p:txBody>
       </p:sp>
-      <p:sp>
-        <p:nvSpPr>
-          <p:cNvPr id="45" name="TextBox 44"/>
+      <p:pic>
+        <p:nvPicPr>
+          <p:cNvPr id="45" name="Picture 44" descr="academica.png"/>
+          <p:cNvPicPr>
+            <a:picLocks noChangeAspect="1"/>
+          </p:cNvPicPr>
+          <p:nvPr/>
+        </p:nvPicPr>
+        <p:blipFill>
+          <a:blip r:embed="rId5"/>
+          <a:stretch>
+            <a:fillRect/>
+          </a:stretch>
+        </p:blipFill>
+        <p:spPr>
+          <a:xfrm>
+            <a:off x="723900" y="10182225"/>
+            <a:ext cx="784860" cy="152400"/>
+          </a:xfrm>
+          <a:prstGeom prst="rect">
+            <a:avLst/>
+          </a:prstGeom>
+        </p:spPr>
+      </p:pic>
+      <p:sp>
+        <p:nvSpPr>
+          <p:cNvPr id="46" name="TextBox 45"/>
           <p:cNvSpPr txBox="1"/>
           <p:nvPr/>
         </p:nvSpPr>
@@ -9404,9 +9476,33 @@
           </a:p>
         </p:txBody>
       </p:sp>
-      <p:sp>
-        <p:nvSpPr>
-          <p:cNvPr id="38" name="TextBox 37"/>
+      <p:pic>
+        <p:nvPicPr>
+          <p:cNvPr id="38" name="Picture 37" descr="academica.png"/>
+          <p:cNvPicPr>
+            <a:picLocks noChangeAspect="1"/>
+          </p:cNvPicPr>
+          <p:nvPr/>
+        </p:nvPicPr>
+        <p:blipFill>
+          <a:blip r:embed="rId5"/>
+          <a:stretch>
+            <a:fillRect/>
+          </a:stretch>
+        </p:blipFill>
+        <p:spPr>
+          <a:xfrm>
+            <a:off x="723900" y="10182225"/>
+            <a:ext cx="784860" cy="152400"/>
+          </a:xfrm>
+          <a:prstGeom prst="rect">
+            <a:avLst/>
+          </a:prstGeom>
+        </p:spPr>
+      </p:pic>
+      <p:sp>
+        <p:nvSpPr>
+          <p:cNvPr id="39" name="TextBox 38"/>
           <p:cNvSpPr txBox="1"/>
           <p:nvPr/>
         </p:nvSpPr>
@@ -9505,7 +9601,7 @@
         <p:spPr>
           <a:xfrm>
             <a:off x="719882" y="1602730"/>
-            <a:ext cx="6104573" cy="682526"/>
+            <a:ext cx="5580007" cy="682526"/>
           </a:xfrm>
           <a:prstGeom prst="rect">
             <a:avLst/>
@@ -9530,7 +9626,7 @@
                 </a:solidFill>
                 <a:latin typeface="Inter"/>
               </a:rPr>
-              <a:t>Deze investering sluit naadloos aan op het kopje Efficiëntie uit het koersplan dat Academia voor de komende jaren heeft opgesteld. Binnen dat kopje versterkt het direct drie punten.</a:t>
+              <a:t>Deze investering sluit naadloos aan op het kopje Efficiëntie uit het koersplan dat Academica voor de komende jaren heeft opgesteld. Binnen dat kopje versterkt het direct drie punten.</a:t>
             </a:r>
           </a:p>
         </p:txBody>
@@ -9612,7 +9708,7 @@
                 </a:solidFill>
                 <a:latin typeface="Inter"/>
               </a:rPr>
-              <a:t>Koersplan Academia</a:t>
+              <a:t>Koersplan Academica</a:t>
             </a:r>
           </a:p>
         </p:txBody>
@@ -10103,9 +10199,33 @@
           </a:p>
         </p:txBody>
       </p:sp>
-      <p:sp>
-        <p:nvSpPr>
-          <p:cNvPr id="19" name="TextBox 18"/>
+      <p:pic>
+        <p:nvPicPr>
+          <p:cNvPr id="19" name="Picture 18" descr="academica.png"/>
+          <p:cNvPicPr>
+            <a:picLocks noChangeAspect="1"/>
+          </p:cNvPicPr>
+          <p:nvPr/>
+        </p:nvPicPr>
+        <p:blipFill>
+          <a:blip r:embed="rId5"/>
+          <a:stretch>
+            <a:fillRect/>
+          </a:stretch>
+        </p:blipFill>
+        <p:spPr>
+          <a:xfrm>
+            <a:off x="723900" y="10182225"/>
+            <a:ext cx="784860" cy="152400"/>
+          </a:xfrm>
+          <a:prstGeom prst="rect">
+            <a:avLst/>
+          </a:prstGeom>
+        </p:spPr>
+      </p:pic>
+      <p:sp>
+        <p:nvSpPr>
+          <p:cNvPr id="20" name="TextBox 19"/>
           <p:cNvSpPr txBox="1"/>
           <p:nvPr/>
         </p:nvSpPr>
@@ -11396,9 +11516,33 @@
           </a:p>
         </p:txBody>
       </p:sp>
-      <p:sp>
-        <p:nvSpPr>
-          <p:cNvPr id="37" name="TextBox 36"/>
+      <p:pic>
+        <p:nvPicPr>
+          <p:cNvPr id="37" name="Picture 36" descr="academica.png"/>
+          <p:cNvPicPr>
+            <a:picLocks noChangeAspect="1"/>
+          </p:cNvPicPr>
+          <p:nvPr/>
+        </p:nvPicPr>
+        <p:blipFill>
+          <a:blip r:embed="rId8"/>
+          <a:stretch>
+            <a:fillRect/>
+          </a:stretch>
+        </p:blipFill>
+        <p:spPr>
+          <a:xfrm>
+            <a:off x="723900" y="10182225"/>
+            <a:ext cx="784860" cy="152400"/>
+          </a:xfrm>
+          <a:prstGeom prst="rect">
+            <a:avLst/>
+          </a:prstGeom>
+        </p:spPr>
+      </p:pic>
+      <p:sp>
+        <p:nvSpPr>
+          <p:cNvPr id="38" name="TextBox 37"/>
           <p:cNvSpPr txBox="1"/>
           <p:nvPr/>
         </p:nvSpPr>

</xml_diff>

<commit_message>
Document: tekstvakken binnen de paginamarges
Co-Authored-By: Claude Opus 5.5 <noreply@anthropic.com>
Claude-Session: https://claude.ai/code/session_011t24oNqE5E2i7wh7JuX2xs
</commit_message>
<xml_diff>
--- a/Design/Concepts/document/eduface-document-bewerkbaar.pptx
+++ b/Design/Concepts/document/eduface-document-bewerkbaar.pptx
@@ -3101,8 +3101,8 @@
         </p:nvSpPr>
         <p:spPr>
           <a:xfrm>
-            <a:off x="719882" y="1180505"/>
-            <a:ext cx="6120110" cy="352425"/>
+            <a:off x="723900" y="1180505"/>
+            <a:ext cx="5018937" cy="352425"/>
           </a:xfrm>
           <a:prstGeom prst="rect">
             <a:avLst/>
@@ -3140,8 +3140,8 @@
         </p:nvSpPr>
         <p:spPr>
           <a:xfrm>
-            <a:off x="719882" y="1949946"/>
-            <a:ext cx="6875502" cy="1135261"/>
+            <a:off x="723900" y="1949946"/>
+            <a:ext cx="6087814" cy="1135261"/>
           </a:xfrm>
           <a:prstGeom prst="rect">
             <a:avLst/>
@@ -3221,7 +3221,7 @@
         <p:spPr>
           <a:xfrm>
             <a:off x="928390" y="3428405"/>
-            <a:ext cx="6120110" cy="200025"/>
+            <a:ext cx="5910560" cy="200025"/>
           </a:xfrm>
           <a:prstGeom prst="rect">
             <a:avLst/>
@@ -3303,7 +3303,7 @@
         <p:spPr>
           <a:xfrm>
             <a:off x="1053405" y="4363045"/>
-            <a:ext cx="2284958" cy="142875"/>
+            <a:ext cx="269176" cy="142875"/>
           </a:xfrm>
           <a:prstGeom prst="rect">
             <a:avLst/>
@@ -3342,7 +3342,7 @@
         <p:spPr>
           <a:xfrm>
             <a:off x="1053405" y="4623346"/>
-            <a:ext cx="2284958" cy="428625"/>
+            <a:ext cx="2107740" cy="428625"/>
           </a:xfrm>
           <a:prstGeom prst="rect">
             <a:avLst/>
@@ -3381,7 +3381,7 @@
         <p:spPr>
           <a:xfrm>
             <a:off x="1053405" y="5197971"/>
-            <a:ext cx="2284958" cy="171450"/>
+            <a:ext cx="1756696" cy="171450"/>
           </a:xfrm>
           <a:prstGeom prst="rect">
             <a:avLst/>
@@ -4303,7 +4303,7 @@
         <p:spPr>
           <a:xfrm>
             <a:off x="4211836" y="4353520"/>
-            <a:ext cx="2304157" cy="142875"/>
+            <a:ext cx="1069943" cy="142875"/>
           </a:xfrm>
           <a:prstGeom prst="rect">
             <a:avLst/>
@@ -4342,7 +4342,7 @@
         <p:spPr>
           <a:xfrm>
             <a:off x="4211836" y="4613821"/>
-            <a:ext cx="2304157" cy="428625"/>
+            <a:ext cx="2008894" cy="428625"/>
           </a:xfrm>
           <a:prstGeom prst="rect">
             <a:avLst/>
@@ -4381,7 +4381,7 @@
         <p:spPr>
           <a:xfrm>
             <a:off x="4211836" y="5188446"/>
-            <a:ext cx="2304157" cy="171450"/>
+            <a:ext cx="2103739" cy="171450"/>
           </a:xfrm>
           <a:prstGeom prst="rect">
             <a:avLst/>
@@ -5279,8 +5279,8 @@
         </p:nvSpPr>
         <p:spPr>
           <a:xfrm>
-            <a:off x="719882" y="6433989"/>
-            <a:ext cx="6120110" cy="142875"/>
+            <a:off x="723900" y="6433989"/>
+            <a:ext cx="2055733" cy="142875"/>
           </a:xfrm>
           <a:prstGeom prst="rect">
             <a:avLst/>
@@ -5362,7 +5362,7 @@
         <p:spPr>
           <a:xfrm>
             <a:off x="1043880" y="7143452"/>
-            <a:ext cx="5472112" cy="428625"/>
+            <a:ext cx="3437573" cy="428625"/>
           </a:xfrm>
           <a:prstGeom prst="rect">
             <a:avLst/>
@@ -5401,7 +5401,7 @@
         <p:spPr>
           <a:xfrm>
             <a:off x="1043880" y="7718078"/>
-            <a:ext cx="5472112" cy="171450"/>
+            <a:ext cx="2320766" cy="171450"/>
           </a:xfrm>
           <a:prstGeom prst="rect">
             <a:avLst/>
@@ -5516,8 +5516,8 @@
         </p:nvSpPr>
         <p:spPr>
           <a:xfrm>
-            <a:off x="719882" y="892522"/>
-            <a:ext cx="6120110" cy="352425"/>
+            <a:off x="723900" y="892522"/>
+            <a:ext cx="1269468" cy="352425"/>
           </a:xfrm>
           <a:prstGeom prst="rect">
             <a:avLst/>
@@ -5599,7 +5599,7 @@
         <p:spPr>
           <a:xfrm>
             <a:off x="1043880" y="1976438"/>
-            <a:ext cx="5472112" cy="428625"/>
+            <a:ext cx="1477494" cy="428625"/>
           </a:xfrm>
           <a:prstGeom prst="rect">
             <a:avLst/>
@@ -5638,7 +5638,7 @@
         <p:spPr>
           <a:xfrm>
             <a:off x="1043880" y="2551063"/>
-            <a:ext cx="5472112" cy="171450"/>
+            <a:ext cx="2928842" cy="171450"/>
           </a:xfrm>
           <a:prstGeom prst="rect">
             <a:avLst/>
@@ -5720,7 +5720,7 @@
         <p:spPr>
           <a:xfrm>
             <a:off x="1259830" y="3182987"/>
-            <a:ext cx="5040213" cy="171450"/>
+            <a:ext cx="3889796" cy="171450"/>
           </a:xfrm>
           <a:prstGeom prst="rect">
             <a:avLst/>
@@ -5759,7 +5759,7 @@
         <p:spPr>
           <a:xfrm>
             <a:off x="1259830" y="3376017"/>
-            <a:ext cx="5040213" cy="142875"/>
+            <a:ext cx="1730026" cy="142875"/>
           </a:xfrm>
           <a:prstGeom prst="rect">
             <a:avLst/>
@@ -5798,7 +5798,7 @@
         <p:spPr>
           <a:xfrm>
             <a:off x="1259830" y="3715941"/>
-            <a:ext cx="1223962" cy="152400"/>
+            <a:ext cx="1099947" cy="152400"/>
           </a:xfrm>
           <a:prstGeom prst="rect">
             <a:avLst/>
@@ -5922,8 +5922,8 @@
         </p:nvSpPr>
         <p:spPr>
           <a:xfrm>
-            <a:off x="5580162" y="3715941"/>
-            <a:ext cx="719882" cy="152400"/>
+            <a:off x="5813173" y="3715941"/>
+            <a:ext cx="486870" cy="152400"/>
           </a:xfrm>
           <a:prstGeom prst="rect">
             <a:avLst/>
@@ -5962,7 +5962,7 @@
         <p:spPr>
           <a:xfrm>
             <a:off x="1259830" y="3994249"/>
-            <a:ext cx="1223962" cy="152400"/>
+            <a:ext cx="1007102" cy="152400"/>
           </a:xfrm>
           <a:prstGeom prst="rect">
             <a:avLst/>
@@ -6086,8 +6086,8 @@
         </p:nvSpPr>
         <p:spPr>
           <a:xfrm>
-            <a:off x="5580162" y="3994249"/>
-            <a:ext cx="719882" cy="152400"/>
+            <a:off x="5794171" y="3994249"/>
+            <a:ext cx="505873" cy="152400"/>
           </a:xfrm>
           <a:prstGeom prst="rect">
             <a:avLst/>
@@ -6126,7 +6126,7 @@
         <p:spPr>
           <a:xfrm>
             <a:off x="1043880" y="4506516"/>
-            <a:ext cx="5472112" cy="142875"/>
+            <a:ext cx="3991975" cy="142875"/>
           </a:xfrm>
           <a:prstGeom prst="rect">
             <a:avLst/>
@@ -6241,8 +6241,8 @@
         </p:nvSpPr>
         <p:spPr>
           <a:xfrm>
-            <a:off x="719882" y="892522"/>
-            <a:ext cx="6120110" cy="352425"/>
+            <a:off x="723900" y="892522"/>
+            <a:ext cx="5531834" cy="352425"/>
           </a:xfrm>
           <a:prstGeom prst="rect">
             <a:avLst/>
@@ -6430,7 +6430,7 @@
         <p:spPr>
           <a:xfrm>
             <a:off x="1043880" y="2453729"/>
-            <a:ext cx="5853208" cy="171450"/>
+            <a:ext cx="5795070" cy="171450"/>
           </a:xfrm>
           <a:prstGeom prst="rect">
             <a:avLst/>
@@ -6512,7 +6512,7 @@
         <p:spPr>
           <a:xfrm>
             <a:off x="1259830" y="3085654"/>
-            <a:ext cx="2196108" cy="171450"/>
+            <a:ext cx="602218" cy="171450"/>
           </a:xfrm>
           <a:prstGeom prst="rect">
             <a:avLst/>
@@ -6924,7 +6924,7 @@
         <p:spPr>
           <a:xfrm>
             <a:off x="4103787" y="3085654"/>
-            <a:ext cx="2196257" cy="171450"/>
+            <a:ext cx="1007769" cy="171450"/>
           </a:xfrm>
           <a:prstGeom prst="rect">
             <a:avLst/>
@@ -6963,7 +6963,7 @@
         <p:spPr>
           <a:xfrm>
             <a:off x="4103787" y="3278684"/>
-            <a:ext cx="2196257" cy="142875"/>
+            <a:ext cx="1966222" cy="142875"/>
           </a:xfrm>
           <a:prstGeom prst="rect">
             <a:avLst/>
@@ -7442,7 +7442,7 @@
         <p:spPr>
           <a:xfrm>
             <a:off x="1043880" y="5669161"/>
-            <a:ext cx="5636181" cy="381000"/>
+            <a:ext cx="4981277" cy="381000"/>
           </a:xfrm>
           <a:prstGeom prst="rect">
             <a:avLst/>
@@ -7481,7 +7481,7 @@
         <p:spPr>
           <a:xfrm>
             <a:off x="1043880" y="6249144"/>
-            <a:ext cx="1223962" cy="152400"/>
+            <a:ext cx="1176123" cy="152400"/>
           </a:xfrm>
           <a:prstGeom prst="rect">
             <a:avLst/>
@@ -7605,8 +7605,8 @@
         </p:nvSpPr>
         <p:spPr>
           <a:xfrm>
-            <a:off x="5796111" y="6249144"/>
-            <a:ext cx="719882" cy="152400"/>
+            <a:off x="5826764" y="6249144"/>
+            <a:ext cx="689229" cy="152400"/>
           </a:xfrm>
           <a:prstGeom prst="rect">
             <a:avLst/>
@@ -7769,8 +7769,8 @@
         </p:nvSpPr>
         <p:spPr>
           <a:xfrm>
-            <a:off x="5796111" y="6527453"/>
-            <a:ext cx="719882" cy="152400"/>
+            <a:off x="5833098" y="6527453"/>
+            <a:ext cx="682895" cy="152400"/>
           </a:xfrm>
           <a:prstGeom prst="rect">
             <a:avLst/>
@@ -7997,7 +7997,7 @@
         <p:spPr>
           <a:xfrm>
             <a:off x="1053405" y="8422630"/>
-            <a:ext cx="5537168" cy="381000"/>
+            <a:ext cx="4892873" cy="381000"/>
           </a:xfrm>
           <a:prstGeom prst="rect">
             <a:avLst/>
@@ -8112,8 +8112,8 @@
         </p:nvSpPr>
         <p:spPr>
           <a:xfrm>
-            <a:off x="719882" y="892522"/>
-            <a:ext cx="6120110" cy="352425"/>
+            <a:off x="723900" y="892522"/>
+            <a:ext cx="2260425" cy="352425"/>
           </a:xfrm>
           <a:prstGeom prst="rect">
             <a:avLst/>
@@ -8301,7 +8301,7 @@
         <p:spPr>
           <a:xfrm>
             <a:off x="1043880" y="2453729"/>
-            <a:ext cx="5472112" cy="171450"/>
+            <a:ext cx="3383732" cy="171450"/>
           </a:xfrm>
           <a:prstGeom prst="rect">
             <a:avLst/>
@@ -8461,7 +8461,7 @@
         <p:spPr>
           <a:xfrm>
             <a:off x="1259830" y="3416052"/>
-            <a:ext cx="1223962" cy="152400"/>
+            <a:ext cx="677894" cy="152400"/>
           </a:xfrm>
           <a:prstGeom prst="rect">
             <a:avLst/>
@@ -8626,8 +8626,8 @@
         </p:nvSpPr>
         <p:spPr>
           <a:xfrm>
-            <a:off x="5580162" y="3416052"/>
-            <a:ext cx="719882" cy="152400"/>
+            <a:off x="6044702" y="3416052"/>
+            <a:ext cx="255341" cy="152400"/>
           </a:xfrm>
           <a:prstGeom prst="rect">
             <a:avLst/>
@@ -8666,7 +8666,7 @@
         <p:spPr>
           <a:xfrm>
             <a:off x="1259830" y="3694361"/>
-            <a:ext cx="1223962" cy="152400"/>
+            <a:ext cx="672727" cy="152400"/>
           </a:xfrm>
           <a:prstGeom prst="rect">
             <a:avLst/>
@@ -8831,8 +8831,8 @@
         </p:nvSpPr>
         <p:spPr>
           <a:xfrm>
-            <a:off x="5580162" y="3694361"/>
-            <a:ext cx="719882" cy="152400"/>
+            <a:off x="6043535" y="3694361"/>
+            <a:ext cx="256508" cy="152400"/>
           </a:xfrm>
           <a:prstGeom prst="rect">
             <a:avLst/>
@@ -8871,7 +8871,7 @@
         <p:spPr>
           <a:xfrm>
             <a:off x="1259830" y="3972669"/>
-            <a:ext cx="1223962" cy="152400"/>
+            <a:ext cx="691229" cy="152400"/>
           </a:xfrm>
           <a:prstGeom prst="rect">
             <a:avLst/>
@@ -9036,8 +9036,8 @@
         </p:nvSpPr>
         <p:spPr>
           <a:xfrm>
-            <a:off x="5580162" y="3972669"/>
-            <a:ext cx="719882" cy="152400"/>
+            <a:off x="6026866" y="3972669"/>
+            <a:ext cx="273177" cy="152400"/>
           </a:xfrm>
           <a:prstGeom prst="rect">
             <a:avLst/>
@@ -9225,7 +9225,7 @@
         <p:spPr>
           <a:xfrm>
             <a:off x="1043880" y="5691783"/>
-            <a:ext cx="5472112" cy="171450"/>
+            <a:ext cx="2622804" cy="171450"/>
           </a:xfrm>
           <a:prstGeom prst="rect">
             <a:avLst/>
@@ -9307,7 +9307,7 @@
         <p:spPr>
           <a:xfrm>
             <a:off x="1187797" y="6116092"/>
-            <a:ext cx="1164729" cy="142875"/>
+            <a:ext cx="1039273" cy="142875"/>
           </a:xfrm>
           <a:prstGeom prst="rect">
             <a:avLst/>
@@ -9495,7 +9495,7 @@
         <p:spPr>
           <a:xfrm>
             <a:off x="1053405" y="7673132"/>
-            <a:ext cx="5453062" cy="171450"/>
+            <a:ext cx="2697980" cy="171450"/>
           </a:xfrm>
           <a:prstGeom prst="rect">
             <a:avLst/>
@@ -9575,7 +9575,7 @@
         <p:spPr>
           <a:xfrm>
             <a:off x="918865" y="8576072"/>
-            <a:ext cx="6501289" cy="604540"/>
+            <a:ext cx="5753695" cy="604540"/>
           </a:xfrm>
           <a:prstGeom prst="rect">
             <a:avLst/>
@@ -9690,8 +9690,8 @@
         </p:nvSpPr>
         <p:spPr>
           <a:xfrm>
-            <a:off x="719882" y="892522"/>
-            <a:ext cx="6120110" cy="352425"/>
+            <a:off x="723900" y="892522"/>
+            <a:ext cx="1860042" cy="352425"/>
           </a:xfrm>
           <a:prstGeom prst="rect">
             <a:avLst/>
@@ -9729,8 +9729,8 @@
         </p:nvSpPr>
         <p:spPr>
           <a:xfrm>
-            <a:off x="719882" y="1661964"/>
-            <a:ext cx="6683312" cy="662880"/>
+            <a:off x="723900" y="1661964"/>
+            <a:ext cx="5916216" cy="662880"/>
           </a:xfrm>
           <a:prstGeom prst="rect">
             <a:avLst/>
@@ -9812,7 +9812,7 @@
         <p:spPr>
           <a:xfrm>
             <a:off x="1043880" y="3035350"/>
-            <a:ext cx="5472112" cy="142875"/>
+            <a:ext cx="1837372" cy="142875"/>
           </a:xfrm>
           <a:prstGeom prst="rect">
             <a:avLst/>
@@ -9851,7 +9851,7 @@
         <p:spPr>
           <a:xfrm>
             <a:off x="1043880" y="3278684"/>
-            <a:ext cx="5472112" cy="200025"/>
+            <a:ext cx="1083278" cy="200025"/>
           </a:xfrm>
           <a:prstGeom prst="rect">
             <a:avLst/>
@@ -10413,8 +10413,8 @@
         </p:nvSpPr>
         <p:spPr>
           <a:xfrm>
-            <a:off x="719882" y="892522"/>
-            <a:ext cx="6120110" cy="352425"/>
+            <a:off x="723900" y="892522"/>
+            <a:ext cx="1411486" cy="352425"/>
           </a:xfrm>
           <a:prstGeom prst="rect">
             <a:avLst/>
@@ -10563,7 +10563,7 @@
         <p:spPr>
           <a:xfrm>
             <a:off x="1547664" y="1995488"/>
-            <a:ext cx="5424821" cy="459135"/>
+            <a:ext cx="4792563" cy="459135"/>
           </a:xfrm>
           <a:prstGeom prst="rect">
             <a:avLst/>
@@ -10838,7 +10838,7 @@
         <p:spPr>
           <a:xfrm>
             <a:off x="1359247" y="4344144"/>
-            <a:ext cx="5321475" cy="374005"/>
+            <a:ext cx="4700290" cy="374005"/>
           </a:xfrm>
           <a:prstGeom prst="rect">
             <a:avLst/>

</xml_diff>

<commit_message>
Document: kopbalk per onderdeel, eigen tint, om en om licht en donker, titel Opbrengst
Co-Authored-By: Claude Opus 5.5 <noreply@anthropic.com>
Claude-Session: https://claude.ai/code/session_011t24oNqE5E2i7wh7JuX2xs
</commit_message>
<xml_diff>
--- a/Design/Concepts/document/eduface-document-bewerkbaar.pptx
+++ b/Design/Concepts/document/eduface-document-bewerkbaar.pptx
@@ -3095,13 +3095,93 @@
       <p:grpSpPr/>
       <p:sp>
         <p:nvSpPr>
-          <p:cNvPr id="2" name="TextBox 1"/>
+          <p:cNvPr id="2" name="Rectangle 1"/>
+          <p:cNvSpPr/>
+          <p:nvPr/>
+        </p:nvSpPr>
+        <p:spPr>
+          <a:xfrm>
+            <a:off x="0" y="0"/>
+            <a:ext cx="7559873" cy="1605707"/>
+          </a:xfrm>
+          <a:prstGeom prst="rect">
+            <a:avLst/>
+          </a:prstGeom>
+          <a:solidFill>
+            <a:srgbClr val="000326"/>
+          </a:solidFill>
+          <a:ln>
+            <a:noFill/>
+          </a:ln>
+        </p:spPr>
+        <p:style>
+          <a:lnRef idx="1">
+            <a:schemeClr val="accent1"/>
+          </a:lnRef>
+          <a:fillRef idx="3">
+            <a:schemeClr val="accent1"/>
+          </a:fillRef>
+          <a:effectRef idx="0">
+            <a:schemeClr val="accent1"/>
+          </a:effectRef>
+          <a:fontRef idx="minor">
+            <a:schemeClr val="lt1"/>
+          </a:fontRef>
+        </p:style>
+        <p:txBody>
+          <a:bodyPr rtlCol="0" anchor="ctr"/>
+          <a:lstStyle/>
+          <a:p/>
+        </p:txBody>
+      </p:sp>
+      <p:sp>
+        <p:nvSpPr>
+          <p:cNvPr id="3" name="TextBox 2"/>
           <p:cNvSpPr txBox="1"/>
           <p:nvPr/>
         </p:nvSpPr>
         <p:spPr>
           <a:xfrm>
-            <a:off x="723900" y="1180505"/>
+            <a:off x="723900" y="575965"/>
+            <a:ext cx="216337" cy="142875"/>
+          </a:xfrm>
+          <a:prstGeom prst="rect">
+            <a:avLst/>
+          </a:prstGeom>
+          <a:noFill/>
+        </p:spPr>
+        <p:txBody>
+          <a:bodyPr wrap="square" anchor="t" lIns="0" rIns="0" tIns="0" bIns="0">
+            <a:noAutofit/>
+          </a:bodyPr>
+          <a:lstStyle/>
+          <a:p>
+            <a:pPr algn="l">
+              <a:lnSpc>
+                <a:spcPts val="1080"/>
+              </a:lnSpc>
+            </a:pPr>
+            <a:r>
+              <a:rPr sz="900" b="1">
+                <a:solidFill>
+                  <a:srgbClr val="FFFFFF"/>
+                </a:solidFill>
+                <a:latin typeface="Inter"/>
+              </a:rPr>
+              <a:t>01</a:t>
+            </a:r>
+          </a:p>
+        </p:txBody>
+      </p:sp>
+      <p:sp>
+        <p:nvSpPr>
+          <p:cNvPr id="4" name="TextBox 3"/>
+          <p:cNvSpPr txBox="1"/>
+          <p:nvPr/>
+        </p:nvSpPr>
+        <p:spPr>
+          <a:xfrm>
+            <a:off x="723900" y="819299"/>
             <a:ext cx="5018937" cy="352425"/>
           </a:xfrm>
           <a:prstGeom prst="rect">
@@ -3123,7 +3203,7 @@
             <a:r>
               <a:rPr sz="3000" b="1">
                 <a:solidFill>
-                  <a:srgbClr val="000326"/>
+                  <a:srgbClr val="FFFFFF"/>
                 </a:solidFill>
                 <a:latin typeface="League Spartan"/>
               </a:rPr>
@@ -3134,13 +3214,13 @@
       </p:sp>
       <p:sp>
         <p:nvSpPr>
-          <p:cNvPr id="3" name="TextBox 2"/>
+          <p:cNvPr id="5" name="TextBox 4"/>
           <p:cNvSpPr txBox="1"/>
           <p:nvPr/>
         </p:nvSpPr>
         <p:spPr>
           <a:xfrm>
-            <a:off x="723900" y="1949946"/>
+            <a:off x="723900" y="1984623"/>
             <a:ext cx="6087814" cy="1135261"/>
           </a:xfrm>
           <a:prstGeom prst="rect">
@@ -3173,13 +3253,13 @@
       </p:sp>
       <p:sp>
         <p:nvSpPr>
-          <p:cNvPr id="4" name="Rectangle 3"/>
+          <p:cNvPr id="6" name="Rectangle 5"/>
           <p:cNvSpPr/>
           <p:nvPr/>
         </p:nvSpPr>
         <p:spPr>
           <a:xfrm>
-            <a:off x="719882" y="3399830"/>
+            <a:off x="719882" y="3434507"/>
             <a:ext cx="28575" cy="269825"/>
           </a:xfrm>
           <a:prstGeom prst="rect">
@@ -3214,13 +3294,13 @@
       </p:sp>
       <p:sp>
         <p:nvSpPr>
-          <p:cNvPr id="5" name="TextBox 4"/>
+          <p:cNvPr id="7" name="TextBox 6"/>
           <p:cNvSpPr txBox="1"/>
           <p:nvPr/>
         </p:nvSpPr>
         <p:spPr>
           <a:xfrm>
-            <a:off x="928390" y="3428405"/>
+            <a:off x="928390" y="3463082"/>
             <a:ext cx="5910560" cy="200025"/>
           </a:xfrm>
           <a:prstGeom prst="rect">
@@ -3253,13 +3333,13 @@
       </p:sp>
       <p:sp>
         <p:nvSpPr>
-          <p:cNvPr id="6" name="Rounded Rectangle 5"/>
+          <p:cNvPr id="8" name="Rounded Rectangle 7"/>
           <p:cNvSpPr/>
           <p:nvPr/>
         </p:nvSpPr>
         <p:spPr>
           <a:xfrm>
-            <a:off x="719882" y="4029521"/>
+            <a:off x="719882" y="4064198"/>
             <a:ext cx="2952006" cy="2296567"/>
           </a:xfrm>
           <a:prstGeom prst="roundRect">
@@ -3296,13 +3376,13 @@
       </p:sp>
       <p:sp>
         <p:nvSpPr>
-          <p:cNvPr id="7" name="TextBox 6"/>
+          <p:cNvPr id="9" name="TextBox 8"/>
           <p:cNvSpPr txBox="1"/>
           <p:nvPr/>
         </p:nvSpPr>
         <p:spPr>
           <a:xfrm>
-            <a:off x="1053405" y="4363045"/>
+            <a:off x="1053405" y="4397722"/>
             <a:ext cx="269176" cy="142875"/>
           </a:xfrm>
           <a:prstGeom prst="rect">
@@ -3335,13 +3415,13 @@
       </p:sp>
       <p:sp>
         <p:nvSpPr>
-          <p:cNvPr id="8" name="TextBox 7"/>
+          <p:cNvPr id="10" name="TextBox 9"/>
           <p:cNvSpPr txBox="1"/>
           <p:nvPr/>
         </p:nvSpPr>
         <p:spPr>
           <a:xfrm>
-            <a:off x="1053405" y="4623346"/>
+            <a:off x="1053405" y="4658023"/>
             <a:ext cx="2107740" cy="428625"/>
           </a:xfrm>
           <a:prstGeom prst="rect">
@@ -3374,13 +3454,13 @@
       </p:sp>
       <p:sp>
         <p:nvSpPr>
-          <p:cNvPr id="9" name="TextBox 8"/>
+          <p:cNvPr id="11" name="TextBox 10"/>
           <p:cNvSpPr txBox="1"/>
           <p:nvPr/>
         </p:nvSpPr>
         <p:spPr>
           <a:xfrm>
-            <a:off x="1053405" y="5197971"/>
+            <a:off x="1053405" y="5232648"/>
             <a:ext cx="1756696" cy="171450"/>
           </a:xfrm>
           <a:prstGeom prst="rect">
@@ -3413,13 +3493,13 @@
       </p:sp>
       <p:sp>
         <p:nvSpPr>
-          <p:cNvPr id="10" name="Oval 9"/>
+          <p:cNvPr id="12" name="Oval 11"/>
           <p:cNvSpPr/>
           <p:nvPr/>
         </p:nvSpPr>
         <p:spPr>
           <a:xfrm>
-            <a:off x="1053405" y="5604421"/>
+            <a:off x="1053405" y="5639098"/>
             <a:ext cx="150912" cy="150912"/>
           </a:xfrm>
           <a:prstGeom prst="ellipse">
@@ -3456,13 +3536,13 @@
       </p:sp>
       <p:sp>
         <p:nvSpPr>
-          <p:cNvPr id="11" name="Oval 10"/>
+          <p:cNvPr id="13" name="Oval 12"/>
           <p:cNvSpPr/>
           <p:nvPr/>
         </p:nvSpPr>
         <p:spPr>
           <a:xfrm>
-            <a:off x="1290638" y="5604421"/>
+            <a:off x="1290638" y="5639098"/>
             <a:ext cx="150912" cy="150912"/>
           </a:xfrm>
           <a:prstGeom prst="ellipse">
@@ -3499,13 +3579,13 @@
       </p:sp>
       <p:sp>
         <p:nvSpPr>
-          <p:cNvPr id="12" name="Oval 11"/>
+          <p:cNvPr id="14" name="Oval 13"/>
           <p:cNvSpPr/>
           <p:nvPr/>
         </p:nvSpPr>
         <p:spPr>
           <a:xfrm>
-            <a:off x="1527870" y="5604421"/>
+            <a:off x="1527870" y="5639098"/>
             <a:ext cx="150912" cy="150912"/>
           </a:xfrm>
           <a:prstGeom prst="ellipse">
@@ -3542,13 +3622,13 @@
       </p:sp>
       <p:sp>
         <p:nvSpPr>
-          <p:cNvPr id="13" name="Oval 12"/>
+          <p:cNvPr id="15" name="Oval 14"/>
           <p:cNvSpPr/>
           <p:nvPr/>
         </p:nvSpPr>
         <p:spPr>
           <a:xfrm>
-            <a:off x="1765102" y="5604421"/>
+            <a:off x="1765102" y="5639098"/>
             <a:ext cx="150912" cy="150912"/>
           </a:xfrm>
           <a:prstGeom prst="ellipse">
@@ -3585,13 +3665,13 @@
       </p:sp>
       <p:sp>
         <p:nvSpPr>
-          <p:cNvPr id="14" name="Oval 13"/>
+          <p:cNvPr id="16" name="Oval 15"/>
           <p:cNvSpPr/>
           <p:nvPr/>
         </p:nvSpPr>
         <p:spPr>
           <a:xfrm>
-            <a:off x="2002334" y="5604421"/>
+            <a:off x="2002334" y="5639098"/>
             <a:ext cx="150912" cy="150912"/>
           </a:xfrm>
           <a:prstGeom prst="ellipse">
@@ -3628,13 +3708,13 @@
       </p:sp>
       <p:sp>
         <p:nvSpPr>
-          <p:cNvPr id="15" name="Oval 14"/>
+          <p:cNvPr id="17" name="Oval 16"/>
           <p:cNvSpPr/>
           <p:nvPr/>
         </p:nvSpPr>
         <p:spPr>
           <a:xfrm>
-            <a:off x="2239566" y="5604421"/>
+            <a:off x="2239566" y="5639098"/>
             <a:ext cx="150912" cy="150912"/>
           </a:xfrm>
           <a:prstGeom prst="ellipse">
@@ -3671,13 +3751,13 @@
       </p:sp>
       <p:sp>
         <p:nvSpPr>
-          <p:cNvPr id="16" name="Oval 15"/>
+          <p:cNvPr id="18" name="Oval 17"/>
           <p:cNvSpPr/>
           <p:nvPr/>
         </p:nvSpPr>
         <p:spPr>
           <a:xfrm>
-            <a:off x="2476798" y="5604421"/>
+            <a:off x="2476798" y="5639098"/>
             <a:ext cx="150912" cy="150912"/>
           </a:xfrm>
           <a:prstGeom prst="ellipse">
@@ -3714,13 +3794,13 @@
       </p:sp>
       <p:sp>
         <p:nvSpPr>
-          <p:cNvPr id="17" name="Oval 16"/>
+          <p:cNvPr id="19" name="Oval 18"/>
           <p:cNvSpPr/>
           <p:nvPr/>
         </p:nvSpPr>
         <p:spPr>
           <a:xfrm>
-            <a:off x="2714030" y="5604421"/>
+            <a:off x="2714030" y="5639098"/>
             <a:ext cx="150912" cy="150912"/>
           </a:xfrm>
           <a:prstGeom prst="ellipse">
@@ -3757,13 +3837,13 @@
       </p:sp>
       <p:sp>
         <p:nvSpPr>
-          <p:cNvPr id="18" name="Oval 17"/>
+          <p:cNvPr id="20" name="Oval 19"/>
           <p:cNvSpPr/>
           <p:nvPr/>
         </p:nvSpPr>
         <p:spPr>
           <a:xfrm>
-            <a:off x="2951262" y="5604421"/>
+            <a:off x="2951262" y="5639098"/>
             <a:ext cx="150912" cy="150912"/>
           </a:xfrm>
           <a:prstGeom prst="ellipse">
@@ -3800,13 +3880,13 @@
       </p:sp>
       <p:sp>
         <p:nvSpPr>
-          <p:cNvPr id="19" name="Oval 18"/>
+          <p:cNvPr id="21" name="Oval 20"/>
           <p:cNvSpPr/>
           <p:nvPr/>
         </p:nvSpPr>
         <p:spPr>
           <a:xfrm>
-            <a:off x="3188494" y="5604421"/>
+            <a:off x="3188494" y="5639098"/>
             <a:ext cx="150912" cy="150912"/>
           </a:xfrm>
           <a:prstGeom prst="ellipse">
@@ -3843,13 +3923,13 @@
       </p:sp>
       <p:sp>
         <p:nvSpPr>
-          <p:cNvPr id="20" name="Oval 19"/>
+          <p:cNvPr id="22" name="Oval 21"/>
           <p:cNvSpPr/>
           <p:nvPr/>
         </p:nvSpPr>
         <p:spPr>
           <a:xfrm>
-            <a:off x="1053405" y="5841653"/>
+            <a:off x="1053405" y="5876330"/>
             <a:ext cx="150912" cy="150912"/>
           </a:xfrm>
           <a:prstGeom prst="ellipse">
@@ -3884,13 +3964,13 @@
       </p:sp>
       <p:sp>
         <p:nvSpPr>
-          <p:cNvPr id="21" name="Oval 20"/>
+          <p:cNvPr id="23" name="Oval 22"/>
           <p:cNvSpPr/>
           <p:nvPr/>
         </p:nvSpPr>
         <p:spPr>
           <a:xfrm>
-            <a:off x="1290638" y="5841653"/>
+            <a:off x="1290638" y="5876330"/>
             <a:ext cx="150912" cy="150912"/>
           </a:xfrm>
           <a:prstGeom prst="ellipse">
@@ -3925,13 +4005,13 @@
       </p:sp>
       <p:sp>
         <p:nvSpPr>
-          <p:cNvPr id="22" name="Oval 21"/>
+          <p:cNvPr id="24" name="Oval 23"/>
           <p:cNvSpPr/>
           <p:nvPr/>
         </p:nvSpPr>
         <p:spPr>
           <a:xfrm>
-            <a:off x="1527870" y="5841653"/>
+            <a:off x="1527870" y="5876330"/>
             <a:ext cx="150912" cy="150912"/>
           </a:xfrm>
           <a:prstGeom prst="ellipse">
@@ -3966,13 +4046,13 @@
       </p:sp>
       <p:sp>
         <p:nvSpPr>
-          <p:cNvPr id="23" name="Oval 22"/>
+          <p:cNvPr id="25" name="Oval 24"/>
           <p:cNvSpPr/>
           <p:nvPr/>
         </p:nvSpPr>
         <p:spPr>
           <a:xfrm>
-            <a:off x="1765102" y="5841653"/>
+            <a:off x="1765102" y="5876330"/>
             <a:ext cx="150912" cy="150912"/>
           </a:xfrm>
           <a:prstGeom prst="ellipse">
@@ -4007,13 +4087,13 @@
       </p:sp>
       <p:sp>
         <p:nvSpPr>
-          <p:cNvPr id="24" name="Oval 23"/>
+          <p:cNvPr id="26" name="Oval 25"/>
           <p:cNvSpPr/>
           <p:nvPr/>
         </p:nvSpPr>
         <p:spPr>
           <a:xfrm>
-            <a:off x="2002334" y="5841653"/>
+            <a:off x="2002334" y="5876330"/>
             <a:ext cx="150912" cy="150912"/>
           </a:xfrm>
           <a:prstGeom prst="ellipse">
@@ -4048,13 +4128,13 @@
       </p:sp>
       <p:sp>
         <p:nvSpPr>
-          <p:cNvPr id="25" name="Oval 24"/>
+          <p:cNvPr id="27" name="Oval 26"/>
           <p:cNvSpPr/>
           <p:nvPr/>
         </p:nvSpPr>
         <p:spPr>
           <a:xfrm>
-            <a:off x="2239566" y="5841653"/>
+            <a:off x="2239566" y="5876330"/>
             <a:ext cx="150912" cy="150912"/>
           </a:xfrm>
           <a:prstGeom prst="ellipse">
@@ -4089,13 +4169,13 @@
       </p:sp>
       <p:sp>
         <p:nvSpPr>
-          <p:cNvPr id="26" name="Oval 25"/>
+          <p:cNvPr id="28" name="Oval 27"/>
           <p:cNvSpPr/>
           <p:nvPr/>
         </p:nvSpPr>
         <p:spPr>
           <a:xfrm>
-            <a:off x="2476798" y="5841653"/>
+            <a:off x="2476798" y="5876330"/>
             <a:ext cx="150912" cy="150912"/>
           </a:xfrm>
           <a:prstGeom prst="ellipse">
@@ -4130,13 +4210,13 @@
       </p:sp>
       <p:sp>
         <p:nvSpPr>
-          <p:cNvPr id="27" name="Oval 26"/>
+          <p:cNvPr id="29" name="Oval 28"/>
           <p:cNvSpPr/>
           <p:nvPr/>
         </p:nvSpPr>
         <p:spPr>
           <a:xfrm>
-            <a:off x="2714030" y="5841653"/>
+            <a:off x="2714030" y="5876330"/>
             <a:ext cx="150912" cy="150912"/>
           </a:xfrm>
           <a:prstGeom prst="ellipse">
@@ -4171,13 +4251,13 @@
       </p:sp>
       <p:sp>
         <p:nvSpPr>
-          <p:cNvPr id="28" name="Oval 27"/>
+          <p:cNvPr id="30" name="Oval 29"/>
           <p:cNvSpPr/>
           <p:nvPr/>
         </p:nvSpPr>
         <p:spPr>
           <a:xfrm>
-            <a:off x="2951262" y="5841653"/>
+            <a:off x="2951262" y="5876330"/>
             <a:ext cx="150912" cy="150912"/>
           </a:xfrm>
           <a:prstGeom prst="ellipse">
@@ -4212,13 +4292,13 @@
       </p:sp>
       <p:sp>
         <p:nvSpPr>
-          <p:cNvPr id="29" name="Oval 28"/>
+          <p:cNvPr id="31" name="Oval 30"/>
           <p:cNvSpPr/>
           <p:nvPr/>
         </p:nvSpPr>
         <p:spPr>
           <a:xfrm>
-            <a:off x="3188494" y="5841653"/>
+            <a:off x="3188494" y="5876330"/>
             <a:ext cx="150912" cy="150912"/>
           </a:xfrm>
           <a:prstGeom prst="ellipse">
@@ -4253,13 +4333,13 @@
       </p:sp>
       <p:sp>
         <p:nvSpPr>
-          <p:cNvPr id="30" name="Rounded Rectangle 29"/>
+          <p:cNvPr id="32" name="Rounded Rectangle 31"/>
           <p:cNvSpPr/>
           <p:nvPr/>
         </p:nvSpPr>
         <p:spPr>
           <a:xfrm>
-            <a:off x="3887837" y="4029521"/>
+            <a:off x="3887837" y="4064198"/>
             <a:ext cx="2952155" cy="2296567"/>
           </a:xfrm>
           <a:prstGeom prst="roundRect">
@@ -4296,13 +4376,13 @@
       </p:sp>
       <p:sp>
         <p:nvSpPr>
-          <p:cNvPr id="31" name="TextBox 30"/>
+          <p:cNvPr id="33" name="TextBox 32"/>
           <p:cNvSpPr txBox="1"/>
           <p:nvPr/>
         </p:nvSpPr>
         <p:spPr>
           <a:xfrm>
-            <a:off x="4211836" y="4353520"/>
+            <a:off x="4211836" y="4388197"/>
             <a:ext cx="1069943" cy="142875"/>
           </a:xfrm>
           <a:prstGeom prst="rect">
@@ -4335,13 +4415,13 @@
       </p:sp>
       <p:sp>
         <p:nvSpPr>
-          <p:cNvPr id="32" name="TextBox 31"/>
+          <p:cNvPr id="34" name="TextBox 33"/>
           <p:cNvSpPr txBox="1"/>
           <p:nvPr/>
         </p:nvSpPr>
         <p:spPr>
           <a:xfrm>
-            <a:off x="4211836" y="4613821"/>
+            <a:off x="4211836" y="4648498"/>
             <a:ext cx="2008894" cy="428625"/>
           </a:xfrm>
           <a:prstGeom prst="rect">
@@ -4374,13 +4454,13 @@
       </p:sp>
       <p:sp>
         <p:nvSpPr>
-          <p:cNvPr id="33" name="TextBox 32"/>
+          <p:cNvPr id="35" name="TextBox 34"/>
           <p:cNvSpPr txBox="1"/>
           <p:nvPr/>
         </p:nvSpPr>
         <p:spPr>
           <a:xfrm>
-            <a:off x="4211836" y="5188446"/>
+            <a:off x="4211836" y="5223123"/>
             <a:ext cx="2103739" cy="171450"/>
           </a:xfrm>
           <a:prstGeom prst="rect">
@@ -4413,13 +4493,13 @@
       </p:sp>
       <p:sp>
         <p:nvSpPr>
-          <p:cNvPr id="34" name="Oval 33"/>
+          <p:cNvPr id="36" name="Oval 35"/>
           <p:cNvSpPr/>
           <p:nvPr/>
         </p:nvSpPr>
         <p:spPr>
           <a:xfrm>
-            <a:off x="4211836" y="5594896"/>
+            <a:off x="4211836" y="5629573"/>
             <a:ext cx="152846" cy="152846"/>
           </a:xfrm>
           <a:prstGeom prst="ellipse">
@@ -4456,13 +4536,13 @@
       </p:sp>
       <p:sp>
         <p:nvSpPr>
-          <p:cNvPr id="35" name="Oval 34"/>
+          <p:cNvPr id="37" name="Oval 36"/>
           <p:cNvSpPr/>
           <p:nvPr/>
         </p:nvSpPr>
         <p:spPr>
           <a:xfrm>
-            <a:off x="4451003" y="5594896"/>
+            <a:off x="4451003" y="5629573"/>
             <a:ext cx="152846" cy="152846"/>
           </a:xfrm>
           <a:prstGeom prst="ellipse">
@@ -4499,13 +4579,13 @@
       </p:sp>
       <p:sp>
         <p:nvSpPr>
-          <p:cNvPr id="36" name="Oval 35"/>
+          <p:cNvPr id="38" name="Oval 37"/>
           <p:cNvSpPr/>
           <p:nvPr/>
         </p:nvSpPr>
         <p:spPr>
           <a:xfrm>
-            <a:off x="4690170" y="5594896"/>
+            <a:off x="4690170" y="5629573"/>
             <a:ext cx="152846" cy="152846"/>
           </a:xfrm>
           <a:prstGeom prst="ellipse">
@@ -4542,13 +4622,13 @@
       </p:sp>
       <p:sp>
         <p:nvSpPr>
-          <p:cNvPr id="37" name="Oval 36"/>
+          <p:cNvPr id="39" name="Oval 38"/>
           <p:cNvSpPr/>
           <p:nvPr/>
         </p:nvSpPr>
         <p:spPr>
           <a:xfrm>
-            <a:off x="4929336" y="5594896"/>
+            <a:off x="4929336" y="5629573"/>
             <a:ext cx="152846" cy="152846"/>
           </a:xfrm>
           <a:prstGeom prst="ellipse">
@@ -4585,13 +4665,13 @@
       </p:sp>
       <p:sp>
         <p:nvSpPr>
-          <p:cNvPr id="38" name="Oval 37"/>
+          <p:cNvPr id="40" name="Oval 39"/>
           <p:cNvSpPr/>
           <p:nvPr/>
         </p:nvSpPr>
         <p:spPr>
           <a:xfrm>
-            <a:off x="5168503" y="5594896"/>
+            <a:off x="5168503" y="5629573"/>
             <a:ext cx="152846" cy="152846"/>
           </a:xfrm>
           <a:prstGeom prst="ellipse">
@@ -4628,13 +4708,13 @@
       </p:sp>
       <p:sp>
         <p:nvSpPr>
-          <p:cNvPr id="39" name="Oval 38"/>
+          <p:cNvPr id="41" name="Oval 40"/>
           <p:cNvSpPr/>
           <p:nvPr/>
         </p:nvSpPr>
         <p:spPr>
           <a:xfrm>
-            <a:off x="5407670" y="5594896"/>
+            <a:off x="5407670" y="5629573"/>
             <a:ext cx="152846" cy="152846"/>
           </a:xfrm>
           <a:prstGeom prst="ellipse">
@@ -4671,13 +4751,13 @@
       </p:sp>
       <p:sp>
         <p:nvSpPr>
-          <p:cNvPr id="40" name="Oval 39"/>
+          <p:cNvPr id="42" name="Oval 41"/>
           <p:cNvSpPr/>
           <p:nvPr/>
         </p:nvSpPr>
         <p:spPr>
           <a:xfrm>
-            <a:off x="5646837" y="5594896"/>
+            <a:off x="5646837" y="5629573"/>
             <a:ext cx="152846" cy="152846"/>
           </a:xfrm>
           <a:prstGeom prst="ellipse">
@@ -4714,13 +4794,13 @@
       </p:sp>
       <p:sp>
         <p:nvSpPr>
-          <p:cNvPr id="41" name="Oval 40"/>
+          <p:cNvPr id="43" name="Oval 42"/>
           <p:cNvSpPr/>
           <p:nvPr/>
         </p:nvSpPr>
         <p:spPr>
           <a:xfrm>
-            <a:off x="5886004" y="5594896"/>
+            <a:off x="5886004" y="5629573"/>
             <a:ext cx="152846" cy="152846"/>
           </a:xfrm>
           <a:prstGeom prst="ellipse">
@@ -4757,13 +4837,13 @@
       </p:sp>
       <p:sp>
         <p:nvSpPr>
-          <p:cNvPr id="42" name="Oval 41"/>
+          <p:cNvPr id="44" name="Oval 43"/>
           <p:cNvSpPr/>
           <p:nvPr/>
         </p:nvSpPr>
         <p:spPr>
           <a:xfrm>
-            <a:off x="6125170" y="5594896"/>
+            <a:off x="6125170" y="5629573"/>
             <a:ext cx="152846" cy="152846"/>
           </a:xfrm>
           <a:prstGeom prst="ellipse">
@@ -4800,13 +4880,13 @@
       </p:sp>
       <p:sp>
         <p:nvSpPr>
-          <p:cNvPr id="43" name="Oval 42"/>
+          <p:cNvPr id="45" name="Oval 44"/>
           <p:cNvSpPr/>
           <p:nvPr/>
         </p:nvSpPr>
         <p:spPr>
           <a:xfrm>
-            <a:off x="6364337" y="5594896"/>
+            <a:off x="6364337" y="5629573"/>
             <a:ext cx="152846" cy="152846"/>
           </a:xfrm>
           <a:prstGeom prst="ellipse">
@@ -4843,13 +4923,13 @@
       </p:sp>
       <p:sp>
         <p:nvSpPr>
-          <p:cNvPr id="44" name="Oval 43"/>
+          <p:cNvPr id="46" name="Oval 45"/>
           <p:cNvSpPr/>
           <p:nvPr/>
         </p:nvSpPr>
         <p:spPr>
           <a:xfrm>
-            <a:off x="4211836" y="5834062"/>
+            <a:off x="4211836" y="5868739"/>
             <a:ext cx="152846" cy="152846"/>
           </a:xfrm>
           <a:prstGeom prst="ellipse">
@@ -4886,13 +4966,13 @@
       </p:sp>
       <p:sp>
         <p:nvSpPr>
-          <p:cNvPr id="45" name="Oval 44"/>
+          <p:cNvPr id="47" name="Oval 46"/>
           <p:cNvSpPr/>
           <p:nvPr/>
         </p:nvSpPr>
         <p:spPr>
           <a:xfrm>
-            <a:off x="4451003" y="5834062"/>
+            <a:off x="4451003" y="5868739"/>
             <a:ext cx="152846" cy="152846"/>
           </a:xfrm>
           <a:prstGeom prst="ellipse">
@@ -4929,13 +5009,13 @@
       </p:sp>
       <p:sp>
         <p:nvSpPr>
-          <p:cNvPr id="46" name="Oval 45"/>
+          <p:cNvPr id="48" name="Oval 47"/>
           <p:cNvSpPr/>
           <p:nvPr/>
         </p:nvSpPr>
         <p:spPr>
           <a:xfrm>
-            <a:off x="4690170" y="5834062"/>
+            <a:off x="4690170" y="5868739"/>
             <a:ext cx="152846" cy="152846"/>
           </a:xfrm>
           <a:prstGeom prst="ellipse">
@@ -4972,13 +5052,13 @@
       </p:sp>
       <p:sp>
         <p:nvSpPr>
-          <p:cNvPr id="47" name="Oval 46"/>
+          <p:cNvPr id="49" name="Oval 48"/>
           <p:cNvSpPr/>
           <p:nvPr/>
         </p:nvSpPr>
         <p:spPr>
           <a:xfrm>
-            <a:off x="4929336" y="5834062"/>
+            <a:off x="4929336" y="5868739"/>
             <a:ext cx="152846" cy="152846"/>
           </a:xfrm>
           <a:prstGeom prst="ellipse">
@@ -5015,13 +5095,13 @@
       </p:sp>
       <p:sp>
         <p:nvSpPr>
-          <p:cNvPr id="48" name="Oval 47"/>
+          <p:cNvPr id="50" name="Oval 49"/>
           <p:cNvSpPr/>
           <p:nvPr/>
         </p:nvSpPr>
         <p:spPr>
           <a:xfrm>
-            <a:off x="5168503" y="5834062"/>
+            <a:off x="5168503" y="5868739"/>
             <a:ext cx="152846" cy="152846"/>
           </a:xfrm>
           <a:prstGeom prst="ellipse">
@@ -5058,13 +5138,13 @@
       </p:sp>
       <p:sp>
         <p:nvSpPr>
-          <p:cNvPr id="49" name="Oval 48"/>
+          <p:cNvPr id="51" name="Oval 50"/>
           <p:cNvSpPr/>
           <p:nvPr/>
         </p:nvSpPr>
         <p:spPr>
           <a:xfrm>
-            <a:off x="5407670" y="5834062"/>
+            <a:off x="5407670" y="5868739"/>
             <a:ext cx="152846" cy="152846"/>
           </a:xfrm>
           <a:prstGeom prst="ellipse">
@@ -5101,13 +5181,13 @@
       </p:sp>
       <p:sp>
         <p:nvSpPr>
-          <p:cNvPr id="50" name="Oval 49"/>
+          <p:cNvPr id="52" name="Oval 51"/>
           <p:cNvSpPr/>
           <p:nvPr/>
         </p:nvSpPr>
         <p:spPr>
           <a:xfrm>
-            <a:off x="5646837" y="5834062"/>
+            <a:off x="5646837" y="5868739"/>
             <a:ext cx="152846" cy="152846"/>
           </a:xfrm>
           <a:prstGeom prst="ellipse">
@@ -5144,13 +5224,13 @@
       </p:sp>
       <p:sp>
         <p:nvSpPr>
-          <p:cNvPr id="51" name="Oval 50"/>
+          <p:cNvPr id="53" name="Oval 52"/>
           <p:cNvSpPr/>
           <p:nvPr/>
         </p:nvSpPr>
         <p:spPr>
           <a:xfrm>
-            <a:off x="5886004" y="5834062"/>
+            <a:off x="5886004" y="5868739"/>
             <a:ext cx="152846" cy="152846"/>
           </a:xfrm>
           <a:prstGeom prst="ellipse">
@@ -5187,13 +5267,13 @@
       </p:sp>
       <p:sp>
         <p:nvSpPr>
-          <p:cNvPr id="52" name="Oval 51"/>
+          <p:cNvPr id="54" name="Oval 53"/>
           <p:cNvSpPr/>
           <p:nvPr/>
         </p:nvSpPr>
         <p:spPr>
           <a:xfrm>
-            <a:off x="6125170" y="5834062"/>
+            <a:off x="6125170" y="5868739"/>
             <a:ext cx="152846" cy="152846"/>
           </a:xfrm>
           <a:prstGeom prst="ellipse">
@@ -5230,13 +5310,13 @@
       </p:sp>
       <p:sp>
         <p:nvSpPr>
-          <p:cNvPr id="53" name="Oval 52"/>
+          <p:cNvPr id="55" name="Oval 54"/>
           <p:cNvSpPr/>
           <p:nvPr/>
         </p:nvSpPr>
         <p:spPr>
           <a:xfrm>
-            <a:off x="6364337" y="5834062"/>
+            <a:off x="6364337" y="5868739"/>
             <a:ext cx="152846" cy="152846"/>
           </a:xfrm>
           <a:prstGeom prst="ellipse">
@@ -5273,13 +5353,13 @@
       </p:sp>
       <p:sp>
         <p:nvSpPr>
-          <p:cNvPr id="54" name="TextBox 53"/>
+          <p:cNvPr id="56" name="TextBox 55"/>
           <p:cNvSpPr txBox="1"/>
           <p:nvPr/>
         </p:nvSpPr>
         <p:spPr>
           <a:xfrm>
-            <a:off x="723900" y="6433989"/>
+            <a:off x="723900" y="6468666"/>
             <a:ext cx="2055733" cy="142875"/>
           </a:xfrm>
           <a:prstGeom prst="rect">
@@ -5312,13 +5392,13 @@
       </p:sp>
       <p:sp>
         <p:nvSpPr>
-          <p:cNvPr id="55" name="Rounded Rectangle 54"/>
+          <p:cNvPr id="57" name="Rounded Rectangle 56"/>
           <p:cNvSpPr/>
           <p:nvPr/>
         </p:nvSpPr>
         <p:spPr>
           <a:xfrm>
-            <a:off x="719882" y="6809929"/>
+            <a:off x="719882" y="6844605"/>
             <a:ext cx="6120110" cy="1422648"/>
           </a:xfrm>
           <a:prstGeom prst="roundRect">
@@ -5355,13 +5435,13 @@
       </p:sp>
       <p:sp>
         <p:nvSpPr>
-          <p:cNvPr id="56" name="TextBox 55"/>
+          <p:cNvPr id="58" name="TextBox 57"/>
           <p:cNvSpPr txBox="1"/>
           <p:nvPr/>
         </p:nvSpPr>
         <p:spPr>
           <a:xfrm>
-            <a:off x="1043880" y="7143452"/>
+            <a:off x="1043880" y="7178129"/>
             <a:ext cx="3437573" cy="428625"/>
           </a:xfrm>
           <a:prstGeom prst="rect">
@@ -5394,13 +5474,13 @@
       </p:sp>
       <p:sp>
         <p:nvSpPr>
-          <p:cNvPr id="57" name="TextBox 56"/>
+          <p:cNvPr id="59" name="TextBox 58"/>
           <p:cNvSpPr txBox="1"/>
           <p:nvPr/>
         </p:nvSpPr>
         <p:spPr>
           <a:xfrm>
-            <a:off x="1043880" y="7718078"/>
+            <a:off x="1043880" y="7752755"/>
             <a:ext cx="2320766" cy="171450"/>
           </a:xfrm>
           <a:prstGeom prst="rect">
@@ -5433,7 +5513,7 @@
       </p:sp>
       <p:pic>
         <p:nvPicPr>
-          <p:cNvPr id="58" name="Picture 57" descr="academica.png"/>
+          <p:cNvPr id="60" name="Picture 59" descr="academica.png"/>
           <p:cNvPicPr>
             <a:picLocks noChangeAspect="1"/>
           </p:cNvPicPr>
@@ -5447,8 +5527,8 @@
         </p:blipFill>
         <p:spPr>
           <a:xfrm>
-            <a:off x="723900" y="381000"/>
-            <a:ext cx="1569720" cy="304800"/>
+            <a:off x="742950" y="10182225"/>
+            <a:ext cx="784860" cy="152400"/>
           </a:xfrm>
           <a:prstGeom prst="rect">
             <a:avLst/>
@@ -5457,7 +5537,7 @@
       </p:pic>
       <p:sp>
         <p:nvSpPr>
-          <p:cNvPr id="59" name="TextBox 58"/>
+          <p:cNvPr id="61" name="TextBox 60"/>
           <p:cNvSpPr txBox="1"/>
           <p:nvPr/>
         </p:nvSpPr>
@@ -5510,13 +5590,93 @@
       <p:grpSpPr/>
       <p:sp>
         <p:nvSpPr>
-          <p:cNvPr id="2" name="TextBox 1"/>
+          <p:cNvPr id="2" name="Rectangle 1"/>
+          <p:cNvSpPr/>
+          <p:nvPr/>
+        </p:nvSpPr>
+        <p:spPr>
+          <a:xfrm>
+            <a:off x="0" y="0"/>
+            <a:ext cx="7562850" cy="10696575"/>
+          </a:xfrm>
+          <a:prstGeom prst="rect">
+            <a:avLst/>
+          </a:prstGeom>
+          <a:solidFill>
+            <a:srgbClr val="000326"/>
+          </a:solidFill>
+          <a:ln>
+            <a:noFill/>
+          </a:ln>
+        </p:spPr>
+        <p:style>
+          <a:lnRef idx="1">
+            <a:schemeClr val="accent1"/>
+          </a:lnRef>
+          <a:fillRef idx="3">
+            <a:schemeClr val="accent1"/>
+          </a:fillRef>
+          <a:effectRef idx="0">
+            <a:schemeClr val="accent1"/>
+          </a:effectRef>
+          <a:fontRef idx="minor">
+            <a:schemeClr val="lt1"/>
+          </a:fontRef>
+        </p:style>
+        <p:txBody>
+          <a:bodyPr rtlCol="0" anchor="ctr"/>
+          <a:lstStyle/>
+          <a:p/>
+        </p:txBody>
+      </p:sp>
+      <p:sp>
+        <p:nvSpPr>
+          <p:cNvPr id="3" name="TextBox 2"/>
           <p:cNvSpPr txBox="1"/>
           <p:nvPr/>
         </p:nvSpPr>
         <p:spPr>
           <a:xfrm>
-            <a:off x="723900" y="892522"/>
+            <a:off x="723900" y="575965"/>
+            <a:ext cx="242006" cy="142875"/>
+          </a:xfrm>
+          <a:prstGeom prst="rect">
+            <a:avLst/>
+          </a:prstGeom>
+          <a:noFill/>
+        </p:spPr>
+        <p:txBody>
+          <a:bodyPr wrap="square" anchor="t" lIns="0" rIns="0" tIns="0" bIns="0">
+            <a:noAutofit/>
+          </a:bodyPr>
+          <a:lstStyle/>
+          <a:p>
+            <a:pPr algn="l">
+              <a:lnSpc>
+                <a:spcPts val="1080"/>
+              </a:lnSpc>
+            </a:pPr>
+            <a:r>
+              <a:rPr sz="900" b="1">
+                <a:solidFill>
+                  <a:srgbClr val="FFFFFF"/>
+                </a:solidFill>
+                <a:latin typeface="Inter"/>
+              </a:rPr>
+              <a:t>02</a:t>
+            </a:r>
+          </a:p>
+        </p:txBody>
+      </p:sp>
+      <p:sp>
+        <p:nvSpPr>
+          <p:cNvPr id="4" name="TextBox 3"/>
+          <p:cNvSpPr txBox="1"/>
+          <p:nvPr/>
+        </p:nvSpPr>
+        <p:spPr>
+          <a:xfrm>
+            <a:off x="723900" y="819299"/>
             <a:ext cx="1269468" cy="352425"/>
           </a:xfrm>
           <a:prstGeom prst="rect">
@@ -5538,7 +5698,7 @@
             <a:r>
               <a:rPr sz="3000" b="1">
                 <a:solidFill>
-                  <a:srgbClr val="000326"/>
+                  <a:srgbClr val="FFFFFF"/>
                 </a:solidFill>
                 <a:latin typeface="League Spartan"/>
               </a:rPr>
@@ -5549,13 +5709,13 @@
       </p:sp>
       <p:sp>
         <p:nvSpPr>
-          <p:cNvPr id="3" name="Rounded Rectangle 2"/>
+          <p:cNvPr id="5" name="Rounded Rectangle 4"/>
           <p:cNvSpPr/>
           <p:nvPr/>
         </p:nvSpPr>
         <p:spPr>
           <a:xfrm>
-            <a:off x="719882" y="1642914"/>
+            <a:off x="719882" y="1795165"/>
             <a:ext cx="6120110" cy="3347591"/>
           </a:xfrm>
           <a:prstGeom prst="roundRect">
@@ -5564,7 +5724,7 @@
             </a:avLst>
           </a:prstGeom>
           <a:solidFill>
-            <a:srgbClr val="E3E6F4"/>
+            <a:srgbClr val="E4E0F5"/>
           </a:solidFill>
           <a:ln>
             <a:noFill/>
@@ -5592,13 +5752,13 @@
       </p:sp>
       <p:sp>
         <p:nvSpPr>
-          <p:cNvPr id="4" name="TextBox 3"/>
+          <p:cNvPr id="6" name="TextBox 5"/>
           <p:cNvSpPr txBox="1"/>
           <p:nvPr/>
         </p:nvSpPr>
         <p:spPr>
           <a:xfrm>
-            <a:off x="1043880" y="1976438"/>
+            <a:off x="1043880" y="2128689"/>
             <a:ext cx="1477494" cy="428625"/>
           </a:xfrm>
           <a:prstGeom prst="rect">
@@ -5631,13 +5791,13 @@
       </p:sp>
       <p:sp>
         <p:nvSpPr>
-          <p:cNvPr id="5" name="TextBox 4"/>
+          <p:cNvPr id="7" name="TextBox 6"/>
           <p:cNvSpPr txBox="1"/>
           <p:nvPr/>
         </p:nvSpPr>
         <p:spPr>
           <a:xfrm>
-            <a:off x="1043880" y="2551063"/>
+            <a:off x="1043880" y="2703314"/>
             <a:ext cx="2928842" cy="171450"/>
           </a:xfrm>
           <a:prstGeom prst="rect">
@@ -5670,13 +5830,13 @@
       </p:sp>
       <p:sp>
         <p:nvSpPr>
-          <p:cNvPr id="6" name="Rounded Rectangle 5"/>
+          <p:cNvPr id="8" name="Rounded Rectangle 7"/>
           <p:cNvSpPr/>
           <p:nvPr/>
         </p:nvSpPr>
         <p:spPr>
           <a:xfrm>
-            <a:off x="1043880" y="2957512"/>
+            <a:off x="1043880" y="3109764"/>
             <a:ext cx="5472112" cy="1405086"/>
           </a:xfrm>
           <a:prstGeom prst="roundRect">
@@ -5713,13 +5873,13 @@
       </p:sp>
       <p:sp>
         <p:nvSpPr>
-          <p:cNvPr id="7" name="TextBox 6"/>
+          <p:cNvPr id="9" name="TextBox 8"/>
           <p:cNvSpPr txBox="1"/>
           <p:nvPr/>
         </p:nvSpPr>
         <p:spPr>
           <a:xfrm>
-            <a:off x="1259830" y="3182987"/>
+            <a:off x="1259830" y="3335238"/>
             <a:ext cx="3889796" cy="171450"/>
           </a:xfrm>
           <a:prstGeom prst="rect">
@@ -5752,13 +5912,13 @@
       </p:sp>
       <p:sp>
         <p:nvSpPr>
-          <p:cNvPr id="8" name="TextBox 7"/>
+          <p:cNvPr id="10" name="TextBox 9"/>
           <p:cNvSpPr txBox="1"/>
           <p:nvPr/>
         </p:nvSpPr>
         <p:spPr>
           <a:xfrm>
-            <a:off x="1259830" y="3376017"/>
+            <a:off x="1259830" y="3528268"/>
             <a:ext cx="1730026" cy="142875"/>
           </a:xfrm>
           <a:prstGeom prst="rect">
@@ -5791,13 +5951,13 @@
       </p:sp>
       <p:sp>
         <p:nvSpPr>
-          <p:cNvPr id="9" name="TextBox 8"/>
+          <p:cNvPr id="11" name="TextBox 10"/>
           <p:cNvSpPr txBox="1"/>
           <p:nvPr/>
         </p:nvSpPr>
         <p:spPr>
           <a:xfrm>
-            <a:off x="1259830" y="3715941"/>
+            <a:off x="1259830" y="3868192"/>
             <a:ext cx="1099947" cy="152400"/>
           </a:xfrm>
           <a:prstGeom prst="rect">
@@ -5830,13 +5990,13 @@
       </p:sp>
       <p:sp>
         <p:nvSpPr>
-          <p:cNvPr id="10" name="Rounded Rectangle 9"/>
+          <p:cNvPr id="12" name="Rounded Rectangle 11"/>
           <p:cNvSpPr/>
           <p:nvPr/>
         </p:nvSpPr>
         <p:spPr>
           <a:xfrm>
-            <a:off x="2627709" y="3738116"/>
+            <a:off x="2627709" y="3890367"/>
             <a:ext cx="2808536" cy="107900"/>
           </a:xfrm>
           <a:prstGeom prst="roundRect">
@@ -5873,13 +6033,13 @@
       </p:sp>
       <p:sp>
         <p:nvSpPr>
-          <p:cNvPr id="11" name="Rounded Rectangle 10"/>
+          <p:cNvPr id="13" name="Rounded Rectangle 12"/>
           <p:cNvSpPr/>
           <p:nvPr/>
         </p:nvSpPr>
         <p:spPr>
           <a:xfrm>
-            <a:off x="2627709" y="3738116"/>
+            <a:off x="2627709" y="3890367"/>
             <a:ext cx="2808536" cy="107900"/>
           </a:xfrm>
           <a:prstGeom prst="roundRect">
@@ -5916,13 +6076,13 @@
       </p:sp>
       <p:sp>
         <p:nvSpPr>
-          <p:cNvPr id="12" name="TextBox 11"/>
+          <p:cNvPr id="14" name="TextBox 13"/>
           <p:cNvSpPr txBox="1"/>
           <p:nvPr/>
         </p:nvSpPr>
         <p:spPr>
           <a:xfrm>
-            <a:off x="5813173" y="3715941"/>
+            <a:off x="5813173" y="3868192"/>
             <a:ext cx="486870" cy="152400"/>
           </a:xfrm>
           <a:prstGeom prst="rect">
@@ -5955,13 +6115,13 @@
       </p:sp>
       <p:sp>
         <p:nvSpPr>
-          <p:cNvPr id="13" name="TextBox 12"/>
+          <p:cNvPr id="15" name="TextBox 14"/>
           <p:cNvSpPr txBox="1"/>
           <p:nvPr/>
         </p:nvSpPr>
         <p:spPr>
           <a:xfrm>
-            <a:off x="1259830" y="3994249"/>
+            <a:off x="1259830" y="4146500"/>
             <a:ext cx="1007102" cy="152400"/>
           </a:xfrm>
           <a:prstGeom prst="rect">
@@ -5994,13 +6154,13 @@
       </p:sp>
       <p:sp>
         <p:nvSpPr>
-          <p:cNvPr id="14" name="Rounded Rectangle 13"/>
+          <p:cNvPr id="16" name="Rounded Rectangle 15"/>
           <p:cNvSpPr/>
           <p:nvPr/>
         </p:nvSpPr>
         <p:spPr>
           <a:xfrm>
-            <a:off x="2627709" y="4016425"/>
+            <a:off x="2627709" y="4168676"/>
             <a:ext cx="2808536" cy="107900"/>
           </a:xfrm>
           <a:prstGeom prst="roundRect">
@@ -6037,13 +6197,13 @@
       </p:sp>
       <p:sp>
         <p:nvSpPr>
-          <p:cNvPr id="15" name="Rounded Rectangle 14"/>
+          <p:cNvPr id="17" name="Rounded Rectangle 16"/>
           <p:cNvSpPr/>
           <p:nvPr/>
         </p:nvSpPr>
         <p:spPr>
           <a:xfrm>
-            <a:off x="2627709" y="4016425"/>
+            <a:off x="2627709" y="4168676"/>
             <a:ext cx="2246709" cy="107900"/>
           </a:xfrm>
           <a:prstGeom prst="roundRect">
@@ -6080,13 +6240,13 @@
       </p:sp>
       <p:sp>
         <p:nvSpPr>
-          <p:cNvPr id="16" name="TextBox 15"/>
+          <p:cNvPr id="18" name="TextBox 17"/>
           <p:cNvSpPr txBox="1"/>
           <p:nvPr/>
         </p:nvSpPr>
         <p:spPr>
           <a:xfrm>
-            <a:off x="5794171" y="3994249"/>
+            <a:off x="5794171" y="4146500"/>
             <a:ext cx="505873" cy="152400"/>
           </a:xfrm>
           <a:prstGeom prst="rect">
@@ -6119,13 +6279,13 @@
       </p:sp>
       <p:sp>
         <p:nvSpPr>
-          <p:cNvPr id="17" name="TextBox 16"/>
+          <p:cNvPr id="19" name="TextBox 18"/>
           <p:cNvSpPr txBox="1"/>
           <p:nvPr/>
         </p:nvSpPr>
         <p:spPr>
           <a:xfrm>
-            <a:off x="1043880" y="4506516"/>
+            <a:off x="1043880" y="4658767"/>
             <a:ext cx="3991975" cy="142875"/>
           </a:xfrm>
           <a:prstGeom prst="rect">
@@ -6156,9 +6316,54 @@
           </a:p>
         </p:txBody>
       </p:sp>
+      <p:sp>
+        <p:nvSpPr>
+          <p:cNvPr id="20" name="Rounded Rectangle 19"/>
+          <p:cNvSpPr/>
+          <p:nvPr/>
+        </p:nvSpPr>
+        <p:spPr>
+          <a:xfrm>
+            <a:off x="666750" y="10125075"/>
+            <a:ext cx="904875" cy="266700"/>
+          </a:xfrm>
+          <a:prstGeom prst="roundRect">
+            <a:avLst>
+              <a:gd name="adj" fmla="val 30000"/>
+            </a:avLst>
+          </a:prstGeom>
+          <a:solidFill>
+            <a:srgbClr val="FFFFFF"/>
+          </a:solidFill>
+          <a:ln>
+            <a:noFill/>
+          </a:ln>
+        </p:spPr>
+        <p:style>
+          <a:lnRef idx="1">
+            <a:schemeClr val="accent1"/>
+          </a:lnRef>
+          <a:fillRef idx="3">
+            <a:schemeClr val="accent1"/>
+          </a:fillRef>
+          <a:effectRef idx="0">
+            <a:schemeClr val="accent1"/>
+          </a:effectRef>
+          <a:fontRef idx="minor">
+            <a:schemeClr val="lt1"/>
+          </a:fontRef>
+        </p:style>
+        <p:txBody>
+          <a:bodyPr rtlCol="0" anchor="ctr"/>
+          <a:lstStyle/>
+          <a:p>
+            <a:pPr algn="ctr"/>
+          </a:p>
+        </p:txBody>
+      </p:sp>
       <p:pic>
         <p:nvPicPr>
-          <p:cNvPr id="18" name="Picture 17" descr="academica.png"/>
+          <p:cNvPr id="21" name="Picture 20" descr="academica.png"/>
           <p:cNvPicPr>
             <a:picLocks noChangeAspect="1"/>
           </p:cNvPicPr>
@@ -6172,7 +6377,7 @@
         </p:blipFill>
         <p:spPr>
           <a:xfrm>
-            <a:off x="723900" y="10182225"/>
+            <a:off x="742950" y="10182225"/>
             <a:ext cx="784860" cy="152400"/>
           </a:xfrm>
           <a:prstGeom prst="rect">
@@ -6182,7 +6387,7 @@
       </p:pic>
       <p:sp>
         <p:nvSpPr>
-          <p:cNvPr id="19" name="TextBox 18"/>
+          <p:cNvPr id="22" name="TextBox 21"/>
           <p:cNvSpPr txBox="1"/>
           <p:nvPr/>
         </p:nvSpPr>
@@ -6206,7 +6411,7 @@
             <a:r>
               <a:rPr sz="800">
                 <a:solidFill>
-                  <a:srgbClr val="555A78"/>
+                  <a:srgbClr val="B3B5C6"/>
                 </a:solidFill>
                 <a:latin typeface="Inter"/>
               </a:rPr>
@@ -6235,101 +6440,17 @@
       <p:grpSpPr/>
       <p:sp>
         <p:nvSpPr>
-          <p:cNvPr id="2" name="TextBox 1"/>
-          <p:cNvSpPr txBox="1"/>
-          <p:nvPr/>
-        </p:nvSpPr>
-        <p:spPr>
-          <a:xfrm>
-            <a:off x="723900" y="892522"/>
-            <a:ext cx="5531834" cy="352425"/>
-          </a:xfrm>
-          <a:prstGeom prst="rect">
-            <a:avLst/>
-          </a:prstGeom>
-          <a:noFill/>
-        </p:spPr>
-        <p:txBody>
-          <a:bodyPr wrap="square" anchor="t" lIns="0" rIns="0" tIns="0" bIns="0">
-            <a:noAutofit/>
-          </a:bodyPr>
-          <a:lstStyle/>
-          <a:p>
-            <a:pPr algn="l">
-              <a:lnSpc>
-                <a:spcPts val="3300"/>
-              </a:lnSpc>
-            </a:pPr>
-            <a:r>
-              <a:rPr sz="3000" b="1">
-                <a:solidFill>
-                  <a:srgbClr val="000326"/>
-                </a:solidFill>
-                <a:latin typeface="League Spartan"/>
-              </a:rPr>
-              <a:t>Wat de instelling ervoor krijgt</a:t>
-            </a:r>
-          </a:p>
-        </p:txBody>
-      </p:sp>
-      <p:sp>
-        <p:nvSpPr>
-          <p:cNvPr id="3" name="Rounded Rectangle 2"/>
+          <p:cNvPr id="2" name="Rectangle 1"/>
           <p:cNvSpPr/>
           <p:nvPr/>
         </p:nvSpPr>
         <p:spPr>
           <a:xfrm>
-            <a:off x="719882" y="1642914"/>
-            <a:ext cx="6120110" cy="2999482"/>
-          </a:xfrm>
-          <a:prstGeom prst="roundRect">
-            <a:avLst>
-              <a:gd name="adj" fmla="val 7201"/>
-            </a:avLst>
-          </a:prstGeom>
-          <a:solidFill>
-            <a:srgbClr val="E3E6F4"/>
-          </a:solidFill>
-          <a:ln>
-            <a:noFill/>
-          </a:ln>
-        </p:spPr>
-        <p:style>
-          <a:lnRef idx="1">
-            <a:schemeClr val="accent1"/>
-          </a:lnRef>
-          <a:fillRef idx="3">
-            <a:schemeClr val="accent1"/>
-          </a:fillRef>
-          <a:effectRef idx="0">
-            <a:schemeClr val="accent1"/>
-          </a:effectRef>
-          <a:fontRef idx="minor">
-            <a:schemeClr val="lt1"/>
-          </a:fontRef>
-        </p:style>
-        <p:txBody>
-          <a:bodyPr rtlCol="0" anchor="ctr"/>
-          <a:lstStyle/>
-          <a:p/>
-        </p:txBody>
-      </p:sp>
-      <p:sp>
-        <p:nvSpPr>
-          <p:cNvPr id="4" name="Rounded Rectangle 3"/>
-          <p:cNvSpPr/>
-          <p:nvPr/>
-        </p:nvSpPr>
-        <p:spPr>
-          <a:xfrm>
-            <a:off x="1043880" y="1966912"/>
-            <a:ext cx="359866" cy="359866"/>
-          </a:xfrm>
-          <a:prstGeom prst="roundRect">
-            <a:avLst>
-              <a:gd name="adj" fmla="val 30011"/>
-            </a:avLst>
+            <a:off x="0" y="0"/>
+            <a:ext cx="7559873" cy="1605707"/>
+          </a:xfrm>
+          <a:prstGeom prst="rect">
+            <a:avLst/>
           </a:prstGeom>
           <a:solidFill>
             <a:srgbClr val="000326"/>
@@ -6358,9 +6479,173 @@
           <a:p/>
         </p:txBody>
       </p:sp>
+      <p:sp>
+        <p:nvSpPr>
+          <p:cNvPr id="3" name="TextBox 2"/>
+          <p:cNvSpPr txBox="1"/>
+          <p:nvPr/>
+        </p:nvSpPr>
+        <p:spPr>
+          <a:xfrm>
+            <a:off x="723900" y="575965"/>
+            <a:ext cx="243673" cy="142875"/>
+          </a:xfrm>
+          <a:prstGeom prst="rect">
+            <a:avLst/>
+          </a:prstGeom>
+          <a:noFill/>
+        </p:spPr>
+        <p:txBody>
+          <a:bodyPr wrap="square" anchor="t" lIns="0" rIns="0" tIns="0" bIns="0">
+            <a:noAutofit/>
+          </a:bodyPr>
+          <a:lstStyle/>
+          <a:p>
+            <a:pPr algn="l">
+              <a:lnSpc>
+                <a:spcPts val="1080"/>
+              </a:lnSpc>
+            </a:pPr>
+            <a:r>
+              <a:rPr sz="900" b="1">
+                <a:solidFill>
+                  <a:srgbClr val="FFFFFF"/>
+                </a:solidFill>
+                <a:latin typeface="Inter"/>
+              </a:rPr>
+              <a:t>03</a:t>
+            </a:r>
+          </a:p>
+        </p:txBody>
+      </p:sp>
+      <p:sp>
+        <p:nvSpPr>
+          <p:cNvPr id="4" name="TextBox 3"/>
+          <p:cNvSpPr txBox="1"/>
+          <p:nvPr/>
+        </p:nvSpPr>
+        <p:spPr>
+          <a:xfrm>
+            <a:off x="723900" y="819299"/>
+            <a:ext cx="2002226" cy="352425"/>
+          </a:xfrm>
+          <a:prstGeom prst="rect">
+            <a:avLst/>
+          </a:prstGeom>
+          <a:noFill/>
+        </p:spPr>
+        <p:txBody>
+          <a:bodyPr wrap="square" anchor="t" lIns="0" rIns="0" tIns="0" bIns="0">
+            <a:noAutofit/>
+          </a:bodyPr>
+          <a:lstStyle/>
+          <a:p>
+            <a:pPr algn="l">
+              <a:lnSpc>
+                <a:spcPts val="3300"/>
+              </a:lnSpc>
+            </a:pPr>
+            <a:r>
+              <a:rPr sz="3000" b="1">
+                <a:solidFill>
+                  <a:srgbClr val="FFFFFF"/>
+                </a:solidFill>
+                <a:latin typeface="League Spartan"/>
+              </a:rPr>
+              <a:t>Opbrengst</a:t>
+            </a:r>
+          </a:p>
+        </p:txBody>
+      </p:sp>
+      <p:sp>
+        <p:nvSpPr>
+          <p:cNvPr id="5" name="Rounded Rectangle 4"/>
+          <p:cNvSpPr/>
+          <p:nvPr/>
+        </p:nvSpPr>
+        <p:spPr>
+          <a:xfrm>
+            <a:off x="719882" y="1965573"/>
+            <a:ext cx="6120110" cy="2999482"/>
+          </a:xfrm>
+          <a:prstGeom prst="roundRect">
+            <a:avLst>
+              <a:gd name="adj" fmla="val 7201"/>
+            </a:avLst>
+          </a:prstGeom>
+          <a:solidFill>
+            <a:srgbClr val="DFE8F3"/>
+          </a:solidFill>
+          <a:ln>
+            <a:noFill/>
+          </a:ln>
+        </p:spPr>
+        <p:style>
+          <a:lnRef idx="1">
+            <a:schemeClr val="accent1"/>
+          </a:lnRef>
+          <a:fillRef idx="3">
+            <a:schemeClr val="accent1"/>
+          </a:fillRef>
+          <a:effectRef idx="0">
+            <a:schemeClr val="accent1"/>
+          </a:effectRef>
+          <a:fontRef idx="minor">
+            <a:schemeClr val="lt1"/>
+          </a:fontRef>
+        </p:style>
+        <p:txBody>
+          <a:bodyPr rtlCol="0" anchor="ctr"/>
+          <a:lstStyle/>
+          <a:p/>
+        </p:txBody>
+      </p:sp>
+      <p:sp>
+        <p:nvSpPr>
+          <p:cNvPr id="6" name="Rounded Rectangle 5"/>
+          <p:cNvSpPr/>
+          <p:nvPr/>
+        </p:nvSpPr>
+        <p:spPr>
+          <a:xfrm>
+            <a:off x="1043880" y="2289572"/>
+            <a:ext cx="359866" cy="359866"/>
+          </a:xfrm>
+          <a:prstGeom prst="roundRect">
+            <a:avLst>
+              <a:gd name="adj" fmla="val 30011"/>
+            </a:avLst>
+          </a:prstGeom>
+          <a:solidFill>
+            <a:srgbClr val="000326"/>
+          </a:solidFill>
+          <a:ln>
+            <a:noFill/>
+          </a:ln>
+        </p:spPr>
+        <p:style>
+          <a:lnRef idx="1">
+            <a:schemeClr val="accent1"/>
+          </a:lnRef>
+          <a:fillRef idx="3">
+            <a:schemeClr val="accent1"/>
+          </a:fillRef>
+          <a:effectRef idx="0">
+            <a:schemeClr val="accent1"/>
+          </a:effectRef>
+          <a:fontRef idx="minor">
+            <a:schemeClr val="lt1"/>
+          </a:fontRef>
+        </p:style>
+        <p:txBody>
+          <a:bodyPr rtlCol="0" anchor="ctr"/>
+          <a:lstStyle/>
+          <a:p/>
+        </p:txBody>
+      </p:sp>
       <p:pic>
         <p:nvPicPr>
-          <p:cNvPr id="5" name="Picture 4" descr="svg-2-0.png"/>
+          <p:cNvPr id="7" name="Picture 6" descr="svg-2-0.png"/>
           <p:cNvPicPr>
             <a:picLocks noChangeAspect="1"/>
           </p:cNvPicPr>
@@ -6374,7 +6659,7 @@
         </p:blipFill>
         <p:spPr>
           <a:xfrm>
-            <a:off x="1133773" y="2056805"/>
+            <a:off x="1133773" y="2379464"/>
             <a:ext cx="179933" cy="179933"/>
           </a:xfrm>
           <a:prstGeom prst="rect">
@@ -6384,13 +6669,13 @@
       </p:pic>
       <p:sp>
         <p:nvSpPr>
-          <p:cNvPr id="6" name="TextBox 5"/>
+          <p:cNvPr id="8" name="TextBox 7"/>
           <p:cNvSpPr txBox="1"/>
           <p:nvPr/>
         </p:nvSpPr>
         <p:spPr>
           <a:xfrm>
-            <a:off x="1547664" y="2045791"/>
+            <a:off x="1547664" y="2368451"/>
             <a:ext cx="2291763" cy="200025"/>
           </a:xfrm>
           <a:prstGeom prst="rect">
@@ -6423,13 +6708,13 @@
       </p:sp>
       <p:sp>
         <p:nvSpPr>
-          <p:cNvPr id="7" name="TextBox 6"/>
+          <p:cNvPr id="9" name="TextBox 8"/>
           <p:cNvSpPr txBox="1"/>
           <p:nvPr/>
         </p:nvSpPr>
         <p:spPr>
           <a:xfrm>
-            <a:off x="1043880" y="2453729"/>
+            <a:off x="1043880" y="2776389"/>
             <a:ext cx="5795070" cy="171450"/>
           </a:xfrm>
           <a:prstGeom prst="rect">
@@ -6462,13 +6747,13 @@
       </p:sp>
       <p:sp>
         <p:nvSpPr>
-          <p:cNvPr id="8" name="Rounded Rectangle 7"/>
+          <p:cNvPr id="10" name="Rounded Rectangle 9"/>
           <p:cNvSpPr/>
           <p:nvPr/>
         </p:nvSpPr>
         <p:spPr>
           <a:xfrm>
-            <a:off x="1043880" y="2860179"/>
+            <a:off x="1043880" y="3182838"/>
             <a:ext cx="2628007" cy="1458218"/>
           </a:xfrm>
           <a:prstGeom prst="roundRect">
@@ -6505,13 +6790,13 @@
       </p:sp>
       <p:sp>
         <p:nvSpPr>
-          <p:cNvPr id="9" name="TextBox 8"/>
+          <p:cNvPr id="11" name="TextBox 10"/>
           <p:cNvSpPr txBox="1"/>
           <p:nvPr/>
         </p:nvSpPr>
         <p:spPr>
           <a:xfrm>
-            <a:off x="1259830" y="3085654"/>
+            <a:off x="1259830" y="3408313"/>
             <a:ext cx="602218" cy="171450"/>
           </a:xfrm>
           <a:prstGeom prst="rect">
@@ -6544,13 +6829,13 @@
       </p:sp>
       <p:sp>
         <p:nvSpPr>
-          <p:cNvPr id="10" name="TextBox 9"/>
+          <p:cNvPr id="12" name="TextBox 11"/>
           <p:cNvSpPr txBox="1"/>
           <p:nvPr/>
         </p:nvSpPr>
         <p:spPr>
           <a:xfrm>
-            <a:off x="1259830" y="3278684"/>
+            <a:off x="1259830" y="3601343"/>
             <a:ext cx="2214420" cy="142875"/>
           </a:xfrm>
           <a:prstGeom prst="rect">
@@ -6583,13 +6868,13 @@
       </p:sp>
       <p:sp>
         <p:nvSpPr>
-          <p:cNvPr id="11" name="Rectangle 10"/>
+          <p:cNvPr id="13" name="Rectangle 12"/>
           <p:cNvSpPr/>
           <p:nvPr/>
         </p:nvSpPr>
         <p:spPr>
           <a:xfrm>
-            <a:off x="1259830" y="3755380"/>
+            <a:off x="1259830" y="4078039"/>
             <a:ext cx="2196108" cy="14288"/>
           </a:xfrm>
           <a:prstGeom prst="rect">
@@ -6624,13 +6909,13 @@
       </p:sp>
       <p:sp>
         <p:nvSpPr>
-          <p:cNvPr id="12" name="Oval 11"/>
+          <p:cNvPr id="14" name="Oval 13"/>
           <p:cNvSpPr/>
           <p:nvPr/>
         </p:nvSpPr>
         <p:spPr>
           <a:xfrm>
-            <a:off x="1491555" y="3686919"/>
+            <a:off x="1491555" y="4009579"/>
             <a:ext cx="151061" cy="151061"/>
           </a:xfrm>
           <a:prstGeom prst="ellipse">
@@ -6667,13 +6952,13 @@
       </p:sp>
       <p:sp>
         <p:nvSpPr>
-          <p:cNvPr id="13" name="Oval 12"/>
+          <p:cNvPr id="15" name="Oval 14"/>
           <p:cNvSpPr/>
           <p:nvPr/>
         </p:nvSpPr>
         <p:spPr>
           <a:xfrm>
-            <a:off x="2106513" y="3686919"/>
+            <a:off x="2106513" y="4009579"/>
             <a:ext cx="151061" cy="151061"/>
           </a:xfrm>
           <a:prstGeom prst="ellipse">
@@ -6710,13 +6995,13 @@
       </p:sp>
       <p:sp>
         <p:nvSpPr>
-          <p:cNvPr id="14" name="Oval 13"/>
+          <p:cNvPr id="16" name="Oval 15"/>
           <p:cNvSpPr/>
           <p:nvPr/>
         </p:nvSpPr>
         <p:spPr>
           <a:xfrm>
-            <a:off x="2567732" y="3686919"/>
+            <a:off x="2567732" y="4009579"/>
             <a:ext cx="151061" cy="151061"/>
           </a:xfrm>
           <a:prstGeom prst="ellipse">
@@ -6753,13 +7038,13 @@
       </p:sp>
       <p:sp>
         <p:nvSpPr>
-          <p:cNvPr id="15" name="Oval 14"/>
+          <p:cNvPr id="17" name="Oval 16"/>
           <p:cNvSpPr/>
           <p:nvPr/>
         </p:nvSpPr>
         <p:spPr>
           <a:xfrm>
-            <a:off x="3116759" y="3686919"/>
+            <a:off x="3116759" y="4009579"/>
             <a:ext cx="151061" cy="151061"/>
           </a:xfrm>
           <a:prstGeom prst="ellipse">
@@ -6796,13 +7081,13 @@
       </p:sp>
       <p:sp>
         <p:nvSpPr>
-          <p:cNvPr id="16" name="TextBox 15"/>
+          <p:cNvPr id="18" name="TextBox 17"/>
           <p:cNvSpPr txBox="1"/>
           <p:nvPr/>
         </p:nvSpPr>
         <p:spPr>
           <a:xfrm>
-            <a:off x="1259830" y="3942457"/>
+            <a:off x="1259830" y="4265116"/>
             <a:ext cx="578882" cy="142875"/>
           </a:xfrm>
           <a:prstGeom prst="rect">
@@ -6835,13 +7120,13 @@
       </p:sp>
       <p:sp>
         <p:nvSpPr>
-          <p:cNvPr id="17" name="TextBox 16"/>
+          <p:cNvPr id="19" name="TextBox 18"/>
           <p:cNvSpPr txBox="1"/>
           <p:nvPr/>
         </p:nvSpPr>
         <p:spPr>
           <a:xfrm>
-            <a:off x="3117652" y="3942457"/>
+            <a:off x="3117652" y="4265116"/>
             <a:ext cx="436031" cy="142875"/>
           </a:xfrm>
           <a:prstGeom prst="rect">
@@ -6874,13 +7159,13 @@
       </p:sp>
       <p:sp>
         <p:nvSpPr>
-          <p:cNvPr id="18" name="Rounded Rectangle 17"/>
+          <p:cNvPr id="20" name="Rounded Rectangle 19"/>
           <p:cNvSpPr/>
           <p:nvPr/>
         </p:nvSpPr>
         <p:spPr>
           <a:xfrm>
-            <a:off x="3887837" y="2860179"/>
+            <a:off x="3887837" y="3182838"/>
             <a:ext cx="2628156" cy="1458218"/>
           </a:xfrm>
           <a:prstGeom prst="roundRect">
@@ -6917,13 +7202,13 @@
       </p:sp>
       <p:sp>
         <p:nvSpPr>
-          <p:cNvPr id="19" name="TextBox 18"/>
+          <p:cNvPr id="21" name="TextBox 20"/>
           <p:cNvSpPr txBox="1"/>
           <p:nvPr/>
         </p:nvSpPr>
         <p:spPr>
           <a:xfrm>
-            <a:off x="4103787" y="3085654"/>
+            <a:off x="4103787" y="3408313"/>
             <a:ext cx="1007769" cy="171450"/>
           </a:xfrm>
           <a:prstGeom prst="rect">
@@ -6956,13 +7241,13 @@
       </p:sp>
       <p:sp>
         <p:nvSpPr>
-          <p:cNvPr id="20" name="TextBox 19"/>
+          <p:cNvPr id="22" name="TextBox 21"/>
           <p:cNvSpPr txBox="1"/>
           <p:nvPr/>
         </p:nvSpPr>
         <p:spPr>
           <a:xfrm>
-            <a:off x="4103787" y="3278684"/>
+            <a:off x="4103787" y="3601343"/>
             <a:ext cx="1966222" cy="142875"/>
           </a:xfrm>
           <a:prstGeom prst="rect">
@@ -6995,13 +7280,13 @@
       </p:sp>
       <p:sp>
         <p:nvSpPr>
-          <p:cNvPr id="21" name="Rectangle 20"/>
+          <p:cNvPr id="23" name="Rectangle 22"/>
           <p:cNvSpPr/>
           <p:nvPr/>
         </p:nvSpPr>
         <p:spPr>
           <a:xfrm>
-            <a:off x="4103787" y="3755380"/>
+            <a:off x="4103787" y="4078039"/>
             <a:ext cx="2196257" cy="14288"/>
           </a:xfrm>
           <a:prstGeom prst="rect">
@@ -7036,13 +7321,13 @@
       </p:sp>
       <p:sp>
         <p:nvSpPr>
-          <p:cNvPr id="22" name="Oval 21"/>
+          <p:cNvPr id="24" name="Oval 23"/>
           <p:cNvSpPr/>
           <p:nvPr/>
         </p:nvSpPr>
         <p:spPr>
           <a:xfrm>
-            <a:off x="4994523" y="3686919"/>
+            <a:off x="4994523" y="4009579"/>
             <a:ext cx="151061" cy="151061"/>
           </a:xfrm>
           <a:prstGeom prst="ellipse">
@@ -7079,13 +7364,13 @@
       </p:sp>
       <p:sp>
         <p:nvSpPr>
-          <p:cNvPr id="23" name="Oval 22"/>
+          <p:cNvPr id="25" name="Oval 24"/>
           <p:cNvSpPr/>
           <p:nvPr/>
         </p:nvSpPr>
         <p:spPr>
           <a:xfrm>
-            <a:off x="5126236" y="3686919"/>
+            <a:off x="5126236" y="4009579"/>
             <a:ext cx="151061" cy="151061"/>
           </a:xfrm>
           <a:prstGeom prst="ellipse">
@@ -7122,13 +7407,13 @@
       </p:sp>
       <p:sp>
         <p:nvSpPr>
-          <p:cNvPr id="24" name="Oval 23"/>
+          <p:cNvPr id="26" name="Oval 25"/>
           <p:cNvSpPr/>
           <p:nvPr/>
         </p:nvSpPr>
         <p:spPr>
           <a:xfrm>
-            <a:off x="5257949" y="3686919"/>
+            <a:off x="5257949" y="4009579"/>
             <a:ext cx="151061" cy="151061"/>
           </a:xfrm>
           <a:prstGeom prst="ellipse">
@@ -7165,13 +7450,13 @@
       </p:sp>
       <p:sp>
         <p:nvSpPr>
-          <p:cNvPr id="25" name="Oval 24"/>
+          <p:cNvPr id="27" name="Oval 26"/>
           <p:cNvSpPr/>
           <p:nvPr/>
         </p:nvSpPr>
         <p:spPr>
           <a:xfrm>
-            <a:off x="5389811" y="3686919"/>
+            <a:off x="5389811" y="4009579"/>
             <a:ext cx="151061" cy="151061"/>
           </a:xfrm>
           <a:prstGeom prst="ellipse">
@@ -7208,13 +7493,13 @@
       </p:sp>
       <p:sp>
         <p:nvSpPr>
-          <p:cNvPr id="26" name="TextBox 25"/>
+          <p:cNvPr id="28" name="TextBox 27"/>
           <p:cNvSpPr txBox="1"/>
           <p:nvPr/>
         </p:nvSpPr>
         <p:spPr>
           <a:xfrm>
-            <a:off x="4103787" y="3942457"/>
+            <a:off x="4103787" y="4265116"/>
             <a:ext cx="578882" cy="142875"/>
           </a:xfrm>
           <a:prstGeom prst="rect">
@@ -7247,13 +7532,13 @@
       </p:sp>
       <p:sp>
         <p:nvSpPr>
-          <p:cNvPr id="27" name="TextBox 26"/>
+          <p:cNvPr id="29" name="TextBox 28"/>
           <p:cNvSpPr txBox="1"/>
           <p:nvPr/>
         </p:nvSpPr>
         <p:spPr>
           <a:xfrm>
-            <a:off x="5961757" y="3942457"/>
+            <a:off x="5961757" y="4265116"/>
             <a:ext cx="436031" cy="142875"/>
           </a:xfrm>
           <a:prstGeom prst="rect">
@@ -7286,13 +7571,13 @@
       </p:sp>
       <p:sp>
         <p:nvSpPr>
-          <p:cNvPr id="28" name="Rounded Rectangle 27"/>
+          <p:cNvPr id="30" name="Rounded Rectangle 29"/>
           <p:cNvSpPr/>
           <p:nvPr/>
         </p:nvSpPr>
         <p:spPr>
           <a:xfrm>
-            <a:off x="719882" y="4858345"/>
+            <a:off x="719882" y="5181005"/>
             <a:ext cx="6120110" cy="2527995"/>
           </a:xfrm>
           <a:prstGeom prst="roundRect">
@@ -7301,7 +7586,7 @@
             </a:avLst>
           </a:prstGeom>
           <a:solidFill>
-            <a:srgbClr val="F1F2F9"/>
+            <a:srgbClr val="EEF3F9"/>
           </a:solidFill>
           <a:ln>
             <a:noFill/>
@@ -7329,13 +7614,13 @@
       </p:sp>
       <p:sp>
         <p:nvSpPr>
-          <p:cNvPr id="29" name="Rounded Rectangle 28"/>
+          <p:cNvPr id="31" name="Rounded Rectangle 30"/>
           <p:cNvSpPr/>
           <p:nvPr/>
         </p:nvSpPr>
         <p:spPr>
           <a:xfrm>
-            <a:off x="1043880" y="5182344"/>
+            <a:off x="1043880" y="5505004"/>
             <a:ext cx="359866" cy="359866"/>
           </a:xfrm>
           <a:prstGeom prst="roundRect">
@@ -7372,7 +7657,7 @@
       </p:sp>
       <p:pic>
         <p:nvPicPr>
-          <p:cNvPr id="30" name="Picture 29" descr="svg-2-1.png"/>
+          <p:cNvPr id="32" name="Picture 31" descr="svg-2-1.png"/>
           <p:cNvPicPr>
             <a:picLocks noChangeAspect="1"/>
           </p:cNvPicPr>
@@ -7386,7 +7671,7 @@
         </p:blipFill>
         <p:spPr>
           <a:xfrm>
-            <a:off x="1133773" y="5272236"/>
+            <a:off x="1133773" y="5594896"/>
             <a:ext cx="179933" cy="179933"/>
           </a:xfrm>
           <a:prstGeom prst="rect">
@@ -7396,13 +7681,13 @@
       </p:pic>
       <p:sp>
         <p:nvSpPr>
-          <p:cNvPr id="31" name="TextBox 30"/>
+          <p:cNvPr id="33" name="TextBox 32"/>
           <p:cNvSpPr txBox="1"/>
           <p:nvPr/>
         </p:nvSpPr>
         <p:spPr>
           <a:xfrm>
-            <a:off x="1547664" y="5261223"/>
+            <a:off x="1547664" y="5583882"/>
             <a:ext cx="4066818" cy="200025"/>
           </a:xfrm>
           <a:prstGeom prst="rect">
@@ -7435,13 +7720,13 @@
       </p:sp>
       <p:sp>
         <p:nvSpPr>
-          <p:cNvPr id="32" name="TextBox 31"/>
+          <p:cNvPr id="34" name="TextBox 33"/>
           <p:cNvSpPr txBox="1"/>
           <p:nvPr/>
         </p:nvSpPr>
         <p:spPr>
           <a:xfrm>
-            <a:off x="1043880" y="5669161"/>
+            <a:off x="1043880" y="5991820"/>
             <a:ext cx="4981277" cy="381000"/>
           </a:xfrm>
           <a:prstGeom prst="rect">
@@ -7474,13 +7759,13 @@
       </p:sp>
       <p:sp>
         <p:nvSpPr>
-          <p:cNvPr id="33" name="TextBox 32"/>
+          <p:cNvPr id="35" name="TextBox 34"/>
           <p:cNvSpPr txBox="1"/>
           <p:nvPr/>
         </p:nvSpPr>
         <p:spPr>
           <a:xfrm>
-            <a:off x="1043880" y="6249144"/>
+            <a:off x="1043880" y="6571804"/>
             <a:ext cx="1176123" cy="152400"/>
           </a:xfrm>
           <a:prstGeom prst="rect">
@@ -7513,13 +7798,13 @@
       </p:sp>
       <p:sp>
         <p:nvSpPr>
-          <p:cNvPr id="34" name="Rounded Rectangle 33"/>
+          <p:cNvPr id="36" name="Rounded Rectangle 35"/>
           <p:cNvSpPr/>
           <p:nvPr/>
         </p:nvSpPr>
         <p:spPr>
           <a:xfrm>
-            <a:off x="2411760" y="6271320"/>
+            <a:off x="2411760" y="6593979"/>
             <a:ext cx="3240435" cy="107900"/>
           </a:xfrm>
           <a:prstGeom prst="roundRect">
@@ -7556,13 +7841,13 @@
       </p:sp>
       <p:sp>
         <p:nvSpPr>
-          <p:cNvPr id="35" name="Rounded Rectangle 34"/>
+          <p:cNvPr id="37" name="Rounded Rectangle 36"/>
           <p:cNvSpPr/>
           <p:nvPr/>
         </p:nvSpPr>
         <p:spPr>
           <a:xfrm>
-            <a:off x="2411760" y="6271320"/>
+            <a:off x="2411760" y="6593979"/>
             <a:ext cx="1620143" cy="107900"/>
           </a:xfrm>
           <a:prstGeom prst="roundRect">
@@ -7599,13 +7884,13 @@
       </p:sp>
       <p:sp>
         <p:nvSpPr>
-          <p:cNvPr id="36" name="TextBox 35"/>
+          <p:cNvPr id="38" name="TextBox 37"/>
           <p:cNvSpPr txBox="1"/>
           <p:nvPr/>
         </p:nvSpPr>
         <p:spPr>
           <a:xfrm>
-            <a:off x="5826764" y="6249144"/>
+            <a:off x="5826764" y="6571804"/>
             <a:ext cx="689229" cy="152400"/>
           </a:xfrm>
           <a:prstGeom prst="rect">
@@ -7638,13 +7923,13 @@
       </p:sp>
       <p:sp>
         <p:nvSpPr>
-          <p:cNvPr id="37" name="TextBox 36"/>
+          <p:cNvPr id="39" name="TextBox 38"/>
           <p:cNvSpPr txBox="1"/>
           <p:nvPr/>
         </p:nvSpPr>
         <p:spPr>
           <a:xfrm>
-            <a:off x="1043880" y="6527453"/>
+            <a:off x="1043880" y="6850112"/>
             <a:ext cx="1388983" cy="152400"/>
           </a:xfrm>
           <a:prstGeom prst="rect">
@@ -7677,13 +7962,13 @@
       </p:sp>
       <p:sp>
         <p:nvSpPr>
-          <p:cNvPr id="38" name="Rounded Rectangle 37"/>
+          <p:cNvPr id="40" name="Rounded Rectangle 39"/>
           <p:cNvSpPr/>
           <p:nvPr/>
         </p:nvSpPr>
         <p:spPr>
           <a:xfrm>
-            <a:off x="2411760" y="6549628"/>
+            <a:off x="2411760" y="6872288"/>
             <a:ext cx="3240435" cy="107900"/>
           </a:xfrm>
           <a:prstGeom prst="roundRect">
@@ -7720,13 +8005,13 @@
       </p:sp>
       <p:sp>
         <p:nvSpPr>
-          <p:cNvPr id="39" name="Rounded Rectangle 38"/>
+          <p:cNvPr id="41" name="Rounded Rectangle 40"/>
           <p:cNvSpPr/>
           <p:nvPr/>
         </p:nvSpPr>
         <p:spPr>
           <a:xfrm>
-            <a:off x="2411760" y="6549628"/>
+            <a:off x="2411760" y="6872288"/>
             <a:ext cx="3240435" cy="107900"/>
           </a:xfrm>
           <a:prstGeom prst="roundRect">
@@ -7763,13 +8048,13 @@
       </p:sp>
       <p:sp>
         <p:nvSpPr>
-          <p:cNvPr id="40" name="TextBox 39"/>
+          <p:cNvPr id="42" name="TextBox 41"/>
           <p:cNvSpPr txBox="1"/>
           <p:nvPr/>
         </p:nvSpPr>
         <p:spPr>
           <a:xfrm>
-            <a:off x="5833098" y="6527453"/>
+            <a:off x="5833098" y="6850112"/>
             <a:ext cx="682895" cy="152400"/>
           </a:xfrm>
           <a:prstGeom prst="rect">
@@ -7802,13 +8087,13 @@
       </p:sp>
       <p:sp>
         <p:nvSpPr>
-          <p:cNvPr id="41" name="TextBox 40"/>
+          <p:cNvPr id="43" name="TextBox 42"/>
           <p:cNvSpPr txBox="1"/>
           <p:nvPr/>
         </p:nvSpPr>
         <p:spPr>
           <a:xfrm>
-            <a:off x="1043880" y="6869311"/>
+            <a:off x="1043880" y="7191970"/>
             <a:ext cx="5694021" cy="171450"/>
           </a:xfrm>
           <a:prstGeom prst="rect">
@@ -7841,13 +8126,13 @@
       </p:sp>
       <p:sp>
         <p:nvSpPr>
-          <p:cNvPr id="42" name="Rounded Rectangle 41"/>
+          <p:cNvPr id="44" name="Rounded Rectangle 43"/>
           <p:cNvSpPr/>
           <p:nvPr/>
         </p:nvSpPr>
         <p:spPr>
           <a:xfrm>
-            <a:off x="719882" y="7602289"/>
+            <a:off x="719882" y="7924949"/>
             <a:ext cx="6120110" cy="1553914"/>
           </a:xfrm>
           <a:prstGeom prst="roundRect">
@@ -7884,13 +8169,13 @@
       </p:sp>
       <p:sp>
         <p:nvSpPr>
-          <p:cNvPr id="43" name="Rounded Rectangle 42"/>
+          <p:cNvPr id="45" name="Rounded Rectangle 44"/>
           <p:cNvSpPr/>
           <p:nvPr/>
         </p:nvSpPr>
         <p:spPr>
           <a:xfrm>
-            <a:off x="1053405" y="7935813"/>
+            <a:off x="1053405" y="8258473"/>
             <a:ext cx="359866" cy="359866"/>
           </a:xfrm>
           <a:prstGeom prst="roundRect">
@@ -7927,7 +8212,7 @@
       </p:sp>
       <p:pic>
         <p:nvPicPr>
-          <p:cNvPr id="44" name="Picture 43" descr="svg-2-2.png"/>
+          <p:cNvPr id="46" name="Picture 45" descr="svg-2-2.png"/>
           <p:cNvPicPr>
             <a:picLocks noChangeAspect="1"/>
           </p:cNvPicPr>
@@ -7941,7 +8226,7 @@
         </p:blipFill>
         <p:spPr>
           <a:xfrm>
-            <a:off x="1143298" y="8025705"/>
+            <a:off x="1143298" y="8348365"/>
             <a:ext cx="179933" cy="179933"/>
           </a:xfrm>
           <a:prstGeom prst="rect">
@@ -7951,13 +8236,13 @@
       </p:pic>
       <p:sp>
         <p:nvSpPr>
-          <p:cNvPr id="45" name="TextBox 44"/>
+          <p:cNvPr id="47" name="TextBox 46"/>
           <p:cNvSpPr txBox="1"/>
           <p:nvPr/>
         </p:nvSpPr>
         <p:spPr>
           <a:xfrm>
-            <a:off x="1557189" y="8014692"/>
+            <a:off x="1557189" y="8337352"/>
             <a:ext cx="2374440" cy="200025"/>
           </a:xfrm>
           <a:prstGeom prst="rect">
@@ -7990,13 +8275,13 @@
       </p:sp>
       <p:sp>
         <p:nvSpPr>
-          <p:cNvPr id="46" name="TextBox 45"/>
+          <p:cNvPr id="48" name="TextBox 47"/>
           <p:cNvSpPr txBox="1"/>
           <p:nvPr/>
         </p:nvSpPr>
         <p:spPr>
           <a:xfrm>
-            <a:off x="1053405" y="8422630"/>
+            <a:off x="1053405" y="8745289"/>
             <a:ext cx="4892873" cy="381000"/>
           </a:xfrm>
           <a:prstGeom prst="rect">
@@ -8029,7 +8314,7 @@
       </p:sp>
       <p:pic>
         <p:nvPicPr>
-          <p:cNvPr id="47" name="Picture 46" descr="academica.png"/>
+          <p:cNvPr id="49" name="Picture 48" descr="academica.png"/>
           <p:cNvPicPr>
             <a:picLocks noChangeAspect="1"/>
           </p:cNvPicPr>
@@ -8043,7 +8328,7 @@
         </p:blipFill>
         <p:spPr>
           <a:xfrm>
-            <a:off x="723900" y="10182225"/>
+            <a:off x="742950" y="10182225"/>
             <a:ext cx="784860" cy="152400"/>
           </a:xfrm>
           <a:prstGeom prst="rect">
@@ -8053,7 +8338,7 @@
       </p:pic>
       <p:sp>
         <p:nvSpPr>
-          <p:cNvPr id="48" name="TextBox 47"/>
+          <p:cNvPr id="50" name="TextBox 49"/>
           <p:cNvSpPr txBox="1"/>
           <p:nvPr/>
         </p:nvSpPr>
@@ -8106,101 +8391,17 @@
       <p:grpSpPr/>
       <p:sp>
         <p:nvSpPr>
-          <p:cNvPr id="2" name="TextBox 1"/>
-          <p:cNvSpPr txBox="1"/>
-          <p:nvPr/>
-        </p:nvSpPr>
-        <p:spPr>
-          <a:xfrm>
-            <a:off x="723900" y="892522"/>
-            <a:ext cx="2260425" cy="352425"/>
-          </a:xfrm>
-          <a:prstGeom prst="rect">
-            <a:avLst/>
-          </a:prstGeom>
-          <a:noFill/>
-        </p:spPr>
-        <p:txBody>
-          <a:bodyPr wrap="square" anchor="t" lIns="0" rIns="0" tIns="0" bIns="0">
-            <a:noAutofit/>
-          </a:bodyPr>
-          <a:lstStyle/>
-          <a:p>
-            <a:pPr algn="l">
-              <a:lnSpc>
-                <a:spcPts val="3300"/>
-              </a:lnSpc>
-            </a:pPr>
-            <a:r>
-              <a:rPr sz="3000" b="1">
-                <a:solidFill>
-                  <a:srgbClr val="000326"/>
-                </a:solidFill>
-                <a:latin typeface="League Spartan"/>
-              </a:rPr>
-              <a:t>Accreditatie</a:t>
-            </a:r>
-          </a:p>
-        </p:txBody>
-      </p:sp>
-      <p:sp>
-        <p:nvSpPr>
-          <p:cNvPr id="3" name="Rounded Rectangle 2"/>
+          <p:cNvPr id="2" name="Rectangle 1"/>
           <p:cNvSpPr/>
           <p:nvPr/>
         </p:nvSpPr>
         <p:spPr>
           <a:xfrm>
-            <a:off x="719882" y="1642914"/>
-            <a:ext cx="6120110" cy="3022104"/>
-          </a:xfrm>
-          <a:prstGeom prst="roundRect">
-            <a:avLst>
-              <a:gd name="adj" fmla="val 7147"/>
-            </a:avLst>
-          </a:prstGeom>
-          <a:solidFill>
-            <a:srgbClr val="E3E6F4"/>
-          </a:solidFill>
-          <a:ln>
-            <a:noFill/>
-          </a:ln>
-        </p:spPr>
-        <p:style>
-          <a:lnRef idx="1">
-            <a:schemeClr val="accent1"/>
-          </a:lnRef>
-          <a:fillRef idx="3">
-            <a:schemeClr val="accent1"/>
-          </a:fillRef>
-          <a:effectRef idx="0">
-            <a:schemeClr val="accent1"/>
-          </a:effectRef>
-          <a:fontRef idx="minor">
-            <a:schemeClr val="lt1"/>
-          </a:fontRef>
-        </p:style>
-        <p:txBody>
-          <a:bodyPr rtlCol="0" anchor="ctr"/>
-          <a:lstStyle/>
-          <a:p/>
-        </p:txBody>
-      </p:sp>
-      <p:sp>
-        <p:nvSpPr>
-          <p:cNvPr id="4" name="Rounded Rectangle 3"/>
-          <p:cNvSpPr/>
-          <p:nvPr/>
-        </p:nvSpPr>
-        <p:spPr>
-          <a:xfrm>
-            <a:off x="1043880" y="1966912"/>
-            <a:ext cx="359866" cy="359866"/>
-          </a:xfrm>
-          <a:prstGeom prst="roundRect">
-            <a:avLst>
-              <a:gd name="adj" fmla="val 30011"/>
-            </a:avLst>
+            <a:off x="0" y="0"/>
+            <a:ext cx="7562850" cy="10696575"/>
+          </a:xfrm>
+          <a:prstGeom prst="rect">
+            <a:avLst/>
           </a:prstGeom>
           <a:solidFill>
             <a:srgbClr val="000326"/>
@@ -8229,9 +8430,173 @@
           <a:p/>
         </p:txBody>
       </p:sp>
+      <p:sp>
+        <p:nvSpPr>
+          <p:cNvPr id="3" name="TextBox 2"/>
+          <p:cNvSpPr txBox="1"/>
+          <p:nvPr/>
+        </p:nvSpPr>
+        <p:spPr>
+          <a:xfrm>
+            <a:off x="723900" y="575965"/>
+            <a:ext cx="247507" cy="142875"/>
+          </a:xfrm>
+          <a:prstGeom prst="rect">
+            <a:avLst/>
+          </a:prstGeom>
+          <a:noFill/>
+        </p:spPr>
+        <p:txBody>
+          <a:bodyPr wrap="square" anchor="t" lIns="0" rIns="0" tIns="0" bIns="0">
+            <a:noAutofit/>
+          </a:bodyPr>
+          <a:lstStyle/>
+          <a:p>
+            <a:pPr algn="l">
+              <a:lnSpc>
+                <a:spcPts val="1080"/>
+              </a:lnSpc>
+            </a:pPr>
+            <a:r>
+              <a:rPr sz="900" b="1">
+                <a:solidFill>
+                  <a:srgbClr val="FFFFFF"/>
+                </a:solidFill>
+                <a:latin typeface="Inter"/>
+              </a:rPr>
+              <a:t>04</a:t>
+            </a:r>
+          </a:p>
+        </p:txBody>
+      </p:sp>
+      <p:sp>
+        <p:nvSpPr>
+          <p:cNvPr id="4" name="TextBox 3"/>
+          <p:cNvSpPr txBox="1"/>
+          <p:nvPr/>
+        </p:nvSpPr>
+        <p:spPr>
+          <a:xfrm>
+            <a:off x="723900" y="819299"/>
+            <a:ext cx="2260425" cy="352425"/>
+          </a:xfrm>
+          <a:prstGeom prst="rect">
+            <a:avLst/>
+          </a:prstGeom>
+          <a:noFill/>
+        </p:spPr>
+        <p:txBody>
+          <a:bodyPr wrap="square" anchor="t" lIns="0" rIns="0" tIns="0" bIns="0">
+            <a:noAutofit/>
+          </a:bodyPr>
+          <a:lstStyle/>
+          <a:p>
+            <a:pPr algn="l">
+              <a:lnSpc>
+                <a:spcPts val="3300"/>
+              </a:lnSpc>
+            </a:pPr>
+            <a:r>
+              <a:rPr sz="3000" b="1">
+                <a:solidFill>
+                  <a:srgbClr val="FFFFFF"/>
+                </a:solidFill>
+                <a:latin typeface="League Spartan"/>
+              </a:rPr>
+              <a:t>Accreditatie</a:t>
+            </a:r>
+          </a:p>
+        </p:txBody>
+      </p:sp>
+      <p:sp>
+        <p:nvSpPr>
+          <p:cNvPr id="5" name="Rounded Rectangle 4"/>
+          <p:cNvSpPr/>
+          <p:nvPr/>
+        </p:nvSpPr>
+        <p:spPr>
+          <a:xfrm>
+            <a:off x="719882" y="1795165"/>
+            <a:ext cx="6120110" cy="3022104"/>
+          </a:xfrm>
+          <a:prstGeom prst="roundRect">
+            <a:avLst>
+              <a:gd name="adj" fmla="val 7147"/>
+            </a:avLst>
+          </a:prstGeom>
+          <a:solidFill>
+            <a:srgbClr val="E0EAF0"/>
+          </a:solidFill>
+          <a:ln>
+            <a:noFill/>
+          </a:ln>
+        </p:spPr>
+        <p:style>
+          <a:lnRef idx="1">
+            <a:schemeClr val="accent1"/>
+          </a:lnRef>
+          <a:fillRef idx="3">
+            <a:schemeClr val="accent1"/>
+          </a:fillRef>
+          <a:effectRef idx="0">
+            <a:schemeClr val="accent1"/>
+          </a:effectRef>
+          <a:fontRef idx="minor">
+            <a:schemeClr val="lt1"/>
+          </a:fontRef>
+        </p:style>
+        <p:txBody>
+          <a:bodyPr rtlCol="0" anchor="ctr"/>
+          <a:lstStyle/>
+          <a:p/>
+        </p:txBody>
+      </p:sp>
+      <p:sp>
+        <p:nvSpPr>
+          <p:cNvPr id="6" name="Rounded Rectangle 5"/>
+          <p:cNvSpPr/>
+          <p:nvPr/>
+        </p:nvSpPr>
+        <p:spPr>
+          <a:xfrm>
+            <a:off x="1043880" y="2119164"/>
+            <a:ext cx="359866" cy="359866"/>
+          </a:xfrm>
+          <a:prstGeom prst="roundRect">
+            <a:avLst>
+              <a:gd name="adj" fmla="val 30011"/>
+            </a:avLst>
+          </a:prstGeom>
+          <a:solidFill>
+            <a:srgbClr val="000326"/>
+          </a:solidFill>
+          <a:ln>
+            <a:noFill/>
+          </a:ln>
+        </p:spPr>
+        <p:style>
+          <a:lnRef idx="1">
+            <a:schemeClr val="accent1"/>
+          </a:lnRef>
+          <a:fillRef idx="3">
+            <a:schemeClr val="accent1"/>
+          </a:fillRef>
+          <a:effectRef idx="0">
+            <a:schemeClr val="accent1"/>
+          </a:effectRef>
+          <a:fontRef idx="minor">
+            <a:schemeClr val="lt1"/>
+          </a:fontRef>
+        </p:style>
+        <p:txBody>
+          <a:bodyPr rtlCol="0" anchor="ctr"/>
+          <a:lstStyle/>
+          <a:p/>
+        </p:txBody>
+      </p:sp>
       <p:pic>
         <p:nvPicPr>
-          <p:cNvPr id="5" name="Picture 4" descr="svg-2-0.png"/>
+          <p:cNvPr id="7" name="Picture 6" descr="svg-2-0.png"/>
           <p:cNvPicPr>
             <a:picLocks noChangeAspect="1"/>
           </p:cNvPicPr>
@@ -8245,7 +8610,7 @@
         </p:blipFill>
         <p:spPr>
           <a:xfrm>
-            <a:off x="1133773" y="2056805"/>
+            <a:off x="1133773" y="2209056"/>
             <a:ext cx="179933" cy="179933"/>
           </a:xfrm>
           <a:prstGeom prst="rect">
@@ -8255,13 +8620,13 @@
       </p:pic>
       <p:sp>
         <p:nvSpPr>
-          <p:cNvPr id="6" name="TextBox 5"/>
+          <p:cNvPr id="8" name="TextBox 7"/>
           <p:cNvSpPr txBox="1"/>
           <p:nvPr/>
         </p:nvSpPr>
         <p:spPr>
           <a:xfrm>
-            <a:off x="1547664" y="2045791"/>
+            <a:off x="1547664" y="2198043"/>
             <a:ext cx="3463576" cy="200025"/>
           </a:xfrm>
           <a:prstGeom prst="rect">
@@ -8294,13 +8659,13 @@
       </p:sp>
       <p:sp>
         <p:nvSpPr>
-          <p:cNvPr id="7" name="TextBox 6"/>
+          <p:cNvPr id="9" name="TextBox 8"/>
           <p:cNvSpPr txBox="1"/>
           <p:nvPr/>
         </p:nvSpPr>
         <p:spPr>
           <a:xfrm>
-            <a:off x="1043880" y="2453729"/>
+            <a:off x="1043880" y="2605980"/>
             <a:ext cx="3383732" cy="171450"/>
           </a:xfrm>
           <a:prstGeom prst="rect">
@@ -8333,13 +8698,13 @@
       </p:sp>
       <p:sp>
         <p:nvSpPr>
-          <p:cNvPr id="8" name="Rounded Rectangle 7"/>
+          <p:cNvPr id="10" name="Rounded Rectangle 9"/>
           <p:cNvSpPr/>
           <p:nvPr/>
         </p:nvSpPr>
         <p:spPr>
           <a:xfrm>
-            <a:off x="1043880" y="2860179"/>
+            <a:off x="1043880" y="3012430"/>
             <a:ext cx="5472112" cy="1480840"/>
           </a:xfrm>
           <a:prstGeom prst="roundRect">
@@ -8376,13 +8741,13 @@
       </p:sp>
       <p:sp>
         <p:nvSpPr>
-          <p:cNvPr id="9" name="TextBox 8"/>
+          <p:cNvPr id="11" name="TextBox 10"/>
           <p:cNvSpPr txBox="1"/>
           <p:nvPr/>
         </p:nvSpPr>
         <p:spPr>
           <a:xfrm>
-            <a:off x="1259830" y="3076129"/>
+            <a:off x="1259830" y="3228380"/>
             <a:ext cx="1373481" cy="142875"/>
           </a:xfrm>
           <a:prstGeom prst="rect">
@@ -8415,13 +8780,13 @@
       </p:sp>
       <p:sp>
         <p:nvSpPr>
-          <p:cNvPr id="10" name="TextBox 9"/>
+          <p:cNvPr id="12" name="TextBox 11"/>
           <p:cNvSpPr txBox="1"/>
           <p:nvPr/>
         </p:nvSpPr>
         <p:spPr>
           <a:xfrm>
-            <a:off x="5497264" y="3076129"/>
+            <a:off x="5497264" y="3228380"/>
             <a:ext cx="956262" cy="142875"/>
           </a:xfrm>
           <a:prstGeom prst="rect">
@@ -8454,13 +8819,13 @@
       </p:sp>
       <p:sp>
         <p:nvSpPr>
-          <p:cNvPr id="11" name="TextBox 10"/>
+          <p:cNvPr id="13" name="TextBox 12"/>
           <p:cNvSpPr txBox="1"/>
           <p:nvPr/>
         </p:nvSpPr>
         <p:spPr>
           <a:xfrm>
-            <a:off x="1259830" y="3416052"/>
+            <a:off x="1259830" y="3568303"/>
             <a:ext cx="677894" cy="152400"/>
           </a:xfrm>
           <a:prstGeom prst="rect">
@@ -8493,13 +8858,13 @@
       </p:sp>
       <p:sp>
         <p:nvSpPr>
-          <p:cNvPr id="12" name="Rounded Rectangle 11"/>
+          <p:cNvPr id="14" name="Rounded Rectangle 13"/>
           <p:cNvSpPr/>
           <p:nvPr/>
         </p:nvSpPr>
         <p:spPr>
           <a:xfrm>
-            <a:off x="2627709" y="3438227"/>
+            <a:off x="2627709" y="3590479"/>
             <a:ext cx="2808536" cy="107900"/>
           </a:xfrm>
           <a:prstGeom prst="roundRect">
@@ -8536,13 +8901,13 @@
       </p:sp>
       <p:sp>
         <p:nvSpPr>
-          <p:cNvPr id="13" name="Rounded Rectangle 12"/>
+          <p:cNvPr id="15" name="Rounded Rectangle 14"/>
           <p:cNvSpPr/>
           <p:nvPr/>
         </p:nvSpPr>
         <p:spPr>
           <a:xfrm>
-            <a:off x="2627709" y="3438227"/>
+            <a:off x="2627709" y="3590479"/>
             <a:ext cx="2022128" cy="107900"/>
           </a:xfrm>
           <a:prstGeom prst="roundRect">
@@ -8579,13 +8944,13 @@
       </p:sp>
       <p:sp>
         <p:nvSpPr>
-          <p:cNvPr id="14" name="Rectangle 13"/>
+          <p:cNvPr id="16" name="Rectangle 15"/>
           <p:cNvSpPr/>
           <p:nvPr/>
         </p:nvSpPr>
         <p:spPr>
           <a:xfrm>
-            <a:off x="4621709" y="3384352"/>
+            <a:off x="4621709" y="3536603"/>
             <a:ext cx="17859" cy="215652"/>
           </a:xfrm>
           <a:prstGeom prst="rect">
@@ -8620,13 +8985,13 @@
       </p:sp>
       <p:sp>
         <p:nvSpPr>
-          <p:cNvPr id="15" name="TextBox 14"/>
+          <p:cNvPr id="17" name="TextBox 16"/>
           <p:cNvSpPr txBox="1"/>
           <p:nvPr/>
         </p:nvSpPr>
         <p:spPr>
           <a:xfrm>
-            <a:off x="6044702" y="3416052"/>
+            <a:off x="6044702" y="3568303"/>
             <a:ext cx="255341" cy="152400"/>
           </a:xfrm>
           <a:prstGeom prst="rect">
@@ -8659,13 +9024,13 @@
       </p:sp>
       <p:sp>
         <p:nvSpPr>
-          <p:cNvPr id="16" name="TextBox 15"/>
+          <p:cNvPr id="18" name="TextBox 17"/>
           <p:cNvSpPr txBox="1"/>
           <p:nvPr/>
         </p:nvSpPr>
         <p:spPr>
           <a:xfrm>
-            <a:off x="1259830" y="3694361"/>
+            <a:off x="1259830" y="3846612"/>
             <a:ext cx="672727" cy="152400"/>
           </a:xfrm>
           <a:prstGeom prst="rect">
@@ -8698,13 +9063,13 @@
       </p:sp>
       <p:sp>
         <p:nvSpPr>
-          <p:cNvPr id="17" name="Rounded Rectangle 16"/>
+          <p:cNvPr id="19" name="Rounded Rectangle 18"/>
           <p:cNvSpPr/>
           <p:nvPr/>
         </p:nvSpPr>
         <p:spPr>
           <a:xfrm>
-            <a:off x="2627709" y="3716536"/>
+            <a:off x="2627709" y="3868787"/>
             <a:ext cx="2808536" cy="107900"/>
           </a:xfrm>
           <a:prstGeom prst="roundRect">
@@ -8741,13 +9106,13 @@
       </p:sp>
       <p:sp>
         <p:nvSpPr>
-          <p:cNvPr id="18" name="Rounded Rectangle 17"/>
+          <p:cNvPr id="20" name="Rounded Rectangle 19"/>
           <p:cNvSpPr/>
           <p:nvPr/>
         </p:nvSpPr>
         <p:spPr>
           <a:xfrm>
-            <a:off x="2627709" y="3716536"/>
+            <a:off x="2627709" y="3868787"/>
             <a:ext cx="1965871" cy="107900"/>
           </a:xfrm>
           <a:prstGeom prst="roundRect">
@@ -8784,13 +9149,13 @@
       </p:sp>
       <p:sp>
         <p:nvSpPr>
-          <p:cNvPr id="19" name="Rectangle 18"/>
+          <p:cNvPr id="21" name="Rectangle 20"/>
           <p:cNvSpPr/>
           <p:nvPr/>
         </p:nvSpPr>
         <p:spPr>
           <a:xfrm>
-            <a:off x="4621709" y="3662660"/>
+            <a:off x="4621709" y="3814911"/>
             <a:ext cx="17859" cy="215652"/>
           </a:xfrm>
           <a:prstGeom prst="rect">
@@ -8825,13 +9190,13 @@
       </p:sp>
       <p:sp>
         <p:nvSpPr>
-          <p:cNvPr id="20" name="TextBox 19"/>
+          <p:cNvPr id="22" name="TextBox 21"/>
           <p:cNvSpPr txBox="1"/>
           <p:nvPr/>
         </p:nvSpPr>
         <p:spPr>
           <a:xfrm>
-            <a:off x="6043535" y="3694361"/>
+            <a:off x="6043535" y="3846612"/>
             <a:ext cx="256508" cy="152400"/>
           </a:xfrm>
           <a:prstGeom prst="rect">
@@ -8864,13 +9229,13 @@
       </p:sp>
       <p:sp>
         <p:nvSpPr>
-          <p:cNvPr id="21" name="TextBox 20"/>
+          <p:cNvPr id="23" name="TextBox 22"/>
           <p:cNvSpPr txBox="1"/>
           <p:nvPr/>
         </p:nvSpPr>
         <p:spPr>
           <a:xfrm>
-            <a:off x="1259830" y="3972669"/>
+            <a:off x="1259830" y="4124920"/>
             <a:ext cx="691229" cy="152400"/>
           </a:xfrm>
           <a:prstGeom prst="rect">
@@ -8903,13 +9268,13 @@
       </p:sp>
       <p:sp>
         <p:nvSpPr>
-          <p:cNvPr id="22" name="Rounded Rectangle 21"/>
+          <p:cNvPr id="24" name="Rounded Rectangle 23"/>
           <p:cNvSpPr/>
           <p:nvPr/>
         </p:nvSpPr>
         <p:spPr>
           <a:xfrm>
-            <a:off x="2627709" y="3994845"/>
+            <a:off x="2627709" y="4147096"/>
             <a:ext cx="2808536" cy="107900"/>
           </a:xfrm>
           <a:prstGeom prst="roundRect">
@@ -8946,13 +9311,13 @@
       </p:sp>
       <p:sp>
         <p:nvSpPr>
-          <p:cNvPr id="23" name="Rounded Rectangle 22"/>
+          <p:cNvPr id="25" name="Rounded Rectangle 24"/>
           <p:cNvSpPr/>
           <p:nvPr/>
         </p:nvSpPr>
         <p:spPr>
           <a:xfrm>
-            <a:off x="2627709" y="3994845"/>
+            <a:off x="2627709" y="4147096"/>
             <a:ext cx="1572667" cy="107900"/>
           </a:xfrm>
           <a:prstGeom prst="roundRect">
@@ -8989,13 +9354,13 @@
       </p:sp>
       <p:sp>
         <p:nvSpPr>
-          <p:cNvPr id="24" name="Rectangle 23"/>
+          <p:cNvPr id="26" name="Rectangle 25"/>
           <p:cNvSpPr/>
           <p:nvPr/>
         </p:nvSpPr>
         <p:spPr>
           <a:xfrm>
-            <a:off x="4621709" y="3940969"/>
+            <a:off x="4621709" y="4093220"/>
             <a:ext cx="17859" cy="215652"/>
           </a:xfrm>
           <a:prstGeom prst="rect">
@@ -9030,13 +9395,13 @@
       </p:sp>
       <p:sp>
         <p:nvSpPr>
-          <p:cNvPr id="25" name="TextBox 24"/>
+          <p:cNvPr id="27" name="TextBox 26"/>
           <p:cNvSpPr txBox="1"/>
           <p:nvPr/>
         </p:nvSpPr>
         <p:spPr>
           <a:xfrm>
-            <a:off x="6026866" y="3972669"/>
+            <a:off x="6026866" y="4124920"/>
             <a:ext cx="273177" cy="152400"/>
           </a:xfrm>
           <a:prstGeom prst="rect">
@@ -9069,13 +9434,13 @@
       </p:sp>
       <p:sp>
         <p:nvSpPr>
-          <p:cNvPr id="26" name="Rounded Rectangle 25"/>
+          <p:cNvPr id="28" name="Rounded Rectangle 27"/>
           <p:cNvSpPr/>
           <p:nvPr/>
         </p:nvSpPr>
         <p:spPr>
           <a:xfrm>
-            <a:off x="719882" y="4880967"/>
+            <a:off x="719882" y="5033218"/>
             <a:ext cx="6120110" cy="1755874"/>
           </a:xfrm>
           <a:prstGeom prst="roundRect">
@@ -9084,7 +9449,7 @@
             </a:avLst>
           </a:prstGeom>
           <a:solidFill>
-            <a:srgbClr val="F1F2F9"/>
+            <a:srgbClr val="EFF5F8"/>
           </a:solidFill>
           <a:ln>
             <a:noFill/>
@@ -9112,13 +9477,13 @@
       </p:sp>
       <p:sp>
         <p:nvSpPr>
-          <p:cNvPr id="27" name="Rounded Rectangle 26"/>
+          <p:cNvPr id="29" name="Rounded Rectangle 28"/>
           <p:cNvSpPr/>
           <p:nvPr/>
         </p:nvSpPr>
         <p:spPr>
           <a:xfrm>
-            <a:off x="1043880" y="5204966"/>
+            <a:off x="1043880" y="5357217"/>
             <a:ext cx="359866" cy="359866"/>
           </a:xfrm>
           <a:prstGeom prst="roundRect">
@@ -9155,7 +9520,7 @@
       </p:sp>
       <p:pic>
         <p:nvPicPr>
-          <p:cNvPr id="28" name="Picture 27" descr="svg-3-1.png"/>
+          <p:cNvPr id="30" name="Picture 29" descr="svg-3-1.png"/>
           <p:cNvPicPr>
             <a:picLocks noChangeAspect="1"/>
           </p:cNvPicPr>
@@ -9169,7 +9534,7 @@
         </p:blipFill>
         <p:spPr>
           <a:xfrm>
-            <a:off x="1133773" y="5294858"/>
+            <a:off x="1133773" y="5447109"/>
             <a:ext cx="179933" cy="179933"/>
           </a:xfrm>
           <a:prstGeom prst="rect">
@@ -9179,13 +9544,13 @@
       </p:pic>
       <p:sp>
         <p:nvSpPr>
-          <p:cNvPr id="29" name="TextBox 28"/>
+          <p:cNvPr id="31" name="TextBox 30"/>
           <p:cNvSpPr txBox="1"/>
           <p:nvPr/>
         </p:nvSpPr>
         <p:spPr>
           <a:xfrm>
-            <a:off x="1547664" y="5283845"/>
+            <a:off x="1547664" y="5436096"/>
             <a:ext cx="2431613" cy="200025"/>
           </a:xfrm>
           <a:prstGeom prst="rect">
@@ -9218,13 +9583,13 @@
       </p:sp>
       <p:sp>
         <p:nvSpPr>
-          <p:cNvPr id="30" name="TextBox 29"/>
+          <p:cNvPr id="32" name="TextBox 31"/>
           <p:cNvSpPr txBox="1"/>
           <p:nvPr/>
         </p:nvSpPr>
         <p:spPr>
           <a:xfrm>
-            <a:off x="1043880" y="5691783"/>
+            <a:off x="1043880" y="5844034"/>
             <a:ext cx="2622804" cy="171450"/>
           </a:xfrm>
           <a:prstGeom prst="rect">
@@ -9257,13 +9622,13 @@
       </p:sp>
       <p:sp>
         <p:nvSpPr>
-          <p:cNvPr id="31" name="Rounded Rectangle 30"/>
+          <p:cNvPr id="33" name="Rounded Rectangle 32"/>
           <p:cNvSpPr/>
           <p:nvPr/>
         </p:nvSpPr>
         <p:spPr>
           <a:xfrm>
-            <a:off x="1043880" y="6062216"/>
+            <a:off x="1043880" y="6214467"/>
             <a:ext cx="1164729" cy="250627"/>
           </a:xfrm>
           <a:prstGeom prst="roundRect">
@@ -9300,13 +9665,13 @@
       </p:sp>
       <p:sp>
         <p:nvSpPr>
-          <p:cNvPr id="32" name="TextBox 31"/>
+          <p:cNvPr id="34" name="TextBox 33"/>
           <p:cNvSpPr txBox="1"/>
           <p:nvPr/>
         </p:nvSpPr>
         <p:spPr>
           <a:xfrm>
-            <a:off x="1187797" y="6116092"/>
+            <a:off x="1187797" y="6268343"/>
             <a:ext cx="1039273" cy="142875"/>
           </a:xfrm>
           <a:prstGeom prst="rect">
@@ -9339,13 +9704,13 @@
       </p:sp>
       <p:sp>
         <p:nvSpPr>
-          <p:cNvPr id="33" name="Rounded Rectangle 32"/>
+          <p:cNvPr id="35" name="Rounded Rectangle 34"/>
           <p:cNvSpPr/>
           <p:nvPr/>
         </p:nvSpPr>
         <p:spPr>
           <a:xfrm>
-            <a:off x="719882" y="6852791"/>
+            <a:off x="719882" y="7005042"/>
             <a:ext cx="6120110" cy="1344364"/>
           </a:xfrm>
           <a:prstGeom prst="roundRect">
@@ -9353,10 +9718,12 @@
               <a:gd name="adj" fmla="val 16067"/>
             </a:avLst>
           </a:prstGeom>
-          <a:noFill/>
+          <a:solidFill>
+            <a:srgbClr val="FFFFFF"/>
+          </a:solidFill>
           <a:ln w="9525">
             <a:solidFill>
-              <a:srgbClr val="D6D9EA"/>
+              <a:srgbClr val="FFFFFF"/>
             </a:solidFill>
           </a:ln>
         </p:spPr>
@@ -9382,13 +9749,13 @@
       </p:sp>
       <p:sp>
         <p:nvSpPr>
-          <p:cNvPr id="34" name="Rounded Rectangle 33"/>
+          <p:cNvPr id="36" name="Rounded Rectangle 35"/>
           <p:cNvSpPr/>
           <p:nvPr/>
         </p:nvSpPr>
         <p:spPr>
           <a:xfrm>
-            <a:off x="1053405" y="7186315"/>
+            <a:off x="1053405" y="7338566"/>
             <a:ext cx="359866" cy="359866"/>
           </a:xfrm>
           <a:prstGeom prst="roundRect">
@@ -9425,7 +9792,7 @@
       </p:sp>
       <p:pic>
         <p:nvPicPr>
-          <p:cNvPr id="35" name="Picture 34" descr="svg-3-2.png"/>
+          <p:cNvPr id="37" name="Picture 36" descr="svg-3-2.png"/>
           <p:cNvPicPr>
             <a:picLocks noChangeAspect="1"/>
           </p:cNvPicPr>
@@ -9439,7 +9806,7 @@
         </p:blipFill>
         <p:spPr>
           <a:xfrm>
-            <a:off x="1143298" y="7276207"/>
+            <a:off x="1143298" y="7428458"/>
             <a:ext cx="179933" cy="179933"/>
           </a:xfrm>
           <a:prstGeom prst="rect">
@@ -9449,13 +9816,13 @@
       </p:pic>
       <p:sp>
         <p:nvSpPr>
-          <p:cNvPr id="36" name="TextBox 35"/>
+          <p:cNvPr id="38" name="TextBox 37"/>
           <p:cNvSpPr txBox="1"/>
           <p:nvPr/>
         </p:nvSpPr>
         <p:spPr>
           <a:xfrm>
-            <a:off x="1557189" y="7265194"/>
+            <a:off x="1557189" y="7417445"/>
             <a:ext cx="4148828" cy="200025"/>
           </a:xfrm>
           <a:prstGeom prst="rect">
@@ -9488,13 +9855,13 @@
       </p:sp>
       <p:sp>
         <p:nvSpPr>
-          <p:cNvPr id="37" name="TextBox 36"/>
+          <p:cNvPr id="39" name="TextBox 38"/>
           <p:cNvSpPr txBox="1"/>
           <p:nvPr/>
         </p:nvSpPr>
         <p:spPr>
           <a:xfrm>
-            <a:off x="1053405" y="7673132"/>
+            <a:off x="1053405" y="7825383"/>
             <a:ext cx="2697980" cy="171450"/>
           </a:xfrm>
           <a:prstGeom prst="rect">
@@ -9527,13 +9894,13 @@
       </p:sp>
       <p:sp>
         <p:nvSpPr>
-          <p:cNvPr id="38" name="Rectangle 37"/>
+          <p:cNvPr id="40" name="Rectangle 39"/>
           <p:cNvSpPr/>
           <p:nvPr/>
         </p:nvSpPr>
         <p:spPr>
           <a:xfrm>
-            <a:off x="719882" y="8557022"/>
+            <a:off x="719882" y="8709273"/>
             <a:ext cx="19050" cy="649635"/>
           </a:xfrm>
           <a:prstGeom prst="rect">
@@ -9568,13 +9935,13 @@
       </p:sp>
       <p:sp>
         <p:nvSpPr>
-          <p:cNvPr id="39" name="TextBox 38"/>
+          <p:cNvPr id="41" name="TextBox 40"/>
           <p:cNvSpPr txBox="1"/>
           <p:nvPr/>
         </p:nvSpPr>
         <p:spPr>
           <a:xfrm>
-            <a:off x="918865" y="8576072"/>
+            <a:off x="918865" y="8728323"/>
             <a:ext cx="5753695" cy="604540"/>
           </a:xfrm>
           <a:prstGeom prst="rect">
@@ -9596,7 +9963,7 @@
             <a:r>
               <a:rPr sz="1100" b="0">
                 <a:solidFill>
-                  <a:srgbClr val="000326"/>
+                  <a:srgbClr val="FFFFFF"/>
                 </a:solidFill>
                 <a:latin typeface="Inter"/>
               </a:rPr>
@@ -9605,9 +9972,54 @@
           </a:p>
         </p:txBody>
       </p:sp>
+      <p:sp>
+        <p:nvSpPr>
+          <p:cNvPr id="42" name="Rounded Rectangle 41"/>
+          <p:cNvSpPr/>
+          <p:nvPr/>
+        </p:nvSpPr>
+        <p:spPr>
+          <a:xfrm>
+            <a:off x="666750" y="10125075"/>
+            <a:ext cx="904875" cy="266700"/>
+          </a:xfrm>
+          <a:prstGeom prst="roundRect">
+            <a:avLst>
+              <a:gd name="adj" fmla="val 30000"/>
+            </a:avLst>
+          </a:prstGeom>
+          <a:solidFill>
+            <a:srgbClr val="FFFFFF"/>
+          </a:solidFill>
+          <a:ln>
+            <a:noFill/>
+          </a:ln>
+        </p:spPr>
+        <p:style>
+          <a:lnRef idx="1">
+            <a:schemeClr val="accent1"/>
+          </a:lnRef>
+          <a:fillRef idx="3">
+            <a:schemeClr val="accent1"/>
+          </a:fillRef>
+          <a:effectRef idx="0">
+            <a:schemeClr val="accent1"/>
+          </a:effectRef>
+          <a:fontRef idx="minor">
+            <a:schemeClr val="lt1"/>
+          </a:fontRef>
+        </p:style>
+        <p:txBody>
+          <a:bodyPr rtlCol="0" anchor="ctr"/>
+          <a:lstStyle/>
+          <a:p>
+            <a:pPr algn="ctr"/>
+          </a:p>
+        </p:txBody>
+      </p:sp>
       <p:pic>
         <p:nvPicPr>
-          <p:cNvPr id="40" name="Picture 39" descr="academica.png"/>
+          <p:cNvPr id="43" name="Picture 42" descr="academica.png"/>
           <p:cNvPicPr>
             <a:picLocks noChangeAspect="1"/>
           </p:cNvPicPr>
@@ -9621,7 +10033,7 @@
         </p:blipFill>
         <p:spPr>
           <a:xfrm>
-            <a:off x="723900" y="10182225"/>
+            <a:off x="742950" y="10182225"/>
             <a:ext cx="784860" cy="152400"/>
           </a:xfrm>
           <a:prstGeom prst="rect">
@@ -9631,7 +10043,7 @@
       </p:pic>
       <p:sp>
         <p:nvSpPr>
-          <p:cNvPr id="41" name="TextBox 40"/>
+          <p:cNvPr id="44" name="TextBox 43"/>
           <p:cNvSpPr txBox="1"/>
           <p:nvPr/>
         </p:nvSpPr>
@@ -9655,7 +10067,7 @@
             <a:r>
               <a:rPr sz="800">
                 <a:solidFill>
-                  <a:srgbClr val="555A78"/>
+                  <a:srgbClr val="B3B5C6"/>
                 </a:solidFill>
                 <a:latin typeface="Inter"/>
               </a:rPr>
@@ -9684,13 +10096,93 @@
       <p:grpSpPr/>
       <p:sp>
         <p:nvSpPr>
-          <p:cNvPr id="2" name="TextBox 1"/>
+          <p:cNvPr id="2" name="Rectangle 1"/>
+          <p:cNvSpPr/>
+          <p:nvPr/>
+        </p:nvSpPr>
+        <p:spPr>
+          <a:xfrm>
+            <a:off x="0" y="0"/>
+            <a:ext cx="7559873" cy="1605707"/>
+          </a:xfrm>
+          <a:prstGeom prst="rect">
+            <a:avLst/>
+          </a:prstGeom>
+          <a:solidFill>
+            <a:srgbClr val="000326"/>
+          </a:solidFill>
+          <a:ln>
+            <a:noFill/>
+          </a:ln>
+        </p:spPr>
+        <p:style>
+          <a:lnRef idx="1">
+            <a:schemeClr val="accent1"/>
+          </a:lnRef>
+          <a:fillRef idx="3">
+            <a:schemeClr val="accent1"/>
+          </a:fillRef>
+          <a:effectRef idx="0">
+            <a:schemeClr val="accent1"/>
+          </a:effectRef>
+          <a:fontRef idx="minor">
+            <a:schemeClr val="lt1"/>
+          </a:fontRef>
+        </p:style>
+        <p:txBody>
+          <a:bodyPr rtlCol="0" anchor="ctr"/>
+          <a:lstStyle/>
+          <a:p/>
+        </p:txBody>
+      </p:sp>
+      <p:sp>
+        <p:nvSpPr>
+          <p:cNvPr id="3" name="TextBox 2"/>
           <p:cNvSpPr txBox="1"/>
           <p:nvPr/>
         </p:nvSpPr>
         <p:spPr>
           <a:xfrm>
-            <a:off x="723900" y="892522"/>
+            <a:off x="723900" y="575965"/>
+            <a:ext cx="240506" cy="142875"/>
+          </a:xfrm>
+          <a:prstGeom prst="rect">
+            <a:avLst/>
+          </a:prstGeom>
+          <a:noFill/>
+        </p:spPr>
+        <p:txBody>
+          <a:bodyPr wrap="square" anchor="t" lIns="0" rIns="0" tIns="0" bIns="0">
+            <a:noAutofit/>
+          </a:bodyPr>
+          <a:lstStyle/>
+          <a:p>
+            <a:pPr algn="l">
+              <a:lnSpc>
+                <a:spcPts val="1080"/>
+              </a:lnSpc>
+            </a:pPr>
+            <a:r>
+              <a:rPr sz="900" b="1">
+                <a:solidFill>
+                  <a:srgbClr val="FFFFFF"/>
+                </a:solidFill>
+                <a:latin typeface="Inter"/>
+              </a:rPr>
+              <a:t>05</a:t>
+            </a:r>
+          </a:p>
+        </p:txBody>
+      </p:sp>
+      <p:sp>
+        <p:nvSpPr>
+          <p:cNvPr id="4" name="TextBox 3"/>
+          <p:cNvSpPr txBox="1"/>
+          <p:nvPr/>
+        </p:nvSpPr>
+        <p:spPr>
+          <a:xfrm>
+            <a:off x="723900" y="819299"/>
             <a:ext cx="1860042" cy="352425"/>
           </a:xfrm>
           <a:prstGeom prst="rect">
@@ -9712,7 +10204,7 @@
             <a:r>
               <a:rPr sz="3000" b="1">
                 <a:solidFill>
-                  <a:srgbClr val="000326"/>
+                  <a:srgbClr val="FFFFFF"/>
                 </a:solidFill>
                 <a:latin typeface="League Spartan"/>
               </a:rPr>
@@ -9723,13 +10215,13 @@
       </p:sp>
       <p:sp>
         <p:nvSpPr>
-          <p:cNvPr id="3" name="TextBox 2"/>
+          <p:cNvPr id="5" name="TextBox 4"/>
           <p:cNvSpPr txBox="1"/>
           <p:nvPr/>
         </p:nvSpPr>
         <p:spPr>
           <a:xfrm>
-            <a:off x="723900" y="1661964"/>
+            <a:off x="723900" y="1984623"/>
             <a:ext cx="5916216" cy="662880"/>
           </a:xfrm>
           <a:prstGeom prst="rect">
@@ -9762,13 +10254,13 @@
       </p:sp>
       <p:sp>
         <p:nvSpPr>
-          <p:cNvPr id="4" name="Rounded Rectangle 3"/>
+          <p:cNvPr id="6" name="Rounded Rectangle 5"/>
           <p:cNvSpPr/>
           <p:nvPr/>
         </p:nvSpPr>
         <p:spPr>
           <a:xfrm>
-            <a:off x="719882" y="2711351"/>
+            <a:off x="719882" y="3034010"/>
             <a:ext cx="6120110" cy="3712815"/>
           </a:xfrm>
           <a:prstGeom prst="roundRect">
@@ -9777,7 +10269,7 @@
             </a:avLst>
           </a:prstGeom>
           <a:solidFill>
-            <a:srgbClr val="E3E6F4"/>
+            <a:srgbClr val="DDE4F7"/>
           </a:solidFill>
           <a:ln>
             <a:noFill/>
@@ -9805,13 +10297,13 @@
       </p:sp>
       <p:sp>
         <p:nvSpPr>
-          <p:cNvPr id="5" name="TextBox 4"/>
+          <p:cNvPr id="7" name="TextBox 6"/>
           <p:cNvSpPr txBox="1"/>
           <p:nvPr/>
         </p:nvSpPr>
         <p:spPr>
           <a:xfrm>
-            <a:off x="1043880" y="3035350"/>
+            <a:off x="1043880" y="3358009"/>
             <a:ext cx="1837372" cy="142875"/>
           </a:xfrm>
           <a:prstGeom prst="rect">
@@ -9844,13 +10336,13 @@
       </p:sp>
       <p:sp>
         <p:nvSpPr>
-          <p:cNvPr id="6" name="TextBox 5"/>
+          <p:cNvPr id="8" name="TextBox 7"/>
           <p:cNvSpPr txBox="1"/>
           <p:nvPr/>
         </p:nvSpPr>
         <p:spPr>
           <a:xfrm>
-            <a:off x="1043880" y="3278684"/>
+            <a:off x="1043880" y="3601343"/>
             <a:ext cx="1083278" cy="200025"/>
           </a:xfrm>
           <a:prstGeom prst="rect">
@@ -9883,13 +10375,13 @@
       </p:sp>
       <p:sp>
         <p:nvSpPr>
-          <p:cNvPr id="7" name="Rounded Rectangle 6"/>
+          <p:cNvPr id="9" name="Rounded Rectangle 8"/>
           <p:cNvSpPr/>
           <p:nvPr/>
         </p:nvSpPr>
         <p:spPr>
           <a:xfrm>
-            <a:off x="1043880" y="3653135"/>
+            <a:off x="1043880" y="3975795"/>
             <a:ext cx="5472112" cy="719733"/>
           </a:xfrm>
           <a:prstGeom prst="roundRect">
@@ -9926,13 +10418,13 @@
       </p:sp>
       <p:sp>
         <p:nvSpPr>
-          <p:cNvPr id="8" name="Rounded Rectangle 7"/>
+          <p:cNvPr id="10" name="Rounded Rectangle 9"/>
           <p:cNvSpPr/>
           <p:nvPr/>
         </p:nvSpPr>
         <p:spPr>
           <a:xfrm>
-            <a:off x="1223814" y="3833068"/>
+            <a:off x="1223814" y="4155728"/>
             <a:ext cx="359866" cy="359866"/>
           </a:xfrm>
           <a:prstGeom prst="roundRect">
@@ -9969,7 +10461,7 @@
       </p:sp>
       <p:pic>
         <p:nvPicPr>
-          <p:cNvPr id="9" name="Picture 8" descr="svg-4-0.png"/>
+          <p:cNvPr id="11" name="Picture 10" descr="svg-4-0.png"/>
           <p:cNvPicPr>
             <a:picLocks noChangeAspect="1"/>
           </p:cNvPicPr>
@@ -9983,7 +10475,7 @@
         </p:blipFill>
         <p:spPr>
           <a:xfrm>
-            <a:off x="1313706" y="3922961"/>
+            <a:off x="1313706" y="4245620"/>
             <a:ext cx="179933" cy="179933"/>
           </a:xfrm>
           <a:prstGeom prst="rect">
@@ -9993,13 +10485,13 @@
       </p:pic>
       <p:sp>
         <p:nvSpPr>
-          <p:cNvPr id="10" name="TextBox 9"/>
+          <p:cNvPr id="12" name="TextBox 11"/>
           <p:cNvSpPr txBox="1"/>
           <p:nvPr/>
         </p:nvSpPr>
         <p:spPr>
           <a:xfrm>
-            <a:off x="1727597" y="3912096"/>
+            <a:off x="1727597" y="4234755"/>
             <a:ext cx="1734693" cy="190500"/>
           </a:xfrm>
           <a:prstGeom prst="rect">
@@ -10032,13 +10524,13 @@
       </p:sp>
       <p:sp>
         <p:nvSpPr>
-          <p:cNvPr id="11" name="Rounded Rectangle 10"/>
+          <p:cNvPr id="13" name="Rounded Rectangle 12"/>
           <p:cNvSpPr/>
           <p:nvPr/>
         </p:nvSpPr>
         <p:spPr>
           <a:xfrm>
-            <a:off x="1043880" y="4516785"/>
+            <a:off x="1043880" y="4839444"/>
             <a:ext cx="5472112" cy="719733"/>
           </a:xfrm>
           <a:prstGeom prst="roundRect">
@@ -10075,13 +10567,13 @@
       </p:sp>
       <p:sp>
         <p:nvSpPr>
-          <p:cNvPr id="12" name="Rounded Rectangle 11"/>
+          <p:cNvPr id="14" name="Rounded Rectangle 13"/>
           <p:cNvSpPr/>
           <p:nvPr/>
         </p:nvSpPr>
         <p:spPr>
           <a:xfrm>
-            <a:off x="1223814" y="4696718"/>
+            <a:off x="1223814" y="5019377"/>
             <a:ext cx="359866" cy="359866"/>
           </a:xfrm>
           <a:prstGeom prst="roundRect">
@@ -10118,7 +10610,7 @@
       </p:sp>
       <p:pic>
         <p:nvPicPr>
-          <p:cNvPr id="13" name="Picture 12" descr="svg-4-1.png"/>
+          <p:cNvPr id="15" name="Picture 14" descr="svg-4-1.png"/>
           <p:cNvPicPr>
             <a:picLocks noChangeAspect="1"/>
           </p:cNvPicPr>
@@ -10132,7 +10624,7 @@
         </p:blipFill>
         <p:spPr>
           <a:xfrm>
-            <a:off x="1313706" y="4786610"/>
+            <a:off x="1313706" y="5109270"/>
             <a:ext cx="179933" cy="179933"/>
           </a:xfrm>
           <a:prstGeom prst="rect">
@@ -10142,13 +10634,13 @@
       </p:pic>
       <p:sp>
         <p:nvSpPr>
-          <p:cNvPr id="14" name="TextBox 13"/>
+          <p:cNvPr id="16" name="TextBox 15"/>
           <p:cNvSpPr txBox="1"/>
           <p:nvPr/>
         </p:nvSpPr>
         <p:spPr>
           <a:xfrm>
-            <a:off x="1727597" y="4775746"/>
+            <a:off x="1727597" y="5098405"/>
             <a:ext cx="1505831" cy="190500"/>
           </a:xfrm>
           <a:prstGeom prst="rect">
@@ -10181,13 +10673,13 @@
       </p:sp>
       <p:sp>
         <p:nvSpPr>
-          <p:cNvPr id="15" name="Rounded Rectangle 14"/>
+          <p:cNvPr id="17" name="Rounded Rectangle 16"/>
           <p:cNvSpPr/>
           <p:nvPr/>
         </p:nvSpPr>
         <p:spPr>
           <a:xfrm>
-            <a:off x="1043880" y="5380434"/>
+            <a:off x="1043880" y="5703094"/>
             <a:ext cx="5472112" cy="719733"/>
           </a:xfrm>
           <a:prstGeom prst="roundRect">
@@ -10224,13 +10716,13 @@
       </p:sp>
       <p:sp>
         <p:nvSpPr>
-          <p:cNvPr id="16" name="Rounded Rectangle 15"/>
+          <p:cNvPr id="18" name="Rounded Rectangle 17"/>
           <p:cNvSpPr/>
           <p:nvPr/>
         </p:nvSpPr>
         <p:spPr>
           <a:xfrm>
-            <a:off x="1223814" y="5560368"/>
+            <a:off x="1223814" y="5883027"/>
             <a:ext cx="359866" cy="359866"/>
           </a:xfrm>
           <a:prstGeom prst="roundRect">
@@ -10267,7 +10759,7 @@
       </p:sp>
       <p:pic>
         <p:nvPicPr>
-          <p:cNvPr id="17" name="Picture 16" descr="svg-4-2.png"/>
+          <p:cNvPr id="19" name="Picture 18" descr="svg-4-2.png"/>
           <p:cNvPicPr>
             <a:picLocks noChangeAspect="1"/>
           </p:cNvPicPr>
@@ -10281,7 +10773,7 @@
         </p:blipFill>
         <p:spPr>
           <a:xfrm>
-            <a:off x="1313706" y="5650260"/>
+            <a:off x="1313706" y="5972919"/>
             <a:ext cx="179933" cy="179933"/>
           </a:xfrm>
           <a:prstGeom prst="rect">
@@ -10291,13 +10783,13 @@
       </p:pic>
       <p:sp>
         <p:nvSpPr>
-          <p:cNvPr id="18" name="TextBox 17"/>
+          <p:cNvPr id="20" name="TextBox 19"/>
           <p:cNvSpPr txBox="1"/>
           <p:nvPr/>
         </p:nvSpPr>
         <p:spPr>
           <a:xfrm>
-            <a:off x="1727597" y="5639395"/>
+            <a:off x="1727597" y="5962055"/>
             <a:ext cx="1215962" cy="190500"/>
           </a:xfrm>
           <a:prstGeom prst="rect">
@@ -10330,7 +10822,7 @@
       </p:sp>
       <p:pic>
         <p:nvPicPr>
-          <p:cNvPr id="19" name="Picture 18" descr="academica.png"/>
+          <p:cNvPr id="21" name="Picture 20" descr="academica.png"/>
           <p:cNvPicPr>
             <a:picLocks noChangeAspect="1"/>
           </p:cNvPicPr>
@@ -10344,7 +10836,7 @@
         </p:blipFill>
         <p:spPr>
           <a:xfrm>
-            <a:off x="723900" y="10182225"/>
+            <a:off x="742950" y="10182225"/>
             <a:ext cx="784860" cy="152400"/>
           </a:xfrm>
           <a:prstGeom prst="rect">
@@ -10354,7 +10846,7 @@
       </p:pic>
       <p:sp>
         <p:nvSpPr>
-          <p:cNvPr id="20" name="TextBox 19"/>
+          <p:cNvPr id="22" name="TextBox 21"/>
           <p:cNvSpPr txBox="1"/>
           <p:nvPr/>
         </p:nvSpPr>
@@ -10407,101 +10899,17 @@
       <p:grpSpPr/>
       <p:sp>
         <p:nvSpPr>
-          <p:cNvPr id="2" name="TextBox 1"/>
-          <p:cNvSpPr txBox="1"/>
-          <p:nvPr/>
-        </p:nvSpPr>
-        <p:spPr>
-          <a:xfrm>
-            <a:off x="723900" y="892522"/>
-            <a:ext cx="1411486" cy="352425"/>
-          </a:xfrm>
-          <a:prstGeom prst="rect">
-            <a:avLst/>
-          </a:prstGeom>
-          <a:noFill/>
-        </p:spPr>
-        <p:txBody>
-          <a:bodyPr wrap="square" anchor="t" lIns="0" rIns="0" tIns="0" bIns="0">
-            <a:noAutofit/>
-          </a:bodyPr>
-          <a:lstStyle/>
-          <a:p>
-            <a:pPr algn="l">
-              <a:lnSpc>
-                <a:spcPts val="3300"/>
-              </a:lnSpc>
-            </a:pPr>
-            <a:r>
-              <a:rPr sz="3000" b="1">
-                <a:solidFill>
-                  <a:srgbClr val="000326"/>
-                </a:solidFill>
-                <a:latin typeface="League Spartan"/>
-              </a:rPr>
-              <a:t>Privacy</a:t>
-            </a:r>
-          </a:p>
-        </p:txBody>
-      </p:sp>
-      <p:sp>
-        <p:nvSpPr>
-          <p:cNvPr id="3" name="Rounded Rectangle 2"/>
+          <p:cNvPr id="2" name="Rectangle 1"/>
           <p:cNvSpPr/>
           <p:nvPr/>
         </p:nvSpPr>
         <p:spPr>
           <a:xfrm>
-            <a:off x="719882" y="1642914"/>
-            <a:ext cx="6120110" cy="1166217"/>
-          </a:xfrm>
-          <a:prstGeom prst="roundRect">
-            <a:avLst>
-              <a:gd name="adj" fmla="val 18521"/>
-            </a:avLst>
-          </a:prstGeom>
-          <a:solidFill>
-            <a:srgbClr val="E3E6F4"/>
-          </a:solidFill>
-          <a:ln>
-            <a:noFill/>
-          </a:ln>
-        </p:spPr>
-        <p:style>
-          <a:lnRef idx="1">
-            <a:schemeClr val="accent1"/>
-          </a:lnRef>
-          <a:fillRef idx="3">
-            <a:schemeClr val="accent1"/>
-          </a:fillRef>
-          <a:effectRef idx="0">
-            <a:schemeClr val="accent1"/>
-          </a:effectRef>
-          <a:fontRef idx="minor">
-            <a:schemeClr val="lt1"/>
-          </a:fontRef>
-        </p:style>
-        <p:txBody>
-          <a:bodyPr rtlCol="0" anchor="ctr"/>
-          <a:lstStyle/>
-          <a:p/>
-        </p:txBody>
-      </p:sp>
-      <p:sp>
-        <p:nvSpPr>
-          <p:cNvPr id="4" name="Rounded Rectangle 3"/>
-          <p:cNvSpPr/>
-          <p:nvPr/>
-        </p:nvSpPr>
-        <p:spPr>
-          <a:xfrm>
-            <a:off x="1043880" y="2046089"/>
-            <a:ext cx="359866" cy="359866"/>
-          </a:xfrm>
-          <a:prstGeom prst="roundRect">
-            <a:avLst>
-              <a:gd name="adj" fmla="val 30011"/>
-            </a:avLst>
+            <a:off x="0" y="0"/>
+            <a:ext cx="7562850" cy="10696575"/>
+          </a:xfrm>
+          <a:prstGeom prst="rect">
+            <a:avLst/>
           </a:prstGeom>
           <a:solidFill>
             <a:srgbClr val="000326"/>
@@ -10530,9 +10938,173 @@
           <a:p/>
         </p:txBody>
       </p:sp>
+      <p:sp>
+        <p:nvSpPr>
+          <p:cNvPr id="3" name="TextBox 2"/>
+          <p:cNvSpPr txBox="1"/>
+          <p:nvPr/>
+        </p:nvSpPr>
+        <p:spPr>
+          <a:xfrm>
+            <a:off x="723900" y="575965"/>
+            <a:ext cx="244007" cy="142875"/>
+          </a:xfrm>
+          <a:prstGeom prst="rect">
+            <a:avLst/>
+          </a:prstGeom>
+          <a:noFill/>
+        </p:spPr>
+        <p:txBody>
+          <a:bodyPr wrap="square" anchor="t" lIns="0" rIns="0" tIns="0" bIns="0">
+            <a:noAutofit/>
+          </a:bodyPr>
+          <a:lstStyle/>
+          <a:p>
+            <a:pPr algn="l">
+              <a:lnSpc>
+                <a:spcPts val="1080"/>
+              </a:lnSpc>
+            </a:pPr>
+            <a:r>
+              <a:rPr sz="900" b="1">
+                <a:solidFill>
+                  <a:srgbClr val="FFFFFF"/>
+                </a:solidFill>
+                <a:latin typeface="Inter"/>
+              </a:rPr>
+              <a:t>06</a:t>
+            </a:r>
+          </a:p>
+        </p:txBody>
+      </p:sp>
+      <p:sp>
+        <p:nvSpPr>
+          <p:cNvPr id="4" name="TextBox 3"/>
+          <p:cNvSpPr txBox="1"/>
+          <p:nvPr/>
+        </p:nvSpPr>
+        <p:spPr>
+          <a:xfrm>
+            <a:off x="723900" y="819299"/>
+            <a:ext cx="1411486" cy="352425"/>
+          </a:xfrm>
+          <a:prstGeom prst="rect">
+            <a:avLst/>
+          </a:prstGeom>
+          <a:noFill/>
+        </p:spPr>
+        <p:txBody>
+          <a:bodyPr wrap="square" anchor="t" lIns="0" rIns="0" tIns="0" bIns="0">
+            <a:noAutofit/>
+          </a:bodyPr>
+          <a:lstStyle/>
+          <a:p>
+            <a:pPr algn="l">
+              <a:lnSpc>
+                <a:spcPts val="3300"/>
+              </a:lnSpc>
+            </a:pPr>
+            <a:r>
+              <a:rPr sz="3000" b="1">
+                <a:solidFill>
+                  <a:srgbClr val="FFFFFF"/>
+                </a:solidFill>
+                <a:latin typeface="League Spartan"/>
+              </a:rPr>
+              <a:t>Privacy</a:t>
+            </a:r>
+          </a:p>
+        </p:txBody>
+      </p:sp>
+      <p:sp>
+        <p:nvSpPr>
+          <p:cNvPr id="5" name="Rounded Rectangle 4"/>
+          <p:cNvSpPr/>
+          <p:nvPr/>
+        </p:nvSpPr>
+        <p:spPr>
+          <a:xfrm>
+            <a:off x="719882" y="1795165"/>
+            <a:ext cx="6120110" cy="1166217"/>
+          </a:xfrm>
+          <a:prstGeom prst="roundRect">
+            <a:avLst>
+              <a:gd name="adj" fmla="val 18521"/>
+            </a:avLst>
+          </a:prstGeom>
+          <a:solidFill>
+            <a:srgbClr val="E6E8EE"/>
+          </a:solidFill>
+          <a:ln>
+            <a:noFill/>
+          </a:ln>
+        </p:spPr>
+        <p:style>
+          <a:lnRef idx="1">
+            <a:schemeClr val="accent1"/>
+          </a:lnRef>
+          <a:fillRef idx="3">
+            <a:schemeClr val="accent1"/>
+          </a:fillRef>
+          <a:effectRef idx="0">
+            <a:schemeClr val="accent1"/>
+          </a:effectRef>
+          <a:fontRef idx="minor">
+            <a:schemeClr val="lt1"/>
+          </a:fontRef>
+        </p:style>
+        <p:txBody>
+          <a:bodyPr rtlCol="0" anchor="ctr"/>
+          <a:lstStyle/>
+          <a:p/>
+        </p:txBody>
+      </p:sp>
+      <p:sp>
+        <p:nvSpPr>
+          <p:cNvPr id="6" name="Rounded Rectangle 5"/>
+          <p:cNvSpPr/>
+          <p:nvPr/>
+        </p:nvSpPr>
+        <p:spPr>
+          <a:xfrm>
+            <a:off x="1043880" y="2198340"/>
+            <a:ext cx="359866" cy="359866"/>
+          </a:xfrm>
+          <a:prstGeom prst="roundRect">
+            <a:avLst>
+              <a:gd name="adj" fmla="val 30011"/>
+            </a:avLst>
+          </a:prstGeom>
+          <a:solidFill>
+            <a:srgbClr val="000326"/>
+          </a:solidFill>
+          <a:ln>
+            <a:noFill/>
+          </a:ln>
+        </p:spPr>
+        <p:style>
+          <a:lnRef idx="1">
+            <a:schemeClr val="accent1"/>
+          </a:lnRef>
+          <a:fillRef idx="3">
+            <a:schemeClr val="accent1"/>
+          </a:fillRef>
+          <a:effectRef idx="0">
+            <a:schemeClr val="accent1"/>
+          </a:effectRef>
+          <a:fontRef idx="minor">
+            <a:schemeClr val="lt1"/>
+          </a:fontRef>
+        </p:style>
+        <p:txBody>
+          <a:bodyPr rtlCol="0" anchor="ctr"/>
+          <a:lstStyle/>
+          <a:p/>
+        </p:txBody>
+      </p:sp>
       <p:pic>
         <p:nvPicPr>
-          <p:cNvPr id="5" name="Picture 4" descr="svg-5-0.png"/>
+          <p:cNvPr id="7" name="Picture 6" descr="svg-5-0.png"/>
           <p:cNvPicPr>
             <a:picLocks noChangeAspect="1"/>
           </p:cNvPicPr>
@@ -10546,7 +11118,7 @@
         </p:blipFill>
         <p:spPr>
           <a:xfrm>
-            <a:off x="1133773" y="2135981"/>
+            <a:off x="1133773" y="2288232"/>
             <a:ext cx="179933" cy="179933"/>
           </a:xfrm>
           <a:prstGeom prst="rect">
@@ -10556,13 +11128,13 @@
       </p:pic>
       <p:sp>
         <p:nvSpPr>
-          <p:cNvPr id="6" name="TextBox 5"/>
+          <p:cNvPr id="8" name="TextBox 7"/>
           <p:cNvSpPr txBox="1"/>
           <p:nvPr/>
         </p:nvSpPr>
         <p:spPr>
           <a:xfrm>
-            <a:off x="1547664" y="1995488"/>
+            <a:off x="1547664" y="2147739"/>
             <a:ext cx="4792563" cy="459135"/>
           </a:xfrm>
           <a:prstGeom prst="rect">
@@ -10595,13 +11167,13 @@
       </p:sp>
       <p:sp>
         <p:nvSpPr>
-          <p:cNvPr id="7" name="Rounded Rectangle 6"/>
+          <p:cNvPr id="9" name="Rounded Rectangle 8"/>
           <p:cNvSpPr/>
           <p:nvPr/>
         </p:nvSpPr>
         <p:spPr>
           <a:xfrm>
-            <a:off x="719882" y="3025080"/>
+            <a:off x="719882" y="3177332"/>
             <a:ext cx="6120110" cy="2138065"/>
           </a:xfrm>
           <a:prstGeom prst="roundRect">
@@ -10609,10 +11181,12 @@
               <a:gd name="adj" fmla="val 10102"/>
             </a:avLst>
           </a:prstGeom>
-          <a:noFill/>
+          <a:solidFill>
+            <a:srgbClr val="FFFFFF"/>
+          </a:solidFill>
           <a:ln w="9525">
             <a:solidFill>
-              <a:srgbClr val="D6D9EA"/>
+              <a:srgbClr val="FFFFFF"/>
             </a:solidFill>
           </a:ln>
         </p:spPr>
@@ -10638,13 +11212,13 @@
       </p:sp>
       <p:sp>
         <p:nvSpPr>
-          <p:cNvPr id="8" name="Rounded Rectangle 7"/>
+          <p:cNvPr id="10" name="Rounded Rectangle 9"/>
           <p:cNvSpPr/>
           <p:nvPr/>
         </p:nvSpPr>
         <p:spPr>
           <a:xfrm>
-            <a:off x="1053405" y="3358604"/>
+            <a:off x="1053405" y="3510855"/>
             <a:ext cx="359866" cy="359866"/>
           </a:xfrm>
           <a:prstGeom prst="roundRect">
@@ -10681,7 +11255,7 @@
       </p:sp>
       <p:pic>
         <p:nvPicPr>
-          <p:cNvPr id="9" name="Picture 8" descr="svg-5-1.png"/>
+          <p:cNvPr id="11" name="Picture 10" descr="svg-5-1.png"/>
           <p:cNvPicPr>
             <a:picLocks noChangeAspect="1"/>
           </p:cNvPicPr>
@@ -10695,7 +11269,7 @@
         </p:blipFill>
         <p:spPr>
           <a:xfrm>
-            <a:off x="1143298" y="3448496"/>
+            <a:off x="1143298" y="3600748"/>
             <a:ext cx="179933" cy="179933"/>
           </a:xfrm>
           <a:prstGeom prst="rect">
@@ -10705,13 +11279,13 @@
       </p:pic>
       <p:sp>
         <p:nvSpPr>
-          <p:cNvPr id="10" name="TextBox 9"/>
+          <p:cNvPr id="12" name="TextBox 11"/>
           <p:cNvSpPr txBox="1"/>
           <p:nvPr/>
         </p:nvSpPr>
         <p:spPr>
           <a:xfrm>
-            <a:off x="1557189" y="3437483"/>
+            <a:off x="1557189" y="3589734"/>
             <a:ext cx="2204418" cy="200025"/>
           </a:xfrm>
           <a:prstGeom prst="rect">
@@ -10744,7 +11318,7 @@
       </p:sp>
       <p:pic>
         <p:nvPicPr>
-          <p:cNvPr id="11" name="Picture 10" descr="svg-5-2.png"/>
+          <p:cNvPr id="13" name="Picture 12" descr="svg-5-2.png"/>
           <p:cNvPicPr>
             <a:picLocks noChangeAspect="1"/>
           </p:cNvPicPr>
@@ -10758,7 +11332,7 @@
         </p:blipFill>
         <p:spPr>
           <a:xfrm>
-            <a:off x="1053405" y="3966567"/>
+            <a:off x="1053405" y="4118818"/>
             <a:ext cx="179933" cy="179933"/>
           </a:xfrm>
           <a:prstGeom prst="rect">
@@ -10768,13 +11342,13 @@
       </p:pic>
       <p:sp>
         <p:nvSpPr>
-          <p:cNvPr id="12" name="TextBox 11"/>
+          <p:cNvPr id="14" name="TextBox 13"/>
           <p:cNvSpPr txBox="1"/>
           <p:nvPr/>
         </p:nvSpPr>
         <p:spPr>
           <a:xfrm>
-            <a:off x="1359247" y="3961805"/>
+            <a:off x="1359247" y="4114056"/>
             <a:ext cx="4713732" cy="171450"/>
           </a:xfrm>
           <a:prstGeom prst="rect">
@@ -10807,7 +11381,7 @@
       </p:sp>
       <p:pic>
         <p:nvPicPr>
-          <p:cNvPr id="13" name="Picture 12" descr="svg-5-3.png"/>
+          <p:cNvPr id="15" name="Picture 14" descr="svg-5-3.png"/>
           <p:cNvPicPr>
             <a:picLocks noChangeAspect="1"/>
           </p:cNvPicPr>
@@ -10821,7 +11395,7 @@
         </p:blipFill>
         <p:spPr>
           <a:xfrm>
-            <a:off x="1053405" y="4348907"/>
+            <a:off x="1053405" y="4501158"/>
             <a:ext cx="179933" cy="179933"/>
           </a:xfrm>
           <a:prstGeom prst="rect">
@@ -10831,13 +11405,13 @@
       </p:pic>
       <p:sp>
         <p:nvSpPr>
-          <p:cNvPr id="14" name="TextBox 13"/>
+          <p:cNvPr id="16" name="TextBox 15"/>
           <p:cNvSpPr txBox="1"/>
           <p:nvPr/>
         </p:nvSpPr>
         <p:spPr>
           <a:xfrm>
-            <a:off x="1359247" y="4344144"/>
+            <a:off x="1359247" y="4496395"/>
             <a:ext cx="4700290" cy="374005"/>
           </a:xfrm>
           <a:prstGeom prst="rect">
@@ -10870,13 +11444,13 @@
       </p:sp>
       <p:sp>
         <p:nvSpPr>
-          <p:cNvPr id="15" name="Rounded Rectangle 14"/>
+          <p:cNvPr id="17" name="Rounded Rectangle 16"/>
           <p:cNvSpPr/>
           <p:nvPr/>
         </p:nvSpPr>
         <p:spPr>
           <a:xfrm>
-            <a:off x="719882" y="5379095"/>
+            <a:off x="719882" y="5531346"/>
             <a:ext cx="6120110" cy="1935510"/>
           </a:xfrm>
           <a:prstGeom prst="roundRect">
@@ -10884,10 +11458,12 @@
               <a:gd name="adj" fmla="val 11159"/>
             </a:avLst>
           </a:prstGeom>
-          <a:noFill/>
+          <a:solidFill>
+            <a:srgbClr val="FFFFFF"/>
+          </a:solidFill>
           <a:ln w="9525">
             <a:solidFill>
-              <a:srgbClr val="D6D9EA"/>
+              <a:srgbClr val="FFFFFF"/>
             </a:solidFill>
           </a:ln>
         </p:spPr>
@@ -10913,13 +11489,13 @@
       </p:sp>
       <p:sp>
         <p:nvSpPr>
-          <p:cNvPr id="16" name="Rounded Rectangle 15"/>
+          <p:cNvPr id="18" name="Rounded Rectangle 17"/>
           <p:cNvSpPr/>
           <p:nvPr/>
         </p:nvSpPr>
         <p:spPr>
           <a:xfrm>
-            <a:off x="1053405" y="5712619"/>
+            <a:off x="1053405" y="5864870"/>
             <a:ext cx="359866" cy="359866"/>
           </a:xfrm>
           <a:prstGeom prst="roundRect">
@@ -10956,7 +11532,7 @@
       </p:sp>
       <p:pic>
         <p:nvPicPr>
-          <p:cNvPr id="17" name="Picture 16" descr="svg-5-4.png"/>
+          <p:cNvPr id="19" name="Picture 18" descr="svg-5-4.png"/>
           <p:cNvPicPr>
             <a:picLocks noChangeAspect="1"/>
           </p:cNvPicPr>
@@ -10970,7 +11546,7 @@
         </p:blipFill>
         <p:spPr>
           <a:xfrm>
-            <a:off x="1143298" y="5802511"/>
+            <a:off x="1143298" y="5954762"/>
             <a:ext cx="179933" cy="179933"/>
           </a:xfrm>
           <a:prstGeom prst="rect">
@@ -10980,13 +11556,13 @@
       </p:pic>
       <p:sp>
         <p:nvSpPr>
-          <p:cNvPr id="18" name="TextBox 17"/>
+          <p:cNvPr id="20" name="TextBox 19"/>
           <p:cNvSpPr txBox="1"/>
           <p:nvPr/>
         </p:nvSpPr>
         <p:spPr>
           <a:xfrm>
-            <a:off x="1557189" y="5791498"/>
+            <a:off x="1557189" y="5943749"/>
             <a:ext cx="2089904" cy="200025"/>
           </a:xfrm>
           <a:prstGeom prst="rect">
@@ -11019,7 +11595,7 @@
       </p:sp>
       <p:pic>
         <p:nvPicPr>
-          <p:cNvPr id="19" name="Picture 18" descr="svg-5-3.png"/>
+          <p:cNvPr id="21" name="Picture 20" descr="svg-5-3.png"/>
           <p:cNvPicPr>
             <a:picLocks noChangeAspect="1"/>
           </p:cNvPicPr>
@@ -11033,7 +11609,7 @@
         </p:blipFill>
         <p:spPr>
           <a:xfrm>
-            <a:off x="1053405" y="6320582"/>
+            <a:off x="1053405" y="6472833"/>
             <a:ext cx="179933" cy="179933"/>
           </a:xfrm>
           <a:prstGeom prst="rect">
@@ -11043,13 +11619,13 @@
       </p:pic>
       <p:sp>
         <p:nvSpPr>
-          <p:cNvPr id="20" name="TextBox 19"/>
+          <p:cNvPr id="22" name="TextBox 21"/>
           <p:cNvSpPr txBox="1"/>
           <p:nvPr/>
         </p:nvSpPr>
         <p:spPr>
           <a:xfrm>
-            <a:off x="1359247" y="6315819"/>
+            <a:off x="1359247" y="6468070"/>
             <a:ext cx="4346519" cy="171450"/>
           </a:xfrm>
           <a:prstGeom prst="rect">
@@ -11082,7 +11658,7 @@
       </p:sp>
       <p:pic>
         <p:nvPicPr>
-          <p:cNvPr id="21" name="Picture 20" descr="svg-5-3.png"/>
+          <p:cNvPr id="23" name="Picture 22" descr="svg-5-3.png"/>
           <p:cNvPicPr>
             <a:picLocks noChangeAspect="1"/>
           </p:cNvPicPr>
@@ -11096,7 +11672,7 @@
         </p:blipFill>
         <p:spPr>
           <a:xfrm>
-            <a:off x="1053405" y="6702921"/>
+            <a:off x="1053405" y="6855172"/>
             <a:ext cx="179933" cy="179933"/>
           </a:xfrm>
           <a:prstGeom prst="rect">
@@ -11106,13 +11682,13 @@
       </p:pic>
       <p:sp>
         <p:nvSpPr>
-          <p:cNvPr id="22" name="TextBox 21"/>
+          <p:cNvPr id="24" name="TextBox 23"/>
           <p:cNvSpPr txBox="1"/>
           <p:nvPr/>
         </p:nvSpPr>
         <p:spPr>
           <a:xfrm>
-            <a:off x="1359247" y="6698159"/>
+            <a:off x="1359247" y="6850410"/>
             <a:ext cx="4116824" cy="171450"/>
           </a:xfrm>
           <a:prstGeom prst="rect">
@@ -11145,13 +11721,13 @@
       </p:sp>
       <p:sp>
         <p:nvSpPr>
-          <p:cNvPr id="23" name="Rounded Rectangle 22"/>
+          <p:cNvPr id="25" name="Rounded Rectangle 24"/>
           <p:cNvSpPr/>
           <p:nvPr/>
         </p:nvSpPr>
         <p:spPr>
           <a:xfrm>
-            <a:off x="719882" y="7530554"/>
+            <a:off x="719882" y="7682805"/>
             <a:ext cx="6120110" cy="2317849"/>
           </a:xfrm>
           <a:prstGeom prst="roundRect">
@@ -11159,10 +11735,12 @@
               <a:gd name="adj" fmla="val 9318"/>
             </a:avLst>
           </a:prstGeom>
-          <a:noFill/>
+          <a:solidFill>
+            <a:srgbClr val="FFFFFF"/>
+          </a:solidFill>
           <a:ln w="9525">
             <a:solidFill>
-              <a:srgbClr val="D6D9EA"/>
+              <a:srgbClr val="FFFFFF"/>
             </a:solidFill>
           </a:ln>
         </p:spPr>
@@ -11188,13 +11766,13 @@
       </p:sp>
       <p:sp>
         <p:nvSpPr>
-          <p:cNvPr id="24" name="Rounded Rectangle 23"/>
+          <p:cNvPr id="26" name="Rounded Rectangle 25"/>
           <p:cNvSpPr/>
           <p:nvPr/>
         </p:nvSpPr>
         <p:spPr>
           <a:xfrm>
-            <a:off x="1053405" y="7864078"/>
+            <a:off x="1053405" y="8016329"/>
             <a:ext cx="359866" cy="359866"/>
           </a:xfrm>
           <a:prstGeom prst="roundRect">
@@ -11231,7 +11809,7 @@
       </p:sp>
       <p:pic>
         <p:nvPicPr>
-          <p:cNvPr id="25" name="Picture 24" descr="svg-5-7.png"/>
+          <p:cNvPr id="27" name="Picture 26" descr="svg-5-7.png"/>
           <p:cNvPicPr>
             <a:picLocks noChangeAspect="1"/>
           </p:cNvPicPr>
@@ -11245,7 +11823,7 @@
         </p:blipFill>
         <p:spPr>
           <a:xfrm>
-            <a:off x="1143298" y="7953970"/>
+            <a:off x="1143298" y="8106221"/>
             <a:ext cx="179933" cy="179933"/>
           </a:xfrm>
           <a:prstGeom prst="rect">
@@ -11255,13 +11833,13 @@
       </p:pic>
       <p:sp>
         <p:nvSpPr>
-          <p:cNvPr id="26" name="TextBox 25"/>
+          <p:cNvPr id="28" name="TextBox 27"/>
           <p:cNvSpPr txBox="1"/>
           <p:nvPr/>
         </p:nvSpPr>
         <p:spPr>
           <a:xfrm>
-            <a:off x="1557189" y="7942957"/>
+            <a:off x="1557189" y="8095208"/>
             <a:ext cx="1364980" cy="200025"/>
           </a:xfrm>
           <a:prstGeom prst="rect">
@@ -11294,21 +11872,21 @@
       </p:sp>
       <p:pic>
         <p:nvPicPr>
-          <p:cNvPr id="27" name="Picture 26" descr="svg-5-2.png"/>
+          <p:cNvPr id="29" name="Picture 28" descr="svg-5-8.png"/>
           <p:cNvPicPr>
             <a:picLocks noChangeAspect="1"/>
           </p:cNvPicPr>
           <p:nvPr/>
         </p:nvPicPr>
         <p:blipFill>
-          <a:blip r:embed="rId4"/>
+          <a:blip r:embed="rId8"/>
           <a:stretch>
             <a:fillRect/>
           </a:stretch>
         </p:blipFill>
         <p:spPr>
           <a:xfrm>
-            <a:off x="1053405" y="8472041"/>
+            <a:off x="1053405" y="8624292"/>
             <a:ext cx="179933" cy="179933"/>
           </a:xfrm>
           <a:prstGeom prst="rect">
@@ -11318,13 +11896,13 @@
       </p:pic>
       <p:sp>
         <p:nvSpPr>
-          <p:cNvPr id="28" name="TextBox 27"/>
+          <p:cNvPr id="30" name="TextBox 29"/>
           <p:cNvSpPr txBox="1"/>
           <p:nvPr/>
         </p:nvSpPr>
         <p:spPr>
           <a:xfrm>
-            <a:off x="1359247" y="8467279"/>
+            <a:off x="1359247" y="8619530"/>
             <a:ext cx="4994434" cy="171450"/>
           </a:xfrm>
           <a:prstGeom prst="rect">
@@ -11357,7 +11935,70 @@
       </p:sp>
       <p:pic>
         <p:nvPicPr>
-          <p:cNvPr id="29" name="Picture 28" descr="svg-5-3.png"/>
+          <p:cNvPr id="31" name="Picture 30" descr="svg-5-9.png"/>
+          <p:cNvPicPr>
+            <a:picLocks noChangeAspect="1"/>
+          </p:cNvPicPr>
+          <p:nvPr/>
+        </p:nvPicPr>
+        <p:blipFill>
+          <a:blip r:embed="rId9"/>
+          <a:stretch>
+            <a:fillRect/>
+          </a:stretch>
+        </p:blipFill>
+        <p:spPr>
+          <a:xfrm>
+            <a:off x="1053405" y="9006632"/>
+            <a:ext cx="179933" cy="179933"/>
+          </a:xfrm>
+          <a:prstGeom prst="rect">
+            <a:avLst/>
+          </a:prstGeom>
+        </p:spPr>
+      </p:pic>
+      <p:sp>
+        <p:nvSpPr>
+          <p:cNvPr id="32" name="TextBox 31"/>
+          <p:cNvSpPr txBox="1"/>
+          <p:nvPr/>
+        </p:nvSpPr>
+        <p:spPr>
+          <a:xfrm>
+            <a:off x="1359247" y="9001869"/>
+            <a:ext cx="3896963" cy="171450"/>
+          </a:xfrm>
+          <a:prstGeom prst="rect">
+            <a:avLst/>
+          </a:prstGeom>
+          <a:noFill/>
+        </p:spPr>
+        <p:txBody>
+          <a:bodyPr wrap="square" anchor="t" lIns="0" rIns="0" tIns="0" bIns="0">
+            <a:noAutofit/>
+          </a:bodyPr>
+          <a:lstStyle/>
+          <a:p>
+            <a:pPr algn="l">
+              <a:lnSpc>
+                <a:spcPts val="1595"/>
+              </a:lnSpc>
+            </a:pPr>
+            <a:r>
+              <a:rPr sz="1100" b="0">
+                <a:solidFill>
+                  <a:srgbClr val="000326"/>
+                </a:solidFill>
+                <a:latin typeface="Inter"/>
+              </a:rPr>
+              <a:t>AI Act: audit trail voor elke summatieve beoordeling.</a:t>
+            </a:r>
+          </a:p>
+        </p:txBody>
+      </p:sp>
+      <p:pic>
+        <p:nvPicPr>
+          <p:cNvPr id="33" name="Picture 32" descr="svg-5-3.png"/>
           <p:cNvPicPr>
             <a:picLocks noChangeAspect="1"/>
           </p:cNvPicPr>
@@ -11371,7 +12012,7 @@
         </p:blipFill>
         <p:spPr>
           <a:xfrm>
-            <a:off x="1053405" y="8854380"/>
+            <a:off x="1053405" y="9388971"/>
             <a:ext cx="179933" cy="179933"/>
           </a:xfrm>
           <a:prstGeom prst="rect">
@@ -11381,76 +12022,13 @@
       </p:pic>
       <p:sp>
         <p:nvSpPr>
-          <p:cNvPr id="30" name="TextBox 29"/>
+          <p:cNvPr id="34" name="TextBox 33"/>
           <p:cNvSpPr txBox="1"/>
           <p:nvPr/>
         </p:nvSpPr>
         <p:spPr>
           <a:xfrm>
-            <a:off x="1359247" y="8849618"/>
-            <a:ext cx="3896963" cy="171450"/>
-          </a:xfrm>
-          <a:prstGeom prst="rect">
-            <a:avLst/>
-          </a:prstGeom>
-          <a:noFill/>
-        </p:spPr>
-        <p:txBody>
-          <a:bodyPr wrap="square" anchor="t" lIns="0" rIns="0" tIns="0" bIns="0">
-            <a:noAutofit/>
-          </a:bodyPr>
-          <a:lstStyle/>
-          <a:p>
-            <a:pPr algn="l">
-              <a:lnSpc>
-                <a:spcPts val="1595"/>
-              </a:lnSpc>
-            </a:pPr>
-            <a:r>
-              <a:rPr sz="1100" b="0">
-                <a:solidFill>
-                  <a:srgbClr val="000326"/>
-                </a:solidFill>
-                <a:latin typeface="Inter"/>
-              </a:rPr>
-              <a:t>AI Act: audit trail voor elke summatieve beoordeling.</a:t>
-            </a:r>
-          </a:p>
-        </p:txBody>
-      </p:sp>
-      <p:pic>
-        <p:nvPicPr>
-          <p:cNvPr id="31" name="Picture 30" descr="svg-5-3.png"/>
-          <p:cNvPicPr>
-            <a:picLocks noChangeAspect="1"/>
-          </p:cNvPicPr>
-          <p:nvPr/>
-        </p:nvPicPr>
-        <p:blipFill>
-          <a:blip r:embed="rId5"/>
-          <a:stretch>
-            <a:fillRect/>
-          </a:stretch>
-        </p:blipFill>
-        <p:spPr>
-          <a:xfrm>
-            <a:off x="1053405" y="9236720"/>
-            <a:ext cx="179933" cy="179933"/>
-          </a:xfrm>
-          <a:prstGeom prst="rect">
-            <a:avLst/>
-          </a:prstGeom>
-        </p:spPr>
-      </p:pic>
-      <p:sp>
-        <p:nvSpPr>
-          <p:cNvPr id="32" name="TextBox 31"/>
-          <p:cNvSpPr txBox="1"/>
-          <p:nvPr/>
-        </p:nvSpPr>
-        <p:spPr>
-          <a:xfrm>
-            <a:off x="1359247" y="9231957"/>
+            <a:off x="1359247" y="9384209"/>
             <a:ext cx="2617970" cy="171450"/>
           </a:xfrm>
           <a:prstGeom prst="rect">
@@ -11481,23 +12059,68 @@
           </a:p>
         </p:txBody>
       </p:sp>
+      <p:sp>
+        <p:nvSpPr>
+          <p:cNvPr id="35" name="Rounded Rectangle 34"/>
+          <p:cNvSpPr/>
+          <p:nvPr/>
+        </p:nvSpPr>
+        <p:spPr>
+          <a:xfrm>
+            <a:off x="666750" y="10125075"/>
+            <a:ext cx="904875" cy="266700"/>
+          </a:xfrm>
+          <a:prstGeom prst="roundRect">
+            <a:avLst>
+              <a:gd name="adj" fmla="val 30000"/>
+            </a:avLst>
+          </a:prstGeom>
+          <a:solidFill>
+            <a:srgbClr val="FFFFFF"/>
+          </a:solidFill>
+          <a:ln>
+            <a:noFill/>
+          </a:ln>
+        </p:spPr>
+        <p:style>
+          <a:lnRef idx="1">
+            <a:schemeClr val="accent1"/>
+          </a:lnRef>
+          <a:fillRef idx="3">
+            <a:schemeClr val="accent1"/>
+          </a:fillRef>
+          <a:effectRef idx="0">
+            <a:schemeClr val="accent1"/>
+          </a:effectRef>
+          <a:fontRef idx="minor">
+            <a:schemeClr val="lt1"/>
+          </a:fontRef>
+        </p:style>
+        <p:txBody>
+          <a:bodyPr rtlCol="0" anchor="ctr"/>
+          <a:lstStyle/>
+          <a:p>
+            <a:pPr algn="ctr"/>
+          </a:p>
+        </p:txBody>
+      </p:sp>
       <p:pic>
         <p:nvPicPr>
-          <p:cNvPr id="33" name="Picture 32" descr="academica.png"/>
+          <p:cNvPr id="36" name="Picture 35" descr="academica.png"/>
           <p:cNvPicPr>
             <a:picLocks noChangeAspect="1"/>
           </p:cNvPicPr>
           <p:nvPr/>
         </p:nvPicPr>
         <p:blipFill>
-          <a:blip r:embed="rId8"/>
+          <a:blip r:embed="rId10"/>
           <a:stretch>
             <a:fillRect/>
           </a:stretch>
         </p:blipFill>
         <p:spPr>
           <a:xfrm>
-            <a:off x="723900" y="10182225"/>
+            <a:off x="742950" y="10182225"/>
             <a:ext cx="784860" cy="152400"/>
           </a:xfrm>
           <a:prstGeom prst="rect">
@@ -11507,7 +12130,7 @@
       </p:pic>
       <p:sp>
         <p:nvSpPr>
-          <p:cNvPr id="34" name="TextBox 33"/>
+          <p:cNvPr id="37" name="TextBox 36"/>
           <p:cNvSpPr txBox="1"/>
           <p:nvPr/>
         </p:nvSpPr>
@@ -11531,7 +12154,7 @@
             <a:r>
               <a:rPr sz="800">
                 <a:solidFill>
-                  <a:srgbClr val="555A78"/>
+                  <a:srgbClr val="B3B5C6"/>
                 </a:solidFill>
                 <a:latin typeface="Inter"/>
               </a:rPr>

</xml_diff>

<commit_message>
Document: geen kopbalk op witte pagina's
Co-Authored-By: Claude Opus 5.5 <noreply@anthropic.com>
Claude-Session: https://claude.ai/code/session_011t24oNqE5E2i7wh7JuX2xs
</commit_message>
<xml_diff>
--- a/Design/Concepts/document/eduface-document-bewerkbaar.pptx
+++ b/Design/Concepts/document/eduface-document-bewerkbaar.pptx
@@ -3095,48 +3095,7 @@
       <p:grpSpPr/>
       <p:sp>
         <p:nvSpPr>
-          <p:cNvPr id="2" name="Rectangle 1"/>
-          <p:cNvSpPr/>
-          <p:nvPr/>
-        </p:nvSpPr>
-        <p:spPr>
-          <a:xfrm>
-            <a:off x="0" y="0"/>
-            <a:ext cx="7559873" cy="1605707"/>
-          </a:xfrm>
-          <a:prstGeom prst="rect">
-            <a:avLst/>
-          </a:prstGeom>
-          <a:solidFill>
-            <a:srgbClr val="000326"/>
-          </a:solidFill>
-          <a:ln>
-            <a:noFill/>
-          </a:ln>
-        </p:spPr>
-        <p:style>
-          <a:lnRef idx="1">
-            <a:schemeClr val="accent1"/>
-          </a:lnRef>
-          <a:fillRef idx="3">
-            <a:schemeClr val="accent1"/>
-          </a:fillRef>
-          <a:effectRef idx="0">
-            <a:schemeClr val="accent1"/>
-          </a:effectRef>
-          <a:fontRef idx="minor">
-            <a:schemeClr val="lt1"/>
-          </a:fontRef>
-        </p:style>
-        <p:txBody>
-          <a:bodyPr rtlCol="0" anchor="ctr"/>
-          <a:lstStyle/>
-          <a:p/>
-        </p:txBody>
-      </p:sp>
-      <p:sp>
-        <p:nvSpPr>
-          <p:cNvPr id="3" name="TextBox 2"/>
+          <p:cNvPr id="2" name="TextBox 1"/>
           <p:cNvSpPr txBox="1"/>
           <p:nvPr/>
         </p:nvSpPr>
@@ -3164,7 +3123,7 @@
             <a:r>
               <a:rPr sz="900" b="1">
                 <a:solidFill>
-                  <a:srgbClr val="FFFFFF"/>
+                  <a:srgbClr val="555A78"/>
                 </a:solidFill>
                 <a:latin typeface="Inter"/>
               </a:rPr>
@@ -3175,7 +3134,7 @@
       </p:sp>
       <p:sp>
         <p:nvSpPr>
-          <p:cNvPr id="4" name="TextBox 3"/>
+          <p:cNvPr id="3" name="TextBox 2"/>
           <p:cNvSpPr txBox="1"/>
           <p:nvPr/>
         </p:nvSpPr>
@@ -3203,7 +3162,7 @@
             <a:r>
               <a:rPr sz="3000" b="1">
                 <a:solidFill>
-                  <a:srgbClr val="FFFFFF"/>
+                  <a:srgbClr val="000326"/>
                 </a:solidFill>
                 <a:latin typeface="League Spartan"/>
               </a:rPr>
@@ -3214,13 +3173,13 @@
       </p:sp>
       <p:sp>
         <p:nvSpPr>
-          <p:cNvPr id="5" name="TextBox 4"/>
+          <p:cNvPr id="4" name="TextBox 3"/>
           <p:cNvSpPr txBox="1"/>
           <p:nvPr/>
         </p:nvSpPr>
         <p:spPr>
           <a:xfrm>
-            <a:off x="723900" y="1984623"/>
+            <a:off x="723900" y="1814215"/>
             <a:ext cx="6087814" cy="1135261"/>
           </a:xfrm>
           <a:prstGeom prst="rect">
@@ -3253,13 +3212,13 @@
       </p:sp>
       <p:sp>
         <p:nvSpPr>
-          <p:cNvPr id="6" name="Rectangle 5"/>
+          <p:cNvPr id="5" name="Rectangle 4"/>
           <p:cNvSpPr/>
           <p:nvPr/>
         </p:nvSpPr>
         <p:spPr>
           <a:xfrm>
-            <a:off x="719882" y="3434507"/>
+            <a:off x="719882" y="3264098"/>
             <a:ext cx="28575" cy="269825"/>
           </a:xfrm>
           <a:prstGeom prst="rect">
@@ -3294,13 +3253,13 @@
       </p:sp>
       <p:sp>
         <p:nvSpPr>
-          <p:cNvPr id="7" name="TextBox 6"/>
+          <p:cNvPr id="6" name="TextBox 5"/>
           <p:cNvSpPr txBox="1"/>
           <p:nvPr/>
         </p:nvSpPr>
         <p:spPr>
           <a:xfrm>
-            <a:off x="928390" y="3463082"/>
+            <a:off x="928390" y="3292673"/>
             <a:ext cx="5910560" cy="200025"/>
           </a:xfrm>
           <a:prstGeom prst="rect">
@@ -3333,13 +3292,13 @@
       </p:sp>
       <p:sp>
         <p:nvSpPr>
-          <p:cNvPr id="8" name="Rounded Rectangle 7"/>
+          <p:cNvPr id="7" name="Rounded Rectangle 6"/>
           <p:cNvSpPr/>
           <p:nvPr/>
         </p:nvSpPr>
         <p:spPr>
           <a:xfrm>
-            <a:off x="719882" y="4064198"/>
+            <a:off x="719882" y="3893790"/>
             <a:ext cx="2952006" cy="2296567"/>
           </a:xfrm>
           <a:prstGeom prst="roundRect">
@@ -3376,13 +3335,13 @@
       </p:sp>
       <p:sp>
         <p:nvSpPr>
-          <p:cNvPr id="9" name="TextBox 8"/>
+          <p:cNvPr id="8" name="TextBox 7"/>
           <p:cNvSpPr txBox="1"/>
           <p:nvPr/>
         </p:nvSpPr>
         <p:spPr>
           <a:xfrm>
-            <a:off x="1053405" y="4397722"/>
+            <a:off x="1053405" y="4227314"/>
             <a:ext cx="269176" cy="142875"/>
           </a:xfrm>
           <a:prstGeom prst="rect">
@@ -3415,13 +3374,13 @@
       </p:sp>
       <p:sp>
         <p:nvSpPr>
-          <p:cNvPr id="10" name="TextBox 9"/>
+          <p:cNvPr id="9" name="TextBox 8"/>
           <p:cNvSpPr txBox="1"/>
           <p:nvPr/>
         </p:nvSpPr>
         <p:spPr>
           <a:xfrm>
-            <a:off x="1053405" y="4658023"/>
+            <a:off x="1053405" y="4487614"/>
             <a:ext cx="2107740" cy="428625"/>
           </a:xfrm>
           <a:prstGeom prst="rect">
@@ -3454,13 +3413,13 @@
       </p:sp>
       <p:sp>
         <p:nvSpPr>
-          <p:cNvPr id="11" name="TextBox 10"/>
+          <p:cNvPr id="10" name="TextBox 9"/>
           <p:cNvSpPr txBox="1"/>
           <p:nvPr/>
         </p:nvSpPr>
         <p:spPr>
           <a:xfrm>
-            <a:off x="1053405" y="5232648"/>
+            <a:off x="1053405" y="5062240"/>
             <a:ext cx="1756696" cy="171450"/>
           </a:xfrm>
           <a:prstGeom prst="rect">
@@ -3493,13 +3452,13 @@
       </p:sp>
       <p:sp>
         <p:nvSpPr>
-          <p:cNvPr id="12" name="Oval 11"/>
+          <p:cNvPr id="11" name="Oval 10"/>
           <p:cNvSpPr/>
           <p:nvPr/>
         </p:nvSpPr>
         <p:spPr>
           <a:xfrm>
-            <a:off x="1053405" y="5639098"/>
+            <a:off x="1053405" y="5468689"/>
             <a:ext cx="150912" cy="150912"/>
           </a:xfrm>
           <a:prstGeom prst="ellipse">
@@ -3536,13 +3495,13 @@
       </p:sp>
       <p:sp>
         <p:nvSpPr>
-          <p:cNvPr id="13" name="Oval 12"/>
+          <p:cNvPr id="12" name="Oval 11"/>
           <p:cNvSpPr/>
           <p:nvPr/>
         </p:nvSpPr>
         <p:spPr>
           <a:xfrm>
-            <a:off x="1290638" y="5639098"/>
+            <a:off x="1290638" y="5468689"/>
             <a:ext cx="150912" cy="150912"/>
           </a:xfrm>
           <a:prstGeom prst="ellipse">
@@ -3579,13 +3538,13 @@
       </p:sp>
       <p:sp>
         <p:nvSpPr>
-          <p:cNvPr id="14" name="Oval 13"/>
+          <p:cNvPr id="13" name="Oval 12"/>
           <p:cNvSpPr/>
           <p:nvPr/>
         </p:nvSpPr>
         <p:spPr>
           <a:xfrm>
-            <a:off x="1527870" y="5639098"/>
+            <a:off x="1527870" y="5468689"/>
             <a:ext cx="150912" cy="150912"/>
           </a:xfrm>
           <a:prstGeom prst="ellipse">
@@ -3622,13 +3581,13 @@
       </p:sp>
       <p:sp>
         <p:nvSpPr>
-          <p:cNvPr id="15" name="Oval 14"/>
+          <p:cNvPr id="14" name="Oval 13"/>
           <p:cNvSpPr/>
           <p:nvPr/>
         </p:nvSpPr>
         <p:spPr>
           <a:xfrm>
-            <a:off x="1765102" y="5639098"/>
+            <a:off x="1765102" y="5468689"/>
             <a:ext cx="150912" cy="150912"/>
           </a:xfrm>
           <a:prstGeom prst="ellipse">
@@ -3665,13 +3624,13 @@
       </p:sp>
       <p:sp>
         <p:nvSpPr>
-          <p:cNvPr id="16" name="Oval 15"/>
+          <p:cNvPr id="15" name="Oval 14"/>
           <p:cNvSpPr/>
           <p:nvPr/>
         </p:nvSpPr>
         <p:spPr>
           <a:xfrm>
-            <a:off x="2002334" y="5639098"/>
+            <a:off x="2002334" y="5468689"/>
             <a:ext cx="150912" cy="150912"/>
           </a:xfrm>
           <a:prstGeom prst="ellipse">
@@ -3708,13 +3667,13 @@
       </p:sp>
       <p:sp>
         <p:nvSpPr>
-          <p:cNvPr id="17" name="Oval 16"/>
+          <p:cNvPr id="16" name="Oval 15"/>
           <p:cNvSpPr/>
           <p:nvPr/>
         </p:nvSpPr>
         <p:spPr>
           <a:xfrm>
-            <a:off x="2239566" y="5639098"/>
+            <a:off x="2239566" y="5468689"/>
             <a:ext cx="150912" cy="150912"/>
           </a:xfrm>
           <a:prstGeom prst="ellipse">
@@ -3751,13 +3710,13 @@
       </p:sp>
       <p:sp>
         <p:nvSpPr>
-          <p:cNvPr id="18" name="Oval 17"/>
+          <p:cNvPr id="17" name="Oval 16"/>
           <p:cNvSpPr/>
           <p:nvPr/>
         </p:nvSpPr>
         <p:spPr>
           <a:xfrm>
-            <a:off x="2476798" y="5639098"/>
+            <a:off x="2476798" y="5468689"/>
             <a:ext cx="150912" cy="150912"/>
           </a:xfrm>
           <a:prstGeom prst="ellipse">
@@ -3794,13 +3753,13 @@
       </p:sp>
       <p:sp>
         <p:nvSpPr>
-          <p:cNvPr id="19" name="Oval 18"/>
+          <p:cNvPr id="18" name="Oval 17"/>
           <p:cNvSpPr/>
           <p:nvPr/>
         </p:nvSpPr>
         <p:spPr>
           <a:xfrm>
-            <a:off x="2714030" y="5639098"/>
+            <a:off x="2714030" y="5468689"/>
             <a:ext cx="150912" cy="150912"/>
           </a:xfrm>
           <a:prstGeom prst="ellipse">
@@ -3837,13 +3796,13 @@
       </p:sp>
       <p:sp>
         <p:nvSpPr>
-          <p:cNvPr id="20" name="Oval 19"/>
+          <p:cNvPr id="19" name="Oval 18"/>
           <p:cNvSpPr/>
           <p:nvPr/>
         </p:nvSpPr>
         <p:spPr>
           <a:xfrm>
-            <a:off x="2951262" y="5639098"/>
+            <a:off x="2951262" y="5468689"/>
             <a:ext cx="150912" cy="150912"/>
           </a:xfrm>
           <a:prstGeom prst="ellipse">
@@ -3880,13 +3839,13 @@
       </p:sp>
       <p:sp>
         <p:nvSpPr>
-          <p:cNvPr id="21" name="Oval 20"/>
+          <p:cNvPr id="20" name="Oval 19"/>
           <p:cNvSpPr/>
           <p:nvPr/>
         </p:nvSpPr>
         <p:spPr>
           <a:xfrm>
-            <a:off x="3188494" y="5639098"/>
+            <a:off x="3188494" y="5468689"/>
             <a:ext cx="150912" cy="150912"/>
           </a:xfrm>
           <a:prstGeom prst="ellipse">
@@ -3923,13 +3882,13 @@
       </p:sp>
       <p:sp>
         <p:nvSpPr>
-          <p:cNvPr id="22" name="Oval 21"/>
+          <p:cNvPr id="21" name="Oval 20"/>
           <p:cNvSpPr/>
           <p:nvPr/>
         </p:nvSpPr>
         <p:spPr>
           <a:xfrm>
-            <a:off x="1053405" y="5876330"/>
+            <a:off x="1053405" y="5705921"/>
             <a:ext cx="150912" cy="150912"/>
           </a:xfrm>
           <a:prstGeom prst="ellipse">
@@ -3964,13 +3923,13 @@
       </p:sp>
       <p:sp>
         <p:nvSpPr>
-          <p:cNvPr id="23" name="Oval 22"/>
+          <p:cNvPr id="22" name="Oval 21"/>
           <p:cNvSpPr/>
           <p:nvPr/>
         </p:nvSpPr>
         <p:spPr>
           <a:xfrm>
-            <a:off x="1290638" y="5876330"/>
+            <a:off x="1290638" y="5705921"/>
             <a:ext cx="150912" cy="150912"/>
           </a:xfrm>
           <a:prstGeom prst="ellipse">
@@ -4005,13 +3964,13 @@
       </p:sp>
       <p:sp>
         <p:nvSpPr>
-          <p:cNvPr id="24" name="Oval 23"/>
+          <p:cNvPr id="23" name="Oval 22"/>
           <p:cNvSpPr/>
           <p:nvPr/>
         </p:nvSpPr>
         <p:spPr>
           <a:xfrm>
-            <a:off x="1527870" y="5876330"/>
+            <a:off x="1527870" y="5705921"/>
             <a:ext cx="150912" cy="150912"/>
           </a:xfrm>
           <a:prstGeom prst="ellipse">
@@ -4046,13 +4005,13 @@
       </p:sp>
       <p:sp>
         <p:nvSpPr>
-          <p:cNvPr id="25" name="Oval 24"/>
+          <p:cNvPr id="24" name="Oval 23"/>
           <p:cNvSpPr/>
           <p:nvPr/>
         </p:nvSpPr>
         <p:spPr>
           <a:xfrm>
-            <a:off x="1765102" y="5876330"/>
+            <a:off x="1765102" y="5705921"/>
             <a:ext cx="150912" cy="150912"/>
           </a:xfrm>
           <a:prstGeom prst="ellipse">
@@ -4087,13 +4046,13 @@
       </p:sp>
       <p:sp>
         <p:nvSpPr>
-          <p:cNvPr id="26" name="Oval 25"/>
+          <p:cNvPr id="25" name="Oval 24"/>
           <p:cNvSpPr/>
           <p:nvPr/>
         </p:nvSpPr>
         <p:spPr>
           <a:xfrm>
-            <a:off x="2002334" y="5876330"/>
+            <a:off x="2002334" y="5705921"/>
             <a:ext cx="150912" cy="150912"/>
           </a:xfrm>
           <a:prstGeom prst="ellipse">
@@ -4128,13 +4087,13 @@
       </p:sp>
       <p:sp>
         <p:nvSpPr>
-          <p:cNvPr id="27" name="Oval 26"/>
+          <p:cNvPr id="26" name="Oval 25"/>
           <p:cNvSpPr/>
           <p:nvPr/>
         </p:nvSpPr>
         <p:spPr>
           <a:xfrm>
-            <a:off x="2239566" y="5876330"/>
+            <a:off x="2239566" y="5705921"/>
             <a:ext cx="150912" cy="150912"/>
           </a:xfrm>
           <a:prstGeom prst="ellipse">
@@ -4169,13 +4128,13 @@
       </p:sp>
       <p:sp>
         <p:nvSpPr>
-          <p:cNvPr id="28" name="Oval 27"/>
+          <p:cNvPr id="27" name="Oval 26"/>
           <p:cNvSpPr/>
           <p:nvPr/>
         </p:nvSpPr>
         <p:spPr>
           <a:xfrm>
-            <a:off x="2476798" y="5876330"/>
+            <a:off x="2476798" y="5705921"/>
             <a:ext cx="150912" cy="150912"/>
           </a:xfrm>
           <a:prstGeom prst="ellipse">
@@ -4210,13 +4169,13 @@
       </p:sp>
       <p:sp>
         <p:nvSpPr>
-          <p:cNvPr id="29" name="Oval 28"/>
+          <p:cNvPr id="28" name="Oval 27"/>
           <p:cNvSpPr/>
           <p:nvPr/>
         </p:nvSpPr>
         <p:spPr>
           <a:xfrm>
-            <a:off x="2714030" y="5876330"/>
+            <a:off x="2714030" y="5705921"/>
             <a:ext cx="150912" cy="150912"/>
           </a:xfrm>
           <a:prstGeom prst="ellipse">
@@ -4251,13 +4210,13 @@
       </p:sp>
       <p:sp>
         <p:nvSpPr>
-          <p:cNvPr id="30" name="Oval 29"/>
+          <p:cNvPr id="29" name="Oval 28"/>
           <p:cNvSpPr/>
           <p:nvPr/>
         </p:nvSpPr>
         <p:spPr>
           <a:xfrm>
-            <a:off x="2951262" y="5876330"/>
+            <a:off x="2951262" y="5705921"/>
             <a:ext cx="150912" cy="150912"/>
           </a:xfrm>
           <a:prstGeom prst="ellipse">
@@ -4292,13 +4251,13 @@
       </p:sp>
       <p:sp>
         <p:nvSpPr>
-          <p:cNvPr id="31" name="Oval 30"/>
+          <p:cNvPr id="30" name="Oval 29"/>
           <p:cNvSpPr/>
           <p:nvPr/>
         </p:nvSpPr>
         <p:spPr>
           <a:xfrm>
-            <a:off x="3188494" y="5876330"/>
+            <a:off x="3188494" y="5705921"/>
             <a:ext cx="150912" cy="150912"/>
           </a:xfrm>
           <a:prstGeom prst="ellipse">
@@ -4333,13 +4292,13 @@
       </p:sp>
       <p:sp>
         <p:nvSpPr>
-          <p:cNvPr id="32" name="Rounded Rectangle 31"/>
+          <p:cNvPr id="31" name="Rounded Rectangle 30"/>
           <p:cNvSpPr/>
           <p:nvPr/>
         </p:nvSpPr>
         <p:spPr>
           <a:xfrm>
-            <a:off x="3887837" y="4064198"/>
+            <a:off x="3887837" y="3893790"/>
             <a:ext cx="2952155" cy="2296567"/>
           </a:xfrm>
           <a:prstGeom prst="roundRect">
@@ -4376,13 +4335,13 @@
       </p:sp>
       <p:sp>
         <p:nvSpPr>
-          <p:cNvPr id="33" name="TextBox 32"/>
+          <p:cNvPr id="32" name="TextBox 31"/>
           <p:cNvSpPr txBox="1"/>
           <p:nvPr/>
         </p:nvSpPr>
         <p:spPr>
           <a:xfrm>
-            <a:off x="4211836" y="4388197"/>
+            <a:off x="4211836" y="4217789"/>
             <a:ext cx="1069943" cy="142875"/>
           </a:xfrm>
           <a:prstGeom prst="rect">
@@ -4415,13 +4374,13 @@
       </p:sp>
       <p:sp>
         <p:nvSpPr>
-          <p:cNvPr id="34" name="TextBox 33"/>
+          <p:cNvPr id="33" name="TextBox 32"/>
           <p:cNvSpPr txBox="1"/>
           <p:nvPr/>
         </p:nvSpPr>
         <p:spPr>
           <a:xfrm>
-            <a:off x="4211836" y="4648498"/>
+            <a:off x="4211836" y="4478089"/>
             <a:ext cx="2008894" cy="428625"/>
           </a:xfrm>
           <a:prstGeom prst="rect">
@@ -4454,13 +4413,13 @@
       </p:sp>
       <p:sp>
         <p:nvSpPr>
-          <p:cNvPr id="35" name="TextBox 34"/>
+          <p:cNvPr id="34" name="TextBox 33"/>
           <p:cNvSpPr txBox="1"/>
           <p:nvPr/>
         </p:nvSpPr>
         <p:spPr>
           <a:xfrm>
-            <a:off x="4211836" y="5223123"/>
+            <a:off x="4211836" y="5052715"/>
             <a:ext cx="2103739" cy="171450"/>
           </a:xfrm>
           <a:prstGeom prst="rect">
@@ -4493,13 +4452,13 @@
       </p:sp>
       <p:sp>
         <p:nvSpPr>
-          <p:cNvPr id="36" name="Oval 35"/>
+          <p:cNvPr id="35" name="Oval 34"/>
           <p:cNvSpPr/>
           <p:nvPr/>
         </p:nvSpPr>
         <p:spPr>
           <a:xfrm>
-            <a:off x="4211836" y="5629573"/>
+            <a:off x="4211836" y="5459164"/>
             <a:ext cx="152846" cy="152846"/>
           </a:xfrm>
           <a:prstGeom prst="ellipse">
@@ -4536,13 +4495,13 @@
       </p:sp>
       <p:sp>
         <p:nvSpPr>
-          <p:cNvPr id="37" name="Oval 36"/>
+          <p:cNvPr id="36" name="Oval 35"/>
           <p:cNvSpPr/>
           <p:nvPr/>
         </p:nvSpPr>
         <p:spPr>
           <a:xfrm>
-            <a:off x="4451003" y="5629573"/>
+            <a:off x="4451003" y="5459164"/>
             <a:ext cx="152846" cy="152846"/>
           </a:xfrm>
           <a:prstGeom prst="ellipse">
@@ -4579,13 +4538,13 @@
       </p:sp>
       <p:sp>
         <p:nvSpPr>
-          <p:cNvPr id="38" name="Oval 37"/>
+          <p:cNvPr id="37" name="Oval 36"/>
           <p:cNvSpPr/>
           <p:nvPr/>
         </p:nvSpPr>
         <p:spPr>
           <a:xfrm>
-            <a:off x="4690170" y="5629573"/>
+            <a:off x="4690170" y="5459164"/>
             <a:ext cx="152846" cy="152846"/>
           </a:xfrm>
           <a:prstGeom prst="ellipse">
@@ -4622,13 +4581,13 @@
       </p:sp>
       <p:sp>
         <p:nvSpPr>
-          <p:cNvPr id="39" name="Oval 38"/>
+          <p:cNvPr id="38" name="Oval 37"/>
           <p:cNvSpPr/>
           <p:nvPr/>
         </p:nvSpPr>
         <p:spPr>
           <a:xfrm>
-            <a:off x="4929336" y="5629573"/>
+            <a:off x="4929336" y="5459164"/>
             <a:ext cx="152846" cy="152846"/>
           </a:xfrm>
           <a:prstGeom prst="ellipse">
@@ -4665,13 +4624,13 @@
       </p:sp>
       <p:sp>
         <p:nvSpPr>
-          <p:cNvPr id="40" name="Oval 39"/>
+          <p:cNvPr id="39" name="Oval 38"/>
           <p:cNvSpPr/>
           <p:nvPr/>
         </p:nvSpPr>
         <p:spPr>
           <a:xfrm>
-            <a:off x="5168503" y="5629573"/>
+            <a:off x="5168503" y="5459164"/>
             <a:ext cx="152846" cy="152846"/>
           </a:xfrm>
           <a:prstGeom prst="ellipse">
@@ -4708,13 +4667,13 @@
       </p:sp>
       <p:sp>
         <p:nvSpPr>
-          <p:cNvPr id="41" name="Oval 40"/>
+          <p:cNvPr id="40" name="Oval 39"/>
           <p:cNvSpPr/>
           <p:nvPr/>
         </p:nvSpPr>
         <p:spPr>
           <a:xfrm>
-            <a:off x="5407670" y="5629573"/>
+            <a:off x="5407670" y="5459164"/>
             <a:ext cx="152846" cy="152846"/>
           </a:xfrm>
           <a:prstGeom prst="ellipse">
@@ -4751,13 +4710,13 @@
       </p:sp>
       <p:sp>
         <p:nvSpPr>
-          <p:cNvPr id="42" name="Oval 41"/>
+          <p:cNvPr id="41" name="Oval 40"/>
           <p:cNvSpPr/>
           <p:nvPr/>
         </p:nvSpPr>
         <p:spPr>
           <a:xfrm>
-            <a:off x="5646837" y="5629573"/>
+            <a:off x="5646837" y="5459164"/>
             <a:ext cx="152846" cy="152846"/>
           </a:xfrm>
           <a:prstGeom prst="ellipse">
@@ -4794,13 +4753,13 @@
       </p:sp>
       <p:sp>
         <p:nvSpPr>
-          <p:cNvPr id="43" name="Oval 42"/>
+          <p:cNvPr id="42" name="Oval 41"/>
           <p:cNvSpPr/>
           <p:nvPr/>
         </p:nvSpPr>
         <p:spPr>
           <a:xfrm>
-            <a:off x="5886004" y="5629573"/>
+            <a:off x="5886004" y="5459164"/>
             <a:ext cx="152846" cy="152846"/>
           </a:xfrm>
           <a:prstGeom prst="ellipse">
@@ -4837,13 +4796,13 @@
       </p:sp>
       <p:sp>
         <p:nvSpPr>
-          <p:cNvPr id="44" name="Oval 43"/>
+          <p:cNvPr id="43" name="Oval 42"/>
           <p:cNvSpPr/>
           <p:nvPr/>
         </p:nvSpPr>
         <p:spPr>
           <a:xfrm>
-            <a:off x="6125170" y="5629573"/>
+            <a:off x="6125170" y="5459164"/>
             <a:ext cx="152846" cy="152846"/>
           </a:xfrm>
           <a:prstGeom prst="ellipse">
@@ -4880,13 +4839,13 @@
       </p:sp>
       <p:sp>
         <p:nvSpPr>
-          <p:cNvPr id="45" name="Oval 44"/>
+          <p:cNvPr id="44" name="Oval 43"/>
           <p:cNvSpPr/>
           <p:nvPr/>
         </p:nvSpPr>
         <p:spPr>
           <a:xfrm>
-            <a:off x="6364337" y="5629573"/>
+            <a:off x="6364337" y="5459164"/>
             <a:ext cx="152846" cy="152846"/>
           </a:xfrm>
           <a:prstGeom prst="ellipse">
@@ -4923,13 +4882,13 @@
       </p:sp>
       <p:sp>
         <p:nvSpPr>
-          <p:cNvPr id="46" name="Oval 45"/>
+          <p:cNvPr id="45" name="Oval 44"/>
           <p:cNvSpPr/>
           <p:nvPr/>
         </p:nvSpPr>
         <p:spPr>
           <a:xfrm>
-            <a:off x="4211836" y="5868739"/>
+            <a:off x="4211836" y="5698331"/>
             <a:ext cx="152846" cy="152846"/>
           </a:xfrm>
           <a:prstGeom prst="ellipse">
@@ -4966,13 +4925,13 @@
       </p:sp>
       <p:sp>
         <p:nvSpPr>
-          <p:cNvPr id="47" name="Oval 46"/>
+          <p:cNvPr id="46" name="Oval 45"/>
           <p:cNvSpPr/>
           <p:nvPr/>
         </p:nvSpPr>
         <p:spPr>
           <a:xfrm>
-            <a:off x="4451003" y="5868739"/>
+            <a:off x="4451003" y="5698331"/>
             <a:ext cx="152846" cy="152846"/>
           </a:xfrm>
           <a:prstGeom prst="ellipse">
@@ -5009,13 +4968,13 @@
       </p:sp>
       <p:sp>
         <p:nvSpPr>
-          <p:cNvPr id="48" name="Oval 47"/>
+          <p:cNvPr id="47" name="Oval 46"/>
           <p:cNvSpPr/>
           <p:nvPr/>
         </p:nvSpPr>
         <p:spPr>
           <a:xfrm>
-            <a:off x="4690170" y="5868739"/>
+            <a:off x="4690170" y="5698331"/>
             <a:ext cx="152846" cy="152846"/>
           </a:xfrm>
           <a:prstGeom prst="ellipse">
@@ -5052,13 +5011,13 @@
       </p:sp>
       <p:sp>
         <p:nvSpPr>
-          <p:cNvPr id="49" name="Oval 48"/>
+          <p:cNvPr id="48" name="Oval 47"/>
           <p:cNvSpPr/>
           <p:nvPr/>
         </p:nvSpPr>
         <p:spPr>
           <a:xfrm>
-            <a:off x="4929336" y="5868739"/>
+            <a:off x="4929336" y="5698331"/>
             <a:ext cx="152846" cy="152846"/>
           </a:xfrm>
           <a:prstGeom prst="ellipse">
@@ -5095,13 +5054,13 @@
       </p:sp>
       <p:sp>
         <p:nvSpPr>
-          <p:cNvPr id="50" name="Oval 49"/>
+          <p:cNvPr id="49" name="Oval 48"/>
           <p:cNvSpPr/>
           <p:nvPr/>
         </p:nvSpPr>
         <p:spPr>
           <a:xfrm>
-            <a:off x="5168503" y="5868739"/>
+            <a:off x="5168503" y="5698331"/>
             <a:ext cx="152846" cy="152846"/>
           </a:xfrm>
           <a:prstGeom prst="ellipse">
@@ -5138,13 +5097,13 @@
       </p:sp>
       <p:sp>
         <p:nvSpPr>
-          <p:cNvPr id="51" name="Oval 50"/>
+          <p:cNvPr id="50" name="Oval 49"/>
           <p:cNvSpPr/>
           <p:nvPr/>
         </p:nvSpPr>
         <p:spPr>
           <a:xfrm>
-            <a:off x="5407670" y="5868739"/>
+            <a:off x="5407670" y="5698331"/>
             <a:ext cx="152846" cy="152846"/>
           </a:xfrm>
           <a:prstGeom prst="ellipse">
@@ -5181,13 +5140,13 @@
       </p:sp>
       <p:sp>
         <p:nvSpPr>
-          <p:cNvPr id="52" name="Oval 51"/>
+          <p:cNvPr id="51" name="Oval 50"/>
           <p:cNvSpPr/>
           <p:nvPr/>
         </p:nvSpPr>
         <p:spPr>
           <a:xfrm>
-            <a:off x="5646837" y="5868739"/>
+            <a:off x="5646837" y="5698331"/>
             <a:ext cx="152846" cy="152846"/>
           </a:xfrm>
           <a:prstGeom prst="ellipse">
@@ -5224,13 +5183,13 @@
       </p:sp>
       <p:sp>
         <p:nvSpPr>
-          <p:cNvPr id="53" name="Oval 52"/>
+          <p:cNvPr id="52" name="Oval 51"/>
           <p:cNvSpPr/>
           <p:nvPr/>
         </p:nvSpPr>
         <p:spPr>
           <a:xfrm>
-            <a:off x="5886004" y="5868739"/>
+            <a:off x="5886004" y="5698331"/>
             <a:ext cx="152846" cy="152846"/>
           </a:xfrm>
           <a:prstGeom prst="ellipse">
@@ -5267,13 +5226,13 @@
       </p:sp>
       <p:sp>
         <p:nvSpPr>
-          <p:cNvPr id="54" name="Oval 53"/>
+          <p:cNvPr id="53" name="Oval 52"/>
           <p:cNvSpPr/>
           <p:nvPr/>
         </p:nvSpPr>
         <p:spPr>
           <a:xfrm>
-            <a:off x="6125170" y="5868739"/>
+            <a:off x="6125170" y="5698331"/>
             <a:ext cx="152846" cy="152846"/>
           </a:xfrm>
           <a:prstGeom prst="ellipse">
@@ -5310,13 +5269,13 @@
       </p:sp>
       <p:sp>
         <p:nvSpPr>
-          <p:cNvPr id="55" name="Oval 54"/>
+          <p:cNvPr id="54" name="Oval 53"/>
           <p:cNvSpPr/>
           <p:nvPr/>
         </p:nvSpPr>
         <p:spPr>
           <a:xfrm>
-            <a:off x="6364337" y="5868739"/>
+            <a:off x="6364337" y="5698331"/>
             <a:ext cx="152846" cy="152846"/>
           </a:xfrm>
           <a:prstGeom prst="ellipse">
@@ -5353,13 +5312,13 @@
       </p:sp>
       <p:sp>
         <p:nvSpPr>
-          <p:cNvPr id="56" name="TextBox 55"/>
+          <p:cNvPr id="55" name="TextBox 54"/>
           <p:cNvSpPr txBox="1"/>
           <p:nvPr/>
         </p:nvSpPr>
         <p:spPr>
           <a:xfrm>
-            <a:off x="723900" y="6468666"/>
+            <a:off x="723900" y="6298257"/>
             <a:ext cx="2055733" cy="142875"/>
           </a:xfrm>
           <a:prstGeom prst="rect">
@@ -5392,13 +5351,13 @@
       </p:sp>
       <p:sp>
         <p:nvSpPr>
-          <p:cNvPr id="57" name="Rounded Rectangle 56"/>
+          <p:cNvPr id="56" name="Rounded Rectangle 55"/>
           <p:cNvSpPr/>
           <p:nvPr/>
         </p:nvSpPr>
         <p:spPr>
           <a:xfrm>
-            <a:off x="719882" y="6844605"/>
+            <a:off x="719882" y="6674197"/>
             <a:ext cx="6120110" cy="1422648"/>
           </a:xfrm>
           <a:prstGeom prst="roundRect">
@@ -5435,13 +5394,13 @@
       </p:sp>
       <p:sp>
         <p:nvSpPr>
-          <p:cNvPr id="58" name="TextBox 57"/>
+          <p:cNvPr id="57" name="TextBox 56"/>
           <p:cNvSpPr txBox="1"/>
           <p:nvPr/>
         </p:nvSpPr>
         <p:spPr>
           <a:xfrm>
-            <a:off x="1043880" y="7178129"/>
+            <a:off x="1043880" y="7007721"/>
             <a:ext cx="3437573" cy="428625"/>
           </a:xfrm>
           <a:prstGeom prst="rect">
@@ -5474,13 +5433,13 @@
       </p:sp>
       <p:sp>
         <p:nvSpPr>
-          <p:cNvPr id="59" name="TextBox 58"/>
+          <p:cNvPr id="58" name="TextBox 57"/>
           <p:cNvSpPr txBox="1"/>
           <p:nvPr/>
         </p:nvSpPr>
         <p:spPr>
           <a:xfrm>
-            <a:off x="1043880" y="7752755"/>
+            <a:off x="1043880" y="7582346"/>
             <a:ext cx="2320766" cy="171450"/>
           </a:xfrm>
           <a:prstGeom prst="rect">
@@ -5513,7 +5472,7 @@
       </p:sp>
       <p:pic>
         <p:nvPicPr>
-          <p:cNvPr id="60" name="Picture 59" descr="academica.png"/>
+          <p:cNvPr id="59" name="Picture 58" descr="academica.png"/>
           <p:cNvPicPr>
             <a:picLocks noChangeAspect="1"/>
           </p:cNvPicPr>
@@ -5537,7 +5496,7 @@
       </p:pic>
       <p:sp>
         <p:nvSpPr>
-          <p:cNvPr id="61" name="TextBox 60"/>
+          <p:cNvPr id="60" name="TextBox 59"/>
           <p:cNvSpPr txBox="1"/>
           <p:nvPr/>
         </p:nvSpPr>
@@ -6440,17 +6399,140 @@
       <p:grpSpPr/>
       <p:sp>
         <p:nvSpPr>
-          <p:cNvPr id="2" name="Rectangle 1"/>
+          <p:cNvPr id="2" name="TextBox 1"/>
+          <p:cNvSpPr txBox="1"/>
+          <p:nvPr/>
+        </p:nvSpPr>
+        <p:spPr>
+          <a:xfrm>
+            <a:off x="723900" y="575965"/>
+            <a:ext cx="243673" cy="142875"/>
+          </a:xfrm>
+          <a:prstGeom prst="rect">
+            <a:avLst/>
+          </a:prstGeom>
+          <a:noFill/>
+        </p:spPr>
+        <p:txBody>
+          <a:bodyPr wrap="square" anchor="t" lIns="0" rIns="0" tIns="0" bIns="0">
+            <a:noAutofit/>
+          </a:bodyPr>
+          <a:lstStyle/>
+          <a:p>
+            <a:pPr algn="l">
+              <a:lnSpc>
+                <a:spcPts val="1080"/>
+              </a:lnSpc>
+            </a:pPr>
+            <a:r>
+              <a:rPr sz="900" b="1">
+                <a:solidFill>
+                  <a:srgbClr val="555A78"/>
+                </a:solidFill>
+                <a:latin typeface="Inter"/>
+              </a:rPr>
+              <a:t>03</a:t>
+            </a:r>
+          </a:p>
+        </p:txBody>
+      </p:sp>
+      <p:sp>
+        <p:nvSpPr>
+          <p:cNvPr id="3" name="TextBox 2"/>
+          <p:cNvSpPr txBox="1"/>
+          <p:nvPr/>
+        </p:nvSpPr>
+        <p:spPr>
+          <a:xfrm>
+            <a:off x="723900" y="819299"/>
+            <a:ext cx="2002226" cy="352425"/>
+          </a:xfrm>
+          <a:prstGeom prst="rect">
+            <a:avLst/>
+          </a:prstGeom>
+          <a:noFill/>
+        </p:spPr>
+        <p:txBody>
+          <a:bodyPr wrap="square" anchor="t" lIns="0" rIns="0" tIns="0" bIns="0">
+            <a:noAutofit/>
+          </a:bodyPr>
+          <a:lstStyle/>
+          <a:p>
+            <a:pPr algn="l">
+              <a:lnSpc>
+                <a:spcPts val="3300"/>
+              </a:lnSpc>
+            </a:pPr>
+            <a:r>
+              <a:rPr sz="3000" b="1">
+                <a:solidFill>
+                  <a:srgbClr val="000326"/>
+                </a:solidFill>
+                <a:latin typeface="League Spartan"/>
+              </a:rPr>
+              <a:t>Opbrengst</a:t>
+            </a:r>
+          </a:p>
+        </p:txBody>
+      </p:sp>
+      <p:sp>
+        <p:nvSpPr>
+          <p:cNvPr id="4" name="Rounded Rectangle 3"/>
           <p:cNvSpPr/>
           <p:nvPr/>
         </p:nvSpPr>
         <p:spPr>
           <a:xfrm>
-            <a:off x="0" y="0"/>
-            <a:ext cx="7559873" cy="1605707"/>
-          </a:xfrm>
-          <a:prstGeom prst="rect">
-            <a:avLst/>
+            <a:off x="719882" y="1795165"/>
+            <a:ext cx="6120110" cy="2999482"/>
+          </a:xfrm>
+          <a:prstGeom prst="roundRect">
+            <a:avLst>
+              <a:gd name="adj" fmla="val 7201"/>
+            </a:avLst>
+          </a:prstGeom>
+          <a:solidFill>
+            <a:srgbClr val="DFE8F3"/>
+          </a:solidFill>
+          <a:ln>
+            <a:noFill/>
+          </a:ln>
+        </p:spPr>
+        <p:style>
+          <a:lnRef idx="1">
+            <a:schemeClr val="accent1"/>
+          </a:lnRef>
+          <a:fillRef idx="3">
+            <a:schemeClr val="accent1"/>
+          </a:fillRef>
+          <a:effectRef idx="0">
+            <a:schemeClr val="accent1"/>
+          </a:effectRef>
+          <a:fontRef idx="minor">
+            <a:schemeClr val="lt1"/>
+          </a:fontRef>
+        </p:style>
+        <p:txBody>
+          <a:bodyPr rtlCol="0" anchor="ctr"/>
+          <a:lstStyle/>
+          <a:p/>
+        </p:txBody>
+      </p:sp>
+      <p:sp>
+        <p:nvSpPr>
+          <p:cNvPr id="5" name="Rounded Rectangle 4"/>
+          <p:cNvSpPr/>
+          <p:nvPr/>
+        </p:nvSpPr>
+        <p:spPr>
+          <a:xfrm>
+            <a:off x="1043880" y="2119164"/>
+            <a:ext cx="359866" cy="359866"/>
+          </a:xfrm>
+          <a:prstGeom prst="roundRect">
+            <a:avLst>
+              <a:gd name="adj" fmla="val 30011"/>
+            </a:avLst>
           </a:prstGeom>
           <a:solidFill>
             <a:srgbClr val="000326"/>
@@ -6479,173 +6561,9 @@
           <a:p/>
         </p:txBody>
       </p:sp>
-      <p:sp>
-        <p:nvSpPr>
-          <p:cNvPr id="3" name="TextBox 2"/>
-          <p:cNvSpPr txBox="1"/>
-          <p:nvPr/>
-        </p:nvSpPr>
-        <p:spPr>
-          <a:xfrm>
-            <a:off x="723900" y="575965"/>
-            <a:ext cx="243673" cy="142875"/>
-          </a:xfrm>
-          <a:prstGeom prst="rect">
-            <a:avLst/>
-          </a:prstGeom>
-          <a:noFill/>
-        </p:spPr>
-        <p:txBody>
-          <a:bodyPr wrap="square" anchor="t" lIns="0" rIns="0" tIns="0" bIns="0">
-            <a:noAutofit/>
-          </a:bodyPr>
-          <a:lstStyle/>
-          <a:p>
-            <a:pPr algn="l">
-              <a:lnSpc>
-                <a:spcPts val="1080"/>
-              </a:lnSpc>
-            </a:pPr>
-            <a:r>
-              <a:rPr sz="900" b="1">
-                <a:solidFill>
-                  <a:srgbClr val="FFFFFF"/>
-                </a:solidFill>
-                <a:latin typeface="Inter"/>
-              </a:rPr>
-              <a:t>03</a:t>
-            </a:r>
-          </a:p>
-        </p:txBody>
-      </p:sp>
-      <p:sp>
-        <p:nvSpPr>
-          <p:cNvPr id="4" name="TextBox 3"/>
-          <p:cNvSpPr txBox="1"/>
-          <p:nvPr/>
-        </p:nvSpPr>
-        <p:spPr>
-          <a:xfrm>
-            <a:off x="723900" y="819299"/>
-            <a:ext cx="2002226" cy="352425"/>
-          </a:xfrm>
-          <a:prstGeom prst="rect">
-            <a:avLst/>
-          </a:prstGeom>
-          <a:noFill/>
-        </p:spPr>
-        <p:txBody>
-          <a:bodyPr wrap="square" anchor="t" lIns="0" rIns="0" tIns="0" bIns="0">
-            <a:noAutofit/>
-          </a:bodyPr>
-          <a:lstStyle/>
-          <a:p>
-            <a:pPr algn="l">
-              <a:lnSpc>
-                <a:spcPts val="3300"/>
-              </a:lnSpc>
-            </a:pPr>
-            <a:r>
-              <a:rPr sz="3000" b="1">
-                <a:solidFill>
-                  <a:srgbClr val="FFFFFF"/>
-                </a:solidFill>
-                <a:latin typeface="League Spartan"/>
-              </a:rPr>
-              <a:t>Opbrengst</a:t>
-            </a:r>
-          </a:p>
-        </p:txBody>
-      </p:sp>
-      <p:sp>
-        <p:nvSpPr>
-          <p:cNvPr id="5" name="Rounded Rectangle 4"/>
-          <p:cNvSpPr/>
-          <p:nvPr/>
-        </p:nvSpPr>
-        <p:spPr>
-          <a:xfrm>
-            <a:off x="719882" y="1965573"/>
-            <a:ext cx="6120110" cy="2999482"/>
-          </a:xfrm>
-          <a:prstGeom prst="roundRect">
-            <a:avLst>
-              <a:gd name="adj" fmla="val 7201"/>
-            </a:avLst>
-          </a:prstGeom>
-          <a:solidFill>
-            <a:srgbClr val="DFE8F3"/>
-          </a:solidFill>
-          <a:ln>
-            <a:noFill/>
-          </a:ln>
-        </p:spPr>
-        <p:style>
-          <a:lnRef idx="1">
-            <a:schemeClr val="accent1"/>
-          </a:lnRef>
-          <a:fillRef idx="3">
-            <a:schemeClr val="accent1"/>
-          </a:fillRef>
-          <a:effectRef idx="0">
-            <a:schemeClr val="accent1"/>
-          </a:effectRef>
-          <a:fontRef idx="minor">
-            <a:schemeClr val="lt1"/>
-          </a:fontRef>
-        </p:style>
-        <p:txBody>
-          <a:bodyPr rtlCol="0" anchor="ctr"/>
-          <a:lstStyle/>
-          <a:p/>
-        </p:txBody>
-      </p:sp>
-      <p:sp>
-        <p:nvSpPr>
-          <p:cNvPr id="6" name="Rounded Rectangle 5"/>
-          <p:cNvSpPr/>
-          <p:nvPr/>
-        </p:nvSpPr>
-        <p:spPr>
-          <a:xfrm>
-            <a:off x="1043880" y="2289572"/>
-            <a:ext cx="359866" cy="359866"/>
-          </a:xfrm>
-          <a:prstGeom prst="roundRect">
-            <a:avLst>
-              <a:gd name="adj" fmla="val 30011"/>
-            </a:avLst>
-          </a:prstGeom>
-          <a:solidFill>
-            <a:srgbClr val="000326"/>
-          </a:solidFill>
-          <a:ln>
-            <a:noFill/>
-          </a:ln>
-        </p:spPr>
-        <p:style>
-          <a:lnRef idx="1">
-            <a:schemeClr val="accent1"/>
-          </a:lnRef>
-          <a:fillRef idx="3">
-            <a:schemeClr val="accent1"/>
-          </a:fillRef>
-          <a:effectRef idx="0">
-            <a:schemeClr val="accent1"/>
-          </a:effectRef>
-          <a:fontRef idx="minor">
-            <a:schemeClr val="lt1"/>
-          </a:fontRef>
-        </p:style>
-        <p:txBody>
-          <a:bodyPr rtlCol="0" anchor="ctr"/>
-          <a:lstStyle/>
-          <a:p/>
-        </p:txBody>
-      </p:sp>
       <p:pic>
         <p:nvPicPr>
-          <p:cNvPr id="7" name="Picture 6" descr="svg-2-0.png"/>
+          <p:cNvPr id="6" name="Picture 5" descr="svg-2-0.png"/>
           <p:cNvPicPr>
             <a:picLocks noChangeAspect="1"/>
           </p:cNvPicPr>
@@ -6659,7 +6577,7 @@
         </p:blipFill>
         <p:spPr>
           <a:xfrm>
-            <a:off x="1133773" y="2379464"/>
+            <a:off x="1133773" y="2209056"/>
             <a:ext cx="179933" cy="179933"/>
           </a:xfrm>
           <a:prstGeom prst="rect">
@@ -6669,13 +6587,13 @@
       </p:pic>
       <p:sp>
         <p:nvSpPr>
-          <p:cNvPr id="8" name="TextBox 7"/>
+          <p:cNvPr id="7" name="TextBox 6"/>
           <p:cNvSpPr txBox="1"/>
           <p:nvPr/>
         </p:nvSpPr>
         <p:spPr>
           <a:xfrm>
-            <a:off x="1547664" y="2368451"/>
+            <a:off x="1547664" y="2198043"/>
             <a:ext cx="2291763" cy="200025"/>
           </a:xfrm>
           <a:prstGeom prst="rect">
@@ -6708,13 +6626,13 @@
       </p:sp>
       <p:sp>
         <p:nvSpPr>
-          <p:cNvPr id="9" name="TextBox 8"/>
+          <p:cNvPr id="8" name="TextBox 7"/>
           <p:cNvSpPr txBox="1"/>
           <p:nvPr/>
         </p:nvSpPr>
         <p:spPr>
           <a:xfrm>
-            <a:off x="1043880" y="2776389"/>
+            <a:off x="1043880" y="2605980"/>
             <a:ext cx="5795070" cy="171450"/>
           </a:xfrm>
           <a:prstGeom prst="rect">
@@ -6747,13 +6665,13 @@
       </p:sp>
       <p:sp>
         <p:nvSpPr>
-          <p:cNvPr id="10" name="Rounded Rectangle 9"/>
+          <p:cNvPr id="9" name="Rounded Rectangle 8"/>
           <p:cNvSpPr/>
           <p:nvPr/>
         </p:nvSpPr>
         <p:spPr>
           <a:xfrm>
-            <a:off x="1043880" y="3182838"/>
+            <a:off x="1043880" y="3012430"/>
             <a:ext cx="2628007" cy="1458218"/>
           </a:xfrm>
           <a:prstGeom prst="roundRect">
@@ -6790,13 +6708,13 @@
       </p:sp>
       <p:sp>
         <p:nvSpPr>
-          <p:cNvPr id="11" name="TextBox 10"/>
+          <p:cNvPr id="10" name="TextBox 9"/>
           <p:cNvSpPr txBox="1"/>
           <p:nvPr/>
         </p:nvSpPr>
         <p:spPr>
           <a:xfrm>
-            <a:off x="1259830" y="3408313"/>
+            <a:off x="1259830" y="3237905"/>
             <a:ext cx="602218" cy="171450"/>
           </a:xfrm>
           <a:prstGeom prst="rect">
@@ -6829,13 +6747,13 @@
       </p:sp>
       <p:sp>
         <p:nvSpPr>
-          <p:cNvPr id="12" name="TextBox 11"/>
+          <p:cNvPr id="11" name="TextBox 10"/>
           <p:cNvSpPr txBox="1"/>
           <p:nvPr/>
         </p:nvSpPr>
         <p:spPr>
           <a:xfrm>
-            <a:off x="1259830" y="3601343"/>
+            <a:off x="1259830" y="3430935"/>
             <a:ext cx="2214420" cy="142875"/>
           </a:xfrm>
           <a:prstGeom prst="rect">
@@ -6868,13 +6786,13 @@
       </p:sp>
       <p:sp>
         <p:nvSpPr>
-          <p:cNvPr id="13" name="Rectangle 12"/>
+          <p:cNvPr id="12" name="Rectangle 11"/>
           <p:cNvSpPr/>
           <p:nvPr/>
         </p:nvSpPr>
         <p:spPr>
           <a:xfrm>
-            <a:off x="1259830" y="4078039"/>
+            <a:off x="1259830" y="3907631"/>
             <a:ext cx="2196108" cy="14288"/>
           </a:xfrm>
           <a:prstGeom prst="rect">
@@ -6909,13 +6827,13 @@
       </p:sp>
       <p:sp>
         <p:nvSpPr>
-          <p:cNvPr id="14" name="Oval 13"/>
+          <p:cNvPr id="13" name="Oval 12"/>
           <p:cNvSpPr/>
           <p:nvPr/>
         </p:nvSpPr>
         <p:spPr>
           <a:xfrm>
-            <a:off x="1491555" y="4009579"/>
+            <a:off x="1491555" y="3839170"/>
             <a:ext cx="151061" cy="151061"/>
           </a:xfrm>
           <a:prstGeom prst="ellipse">
@@ -6952,13 +6870,13 @@
       </p:sp>
       <p:sp>
         <p:nvSpPr>
-          <p:cNvPr id="15" name="Oval 14"/>
+          <p:cNvPr id="14" name="Oval 13"/>
           <p:cNvSpPr/>
           <p:nvPr/>
         </p:nvSpPr>
         <p:spPr>
           <a:xfrm>
-            <a:off x="2106513" y="4009579"/>
+            <a:off x="2106513" y="3839170"/>
             <a:ext cx="151061" cy="151061"/>
           </a:xfrm>
           <a:prstGeom prst="ellipse">
@@ -6995,13 +6913,13 @@
       </p:sp>
       <p:sp>
         <p:nvSpPr>
-          <p:cNvPr id="16" name="Oval 15"/>
+          <p:cNvPr id="15" name="Oval 14"/>
           <p:cNvSpPr/>
           <p:nvPr/>
         </p:nvSpPr>
         <p:spPr>
           <a:xfrm>
-            <a:off x="2567732" y="4009579"/>
+            <a:off x="2567732" y="3839170"/>
             <a:ext cx="151061" cy="151061"/>
           </a:xfrm>
           <a:prstGeom prst="ellipse">
@@ -7038,13 +6956,13 @@
       </p:sp>
       <p:sp>
         <p:nvSpPr>
-          <p:cNvPr id="17" name="Oval 16"/>
+          <p:cNvPr id="16" name="Oval 15"/>
           <p:cNvSpPr/>
           <p:nvPr/>
         </p:nvSpPr>
         <p:spPr>
           <a:xfrm>
-            <a:off x="3116759" y="4009579"/>
+            <a:off x="3116759" y="3839170"/>
             <a:ext cx="151061" cy="151061"/>
           </a:xfrm>
           <a:prstGeom prst="ellipse">
@@ -7081,13 +6999,13 @@
       </p:sp>
       <p:sp>
         <p:nvSpPr>
-          <p:cNvPr id="18" name="TextBox 17"/>
+          <p:cNvPr id="17" name="TextBox 16"/>
           <p:cNvSpPr txBox="1"/>
           <p:nvPr/>
         </p:nvSpPr>
         <p:spPr>
           <a:xfrm>
-            <a:off x="1259830" y="4265116"/>
+            <a:off x="1259830" y="4094708"/>
             <a:ext cx="578882" cy="142875"/>
           </a:xfrm>
           <a:prstGeom prst="rect">
@@ -7120,13 +7038,13 @@
       </p:sp>
       <p:sp>
         <p:nvSpPr>
-          <p:cNvPr id="19" name="TextBox 18"/>
+          <p:cNvPr id="18" name="TextBox 17"/>
           <p:cNvSpPr txBox="1"/>
           <p:nvPr/>
         </p:nvSpPr>
         <p:spPr>
           <a:xfrm>
-            <a:off x="3117652" y="4265116"/>
+            <a:off x="3117652" y="4094708"/>
             <a:ext cx="436031" cy="142875"/>
           </a:xfrm>
           <a:prstGeom prst="rect">
@@ -7159,13 +7077,13 @@
       </p:sp>
       <p:sp>
         <p:nvSpPr>
-          <p:cNvPr id="20" name="Rounded Rectangle 19"/>
+          <p:cNvPr id="19" name="Rounded Rectangle 18"/>
           <p:cNvSpPr/>
           <p:nvPr/>
         </p:nvSpPr>
         <p:spPr>
           <a:xfrm>
-            <a:off x="3887837" y="3182838"/>
+            <a:off x="3887837" y="3012430"/>
             <a:ext cx="2628156" cy="1458218"/>
           </a:xfrm>
           <a:prstGeom prst="roundRect">
@@ -7202,13 +7120,13 @@
       </p:sp>
       <p:sp>
         <p:nvSpPr>
-          <p:cNvPr id="21" name="TextBox 20"/>
+          <p:cNvPr id="20" name="TextBox 19"/>
           <p:cNvSpPr txBox="1"/>
           <p:nvPr/>
         </p:nvSpPr>
         <p:spPr>
           <a:xfrm>
-            <a:off x="4103787" y="3408313"/>
+            <a:off x="4103787" y="3237905"/>
             <a:ext cx="1007769" cy="171450"/>
           </a:xfrm>
           <a:prstGeom prst="rect">
@@ -7241,13 +7159,13 @@
       </p:sp>
       <p:sp>
         <p:nvSpPr>
-          <p:cNvPr id="22" name="TextBox 21"/>
+          <p:cNvPr id="21" name="TextBox 20"/>
           <p:cNvSpPr txBox="1"/>
           <p:nvPr/>
         </p:nvSpPr>
         <p:spPr>
           <a:xfrm>
-            <a:off x="4103787" y="3601343"/>
+            <a:off x="4103787" y="3430935"/>
             <a:ext cx="1966222" cy="142875"/>
           </a:xfrm>
           <a:prstGeom prst="rect">
@@ -7280,13 +7198,13 @@
       </p:sp>
       <p:sp>
         <p:nvSpPr>
-          <p:cNvPr id="23" name="Rectangle 22"/>
+          <p:cNvPr id="22" name="Rectangle 21"/>
           <p:cNvSpPr/>
           <p:nvPr/>
         </p:nvSpPr>
         <p:spPr>
           <a:xfrm>
-            <a:off x="4103787" y="4078039"/>
+            <a:off x="4103787" y="3907631"/>
             <a:ext cx="2196257" cy="14288"/>
           </a:xfrm>
           <a:prstGeom prst="rect">
@@ -7321,13 +7239,13 @@
       </p:sp>
       <p:sp>
         <p:nvSpPr>
-          <p:cNvPr id="24" name="Oval 23"/>
+          <p:cNvPr id="23" name="Oval 22"/>
           <p:cNvSpPr/>
           <p:nvPr/>
         </p:nvSpPr>
         <p:spPr>
           <a:xfrm>
-            <a:off x="4994523" y="4009579"/>
+            <a:off x="4994523" y="3839170"/>
             <a:ext cx="151061" cy="151061"/>
           </a:xfrm>
           <a:prstGeom prst="ellipse">
@@ -7364,13 +7282,13 @@
       </p:sp>
       <p:sp>
         <p:nvSpPr>
-          <p:cNvPr id="25" name="Oval 24"/>
+          <p:cNvPr id="24" name="Oval 23"/>
           <p:cNvSpPr/>
           <p:nvPr/>
         </p:nvSpPr>
         <p:spPr>
           <a:xfrm>
-            <a:off x="5126236" y="4009579"/>
+            <a:off x="5126236" y="3839170"/>
             <a:ext cx="151061" cy="151061"/>
           </a:xfrm>
           <a:prstGeom prst="ellipse">
@@ -7407,13 +7325,13 @@
       </p:sp>
       <p:sp>
         <p:nvSpPr>
-          <p:cNvPr id="26" name="Oval 25"/>
+          <p:cNvPr id="25" name="Oval 24"/>
           <p:cNvSpPr/>
           <p:nvPr/>
         </p:nvSpPr>
         <p:spPr>
           <a:xfrm>
-            <a:off x="5257949" y="4009579"/>
+            <a:off x="5257949" y="3839170"/>
             <a:ext cx="151061" cy="151061"/>
           </a:xfrm>
           <a:prstGeom prst="ellipse">
@@ -7450,13 +7368,13 @@
       </p:sp>
       <p:sp>
         <p:nvSpPr>
-          <p:cNvPr id="27" name="Oval 26"/>
+          <p:cNvPr id="26" name="Oval 25"/>
           <p:cNvSpPr/>
           <p:nvPr/>
         </p:nvSpPr>
         <p:spPr>
           <a:xfrm>
-            <a:off x="5389811" y="4009579"/>
+            <a:off x="5389811" y="3839170"/>
             <a:ext cx="151061" cy="151061"/>
           </a:xfrm>
           <a:prstGeom prst="ellipse">
@@ -7493,13 +7411,13 @@
       </p:sp>
       <p:sp>
         <p:nvSpPr>
-          <p:cNvPr id="28" name="TextBox 27"/>
+          <p:cNvPr id="27" name="TextBox 26"/>
           <p:cNvSpPr txBox="1"/>
           <p:nvPr/>
         </p:nvSpPr>
         <p:spPr>
           <a:xfrm>
-            <a:off x="4103787" y="4265116"/>
+            <a:off x="4103787" y="4094708"/>
             <a:ext cx="578882" cy="142875"/>
           </a:xfrm>
           <a:prstGeom prst="rect">
@@ -7532,13 +7450,13 @@
       </p:sp>
       <p:sp>
         <p:nvSpPr>
-          <p:cNvPr id="29" name="TextBox 28"/>
+          <p:cNvPr id="28" name="TextBox 27"/>
           <p:cNvSpPr txBox="1"/>
           <p:nvPr/>
         </p:nvSpPr>
         <p:spPr>
           <a:xfrm>
-            <a:off x="5961757" y="4265116"/>
+            <a:off x="5961757" y="4094708"/>
             <a:ext cx="436031" cy="142875"/>
           </a:xfrm>
           <a:prstGeom prst="rect">
@@ -7571,13 +7489,13 @@
       </p:sp>
       <p:sp>
         <p:nvSpPr>
-          <p:cNvPr id="30" name="Rounded Rectangle 29"/>
+          <p:cNvPr id="29" name="Rounded Rectangle 28"/>
           <p:cNvSpPr/>
           <p:nvPr/>
         </p:nvSpPr>
         <p:spPr>
           <a:xfrm>
-            <a:off x="719882" y="5181005"/>
+            <a:off x="719882" y="5010596"/>
             <a:ext cx="6120110" cy="2527995"/>
           </a:xfrm>
           <a:prstGeom prst="roundRect">
@@ -7614,13 +7532,13 @@
       </p:sp>
       <p:sp>
         <p:nvSpPr>
-          <p:cNvPr id="31" name="Rounded Rectangle 30"/>
+          <p:cNvPr id="30" name="Rounded Rectangle 29"/>
           <p:cNvSpPr/>
           <p:nvPr/>
         </p:nvSpPr>
         <p:spPr>
           <a:xfrm>
-            <a:off x="1043880" y="5505004"/>
+            <a:off x="1043880" y="5334595"/>
             <a:ext cx="359866" cy="359866"/>
           </a:xfrm>
           <a:prstGeom prst="roundRect">
@@ -7657,7 +7575,7 @@
       </p:sp>
       <p:pic>
         <p:nvPicPr>
-          <p:cNvPr id="32" name="Picture 31" descr="svg-2-1.png"/>
+          <p:cNvPr id="31" name="Picture 30" descr="svg-2-1.png"/>
           <p:cNvPicPr>
             <a:picLocks noChangeAspect="1"/>
           </p:cNvPicPr>
@@ -7671,7 +7589,7 @@
         </p:blipFill>
         <p:spPr>
           <a:xfrm>
-            <a:off x="1133773" y="5594896"/>
+            <a:off x="1133773" y="5424488"/>
             <a:ext cx="179933" cy="179933"/>
           </a:xfrm>
           <a:prstGeom prst="rect">
@@ -7681,13 +7599,13 @@
       </p:pic>
       <p:sp>
         <p:nvSpPr>
-          <p:cNvPr id="33" name="TextBox 32"/>
+          <p:cNvPr id="32" name="TextBox 31"/>
           <p:cNvSpPr txBox="1"/>
           <p:nvPr/>
         </p:nvSpPr>
         <p:spPr>
           <a:xfrm>
-            <a:off x="1547664" y="5583882"/>
+            <a:off x="1547664" y="5413474"/>
             <a:ext cx="4066818" cy="200025"/>
           </a:xfrm>
           <a:prstGeom prst="rect">
@@ -7720,13 +7638,13 @@
       </p:sp>
       <p:sp>
         <p:nvSpPr>
-          <p:cNvPr id="34" name="TextBox 33"/>
+          <p:cNvPr id="33" name="TextBox 32"/>
           <p:cNvSpPr txBox="1"/>
           <p:nvPr/>
         </p:nvSpPr>
         <p:spPr>
           <a:xfrm>
-            <a:off x="1043880" y="5991820"/>
+            <a:off x="1043880" y="5821412"/>
             <a:ext cx="4981277" cy="381000"/>
           </a:xfrm>
           <a:prstGeom prst="rect">
@@ -7759,13 +7677,13 @@
       </p:sp>
       <p:sp>
         <p:nvSpPr>
-          <p:cNvPr id="35" name="TextBox 34"/>
+          <p:cNvPr id="34" name="TextBox 33"/>
           <p:cNvSpPr txBox="1"/>
           <p:nvPr/>
         </p:nvSpPr>
         <p:spPr>
           <a:xfrm>
-            <a:off x="1043880" y="6571804"/>
+            <a:off x="1043880" y="6401395"/>
             <a:ext cx="1176123" cy="152400"/>
           </a:xfrm>
           <a:prstGeom prst="rect">
@@ -7798,13 +7716,13 @@
       </p:sp>
       <p:sp>
         <p:nvSpPr>
-          <p:cNvPr id="36" name="Rounded Rectangle 35"/>
+          <p:cNvPr id="35" name="Rounded Rectangle 34"/>
           <p:cNvSpPr/>
           <p:nvPr/>
         </p:nvSpPr>
         <p:spPr>
           <a:xfrm>
-            <a:off x="2411760" y="6593979"/>
+            <a:off x="2411760" y="6423571"/>
             <a:ext cx="3240435" cy="107900"/>
           </a:xfrm>
           <a:prstGeom prst="roundRect">
@@ -7841,13 +7759,13 @@
       </p:sp>
       <p:sp>
         <p:nvSpPr>
-          <p:cNvPr id="37" name="Rounded Rectangle 36"/>
+          <p:cNvPr id="36" name="Rounded Rectangle 35"/>
           <p:cNvSpPr/>
           <p:nvPr/>
         </p:nvSpPr>
         <p:spPr>
           <a:xfrm>
-            <a:off x="2411760" y="6593979"/>
+            <a:off x="2411760" y="6423571"/>
             <a:ext cx="1620143" cy="107900"/>
           </a:xfrm>
           <a:prstGeom prst="roundRect">
@@ -7884,13 +7802,13 @@
       </p:sp>
       <p:sp>
         <p:nvSpPr>
-          <p:cNvPr id="38" name="TextBox 37"/>
+          <p:cNvPr id="37" name="TextBox 36"/>
           <p:cNvSpPr txBox="1"/>
           <p:nvPr/>
         </p:nvSpPr>
         <p:spPr>
           <a:xfrm>
-            <a:off x="5826764" y="6571804"/>
+            <a:off x="5826764" y="6401395"/>
             <a:ext cx="689229" cy="152400"/>
           </a:xfrm>
           <a:prstGeom prst="rect">
@@ -7923,13 +7841,13 @@
       </p:sp>
       <p:sp>
         <p:nvSpPr>
-          <p:cNvPr id="39" name="TextBox 38"/>
+          <p:cNvPr id="38" name="TextBox 37"/>
           <p:cNvSpPr txBox="1"/>
           <p:nvPr/>
         </p:nvSpPr>
         <p:spPr>
           <a:xfrm>
-            <a:off x="1043880" y="6850112"/>
+            <a:off x="1043880" y="6679704"/>
             <a:ext cx="1388983" cy="152400"/>
           </a:xfrm>
           <a:prstGeom prst="rect">
@@ -7962,13 +7880,13 @@
       </p:sp>
       <p:sp>
         <p:nvSpPr>
-          <p:cNvPr id="40" name="Rounded Rectangle 39"/>
+          <p:cNvPr id="39" name="Rounded Rectangle 38"/>
           <p:cNvSpPr/>
           <p:nvPr/>
         </p:nvSpPr>
         <p:spPr>
           <a:xfrm>
-            <a:off x="2411760" y="6872288"/>
+            <a:off x="2411760" y="6701879"/>
             <a:ext cx="3240435" cy="107900"/>
           </a:xfrm>
           <a:prstGeom prst="roundRect">
@@ -8005,13 +7923,13 @@
       </p:sp>
       <p:sp>
         <p:nvSpPr>
-          <p:cNvPr id="41" name="Rounded Rectangle 40"/>
+          <p:cNvPr id="40" name="Rounded Rectangle 39"/>
           <p:cNvSpPr/>
           <p:nvPr/>
         </p:nvSpPr>
         <p:spPr>
           <a:xfrm>
-            <a:off x="2411760" y="6872288"/>
+            <a:off x="2411760" y="6701879"/>
             <a:ext cx="3240435" cy="107900"/>
           </a:xfrm>
           <a:prstGeom prst="roundRect">
@@ -8048,13 +7966,13 @@
       </p:sp>
       <p:sp>
         <p:nvSpPr>
-          <p:cNvPr id="42" name="TextBox 41"/>
+          <p:cNvPr id="41" name="TextBox 40"/>
           <p:cNvSpPr txBox="1"/>
           <p:nvPr/>
         </p:nvSpPr>
         <p:spPr>
           <a:xfrm>
-            <a:off x="5833098" y="6850112"/>
+            <a:off x="5833098" y="6679704"/>
             <a:ext cx="682895" cy="152400"/>
           </a:xfrm>
           <a:prstGeom prst="rect">
@@ -8087,13 +8005,13 @@
       </p:sp>
       <p:sp>
         <p:nvSpPr>
-          <p:cNvPr id="43" name="TextBox 42"/>
+          <p:cNvPr id="42" name="TextBox 41"/>
           <p:cNvSpPr txBox="1"/>
           <p:nvPr/>
         </p:nvSpPr>
         <p:spPr>
           <a:xfrm>
-            <a:off x="1043880" y="7191970"/>
+            <a:off x="1043880" y="7021562"/>
             <a:ext cx="5694021" cy="171450"/>
           </a:xfrm>
           <a:prstGeom prst="rect">
@@ -8126,13 +8044,13 @@
       </p:sp>
       <p:sp>
         <p:nvSpPr>
-          <p:cNvPr id="44" name="Rounded Rectangle 43"/>
+          <p:cNvPr id="43" name="Rounded Rectangle 42"/>
           <p:cNvSpPr/>
           <p:nvPr/>
         </p:nvSpPr>
         <p:spPr>
           <a:xfrm>
-            <a:off x="719882" y="7924949"/>
+            <a:off x="719882" y="7754541"/>
             <a:ext cx="6120110" cy="1553914"/>
           </a:xfrm>
           <a:prstGeom prst="roundRect">
@@ -8169,13 +8087,13 @@
       </p:sp>
       <p:sp>
         <p:nvSpPr>
-          <p:cNvPr id="45" name="Rounded Rectangle 44"/>
+          <p:cNvPr id="44" name="Rounded Rectangle 43"/>
           <p:cNvSpPr/>
           <p:nvPr/>
         </p:nvSpPr>
         <p:spPr>
           <a:xfrm>
-            <a:off x="1053405" y="8258473"/>
+            <a:off x="1053405" y="8088064"/>
             <a:ext cx="359866" cy="359866"/>
           </a:xfrm>
           <a:prstGeom prst="roundRect">
@@ -8212,7 +8130,7 @@
       </p:sp>
       <p:pic>
         <p:nvPicPr>
-          <p:cNvPr id="46" name="Picture 45" descr="svg-2-2.png"/>
+          <p:cNvPr id="45" name="Picture 44" descr="svg-2-2.png"/>
           <p:cNvPicPr>
             <a:picLocks noChangeAspect="1"/>
           </p:cNvPicPr>
@@ -8226,7 +8144,7 @@
         </p:blipFill>
         <p:spPr>
           <a:xfrm>
-            <a:off x="1143298" y="8348365"/>
+            <a:off x="1143298" y="8177957"/>
             <a:ext cx="179933" cy="179933"/>
           </a:xfrm>
           <a:prstGeom prst="rect">
@@ -8236,13 +8154,13 @@
       </p:pic>
       <p:sp>
         <p:nvSpPr>
-          <p:cNvPr id="47" name="TextBox 46"/>
+          <p:cNvPr id="46" name="TextBox 45"/>
           <p:cNvSpPr txBox="1"/>
           <p:nvPr/>
         </p:nvSpPr>
         <p:spPr>
           <a:xfrm>
-            <a:off x="1557189" y="8337352"/>
+            <a:off x="1557189" y="8166943"/>
             <a:ext cx="2374440" cy="200025"/>
           </a:xfrm>
           <a:prstGeom prst="rect">
@@ -8275,13 +8193,13 @@
       </p:sp>
       <p:sp>
         <p:nvSpPr>
-          <p:cNvPr id="48" name="TextBox 47"/>
+          <p:cNvPr id="47" name="TextBox 46"/>
           <p:cNvSpPr txBox="1"/>
           <p:nvPr/>
         </p:nvSpPr>
         <p:spPr>
           <a:xfrm>
-            <a:off x="1053405" y="8745289"/>
+            <a:off x="1053405" y="8574881"/>
             <a:ext cx="4892873" cy="381000"/>
           </a:xfrm>
           <a:prstGeom prst="rect">
@@ -8314,7 +8232,7 @@
       </p:sp>
       <p:pic>
         <p:nvPicPr>
-          <p:cNvPr id="49" name="Picture 48" descr="academica.png"/>
+          <p:cNvPr id="48" name="Picture 47" descr="academica.png"/>
           <p:cNvPicPr>
             <a:picLocks noChangeAspect="1"/>
           </p:cNvPicPr>
@@ -8338,7 +8256,7 @@
       </p:pic>
       <p:sp>
         <p:nvSpPr>
-          <p:cNvPr id="50" name="TextBox 49"/>
+          <p:cNvPr id="49" name="TextBox 48"/>
           <p:cNvSpPr txBox="1"/>
           <p:nvPr/>
         </p:nvSpPr>
@@ -10096,48 +10014,7 @@
       <p:grpSpPr/>
       <p:sp>
         <p:nvSpPr>
-          <p:cNvPr id="2" name="Rectangle 1"/>
-          <p:cNvSpPr/>
-          <p:nvPr/>
-        </p:nvSpPr>
-        <p:spPr>
-          <a:xfrm>
-            <a:off x="0" y="0"/>
-            <a:ext cx="7559873" cy="1605707"/>
-          </a:xfrm>
-          <a:prstGeom prst="rect">
-            <a:avLst/>
-          </a:prstGeom>
-          <a:solidFill>
-            <a:srgbClr val="000326"/>
-          </a:solidFill>
-          <a:ln>
-            <a:noFill/>
-          </a:ln>
-        </p:spPr>
-        <p:style>
-          <a:lnRef idx="1">
-            <a:schemeClr val="accent1"/>
-          </a:lnRef>
-          <a:fillRef idx="3">
-            <a:schemeClr val="accent1"/>
-          </a:fillRef>
-          <a:effectRef idx="0">
-            <a:schemeClr val="accent1"/>
-          </a:effectRef>
-          <a:fontRef idx="minor">
-            <a:schemeClr val="lt1"/>
-          </a:fontRef>
-        </p:style>
-        <p:txBody>
-          <a:bodyPr rtlCol="0" anchor="ctr"/>
-          <a:lstStyle/>
-          <a:p/>
-        </p:txBody>
-      </p:sp>
-      <p:sp>
-        <p:nvSpPr>
-          <p:cNvPr id="3" name="TextBox 2"/>
+          <p:cNvPr id="2" name="TextBox 1"/>
           <p:cNvSpPr txBox="1"/>
           <p:nvPr/>
         </p:nvSpPr>
@@ -10165,7 +10042,7 @@
             <a:r>
               <a:rPr sz="900" b="1">
                 <a:solidFill>
-                  <a:srgbClr val="FFFFFF"/>
+                  <a:srgbClr val="555A78"/>
                 </a:solidFill>
                 <a:latin typeface="Inter"/>
               </a:rPr>
@@ -10176,7 +10053,7 @@
       </p:sp>
       <p:sp>
         <p:nvSpPr>
-          <p:cNvPr id="4" name="TextBox 3"/>
+          <p:cNvPr id="3" name="TextBox 2"/>
           <p:cNvSpPr txBox="1"/>
           <p:nvPr/>
         </p:nvSpPr>
@@ -10204,7 +10081,7 @@
             <a:r>
               <a:rPr sz="3000" b="1">
                 <a:solidFill>
-                  <a:srgbClr val="FFFFFF"/>
+                  <a:srgbClr val="000326"/>
                 </a:solidFill>
                 <a:latin typeface="League Spartan"/>
               </a:rPr>
@@ -10215,13 +10092,13 @@
       </p:sp>
       <p:sp>
         <p:nvSpPr>
-          <p:cNvPr id="5" name="TextBox 4"/>
+          <p:cNvPr id="4" name="TextBox 3"/>
           <p:cNvSpPr txBox="1"/>
           <p:nvPr/>
         </p:nvSpPr>
         <p:spPr>
           <a:xfrm>
-            <a:off x="723900" y="1984623"/>
+            <a:off x="723900" y="1814215"/>
             <a:ext cx="5916216" cy="662880"/>
           </a:xfrm>
           <a:prstGeom prst="rect">
@@ -10254,13 +10131,13 @@
       </p:sp>
       <p:sp>
         <p:nvSpPr>
-          <p:cNvPr id="6" name="Rounded Rectangle 5"/>
+          <p:cNvPr id="5" name="Rounded Rectangle 4"/>
           <p:cNvSpPr/>
           <p:nvPr/>
         </p:nvSpPr>
         <p:spPr>
           <a:xfrm>
-            <a:off x="719882" y="3034010"/>
+            <a:off x="719882" y="2863602"/>
             <a:ext cx="6120110" cy="3712815"/>
           </a:xfrm>
           <a:prstGeom prst="roundRect">
@@ -10297,13 +10174,13 @@
       </p:sp>
       <p:sp>
         <p:nvSpPr>
-          <p:cNvPr id="7" name="TextBox 6"/>
+          <p:cNvPr id="6" name="TextBox 5"/>
           <p:cNvSpPr txBox="1"/>
           <p:nvPr/>
         </p:nvSpPr>
         <p:spPr>
           <a:xfrm>
-            <a:off x="1043880" y="3358009"/>
+            <a:off x="1043880" y="3187601"/>
             <a:ext cx="1837372" cy="142875"/>
           </a:xfrm>
           <a:prstGeom prst="rect">
@@ -10336,13 +10213,13 @@
       </p:sp>
       <p:sp>
         <p:nvSpPr>
-          <p:cNvPr id="8" name="TextBox 7"/>
+          <p:cNvPr id="7" name="TextBox 6"/>
           <p:cNvSpPr txBox="1"/>
           <p:nvPr/>
         </p:nvSpPr>
         <p:spPr>
           <a:xfrm>
-            <a:off x="1043880" y="3601343"/>
+            <a:off x="1043880" y="3430935"/>
             <a:ext cx="1083278" cy="200025"/>
           </a:xfrm>
           <a:prstGeom prst="rect">
@@ -10375,13 +10252,13 @@
       </p:sp>
       <p:sp>
         <p:nvSpPr>
-          <p:cNvPr id="9" name="Rounded Rectangle 8"/>
+          <p:cNvPr id="8" name="Rounded Rectangle 7"/>
           <p:cNvSpPr/>
           <p:nvPr/>
         </p:nvSpPr>
         <p:spPr>
           <a:xfrm>
-            <a:off x="1043880" y="3975795"/>
+            <a:off x="1043880" y="3805386"/>
             <a:ext cx="5472112" cy="719733"/>
           </a:xfrm>
           <a:prstGeom prst="roundRect">
@@ -10418,13 +10295,13 @@
       </p:sp>
       <p:sp>
         <p:nvSpPr>
-          <p:cNvPr id="10" name="Rounded Rectangle 9"/>
+          <p:cNvPr id="9" name="Rounded Rectangle 8"/>
           <p:cNvSpPr/>
           <p:nvPr/>
         </p:nvSpPr>
         <p:spPr>
           <a:xfrm>
-            <a:off x="1223814" y="4155728"/>
+            <a:off x="1223814" y="3985320"/>
             <a:ext cx="359866" cy="359866"/>
           </a:xfrm>
           <a:prstGeom prst="roundRect">
@@ -10461,7 +10338,7 @@
       </p:sp>
       <p:pic>
         <p:nvPicPr>
-          <p:cNvPr id="11" name="Picture 10" descr="svg-4-0.png"/>
+          <p:cNvPr id="10" name="Picture 9" descr="svg-4-0.png"/>
           <p:cNvPicPr>
             <a:picLocks noChangeAspect="1"/>
           </p:cNvPicPr>
@@ -10475,7 +10352,7 @@
         </p:blipFill>
         <p:spPr>
           <a:xfrm>
-            <a:off x="1313706" y="4245620"/>
+            <a:off x="1313706" y="4075212"/>
             <a:ext cx="179933" cy="179933"/>
           </a:xfrm>
           <a:prstGeom prst="rect">
@@ -10485,13 +10362,13 @@
       </p:pic>
       <p:sp>
         <p:nvSpPr>
-          <p:cNvPr id="12" name="TextBox 11"/>
+          <p:cNvPr id="11" name="TextBox 10"/>
           <p:cNvSpPr txBox="1"/>
           <p:nvPr/>
         </p:nvSpPr>
         <p:spPr>
           <a:xfrm>
-            <a:off x="1727597" y="4234755"/>
+            <a:off x="1727597" y="4064347"/>
             <a:ext cx="1734693" cy="190500"/>
           </a:xfrm>
           <a:prstGeom prst="rect">
@@ -10524,13 +10401,13 @@
       </p:sp>
       <p:sp>
         <p:nvSpPr>
-          <p:cNvPr id="13" name="Rounded Rectangle 12"/>
+          <p:cNvPr id="12" name="Rounded Rectangle 11"/>
           <p:cNvSpPr/>
           <p:nvPr/>
         </p:nvSpPr>
         <p:spPr>
           <a:xfrm>
-            <a:off x="1043880" y="4839444"/>
+            <a:off x="1043880" y="4669036"/>
             <a:ext cx="5472112" cy="719733"/>
           </a:xfrm>
           <a:prstGeom prst="roundRect">
@@ -10567,13 +10444,13 @@
       </p:sp>
       <p:sp>
         <p:nvSpPr>
-          <p:cNvPr id="14" name="Rounded Rectangle 13"/>
+          <p:cNvPr id="13" name="Rounded Rectangle 12"/>
           <p:cNvSpPr/>
           <p:nvPr/>
         </p:nvSpPr>
         <p:spPr>
           <a:xfrm>
-            <a:off x="1223814" y="5019377"/>
+            <a:off x="1223814" y="4848969"/>
             <a:ext cx="359866" cy="359866"/>
           </a:xfrm>
           <a:prstGeom prst="roundRect">
@@ -10610,7 +10487,7 @@
       </p:sp>
       <p:pic>
         <p:nvPicPr>
-          <p:cNvPr id="15" name="Picture 14" descr="svg-4-1.png"/>
+          <p:cNvPr id="14" name="Picture 13" descr="svg-4-1.png"/>
           <p:cNvPicPr>
             <a:picLocks noChangeAspect="1"/>
           </p:cNvPicPr>
@@ -10624,7 +10501,7 @@
         </p:blipFill>
         <p:spPr>
           <a:xfrm>
-            <a:off x="1313706" y="5109270"/>
+            <a:off x="1313706" y="4938861"/>
             <a:ext cx="179933" cy="179933"/>
           </a:xfrm>
           <a:prstGeom prst="rect">
@@ -10634,13 +10511,13 @@
       </p:pic>
       <p:sp>
         <p:nvSpPr>
-          <p:cNvPr id="16" name="TextBox 15"/>
+          <p:cNvPr id="15" name="TextBox 14"/>
           <p:cNvSpPr txBox="1"/>
           <p:nvPr/>
         </p:nvSpPr>
         <p:spPr>
           <a:xfrm>
-            <a:off x="1727597" y="5098405"/>
+            <a:off x="1727597" y="4927997"/>
             <a:ext cx="1505831" cy="190500"/>
           </a:xfrm>
           <a:prstGeom prst="rect">
@@ -10673,13 +10550,13 @@
       </p:sp>
       <p:sp>
         <p:nvSpPr>
-          <p:cNvPr id="17" name="Rounded Rectangle 16"/>
+          <p:cNvPr id="16" name="Rounded Rectangle 15"/>
           <p:cNvSpPr/>
           <p:nvPr/>
         </p:nvSpPr>
         <p:spPr>
           <a:xfrm>
-            <a:off x="1043880" y="5703094"/>
+            <a:off x="1043880" y="5532686"/>
             <a:ext cx="5472112" cy="719733"/>
           </a:xfrm>
           <a:prstGeom prst="roundRect">
@@ -10716,13 +10593,13 @@
       </p:sp>
       <p:sp>
         <p:nvSpPr>
-          <p:cNvPr id="18" name="Rounded Rectangle 17"/>
+          <p:cNvPr id="17" name="Rounded Rectangle 16"/>
           <p:cNvSpPr/>
           <p:nvPr/>
         </p:nvSpPr>
         <p:spPr>
           <a:xfrm>
-            <a:off x="1223814" y="5883027"/>
+            <a:off x="1223814" y="5712619"/>
             <a:ext cx="359866" cy="359866"/>
           </a:xfrm>
           <a:prstGeom prst="roundRect">
@@ -10759,7 +10636,7 @@
       </p:sp>
       <p:pic>
         <p:nvPicPr>
-          <p:cNvPr id="19" name="Picture 18" descr="svg-4-2.png"/>
+          <p:cNvPr id="18" name="Picture 17" descr="svg-4-2.png"/>
           <p:cNvPicPr>
             <a:picLocks noChangeAspect="1"/>
           </p:cNvPicPr>
@@ -10773,7 +10650,7 @@
         </p:blipFill>
         <p:spPr>
           <a:xfrm>
-            <a:off x="1313706" y="5972919"/>
+            <a:off x="1313706" y="5802511"/>
             <a:ext cx="179933" cy="179933"/>
           </a:xfrm>
           <a:prstGeom prst="rect">
@@ -10783,13 +10660,13 @@
       </p:pic>
       <p:sp>
         <p:nvSpPr>
-          <p:cNvPr id="20" name="TextBox 19"/>
+          <p:cNvPr id="19" name="TextBox 18"/>
           <p:cNvSpPr txBox="1"/>
           <p:nvPr/>
         </p:nvSpPr>
         <p:spPr>
           <a:xfrm>
-            <a:off x="1727597" y="5962055"/>
+            <a:off x="1727597" y="5791646"/>
             <a:ext cx="1215962" cy="190500"/>
           </a:xfrm>
           <a:prstGeom prst="rect">
@@ -10822,7 +10699,7 @@
       </p:sp>
       <p:pic>
         <p:nvPicPr>
-          <p:cNvPr id="21" name="Picture 20" descr="academica.png"/>
+          <p:cNvPr id="20" name="Picture 19" descr="academica.png"/>
           <p:cNvPicPr>
             <a:picLocks noChangeAspect="1"/>
           </p:cNvPicPr>
@@ -10846,7 +10723,7 @@
       </p:pic>
       <p:sp>
         <p:nvSpPr>
-          <p:cNvPr id="22" name="TextBox 21"/>
+          <p:cNvPr id="21" name="TextBox 20"/>
           <p:cNvSpPr txBox="1"/>
           <p:nvPr/>
         </p:nvSpPr>

</xml_diff>

<commit_message>
Opbrengst: formatieve feedback zonder grafiek
Co-Authored-By: Claude Opus 5.5 <noreply@anthropic.com>
Claude-Session: https://claude.ai/code/session_011t24oNqE5E2i7wh7JuX2xs
</commit_message>
<xml_diff>
--- a/Design/Concepts/document/eduface-document-bewerkbaar.pptx
+++ b/Design/Concepts/document/eduface-document-bewerkbaar.pptx
@@ -7496,11 +7496,11 @@
         <p:spPr>
           <a:xfrm>
             <a:off x="719882" y="5010596"/>
-            <a:ext cx="6120110" cy="2527995"/>
+            <a:ext cx="6120110" cy="1534864"/>
           </a:xfrm>
           <a:prstGeom prst="roundRect">
             <a:avLst>
-              <a:gd name="adj" fmla="val 8544"/>
+              <a:gd name="adj" fmla="val 14072"/>
             </a:avLst>
           </a:prstGeom>
           <a:solidFill>
@@ -7677,380 +7677,13 @@
       </p:sp>
       <p:sp>
         <p:nvSpPr>
-          <p:cNvPr id="34" name="TextBox 33"/>
-          <p:cNvSpPr txBox="1"/>
-          <p:nvPr/>
-        </p:nvSpPr>
-        <p:spPr>
-          <a:xfrm>
-            <a:off x="1043880" y="6401395"/>
-            <a:ext cx="1176123" cy="152400"/>
-          </a:xfrm>
-          <a:prstGeom prst="rect">
-            <a:avLst/>
-          </a:prstGeom>
-          <a:noFill/>
-        </p:spPr>
-        <p:txBody>
-          <a:bodyPr wrap="square" anchor="t" lIns="0" rIns="0" tIns="0" bIns="0">
-            <a:noAutofit/>
-          </a:bodyPr>
-          <a:lstStyle/>
-          <a:p>
-            <a:pPr algn="l">
-              <a:lnSpc>
-                <a:spcPts val="1199"/>
-              </a:lnSpc>
-            </a:pPr>
-            <a:r>
-              <a:rPr sz="999" b="0">
-                <a:solidFill>
-                  <a:srgbClr val="555A78"/>
-                </a:solidFill>
-                <a:latin typeface="Inter"/>
-              </a:rPr>
-              <a:t>Nu, voor de helft</a:t>
-            </a:r>
-          </a:p>
-        </p:txBody>
-      </p:sp>
-      <p:sp>
-        <p:nvSpPr>
-          <p:cNvPr id="35" name="Rounded Rectangle 34"/>
+          <p:cNvPr id="34" name="Rounded Rectangle 33"/>
           <p:cNvSpPr/>
           <p:nvPr/>
         </p:nvSpPr>
         <p:spPr>
           <a:xfrm>
-            <a:off x="2411760" y="6423571"/>
-            <a:ext cx="3240435" cy="107900"/>
-          </a:xfrm>
-          <a:prstGeom prst="roundRect">
-            <a:avLst>
-              <a:gd name="adj" fmla="val 50000"/>
-            </a:avLst>
-          </a:prstGeom>
-          <a:solidFill>
-            <a:srgbClr val="FFFFFF"/>
-          </a:solidFill>
-          <a:ln>
-            <a:noFill/>
-          </a:ln>
-        </p:spPr>
-        <p:style>
-          <a:lnRef idx="1">
-            <a:schemeClr val="accent1"/>
-          </a:lnRef>
-          <a:fillRef idx="3">
-            <a:schemeClr val="accent1"/>
-          </a:fillRef>
-          <a:effectRef idx="0">
-            <a:schemeClr val="accent1"/>
-          </a:effectRef>
-          <a:fontRef idx="minor">
-            <a:schemeClr val="lt1"/>
-          </a:fontRef>
-        </p:style>
-        <p:txBody>
-          <a:bodyPr rtlCol="0" anchor="ctr"/>
-          <a:lstStyle/>
-          <a:p/>
-        </p:txBody>
-      </p:sp>
-      <p:sp>
-        <p:nvSpPr>
-          <p:cNvPr id="36" name="Rounded Rectangle 35"/>
-          <p:cNvSpPr/>
-          <p:nvPr/>
-        </p:nvSpPr>
-        <p:spPr>
-          <a:xfrm>
-            <a:off x="2411760" y="6423571"/>
-            <a:ext cx="1620143" cy="107900"/>
-          </a:xfrm>
-          <a:prstGeom prst="roundRect">
-            <a:avLst>
-              <a:gd name="adj" fmla="val 50000"/>
-            </a:avLst>
-          </a:prstGeom>
-          <a:solidFill>
-            <a:srgbClr val="D6D9EA"/>
-          </a:solidFill>
-          <a:ln>
-            <a:noFill/>
-          </a:ln>
-        </p:spPr>
-        <p:style>
-          <a:lnRef idx="1">
-            <a:schemeClr val="accent1"/>
-          </a:lnRef>
-          <a:fillRef idx="3">
-            <a:schemeClr val="accent1"/>
-          </a:fillRef>
-          <a:effectRef idx="0">
-            <a:schemeClr val="accent1"/>
-          </a:effectRef>
-          <a:fontRef idx="minor">
-            <a:schemeClr val="lt1"/>
-          </a:fontRef>
-        </p:style>
-        <p:txBody>
-          <a:bodyPr rtlCol="0" anchor="ctr"/>
-          <a:lstStyle/>
-          <a:p/>
-        </p:txBody>
-      </p:sp>
-      <p:sp>
-        <p:nvSpPr>
-          <p:cNvPr id="37" name="TextBox 36"/>
-          <p:cNvSpPr txBox="1"/>
-          <p:nvPr/>
-        </p:nvSpPr>
-        <p:spPr>
-          <a:xfrm>
-            <a:off x="5826764" y="6401395"/>
-            <a:ext cx="689229" cy="152400"/>
-          </a:xfrm>
-          <a:prstGeom prst="rect">
-            <a:avLst/>
-          </a:prstGeom>
-          <a:noFill/>
-        </p:spPr>
-        <p:txBody>
-          <a:bodyPr wrap="square" anchor="t" lIns="0" rIns="0" tIns="0" bIns="0">
-            <a:noAutofit/>
-          </a:bodyPr>
-          <a:lstStyle/>
-          <a:p>
-            <a:pPr algn="r">
-              <a:lnSpc>
-                <a:spcPts val="1199"/>
-              </a:lnSpc>
-            </a:pPr>
-            <a:r>
-              <a:rPr sz="999" b="1">
-                <a:solidFill>
-                  <a:srgbClr val="000326"/>
-                </a:solidFill>
-                <a:latin typeface="Inter"/>
-              </a:rPr>
-              <a:t>€ 36.000</a:t>
-            </a:r>
-          </a:p>
-        </p:txBody>
-      </p:sp>
-      <p:sp>
-        <p:nvSpPr>
-          <p:cNvPr id="38" name="TextBox 37"/>
-          <p:cNvSpPr txBox="1"/>
-          <p:nvPr/>
-        </p:nvSpPr>
-        <p:spPr>
-          <a:xfrm>
-            <a:off x="1043880" y="6679704"/>
-            <a:ext cx="1388983" cy="152400"/>
-          </a:xfrm>
-          <a:prstGeom prst="rect">
-            <a:avLst/>
-          </a:prstGeom>
-          <a:noFill/>
-        </p:spPr>
-        <p:txBody>
-          <a:bodyPr wrap="square" anchor="t" lIns="0" rIns="0" tIns="0" bIns="0">
-            <a:noAutofit/>
-          </a:bodyPr>
-          <a:lstStyle/>
-          <a:p>
-            <a:pPr algn="l">
-              <a:lnSpc>
-                <a:spcPts val="1199"/>
-              </a:lnSpc>
-            </a:pPr>
-            <a:r>
-              <a:rPr sz="999" b="1">
-                <a:solidFill>
-                  <a:srgbClr val="000326"/>
-                </a:solidFill>
-                <a:latin typeface="Inter"/>
-              </a:rPr>
-              <a:t>Voor alle studenten</a:t>
-            </a:r>
-          </a:p>
-        </p:txBody>
-      </p:sp>
-      <p:sp>
-        <p:nvSpPr>
-          <p:cNvPr id="39" name="Rounded Rectangle 38"/>
-          <p:cNvSpPr/>
-          <p:nvPr/>
-        </p:nvSpPr>
-        <p:spPr>
-          <a:xfrm>
-            <a:off x="2411760" y="6701879"/>
-            <a:ext cx="3240435" cy="107900"/>
-          </a:xfrm>
-          <a:prstGeom prst="roundRect">
-            <a:avLst>
-              <a:gd name="adj" fmla="val 50000"/>
-            </a:avLst>
-          </a:prstGeom>
-          <a:solidFill>
-            <a:srgbClr val="FFFFFF"/>
-          </a:solidFill>
-          <a:ln>
-            <a:noFill/>
-          </a:ln>
-        </p:spPr>
-        <p:style>
-          <a:lnRef idx="1">
-            <a:schemeClr val="accent1"/>
-          </a:lnRef>
-          <a:fillRef idx="3">
-            <a:schemeClr val="accent1"/>
-          </a:fillRef>
-          <a:effectRef idx="0">
-            <a:schemeClr val="accent1"/>
-          </a:effectRef>
-          <a:fontRef idx="minor">
-            <a:schemeClr val="lt1"/>
-          </a:fontRef>
-        </p:style>
-        <p:txBody>
-          <a:bodyPr rtlCol="0" anchor="ctr"/>
-          <a:lstStyle/>
-          <a:p/>
-        </p:txBody>
-      </p:sp>
-      <p:sp>
-        <p:nvSpPr>
-          <p:cNvPr id="40" name="Rounded Rectangle 39"/>
-          <p:cNvSpPr/>
-          <p:nvPr/>
-        </p:nvSpPr>
-        <p:spPr>
-          <a:xfrm>
-            <a:off x="2411760" y="6701879"/>
-            <a:ext cx="3240435" cy="107900"/>
-          </a:xfrm>
-          <a:prstGeom prst="roundRect">
-            <a:avLst>
-              <a:gd name="adj" fmla="val 50000"/>
-            </a:avLst>
-          </a:prstGeom>
-          <a:solidFill>
-            <a:srgbClr val="000326"/>
-          </a:solidFill>
-          <a:ln>
-            <a:noFill/>
-          </a:ln>
-        </p:spPr>
-        <p:style>
-          <a:lnRef idx="1">
-            <a:schemeClr val="accent1"/>
-          </a:lnRef>
-          <a:fillRef idx="3">
-            <a:schemeClr val="accent1"/>
-          </a:fillRef>
-          <a:effectRef idx="0">
-            <a:schemeClr val="accent1"/>
-          </a:effectRef>
-          <a:fontRef idx="minor">
-            <a:schemeClr val="lt1"/>
-          </a:fontRef>
-        </p:style>
-        <p:txBody>
-          <a:bodyPr rtlCol="0" anchor="ctr"/>
-          <a:lstStyle/>
-          <a:p/>
-        </p:txBody>
-      </p:sp>
-      <p:sp>
-        <p:nvSpPr>
-          <p:cNvPr id="41" name="TextBox 40"/>
-          <p:cNvSpPr txBox="1"/>
-          <p:nvPr/>
-        </p:nvSpPr>
-        <p:spPr>
-          <a:xfrm>
-            <a:off x="5833098" y="6679704"/>
-            <a:ext cx="682895" cy="152400"/>
-          </a:xfrm>
-          <a:prstGeom prst="rect">
-            <a:avLst/>
-          </a:prstGeom>
-          <a:noFill/>
-        </p:spPr>
-        <p:txBody>
-          <a:bodyPr wrap="square" anchor="t" lIns="0" rIns="0" tIns="0" bIns="0">
-            <a:noAutofit/>
-          </a:bodyPr>
-          <a:lstStyle/>
-          <a:p>
-            <a:pPr algn="r">
-              <a:lnSpc>
-                <a:spcPts val="1199"/>
-              </a:lnSpc>
-            </a:pPr>
-            <a:r>
-              <a:rPr sz="999" b="1">
-                <a:solidFill>
-                  <a:srgbClr val="000326"/>
-                </a:solidFill>
-                <a:latin typeface="Inter"/>
-              </a:rPr>
-              <a:t>€ 72.000</a:t>
-            </a:r>
-          </a:p>
-        </p:txBody>
-      </p:sp>
-      <p:sp>
-        <p:nvSpPr>
-          <p:cNvPr id="42" name="TextBox 41"/>
-          <p:cNvSpPr txBox="1"/>
-          <p:nvPr/>
-        </p:nvSpPr>
-        <p:spPr>
-          <a:xfrm>
-            <a:off x="1043880" y="7021562"/>
-            <a:ext cx="5694021" cy="171450"/>
-          </a:xfrm>
-          <a:prstGeom prst="rect">
-            <a:avLst/>
-          </a:prstGeom>
-          <a:noFill/>
-        </p:spPr>
-        <p:txBody>
-          <a:bodyPr wrap="square" anchor="t" lIns="0" rIns="0" tIns="0" bIns="0">
-            <a:noAutofit/>
-          </a:bodyPr>
-          <a:lstStyle/>
-          <a:p>
-            <a:pPr algn="l">
-              <a:lnSpc>
-                <a:spcPts val="1595"/>
-              </a:lnSpc>
-            </a:pPr>
-            <a:r>
-              <a:rPr sz="1100" b="1">
-                <a:solidFill>
-                  <a:srgbClr val="000326"/>
-                </a:solidFill>
-                <a:latin typeface="Inter"/>
-              </a:rPr>
-              <a:t>De feitelijke kosten om iedereen te bedienen liggen dus twee keer zo hoog.</a:t>
-            </a:r>
-          </a:p>
-        </p:txBody>
-      </p:sp>
-      <p:sp>
-        <p:nvSpPr>
-          <p:cNvPr id="43" name="Rounded Rectangle 42"/>
-          <p:cNvSpPr/>
-          <p:nvPr/>
-        </p:nvSpPr>
-        <p:spPr>
-          <a:xfrm>
-            <a:off x="719882" y="7754541"/>
+            <a:off x="719882" y="6761411"/>
             <a:ext cx="6120110" cy="1553914"/>
           </a:xfrm>
           <a:prstGeom prst="roundRect">
@@ -8087,13 +7720,13 @@
       </p:sp>
       <p:sp>
         <p:nvSpPr>
-          <p:cNvPr id="44" name="Rounded Rectangle 43"/>
+          <p:cNvPr id="35" name="Rounded Rectangle 34"/>
           <p:cNvSpPr/>
           <p:nvPr/>
         </p:nvSpPr>
         <p:spPr>
           <a:xfrm>
-            <a:off x="1053405" y="8088064"/>
+            <a:off x="1053405" y="7094934"/>
             <a:ext cx="359866" cy="359866"/>
           </a:xfrm>
           <a:prstGeom prst="roundRect">
@@ -8130,7 +7763,7 @@
       </p:sp>
       <p:pic>
         <p:nvPicPr>
-          <p:cNvPr id="45" name="Picture 44" descr="svg-2-2.png"/>
+          <p:cNvPr id="36" name="Picture 35" descr="svg-2-2.png"/>
           <p:cNvPicPr>
             <a:picLocks noChangeAspect="1"/>
           </p:cNvPicPr>
@@ -8144,7 +7777,7 @@
         </p:blipFill>
         <p:spPr>
           <a:xfrm>
-            <a:off x="1143298" y="8177957"/>
+            <a:off x="1143298" y="7184827"/>
             <a:ext cx="179933" cy="179933"/>
           </a:xfrm>
           <a:prstGeom prst="rect">
@@ -8154,13 +7787,13 @@
       </p:pic>
       <p:sp>
         <p:nvSpPr>
-          <p:cNvPr id="46" name="TextBox 45"/>
+          <p:cNvPr id="37" name="TextBox 36"/>
           <p:cNvSpPr txBox="1"/>
           <p:nvPr/>
         </p:nvSpPr>
         <p:spPr>
           <a:xfrm>
-            <a:off x="1557189" y="8166943"/>
+            <a:off x="1557189" y="7173813"/>
             <a:ext cx="2374440" cy="200025"/>
           </a:xfrm>
           <a:prstGeom prst="rect">
@@ -8193,13 +7826,13 @@
       </p:sp>
       <p:sp>
         <p:nvSpPr>
-          <p:cNvPr id="47" name="TextBox 46"/>
+          <p:cNvPr id="38" name="TextBox 37"/>
           <p:cNvSpPr txBox="1"/>
           <p:nvPr/>
         </p:nvSpPr>
         <p:spPr>
           <a:xfrm>
-            <a:off x="1053405" y="8574881"/>
+            <a:off x="1053405" y="7581751"/>
             <a:ext cx="4892873" cy="381000"/>
           </a:xfrm>
           <a:prstGeom prst="rect">
@@ -8232,7 +7865,7 @@
       </p:sp>
       <p:pic>
         <p:nvPicPr>
-          <p:cNvPr id="48" name="Picture 47" descr="academica.png"/>
+          <p:cNvPr id="39" name="Picture 38" descr="academica.png"/>
           <p:cNvPicPr>
             <a:picLocks noChangeAspect="1"/>
           </p:cNvPicPr>
@@ -8256,7 +7889,7 @@
       </p:pic>
       <p:sp>
         <p:nvSpPr>
-          <p:cNvPr id="49" name="TextBox 48"/>
+          <p:cNvPr id="40" name="TextBox 39"/>
           <p:cNvSpPr txBox="1"/>
           <p:nvPr/>
         </p:nvSpPr>

</xml_diff>

<commit_message>
Voorstel: poppetjes in plaats van stippen, lege met rand
Co-Authored-By: Claude Opus 5.5 <noreply@anthropic.com>
Claude-Session: https://claude.ai/code/session_011t24oNqE5E2i7wh7JuX2xs
</commit_message>
<xml_diff>
--- a/Design/Concepts/document/eduface-document-bewerkbaar.pptx
+++ b/Design/Concepts/document/eduface-document-bewerkbaar.pptx
@@ -3299,11 +3299,11 @@
         <p:spPr>
           <a:xfrm>
             <a:off x="719882" y="3893790"/>
-            <a:ext cx="2952006" cy="2296567"/>
+            <a:ext cx="2952006" cy="2345531"/>
           </a:xfrm>
           <a:prstGeom prst="roundRect">
             <a:avLst>
-              <a:gd name="adj" fmla="val 9405"/>
+              <a:gd name="adj" fmla="val 9209"/>
             </a:avLst>
           </a:prstGeom>
           <a:noFill/>
@@ -3450,846 +3450,486 @@
           </a:p>
         </p:txBody>
       </p:sp>
-      <p:sp>
-        <p:nvSpPr>
-          <p:cNvPr id="11" name="Oval 10"/>
-          <p:cNvSpPr/>
-          <p:nvPr/>
-        </p:nvSpPr>
+      <p:pic>
+        <p:nvPicPr>
+          <p:cNvPr id="11" name="Picture 10" descr="svg-0-0.png"/>
+          <p:cNvPicPr>
+            <a:picLocks noChangeAspect="1"/>
+          </p:cNvPicPr>
+          <p:nvPr/>
+        </p:nvPicPr>
+        <p:blipFill>
+          <a:blip r:embed="rId2"/>
+          <a:stretch>
+            <a:fillRect/>
+          </a:stretch>
+        </p:blipFill>
         <p:spPr>
           <a:xfrm>
             <a:off x="1053405" y="5468689"/>
-            <a:ext cx="150912" cy="150912"/>
-          </a:xfrm>
-          <a:prstGeom prst="ellipse">
-            <a:avLst/>
-          </a:prstGeom>
-          <a:solidFill>
-            <a:srgbClr val="000326"/>
-          </a:solidFill>
-          <a:ln w="9525">
-            <a:solidFill>
-              <a:srgbClr val="000326"/>
-            </a:solidFill>
-          </a:ln>
-        </p:spPr>
-        <p:style>
-          <a:lnRef idx="1">
-            <a:schemeClr val="accent1"/>
-          </a:lnRef>
-          <a:fillRef idx="3">
-            <a:schemeClr val="accent1"/>
-          </a:fillRef>
-          <a:effectRef idx="0">
-            <a:schemeClr val="accent1"/>
-          </a:effectRef>
-          <a:fontRef idx="minor">
-            <a:schemeClr val="lt1"/>
-          </a:fontRef>
-        </p:style>
-        <p:txBody>
-          <a:bodyPr rtlCol="0" anchor="ctr"/>
-          <a:lstStyle/>
-          <a:p/>
-        </p:txBody>
-      </p:sp>
-      <p:sp>
-        <p:nvSpPr>
-          <p:cNvPr id="12" name="Oval 11"/>
-          <p:cNvSpPr/>
-          <p:nvPr/>
-        </p:nvSpPr>
-        <p:spPr>
-          <a:xfrm>
-            <a:off x="1290638" y="5468689"/>
-            <a:ext cx="150912" cy="150912"/>
-          </a:xfrm>
-          <a:prstGeom prst="ellipse">
-            <a:avLst/>
-          </a:prstGeom>
-          <a:solidFill>
-            <a:srgbClr val="000326"/>
-          </a:solidFill>
-          <a:ln w="9525">
-            <a:solidFill>
-              <a:srgbClr val="000326"/>
-            </a:solidFill>
-          </a:ln>
-        </p:spPr>
-        <p:style>
-          <a:lnRef idx="1">
-            <a:schemeClr val="accent1"/>
-          </a:lnRef>
-          <a:fillRef idx="3">
-            <a:schemeClr val="accent1"/>
-          </a:fillRef>
-          <a:effectRef idx="0">
-            <a:schemeClr val="accent1"/>
-          </a:effectRef>
-          <a:fontRef idx="minor">
-            <a:schemeClr val="lt1"/>
-          </a:fontRef>
-        </p:style>
-        <p:txBody>
-          <a:bodyPr rtlCol="0" anchor="ctr"/>
-          <a:lstStyle/>
-          <a:p/>
-        </p:txBody>
-      </p:sp>
-      <p:sp>
-        <p:nvSpPr>
-          <p:cNvPr id="13" name="Oval 12"/>
-          <p:cNvSpPr/>
-          <p:nvPr/>
-        </p:nvSpPr>
-        <p:spPr>
-          <a:xfrm>
-            <a:off x="1527870" y="5468689"/>
-            <a:ext cx="150912" cy="150912"/>
-          </a:xfrm>
-          <a:prstGeom prst="ellipse">
-            <a:avLst/>
-          </a:prstGeom>
-          <a:solidFill>
-            <a:srgbClr val="000326"/>
-          </a:solidFill>
-          <a:ln w="9525">
-            <a:solidFill>
-              <a:srgbClr val="000326"/>
-            </a:solidFill>
-          </a:ln>
-        </p:spPr>
-        <p:style>
-          <a:lnRef idx="1">
-            <a:schemeClr val="accent1"/>
-          </a:lnRef>
-          <a:fillRef idx="3">
-            <a:schemeClr val="accent1"/>
-          </a:fillRef>
-          <a:effectRef idx="0">
-            <a:schemeClr val="accent1"/>
-          </a:effectRef>
-          <a:fontRef idx="minor">
-            <a:schemeClr val="lt1"/>
-          </a:fontRef>
-        </p:style>
-        <p:txBody>
-          <a:bodyPr rtlCol="0" anchor="ctr"/>
-          <a:lstStyle/>
-          <a:p/>
-        </p:txBody>
-      </p:sp>
-      <p:sp>
-        <p:nvSpPr>
-          <p:cNvPr id="14" name="Oval 13"/>
-          <p:cNvSpPr/>
-          <p:nvPr/>
-        </p:nvSpPr>
-        <p:spPr>
-          <a:xfrm>
-            <a:off x="1765102" y="5468689"/>
-            <a:ext cx="150912" cy="150912"/>
-          </a:xfrm>
-          <a:prstGeom prst="ellipse">
-            <a:avLst/>
-          </a:prstGeom>
-          <a:solidFill>
-            <a:srgbClr val="000326"/>
-          </a:solidFill>
-          <a:ln w="9525">
-            <a:solidFill>
-              <a:srgbClr val="000326"/>
-            </a:solidFill>
-          </a:ln>
-        </p:spPr>
-        <p:style>
-          <a:lnRef idx="1">
-            <a:schemeClr val="accent1"/>
-          </a:lnRef>
-          <a:fillRef idx="3">
-            <a:schemeClr val="accent1"/>
-          </a:fillRef>
-          <a:effectRef idx="0">
-            <a:schemeClr val="accent1"/>
-          </a:effectRef>
-          <a:fontRef idx="minor">
-            <a:schemeClr val="lt1"/>
-          </a:fontRef>
-        </p:style>
-        <p:txBody>
-          <a:bodyPr rtlCol="0" anchor="ctr"/>
-          <a:lstStyle/>
-          <a:p/>
-        </p:txBody>
-      </p:sp>
-      <p:sp>
-        <p:nvSpPr>
-          <p:cNvPr id="15" name="Oval 14"/>
-          <p:cNvSpPr/>
-          <p:nvPr/>
-        </p:nvSpPr>
-        <p:spPr>
-          <a:xfrm>
-            <a:off x="2002334" y="5468689"/>
-            <a:ext cx="150912" cy="150912"/>
-          </a:xfrm>
-          <a:prstGeom prst="ellipse">
-            <a:avLst/>
-          </a:prstGeom>
-          <a:solidFill>
-            <a:srgbClr val="000326"/>
-          </a:solidFill>
-          <a:ln w="9525">
-            <a:solidFill>
-              <a:srgbClr val="000326"/>
-            </a:solidFill>
-          </a:ln>
-        </p:spPr>
-        <p:style>
-          <a:lnRef idx="1">
-            <a:schemeClr val="accent1"/>
-          </a:lnRef>
-          <a:fillRef idx="3">
-            <a:schemeClr val="accent1"/>
-          </a:fillRef>
-          <a:effectRef idx="0">
-            <a:schemeClr val="accent1"/>
-          </a:effectRef>
-          <a:fontRef idx="minor">
-            <a:schemeClr val="lt1"/>
-          </a:fontRef>
-        </p:style>
-        <p:txBody>
-          <a:bodyPr rtlCol="0" anchor="ctr"/>
-          <a:lstStyle/>
-          <a:p/>
-        </p:txBody>
-      </p:sp>
-      <p:sp>
-        <p:nvSpPr>
-          <p:cNvPr id="16" name="Oval 15"/>
-          <p:cNvSpPr/>
-          <p:nvPr/>
-        </p:nvSpPr>
-        <p:spPr>
-          <a:xfrm>
-            <a:off x="2239566" y="5468689"/>
-            <a:ext cx="150912" cy="150912"/>
-          </a:xfrm>
-          <a:prstGeom prst="ellipse">
-            <a:avLst/>
-          </a:prstGeom>
-          <a:solidFill>
-            <a:srgbClr val="000326"/>
-          </a:solidFill>
-          <a:ln w="9525">
-            <a:solidFill>
-              <a:srgbClr val="000326"/>
-            </a:solidFill>
-          </a:ln>
-        </p:spPr>
-        <p:style>
-          <a:lnRef idx="1">
-            <a:schemeClr val="accent1"/>
-          </a:lnRef>
-          <a:fillRef idx="3">
-            <a:schemeClr val="accent1"/>
-          </a:fillRef>
-          <a:effectRef idx="0">
-            <a:schemeClr val="accent1"/>
-          </a:effectRef>
-          <a:fontRef idx="minor">
-            <a:schemeClr val="lt1"/>
-          </a:fontRef>
-        </p:style>
-        <p:txBody>
-          <a:bodyPr rtlCol="0" anchor="ctr"/>
-          <a:lstStyle/>
-          <a:p/>
-        </p:txBody>
-      </p:sp>
-      <p:sp>
-        <p:nvSpPr>
-          <p:cNvPr id="17" name="Oval 16"/>
-          <p:cNvSpPr/>
-          <p:nvPr/>
-        </p:nvSpPr>
-        <p:spPr>
-          <a:xfrm>
-            <a:off x="2476798" y="5468689"/>
-            <a:ext cx="150912" cy="150912"/>
-          </a:xfrm>
-          <a:prstGeom prst="ellipse">
-            <a:avLst/>
-          </a:prstGeom>
-          <a:solidFill>
-            <a:srgbClr val="000326"/>
-          </a:solidFill>
-          <a:ln w="9525">
-            <a:solidFill>
-              <a:srgbClr val="000326"/>
-            </a:solidFill>
-          </a:ln>
-        </p:spPr>
-        <p:style>
-          <a:lnRef idx="1">
-            <a:schemeClr val="accent1"/>
-          </a:lnRef>
-          <a:fillRef idx="3">
-            <a:schemeClr val="accent1"/>
-          </a:fillRef>
-          <a:effectRef idx="0">
-            <a:schemeClr val="accent1"/>
-          </a:effectRef>
-          <a:fontRef idx="minor">
-            <a:schemeClr val="lt1"/>
-          </a:fontRef>
-        </p:style>
-        <p:txBody>
-          <a:bodyPr rtlCol="0" anchor="ctr"/>
-          <a:lstStyle/>
-          <a:p/>
-        </p:txBody>
-      </p:sp>
-      <p:sp>
-        <p:nvSpPr>
-          <p:cNvPr id="18" name="Oval 17"/>
-          <p:cNvSpPr/>
-          <p:nvPr/>
-        </p:nvSpPr>
-        <p:spPr>
-          <a:xfrm>
-            <a:off x="2714030" y="5468689"/>
-            <a:ext cx="150912" cy="150912"/>
-          </a:xfrm>
-          <a:prstGeom prst="ellipse">
-            <a:avLst/>
-          </a:prstGeom>
-          <a:solidFill>
-            <a:srgbClr val="000326"/>
-          </a:solidFill>
-          <a:ln w="9525">
-            <a:solidFill>
-              <a:srgbClr val="000326"/>
-            </a:solidFill>
-          </a:ln>
-        </p:spPr>
-        <p:style>
-          <a:lnRef idx="1">
-            <a:schemeClr val="accent1"/>
-          </a:lnRef>
-          <a:fillRef idx="3">
-            <a:schemeClr val="accent1"/>
-          </a:fillRef>
-          <a:effectRef idx="0">
-            <a:schemeClr val="accent1"/>
-          </a:effectRef>
-          <a:fontRef idx="minor">
-            <a:schemeClr val="lt1"/>
-          </a:fontRef>
-        </p:style>
-        <p:txBody>
-          <a:bodyPr rtlCol="0" anchor="ctr"/>
-          <a:lstStyle/>
-          <a:p/>
-        </p:txBody>
-      </p:sp>
-      <p:sp>
-        <p:nvSpPr>
-          <p:cNvPr id="19" name="Oval 18"/>
-          <p:cNvSpPr/>
-          <p:nvPr/>
-        </p:nvSpPr>
-        <p:spPr>
-          <a:xfrm>
-            <a:off x="2951262" y="5468689"/>
-            <a:ext cx="150912" cy="150912"/>
-          </a:xfrm>
-          <a:prstGeom prst="ellipse">
-            <a:avLst/>
-          </a:prstGeom>
-          <a:solidFill>
-            <a:srgbClr val="000326"/>
-          </a:solidFill>
-          <a:ln w="9525">
-            <a:solidFill>
-              <a:srgbClr val="000326"/>
-            </a:solidFill>
-          </a:ln>
-        </p:spPr>
-        <p:style>
-          <a:lnRef idx="1">
-            <a:schemeClr val="accent1"/>
-          </a:lnRef>
-          <a:fillRef idx="3">
-            <a:schemeClr val="accent1"/>
-          </a:fillRef>
-          <a:effectRef idx="0">
-            <a:schemeClr val="accent1"/>
-          </a:effectRef>
-          <a:fontRef idx="minor">
-            <a:schemeClr val="lt1"/>
-          </a:fontRef>
-        </p:style>
-        <p:txBody>
-          <a:bodyPr rtlCol="0" anchor="ctr"/>
-          <a:lstStyle/>
-          <a:p/>
-        </p:txBody>
-      </p:sp>
-      <p:sp>
-        <p:nvSpPr>
-          <p:cNvPr id="20" name="Oval 19"/>
-          <p:cNvSpPr/>
-          <p:nvPr/>
-        </p:nvSpPr>
-        <p:spPr>
-          <a:xfrm>
-            <a:off x="3188494" y="5468689"/>
-            <a:ext cx="150912" cy="150912"/>
-          </a:xfrm>
-          <a:prstGeom prst="ellipse">
-            <a:avLst/>
-          </a:prstGeom>
-          <a:solidFill>
-            <a:srgbClr val="000326"/>
-          </a:solidFill>
-          <a:ln w="9525">
-            <a:solidFill>
-              <a:srgbClr val="000326"/>
-            </a:solidFill>
-          </a:ln>
-        </p:spPr>
-        <p:style>
-          <a:lnRef idx="1">
-            <a:schemeClr val="accent1"/>
-          </a:lnRef>
-          <a:fillRef idx="3">
-            <a:schemeClr val="accent1"/>
-          </a:fillRef>
-          <a:effectRef idx="0">
-            <a:schemeClr val="accent1"/>
-          </a:effectRef>
-          <a:fontRef idx="minor">
-            <a:schemeClr val="lt1"/>
-          </a:fontRef>
-        </p:style>
-        <p:txBody>
-          <a:bodyPr rtlCol="0" anchor="ctr"/>
-          <a:lstStyle/>
-          <a:p/>
-        </p:txBody>
-      </p:sp>
-      <p:sp>
-        <p:nvSpPr>
-          <p:cNvPr id="21" name="Oval 20"/>
-          <p:cNvSpPr/>
-          <p:nvPr/>
-        </p:nvSpPr>
-        <p:spPr>
-          <a:xfrm>
-            <a:off x="1053405" y="5705921"/>
-            <a:ext cx="150912" cy="150912"/>
-          </a:xfrm>
-          <a:prstGeom prst="ellipse">
-            <a:avLst/>
-          </a:prstGeom>
-          <a:noFill/>
-          <a:ln w="9525">
-            <a:solidFill>
-              <a:srgbClr val="D6D9EA"/>
-            </a:solidFill>
-          </a:ln>
-        </p:spPr>
-        <p:style>
-          <a:lnRef idx="1">
-            <a:schemeClr val="accent1"/>
-          </a:lnRef>
-          <a:fillRef idx="3">
-            <a:schemeClr val="accent1"/>
-          </a:fillRef>
-          <a:effectRef idx="0">
-            <a:schemeClr val="accent1"/>
-          </a:effectRef>
-          <a:fontRef idx="minor">
-            <a:schemeClr val="lt1"/>
-          </a:fontRef>
-        </p:style>
-        <p:txBody>
-          <a:bodyPr rtlCol="0" anchor="ctr"/>
-          <a:lstStyle/>
-          <a:p/>
-        </p:txBody>
-      </p:sp>
-      <p:sp>
-        <p:nvSpPr>
-          <p:cNvPr id="22" name="Oval 21"/>
-          <p:cNvSpPr/>
-          <p:nvPr/>
-        </p:nvSpPr>
-        <p:spPr>
-          <a:xfrm>
-            <a:off x="1290638" y="5705921"/>
-            <a:ext cx="150912" cy="150912"/>
-          </a:xfrm>
-          <a:prstGeom prst="ellipse">
-            <a:avLst/>
-          </a:prstGeom>
-          <a:noFill/>
-          <a:ln w="9525">
-            <a:solidFill>
-              <a:srgbClr val="D6D9EA"/>
-            </a:solidFill>
-          </a:ln>
-        </p:spPr>
-        <p:style>
-          <a:lnRef idx="1">
-            <a:schemeClr val="accent1"/>
-          </a:lnRef>
-          <a:fillRef idx="3">
-            <a:schemeClr val="accent1"/>
-          </a:fillRef>
-          <a:effectRef idx="0">
-            <a:schemeClr val="accent1"/>
-          </a:effectRef>
-          <a:fontRef idx="minor">
-            <a:schemeClr val="lt1"/>
-          </a:fontRef>
-        </p:style>
-        <p:txBody>
-          <a:bodyPr rtlCol="0" anchor="ctr"/>
-          <a:lstStyle/>
-          <a:p/>
-        </p:txBody>
-      </p:sp>
-      <p:sp>
-        <p:nvSpPr>
-          <p:cNvPr id="23" name="Oval 22"/>
-          <p:cNvSpPr/>
-          <p:nvPr/>
-        </p:nvSpPr>
-        <p:spPr>
-          <a:xfrm>
-            <a:off x="1527870" y="5705921"/>
-            <a:ext cx="150912" cy="150912"/>
-          </a:xfrm>
-          <a:prstGeom prst="ellipse">
-            <a:avLst/>
-          </a:prstGeom>
-          <a:noFill/>
-          <a:ln w="9525">
-            <a:solidFill>
-              <a:srgbClr val="D6D9EA"/>
-            </a:solidFill>
-          </a:ln>
-        </p:spPr>
-        <p:style>
-          <a:lnRef idx="1">
-            <a:schemeClr val="accent1"/>
-          </a:lnRef>
-          <a:fillRef idx="3">
-            <a:schemeClr val="accent1"/>
-          </a:fillRef>
-          <a:effectRef idx="0">
-            <a:schemeClr val="accent1"/>
-          </a:effectRef>
-          <a:fontRef idx="minor">
-            <a:schemeClr val="lt1"/>
-          </a:fontRef>
-        </p:style>
-        <p:txBody>
-          <a:bodyPr rtlCol="0" anchor="ctr"/>
-          <a:lstStyle/>
-          <a:p/>
-        </p:txBody>
-      </p:sp>
-      <p:sp>
-        <p:nvSpPr>
-          <p:cNvPr id="24" name="Oval 23"/>
-          <p:cNvSpPr/>
-          <p:nvPr/>
-        </p:nvSpPr>
-        <p:spPr>
-          <a:xfrm>
-            <a:off x="1765102" y="5705921"/>
-            <a:ext cx="150912" cy="150912"/>
-          </a:xfrm>
-          <a:prstGeom prst="ellipse">
-            <a:avLst/>
-          </a:prstGeom>
-          <a:noFill/>
-          <a:ln w="9525">
-            <a:solidFill>
-              <a:srgbClr val="D6D9EA"/>
-            </a:solidFill>
-          </a:ln>
-        </p:spPr>
-        <p:style>
-          <a:lnRef idx="1">
-            <a:schemeClr val="accent1"/>
-          </a:lnRef>
-          <a:fillRef idx="3">
-            <a:schemeClr val="accent1"/>
-          </a:fillRef>
-          <a:effectRef idx="0">
-            <a:schemeClr val="accent1"/>
-          </a:effectRef>
-          <a:fontRef idx="minor">
-            <a:schemeClr val="lt1"/>
-          </a:fontRef>
-        </p:style>
-        <p:txBody>
-          <a:bodyPr rtlCol="0" anchor="ctr"/>
-          <a:lstStyle/>
-          <a:p/>
-        </p:txBody>
-      </p:sp>
-      <p:sp>
-        <p:nvSpPr>
-          <p:cNvPr id="25" name="Oval 24"/>
-          <p:cNvSpPr/>
-          <p:nvPr/>
-        </p:nvSpPr>
-        <p:spPr>
-          <a:xfrm>
-            <a:off x="2002334" y="5705921"/>
-            <a:ext cx="150912" cy="150912"/>
-          </a:xfrm>
-          <a:prstGeom prst="ellipse">
-            <a:avLst/>
-          </a:prstGeom>
-          <a:noFill/>
-          <a:ln w="9525">
-            <a:solidFill>
-              <a:srgbClr val="D6D9EA"/>
-            </a:solidFill>
-          </a:ln>
-        </p:spPr>
-        <p:style>
-          <a:lnRef idx="1">
-            <a:schemeClr val="accent1"/>
-          </a:lnRef>
-          <a:fillRef idx="3">
-            <a:schemeClr val="accent1"/>
-          </a:fillRef>
-          <a:effectRef idx="0">
-            <a:schemeClr val="accent1"/>
-          </a:effectRef>
-          <a:fontRef idx="minor">
-            <a:schemeClr val="lt1"/>
-          </a:fontRef>
-        </p:style>
-        <p:txBody>
-          <a:bodyPr rtlCol="0" anchor="ctr"/>
-          <a:lstStyle/>
-          <a:p/>
-        </p:txBody>
-      </p:sp>
-      <p:sp>
-        <p:nvSpPr>
-          <p:cNvPr id="26" name="Oval 25"/>
-          <p:cNvSpPr/>
-          <p:nvPr/>
-        </p:nvSpPr>
-        <p:spPr>
-          <a:xfrm>
-            <a:off x="2239566" y="5705921"/>
-            <a:ext cx="150912" cy="150912"/>
-          </a:xfrm>
-          <a:prstGeom prst="ellipse">
-            <a:avLst/>
-          </a:prstGeom>
-          <a:noFill/>
-          <a:ln w="9525">
-            <a:solidFill>
-              <a:srgbClr val="D6D9EA"/>
-            </a:solidFill>
-          </a:ln>
-        </p:spPr>
-        <p:style>
-          <a:lnRef idx="1">
-            <a:schemeClr val="accent1"/>
-          </a:lnRef>
-          <a:fillRef idx="3">
-            <a:schemeClr val="accent1"/>
-          </a:fillRef>
-          <a:effectRef idx="0">
-            <a:schemeClr val="accent1"/>
-          </a:effectRef>
-          <a:fontRef idx="minor">
-            <a:schemeClr val="lt1"/>
-          </a:fontRef>
-        </p:style>
-        <p:txBody>
-          <a:bodyPr rtlCol="0" anchor="ctr"/>
-          <a:lstStyle/>
-          <a:p/>
-        </p:txBody>
-      </p:sp>
-      <p:sp>
-        <p:nvSpPr>
-          <p:cNvPr id="27" name="Oval 26"/>
-          <p:cNvSpPr/>
-          <p:nvPr/>
-        </p:nvSpPr>
-        <p:spPr>
-          <a:xfrm>
-            <a:off x="2476798" y="5705921"/>
-            <a:ext cx="150912" cy="150912"/>
-          </a:xfrm>
-          <a:prstGeom prst="ellipse">
-            <a:avLst/>
-          </a:prstGeom>
-          <a:noFill/>
-          <a:ln w="9525">
-            <a:solidFill>
-              <a:srgbClr val="D6D9EA"/>
-            </a:solidFill>
-          </a:ln>
-        </p:spPr>
-        <p:style>
-          <a:lnRef idx="1">
-            <a:schemeClr val="accent1"/>
-          </a:lnRef>
-          <a:fillRef idx="3">
-            <a:schemeClr val="accent1"/>
-          </a:fillRef>
-          <a:effectRef idx="0">
-            <a:schemeClr val="accent1"/>
-          </a:effectRef>
-          <a:fontRef idx="minor">
-            <a:schemeClr val="lt1"/>
-          </a:fontRef>
-        </p:style>
-        <p:txBody>
-          <a:bodyPr rtlCol="0" anchor="ctr"/>
-          <a:lstStyle/>
-          <a:p/>
-        </p:txBody>
-      </p:sp>
-      <p:sp>
-        <p:nvSpPr>
-          <p:cNvPr id="28" name="Oval 27"/>
-          <p:cNvSpPr/>
-          <p:nvPr/>
-        </p:nvSpPr>
-        <p:spPr>
-          <a:xfrm>
-            <a:off x="2714030" y="5705921"/>
-            <a:ext cx="150912" cy="150912"/>
-          </a:xfrm>
-          <a:prstGeom prst="ellipse">
-            <a:avLst/>
-          </a:prstGeom>
-          <a:noFill/>
-          <a:ln w="9525">
-            <a:solidFill>
-              <a:srgbClr val="D6D9EA"/>
-            </a:solidFill>
-          </a:ln>
-        </p:spPr>
-        <p:style>
-          <a:lnRef idx="1">
-            <a:schemeClr val="accent1"/>
-          </a:lnRef>
-          <a:fillRef idx="3">
-            <a:schemeClr val="accent1"/>
-          </a:fillRef>
-          <a:effectRef idx="0">
-            <a:schemeClr val="accent1"/>
-          </a:effectRef>
-          <a:fontRef idx="minor">
-            <a:schemeClr val="lt1"/>
-          </a:fontRef>
-        </p:style>
-        <p:txBody>
-          <a:bodyPr rtlCol="0" anchor="ctr"/>
-          <a:lstStyle/>
-          <a:p/>
-        </p:txBody>
-      </p:sp>
-      <p:sp>
-        <p:nvSpPr>
-          <p:cNvPr id="29" name="Oval 28"/>
-          <p:cNvSpPr/>
-          <p:nvPr/>
-        </p:nvSpPr>
-        <p:spPr>
-          <a:xfrm>
-            <a:off x="2951262" y="5705921"/>
-            <a:ext cx="150912" cy="150912"/>
-          </a:xfrm>
-          <a:prstGeom prst="ellipse">
-            <a:avLst/>
-          </a:prstGeom>
-          <a:noFill/>
-          <a:ln w="9525">
-            <a:solidFill>
-              <a:srgbClr val="D6D9EA"/>
-            </a:solidFill>
-          </a:ln>
-        </p:spPr>
-        <p:style>
-          <a:lnRef idx="1">
-            <a:schemeClr val="accent1"/>
-          </a:lnRef>
-          <a:fillRef idx="3">
-            <a:schemeClr val="accent1"/>
-          </a:fillRef>
-          <a:effectRef idx="0">
-            <a:schemeClr val="accent1"/>
-          </a:effectRef>
-          <a:fontRef idx="minor">
-            <a:schemeClr val="lt1"/>
-          </a:fontRef>
-        </p:style>
-        <p:txBody>
-          <a:bodyPr rtlCol="0" anchor="ctr"/>
-          <a:lstStyle/>
-          <a:p/>
-        </p:txBody>
-      </p:sp>
-      <p:sp>
-        <p:nvSpPr>
-          <p:cNvPr id="30" name="Oval 29"/>
-          <p:cNvSpPr/>
-          <p:nvPr/>
-        </p:nvSpPr>
-        <p:spPr>
-          <a:xfrm>
-            <a:off x="3188494" y="5705921"/>
-            <a:ext cx="150912" cy="150912"/>
-          </a:xfrm>
-          <a:prstGeom prst="ellipse">
-            <a:avLst/>
-          </a:prstGeom>
-          <a:noFill/>
-          <a:ln w="9525">
-            <a:solidFill>
-              <a:srgbClr val="D6D9EA"/>
-            </a:solidFill>
-          </a:ln>
-        </p:spPr>
-        <p:style>
-          <a:lnRef idx="1">
-            <a:schemeClr val="accent1"/>
-          </a:lnRef>
-          <a:fillRef idx="3">
-            <a:schemeClr val="accent1"/>
-          </a:fillRef>
-          <a:effectRef idx="0">
-            <a:schemeClr val="accent1"/>
-          </a:effectRef>
-          <a:fontRef idx="minor">
-            <a:schemeClr val="lt1"/>
-          </a:fontRef>
-        </p:style>
-        <p:txBody>
-          <a:bodyPr rtlCol="0" anchor="ctr"/>
-          <a:lstStyle/>
-          <a:p/>
-        </p:txBody>
-      </p:sp>
+            <a:ext cx="189607" cy="189607"/>
+          </a:xfrm>
+          <a:prstGeom prst="rect">
+            <a:avLst/>
+          </a:prstGeom>
+        </p:spPr>
+      </p:pic>
+      <p:pic>
+        <p:nvPicPr>
+          <p:cNvPr id="12" name="Picture 11" descr="svg-0-1.png"/>
+          <p:cNvPicPr>
+            <a:picLocks noChangeAspect="1"/>
+          </p:cNvPicPr>
+          <p:nvPr/>
+        </p:nvPicPr>
+        <p:blipFill>
+          <a:blip r:embed="rId3"/>
+          <a:stretch>
+            <a:fillRect/>
+          </a:stretch>
+        </p:blipFill>
+        <p:spPr>
+          <a:xfrm>
+            <a:off x="1286173" y="5468689"/>
+            <a:ext cx="189607" cy="189607"/>
+          </a:xfrm>
+          <a:prstGeom prst="rect">
+            <a:avLst/>
+          </a:prstGeom>
+        </p:spPr>
+      </p:pic>
+      <p:pic>
+        <p:nvPicPr>
+          <p:cNvPr id="13" name="Picture 12" descr="svg-0-2.png"/>
+          <p:cNvPicPr>
+            <a:picLocks noChangeAspect="1"/>
+          </p:cNvPicPr>
+          <p:nvPr/>
+        </p:nvPicPr>
+        <p:blipFill>
+          <a:blip r:embed="rId4"/>
+          <a:stretch>
+            <a:fillRect/>
+          </a:stretch>
+        </p:blipFill>
+        <p:spPr>
+          <a:xfrm>
+            <a:off x="1518940" y="5468689"/>
+            <a:ext cx="189607" cy="189607"/>
+          </a:xfrm>
+          <a:prstGeom prst="rect">
+            <a:avLst/>
+          </a:prstGeom>
+        </p:spPr>
+      </p:pic>
+      <p:pic>
+        <p:nvPicPr>
+          <p:cNvPr id="14" name="Picture 13" descr="svg-0-3.png"/>
+          <p:cNvPicPr>
+            <a:picLocks noChangeAspect="1"/>
+          </p:cNvPicPr>
+          <p:nvPr/>
+        </p:nvPicPr>
+        <p:blipFill>
+          <a:blip r:embed="rId5"/>
+          <a:stretch>
+            <a:fillRect/>
+          </a:stretch>
+        </p:blipFill>
+        <p:spPr>
+          <a:xfrm>
+            <a:off x="1751707" y="5468689"/>
+            <a:ext cx="189756" cy="189756"/>
+          </a:xfrm>
+          <a:prstGeom prst="rect">
+            <a:avLst/>
+          </a:prstGeom>
+        </p:spPr>
+      </p:pic>
+      <p:pic>
+        <p:nvPicPr>
+          <p:cNvPr id="15" name="Picture 14" descr="svg-0-2.png"/>
+          <p:cNvPicPr>
+            <a:picLocks noChangeAspect="1"/>
+          </p:cNvPicPr>
+          <p:nvPr/>
+        </p:nvPicPr>
+        <p:blipFill>
+          <a:blip r:embed="rId4"/>
+          <a:stretch>
+            <a:fillRect/>
+          </a:stretch>
+        </p:blipFill>
+        <p:spPr>
+          <a:xfrm>
+            <a:off x="1984623" y="5468689"/>
+            <a:ext cx="189607" cy="189607"/>
+          </a:xfrm>
+          <a:prstGeom prst="rect">
+            <a:avLst/>
+          </a:prstGeom>
+        </p:spPr>
+      </p:pic>
+      <p:pic>
+        <p:nvPicPr>
+          <p:cNvPr id="16" name="Picture 15" descr="svg-0-5.png"/>
+          <p:cNvPicPr>
+            <a:picLocks noChangeAspect="1"/>
+          </p:cNvPicPr>
+          <p:nvPr/>
+        </p:nvPicPr>
+        <p:blipFill>
+          <a:blip r:embed="rId6"/>
+          <a:stretch>
+            <a:fillRect/>
+          </a:stretch>
+        </p:blipFill>
+        <p:spPr>
+          <a:xfrm>
+            <a:off x="2217390" y="5468689"/>
+            <a:ext cx="189607" cy="189607"/>
+          </a:xfrm>
+          <a:prstGeom prst="rect">
+            <a:avLst/>
+          </a:prstGeom>
+        </p:spPr>
+      </p:pic>
+      <p:pic>
+        <p:nvPicPr>
+          <p:cNvPr id="17" name="Picture 16" descr="svg-0-6.png"/>
+          <p:cNvPicPr>
+            <a:picLocks noChangeAspect="1"/>
+          </p:cNvPicPr>
+          <p:nvPr/>
+        </p:nvPicPr>
+        <p:blipFill>
+          <a:blip r:embed="rId7"/>
+          <a:stretch>
+            <a:fillRect/>
+          </a:stretch>
+        </p:blipFill>
+        <p:spPr>
+          <a:xfrm>
+            <a:off x="2450157" y="5468689"/>
+            <a:ext cx="189756" cy="189756"/>
+          </a:xfrm>
+          <a:prstGeom prst="rect">
+            <a:avLst/>
+          </a:prstGeom>
+        </p:spPr>
+      </p:pic>
+      <p:pic>
+        <p:nvPicPr>
+          <p:cNvPr id="18" name="Picture 17" descr="svg-0-5.png"/>
+          <p:cNvPicPr>
+            <a:picLocks noChangeAspect="1"/>
+          </p:cNvPicPr>
+          <p:nvPr/>
+        </p:nvPicPr>
+        <p:blipFill>
+          <a:blip r:embed="rId6"/>
+          <a:stretch>
+            <a:fillRect/>
+          </a:stretch>
+        </p:blipFill>
+        <p:spPr>
+          <a:xfrm>
+            <a:off x="2683073" y="5468689"/>
+            <a:ext cx="189607" cy="189607"/>
+          </a:xfrm>
+          <a:prstGeom prst="rect">
+            <a:avLst/>
+          </a:prstGeom>
+        </p:spPr>
+      </p:pic>
+      <p:pic>
+        <p:nvPicPr>
+          <p:cNvPr id="19" name="Picture 18" descr="svg-0-8.png"/>
+          <p:cNvPicPr>
+            <a:picLocks noChangeAspect="1"/>
+          </p:cNvPicPr>
+          <p:nvPr/>
+        </p:nvPicPr>
+        <p:blipFill>
+          <a:blip r:embed="rId8"/>
+          <a:stretch>
+            <a:fillRect/>
+          </a:stretch>
+        </p:blipFill>
+        <p:spPr>
+          <a:xfrm>
+            <a:off x="2915841" y="5468689"/>
+            <a:ext cx="189607" cy="189607"/>
+          </a:xfrm>
+          <a:prstGeom prst="rect">
+            <a:avLst/>
+          </a:prstGeom>
+        </p:spPr>
+      </p:pic>
+      <p:pic>
+        <p:nvPicPr>
+          <p:cNvPr id="20" name="Picture 19" descr="svg-0-9.png"/>
+          <p:cNvPicPr>
+            <a:picLocks noChangeAspect="1"/>
+          </p:cNvPicPr>
+          <p:nvPr/>
+        </p:nvPicPr>
+        <p:blipFill>
+          <a:blip r:embed="rId9"/>
+          <a:stretch>
+            <a:fillRect/>
+          </a:stretch>
+        </p:blipFill>
+        <p:spPr>
+          <a:xfrm>
+            <a:off x="3148608" y="5468689"/>
+            <a:ext cx="189756" cy="189756"/>
+          </a:xfrm>
+          <a:prstGeom prst="rect">
+            <a:avLst/>
+          </a:prstGeom>
+        </p:spPr>
+      </p:pic>
+      <p:pic>
+        <p:nvPicPr>
+          <p:cNvPr id="21" name="Picture 20" descr="svg-0-10.png"/>
+          <p:cNvPicPr>
+            <a:picLocks noChangeAspect="1"/>
+          </p:cNvPicPr>
+          <p:nvPr/>
+        </p:nvPicPr>
+        <p:blipFill>
+          <a:blip r:embed="rId10"/>
+          <a:stretch>
+            <a:fillRect/>
+          </a:stretch>
+        </p:blipFill>
+        <p:spPr>
+          <a:xfrm>
+            <a:off x="1053405" y="5716042"/>
+            <a:ext cx="189607" cy="189607"/>
+          </a:xfrm>
+          <a:prstGeom prst="rect">
+            <a:avLst/>
+          </a:prstGeom>
+        </p:spPr>
+      </p:pic>
+      <p:pic>
+        <p:nvPicPr>
+          <p:cNvPr id="22" name="Picture 21" descr="svg-0-11.png"/>
+          <p:cNvPicPr>
+            <a:picLocks noChangeAspect="1"/>
+          </p:cNvPicPr>
+          <p:nvPr/>
+        </p:nvPicPr>
+        <p:blipFill>
+          <a:blip r:embed="rId11"/>
+          <a:stretch>
+            <a:fillRect/>
+          </a:stretch>
+        </p:blipFill>
+        <p:spPr>
+          <a:xfrm>
+            <a:off x="1286173" y="5716042"/>
+            <a:ext cx="189607" cy="189607"/>
+          </a:xfrm>
+          <a:prstGeom prst="rect">
+            <a:avLst/>
+          </a:prstGeom>
+        </p:spPr>
+      </p:pic>
+      <p:pic>
+        <p:nvPicPr>
+          <p:cNvPr id="23" name="Picture 22" descr="svg-0-12.png"/>
+          <p:cNvPicPr>
+            <a:picLocks noChangeAspect="1"/>
+          </p:cNvPicPr>
+          <p:nvPr/>
+        </p:nvPicPr>
+        <p:blipFill>
+          <a:blip r:embed="rId12"/>
+          <a:stretch>
+            <a:fillRect/>
+          </a:stretch>
+        </p:blipFill>
+        <p:spPr>
+          <a:xfrm>
+            <a:off x="1518940" y="5716042"/>
+            <a:ext cx="189607" cy="189607"/>
+          </a:xfrm>
+          <a:prstGeom prst="rect">
+            <a:avLst/>
+          </a:prstGeom>
+        </p:spPr>
+      </p:pic>
+      <p:pic>
+        <p:nvPicPr>
+          <p:cNvPr id="24" name="Picture 23" descr="svg-0-13.png"/>
+          <p:cNvPicPr>
+            <a:picLocks noChangeAspect="1"/>
+          </p:cNvPicPr>
+          <p:nvPr/>
+        </p:nvPicPr>
+        <p:blipFill>
+          <a:blip r:embed="rId13"/>
+          <a:stretch>
+            <a:fillRect/>
+          </a:stretch>
+        </p:blipFill>
+        <p:spPr>
+          <a:xfrm>
+            <a:off x="1751707" y="5716042"/>
+            <a:ext cx="189756" cy="189756"/>
+          </a:xfrm>
+          <a:prstGeom prst="rect">
+            <a:avLst/>
+          </a:prstGeom>
+        </p:spPr>
+      </p:pic>
+      <p:pic>
+        <p:nvPicPr>
+          <p:cNvPr id="25" name="Picture 24" descr="svg-0-12.png"/>
+          <p:cNvPicPr>
+            <a:picLocks noChangeAspect="1"/>
+          </p:cNvPicPr>
+          <p:nvPr/>
+        </p:nvPicPr>
+        <p:blipFill>
+          <a:blip r:embed="rId12"/>
+          <a:stretch>
+            <a:fillRect/>
+          </a:stretch>
+        </p:blipFill>
+        <p:spPr>
+          <a:xfrm>
+            <a:off x="1984623" y="5716042"/>
+            <a:ext cx="189607" cy="189607"/>
+          </a:xfrm>
+          <a:prstGeom prst="rect">
+            <a:avLst/>
+          </a:prstGeom>
+        </p:spPr>
+      </p:pic>
+      <p:pic>
+        <p:nvPicPr>
+          <p:cNvPr id="26" name="Picture 25" descr="svg-0-15.png"/>
+          <p:cNvPicPr>
+            <a:picLocks noChangeAspect="1"/>
+          </p:cNvPicPr>
+          <p:nvPr/>
+        </p:nvPicPr>
+        <p:blipFill>
+          <a:blip r:embed="rId14"/>
+          <a:stretch>
+            <a:fillRect/>
+          </a:stretch>
+        </p:blipFill>
+        <p:spPr>
+          <a:xfrm>
+            <a:off x="2217390" y="5716042"/>
+            <a:ext cx="189607" cy="189607"/>
+          </a:xfrm>
+          <a:prstGeom prst="rect">
+            <a:avLst/>
+          </a:prstGeom>
+        </p:spPr>
+      </p:pic>
+      <p:pic>
+        <p:nvPicPr>
+          <p:cNvPr id="27" name="Picture 26" descr="svg-0-16.png"/>
+          <p:cNvPicPr>
+            <a:picLocks noChangeAspect="1"/>
+          </p:cNvPicPr>
+          <p:nvPr/>
+        </p:nvPicPr>
+        <p:blipFill>
+          <a:blip r:embed="rId15"/>
+          <a:stretch>
+            <a:fillRect/>
+          </a:stretch>
+        </p:blipFill>
+        <p:spPr>
+          <a:xfrm>
+            <a:off x="2450157" y="5716042"/>
+            <a:ext cx="189756" cy="189756"/>
+          </a:xfrm>
+          <a:prstGeom prst="rect">
+            <a:avLst/>
+          </a:prstGeom>
+        </p:spPr>
+      </p:pic>
+      <p:pic>
+        <p:nvPicPr>
+          <p:cNvPr id="28" name="Picture 27" descr="svg-0-15.png"/>
+          <p:cNvPicPr>
+            <a:picLocks noChangeAspect="1"/>
+          </p:cNvPicPr>
+          <p:nvPr/>
+        </p:nvPicPr>
+        <p:blipFill>
+          <a:blip r:embed="rId14"/>
+          <a:stretch>
+            <a:fillRect/>
+          </a:stretch>
+        </p:blipFill>
+        <p:spPr>
+          <a:xfrm>
+            <a:off x="2683073" y="5716042"/>
+            <a:ext cx="189607" cy="189607"/>
+          </a:xfrm>
+          <a:prstGeom prst="rect">
+            <a:avLst/>
+          </a:prstGeom>
+        </p:spPr>
+      </p:pic>
+      <p:pic>
+        <p:nvPicPr>
+          <p:cNvPr id="29" name="Picture 28" descr="svg-0-18.png"/>
+          <p:cNvPicPr>
+            <a:picLocks noChangeAspect="1"/>
+          </p:cNvPicPr>
+          <p:nvPr/>
+        </p:nvPicPr>
+        <p:blipFill>
+          <a:blip r:embed="rId16"/>
+          <a:stretch>
+            <a:fillRect/>
+          </a:stretch>
+        </p:blipFill>
+        <p:spPr>
+          <a:xfrm>
+            <a:off x="2915841" y="5716042"/>
+            <a:ext cx="189607" cy="189607"/>
+          </a:xfrm>
+          <a:prstGeom prst="rect">
+            <a:avLst/>
+          </a:prstGeom>
+        </p:spPr>
+      </p:pic>
+      <p:pic>
+        <p:nvPicPr>
+          <p:cNvPr id="30" name="Picture 29" descr="svg-0-19.png"/>
+          <p:cNvPicPr>
+            <a:picLocks noChangeAspect="1"/>
+          </p:cNvPicPr>
+          <p:nvPr/>
+        </p:nvPicPr>
+        <p:blipFill>
+          <a:blip r:embed="rId17"/>
+          <a:stretch>
+            <a:fillRect/>
+          </a:stretch>
+        </p:blipFill>
+        <p:spPr>
+          <a:xfrm>
+            <a:off x="3148608" y="5716042"/>
+            <a:ext cx="189756" cy="189756"/>
+          </a:xfrm>
+          <a:prstGeom prst="rect">
+            <a:avLst/>
+          </a:prstGeom>
+        </p:spPr>
+      </p:pic>
       <p:sp>
         <p:nvSpPr>
           <p:cNvPr id="31" name="Rounded Rectangle 30"/>
@@ -4299,11 +3939,11 @@
         <p:spPr>
           <a:xfrm>
             <a:off x="3887837" y="3893790"/>
-            <a:ext cx="2952155" cy="2296567"/>
+            <a:ext cx="2952155" cy="2345531"/>
           </a:xfrm>
           <a:prstGeom prst="roundRect">
             <a:avLst>
-              <a:gd name="adj" fmla="val 9405"/>
+              <a:gd name="adj" fmla="val 9209"/>
             </a:avLst>
           </a:prstGeom>
           <a:solidFill>
@@ -4450,866 +4090,486 @@
           </a:p>
         </p:txBody>
       </p:sp>
-      <p:sp>
-        <p:nvSpPr>
-          <p:cNvPr id="35" name="Oval 34"/>
-          <p:cNvSpPr/>
-          <p:nvPr/>
-        </p:nvSpPr>
+      <p:pic>
+        <p:nvPicPr>
+          <p:cNvPr id="35" name="Picture 34" descr="svg-0-20.png"/>
+          <p:cNvPicPr>
+            <a:picLocks noChangeAspect="1"/>
+          </p:cNvPicPr>
+          <p:nvPr/>
+        </p:nvPicPr>
+        <p:blipFill>
+          <a:blip r:embed="rId18"/>
+          <a:stretch>
+            <a:fillRect/>
+          </a:stretch>
+        </p:blipFill>
         <p:spPr>
           <a:xfrm>
             <a:off x="4211836" y="5459164"/>
-            <a:ext cx="152846" cy="152846"/>
-          </a:xfrm>
-          <a:prstGeom prst="ellipse">
-            <a:avLst/>
-          </a:prstGeom>
-          <a:solidFill>
-            <a:srgbClr val="000326"/>
-          </a:solidFill>
-          <a:ln w="9525">
-            <a:solidFill>
-              <a:srgbClr val="000326"/>
-            </a:solidFill>
-          </a:ln>
-        </p:spPr>
-        <p:style>
-          <a:lnRef idx="1">
-            <a:schemeClr val="accent1"/>
-          </a:lnRef>
-          <a:fillRef idx="3">
-            <a:schemeClr val="accent1"/>
-          </a:fillRef>
-          <a:effectRef idx="0">
-            <a:schemeClr val="accent1"/>
-          </a:effectRef>
-          <a:fontRef idx="minor">
-            <a:schemeClr val="lt1"/>
-          </a:fontRef>
-        </p:style>
-        <p:txBody>
-          <a:bodyPr rtlCol="0" anchor="ctr"/>
-          <a:lstStyle/>
-          <a:p/>
-        </p:txBody>
-      </p:sp>
-      <p:sp>
-        <p:nvSpPr>
-          <p:cNvPr id="36" name="Oval 35"/>
-          <p:cNvSpPr/>
-          <p:nvPr/>
-        </p:nvSpPr>
-        <p:spPr>
-          <a:xfrm>
-            <a:off x="4451003" y="5459164"/>
-            <a:ext cx="152846" cy="152846"/>
-          </a:xfrm>
-          <a:prstGeom prst="ellipse">
-            <a:avLst/>
-          </a:prstGeom>
-          <a:solidFill>
-            <a:srgbClr val="000326"/>
-          </a:solidFill>
-          <a:ln w="9525">
-            <a:solidFill>
-              <a:srgbClr val="000326"/>
-            </a:solidFill>
-          </a:ln>
-        </p:spPr>
-        <p:style>
-          <a:lnRef idx="1">
-            <a:schemeClr val="accent1"/>
-          </a:lnRef>
-          <a:fillRef idx="3">
-            <a:schemeClr val="accent1"/>
-          </a:fillRef>
-          <a:effectRef idx="0">
-            <a:schemeClr val="accent1"/>
-          </a:effectRef>
-          <a:fontRef idx="minor">
-            <a:schemeClr val="lt1"/>
-          </a:fontRef>
-        </p:style>
-        <p:txBody>
-          <a:bodyPr rtlCol="0" anchor="ctr"/>
-          <a:lstStyle/>
-          <a:p/>
-        </p:txBody>
-      </p:sp>
-      <p:sp>
-        <p:nvSpPr>
-          <p:cNvPr id="37" name="Oval 36"/>
-          <p:cNvSpPr/>
-          <p:nvPr/>
-        </p:nvSpPr>
-        <p:spPr>
-          <a:xfrm>
-            <a:off x="4690170" y="5459164"/>
-            <a:ext cx="152846" cy="152846"/>
-          </a:xfrm>
-          <a:prstGeom prst="ellipse">
-            <a:avLst/>
-          </a:prstGeom>
-          <a:solidFill>
-            <a:srgbClr val="000326"/>
-          </a:solidFill>
-          <a:ln w="9525">
-            <a:solidFill>
-              <a:srgbClr val="000326"/>
-            </a:solidFill>
-          </a:ln>
-        </p:spPr>
-        <p:style>
-          <a:lnRef idx="1">
-            <a:schemeClr val="accent1"/>
-          </a:lnRef>
-          <a:fillRef idx="3">
-            <a:schemeClr val="accent1"/>
-          </a:fillRef>
-          <a:effectRef idx="0">
-            <a:schemeClr val="accent1"/>
-          </a:effectRef>
-          <a:fontRef idx="minor">
-            <a:schemeClr val="lt1"/>
-          </a:fontRef>
-        </p:style>
-        <p:txBody>
-          <a:bodyPr rtlCol="0" anchor="ctr"/>
-          <a:lstStyle/>
-          <a:p/>
-        </p:txBody>
-      </p:sp>
-      <p:sp>
-        <p:nvSpPr>
-          <p:cNvPr id="38" name="Oval 37"/>
-          <p:cNvSpPr/>
-          <p:nvPr/>
-        </p:nvSpPr>
-        <p:spPr>
-          <a:xfrm>
-            <a:off x="4929336" y="5459164"/>
-            <a:ext cx="152846" cy="152846"/>
-          </a:xfrm>
-          <a:prstGeom prst="ellipse">
-            <a:avLst/>
-          </a:prstGeom>
-          <a:solidFill>
-            <a:srgbClr val="000326"/>
-          </a:solidFill>
-          <a:ln w="9525">
-            <a:solidFill>
-              <a:srgbClr val="000326"/>
-            </a:solidFill>
-          </a:ln>
-        </p:spPr>
-        <p:style>
-          <a:lnRef idx="1">
-            <a:schemeClr val="accent1"/>
-          </a:lnRef>
-          <a:fillRef idx="3">
-            <a:schemeClr val="accent1"/>
-          </a:fillRef>
-          <a:effectRef idx="0">
-            <a:schemeClr val="accent1"/>
-          </a:effectRef>
-          <a:fontRef idx="minor">
-            <a:schemeClr val="lt1"/>
-          </a:fontRef>
-        </p:style>
-        <p:txBody>
-          <a:bodyPr rtlCol="0" anchor="ctr"/>
-          <a:lstStyle/>
-          <a:p/>
-        </p:txBody>
-      </p:sp>
-      <p:sp>
-        <p:nvSpPr>
-          <p:cNvPr id="39" name="Oval 38"/>
-          <p:cNvSpPr/>
-          <p:nvPr/>
-        </p:nvSpPr>
-        <p:spPr>
-          <a:xfrm>
-            <a:off x="5168503" y="5459164"/>
-            <a:ext cx="152846" cy="152846"/>
-          </a:xfrm>
-          <a:prstGeom prst="ellipse">
-            <a:avLst/>
-          </a:prstGeom>
-          <a:solidFill>
-            <a:srgbClr val="000326"/>
-          </a:solidFill>
-          <a:ln w="9525">
-            <a:solidFill>
-              <a:srgbClr val="000326"/>
-            </a:solidFill>
-          </a:ln>
-        </p:spPr>
-        <p:style>
-          <a:lnRef idx="1">
-            <a:schemeClr val="accent1"/>
-          </a:lnRef>
-          <a:fillRef idx="3">
-            <a:schemeClr val="accent1"/>
-          </a:fillRef>
-          <a:effectRef idx="0">
-            <a:schemeClr val="accent1"/>
-          </a:effectRef>
-          <a:fontRef idx="minor">
-            <a:schemeClr val="lt1"/>
-          </a:fontRef>
-        </p:style>
-        <p:txBody>
-          <a:bodyPr rtlCol="0" anchor="ctr"/>
-          <a:lstStyle/>
-          <a:p/>
-        </p:txBody>
-      </p:sp>
-      <p:sp>
-        <p:nvSpPr>
-          <p:cNvPr id="40" name="Oval 39"/>
-          <p:cNvSpPr/>
-          <p:nvPr/>
-        </p:nvSpPr>
-        <p:spPr>
-          <a:xfrm>
-            <a:off x="5407670" y="5459164"/>
-            <a:ext cx="152846" cy="152846"/>
-          </a:xfrm>
-          <a:prstGeom prst="ellipse">
-            <a:avLst/>
-          </a:prstGeom>
-          <a:solidFill>
-            <a:srgbClr val="000326"/>
-          </a:solidFill>
-          <a:ln w="9525">
-            <a:solidFill>
-              <a:srgbClr val="000326"/>
-            </a:solidFill>
-          </a:ln>
-        </p:spPr>
-        <p:style>
-          <a:lnRef idx="1">
-            <a:schemeClr val="accent1"/>
-          </a:lnRef>
-          <a:fillRef idx="3">
-            <a:schemeClr val="accent1"/>
-          </a:fillRef>
-          <a:effectRef idx="0">
-            <a:schemeClr val="accent1"/>
-          </a:effectRef>
-          <a:fontRef idx="minor">
-            <a:schemeClr val="lt1"/>
-          </a:fontRef>
-        </p:style>
-        <p:txBody>
-          <a:bodyPr rtlCol="0" anchor="ctr"/>
-          <a:lstStyle/>
-          <a:p/>
-        </p:txBody>
-      </p:sp>
-      <p:sp>
-        <p:nvSpPr>
-          <p:cNvPr id="41" name="Oval 40"/>
-          <p:cNvSpPr/>
-          <p:nvPr/>
-        </p:nvSpPr>
-        <p:spPr>
-          <a:xfrm>
-            <a:off x="5646837" y="5459164"/>
-            <a:ext cx="152846" cy="152846"/>
-          </a:xfrm>
-          <a:prstGeom prst="ellipse">
-            <a:avLst/>
-          </a:prstGeom>
-          <a:solidFill>
-            <a:srgbClr val="000326"/>
-          </a:solidFill>
-          <a:ln w="9525">
-            <a:solidFill>
-              <a:srgbClr val="000326"/>
-            </a:solidFill>
-          </a:ln>
-        </p:spPr>
-        <p:style>
-          <a:lnRef idx="1">
-            <a:schemeClr val="accent1"/>
-          </a:lnRef>
-          <a:fillRef idx="3">
-            <a:schemeClr val="accent1"/>
-          </a:fillRef>
-          <a:effectRef idx="0">
-            <a:schemeClr val="accent1"/>
-          </a:effectRef>
-          <a:fontRef idx="minor">
-            <a:schemeClr val="lt1"/>
-          </a:fontRef>
-        </p:style>
-        <p:txBody>
-          <a:bodyPr rtlCol="0" anchor="ctr"/>
-          <a:lstStyle/>
-          <a:p/>
-        </p:txBody>
-      </p:sp>
-      <p:sp>
-        <p:nvSpPr>
-          <p:cNvPr id="42" name="Oval 41"/>
-          <p:cNvSpPr/>
-          <p:nvPr/>
-        </p:nvSpPr>
-        <p:spPr>
-          <a:xfrm>
-            <a:off x="5886004" y="5459164"/>
-            <a:ext cx="152846" cy="152846"/>
-          </a:xfrm>
-          <a:prstGeom prst="ellipse">
-            <a:avLst/>
-          </a:prstGeom>
-          <a:solidFill>
-            <a:srgbClr val="000326"/>
-          </a:solidFill>
-          <a:ln w="9525">
-            <a:solidFill>
-              <a:srgbClr val="000326"/>
-            </a:solidFill>
-          </a:ln>
-        </p:spPr>
-        <p:style>
-          <a:lnRef idx="1">
-            <a:schemeClr val="accent1"/>
-          </a:lnRef>
-          <a:fillRef idx="3">
-            <a:schemeClr val="accent1"/>
-          </a:fillRef>
-          <a:effectRef idx="0">
-            <a:schemeClr val="accent1"/>
-          </a:effectRef>
-          <a:fontRef idx="minor">
-            <a:schemeClr val="lt1"/>
-          </a:fontRef>
-        </p:style>
-        <p:txBody>
-          <a:bodyPr rtlCol="0" anchor="ctr"/>
-          <a:lstStyle/>
-          <a:p/>
-        </p:txBody>
-      </p:sp>
-      <p:sp>
-        <p:nvSpPr>
-          <p:cNvPr id="43" name="Oval 42"/>
-          <p:cNvSpPr/>
-          <p:nvPr/>
-        </p:nvSpPr>
-        <p:spPr>
-          <a:xfrm>
-            <a:off x="6125170" y="5459164"/>
-            <a:ext cx="152846" cy="152846"/>
-          </a:xfrm>
-          <a:prstGeom prst="ellipse">
-            <a:avLst/>
-          </a:prstGeom>
-          <a:solidFill>
-            <a:srgbClr val="000326"/>
-          </a:solidFill>
-          <a:ln w="9525">
-            <a:solidFill>
-              <a:srgbClr val="000326"/>
-            </a:solidFill>
-          </a:ln>
-        </p:spPr>
-        <p:style>
-          <a:lnRef idx="1">
-            <a:schemeClr val="accent1"/>
-          </a:lnRef>
-          <a:fillRef idx="3">
-            <a:schemeClr val="accent1"/>
-          </a:fillRef>
-          <a:effectRef idx="0">
-            <a:schemeClr val="accent1"/>
-          </a:effectRef>
-          <a:fontRef idx="minor">
-            <a:schemeClr val="lt1"/>
-          </a:fontRef>
-        </p:style>
-        <p:txBody>
-          <a:bodyPr rtlCol="0" anchor="ctr"/>
-          <a:lstStyle/>
-          <a:p/>
-        </p:txBody>
-      </p:sp>
-      <p:sp>
-        <p:nvSpPr>
-          <p:cNvPr id="44" name="Oval 43"/>
-          <p:cNvSpPr/>
-          <p:nvPr/>
-        </p:nvSpPr>
-        <p:spPr>
-          <a:xfrm>
-            <a:off x="6364337" y="5459164"/>
-            <a:ext cx="152846" cy="152846"/>
-          </a:xfrm>
-          <a:prstGeom prst="ellipse">
-            <a:avLst/>
-          </a:prstGeom>
-          <a:solidFill>
-            <a:srgbClr val="000326"/>
-          </a:solidFill>
-          <a:ln w="9525">
-            <a:solidFill>
-              <a:srgbClr val="000326"/>
-            </a:solidFill>
-          </a:ln>
-        </p:spPr>
-        <p:style>
-          <a:lnRef idx="1">
-            <a:schemeClr val="accent1"/>
-          </a:lnRef>
-          <a:fillRef idx="3">
-            <a:schemeClr val="accent1"/>
-          </a:fillRef>
-          <a:effectRef idx="0">
-            <a:schemeClr val="accent1"/>
-          </a:effectRef>
-          <a:fontRef idx="minor">
-            <a:schemeClr val="lt1"/>
-          </a:fontRef>
-        </p:style>
-        <p:txBody>
-          <a:bodyPr rtlCol="0" anchor="ctr"/>
-          <a:lstStyle/>
-          <a:p/>
-        </p:txBody>
-      </p:sp>
-      <p:sp>
-        <p:nvSpPr>
-          <p:cNvPr id="45" name="Oval 44"/>
-          <p:cNvSpPr/>
-          <p:nvPr/>
-        </p:nvSpPr>
-        <p:spPr>
-          <a:xfrm>
-            <a:off x="4211836" y="5698331"/>
-            <a:ext cx="152846" cy="152846"/>
-          </a:xfrm>
-          <a:prstGeom prst="ellipse">
-            <a:avLst/>
-          </a:prstGeom>
-          <a:solidFill>
-            <a:srgbClr val="000326"/>
-          </a:solidFill>
-          <a:ln w="9525">
-            <a:solidFill>
-              <a:srgbClr val="000326"/>
-            </a:solidFill>
-          </a:ln>
-        </p:spPr>
-        <p:style>
-          <a:lnRef idx="1">
-            <a:schemeClr val="accent1"/>
-          </a:lnRef>
-          <a:fillRef idx="3">
-            <a:schemeClr val="accent1"/>
-          </a:fillRef>
-          <a:effectRef idx="0">
-            <a:schemeClr val="accent1"/>
-          </a:effectRef>
-          <a:fontRef idx="minor">
-            <a:schemeClr val="lt1"/>
-          </a:fontRef>
-        </p:style>
-        <p:txBody>
-          <a:bodyPr rtlCol="0" anchor="ctr"/>
-          <a:lstStyle/>
-          <a:p/>
-        </p:txBody>
-      </p:sp>
-      <p:sp>
-        <p:nvSpPr>
-          <p:cNvPr id="46" name="Oval 45"/>
-          <p:cNvSpPr/>
-          <p:nvPr/>
-        </p:nvSpPr>
-        <p:spPr>
-          <a:xfrm>
-            <a:off x="4451003" y="5698331"/>
-            <a:ext cx="152846" cy="152846"/>
-          </a:xfrm>
-          <a:prstGeom prst="ellipse">
-            <a:avLst/>
-          </a:prstGeom>
-          <a:solidFill>
-            <a:srgbClr val="000326"/>
-          </a:solidFill>
-          <a:ln w="9525">
-            <a:solidFill>
-              <a:srgbClr val="000326"/>
-            </a:solidFill>
-          </a:ln>
-        </p:spPr>
-        <p:style>
-          <a:lnRef idx="1">
-            <a:schemeClr val="accent1"/>
-          </a:lnRef>
-          <a:fillRef idx="3">
-            <a:schemeClr val="accent1"/>
-          </a:fillRef>
-          <a:effectRef idx="0">
-            <a:schemeClr val="accent1"/>
-          </a:effectRef>
-          <a:fontRef idx="minor">
-            <a:schemeClr val="lt1"/>
-          </a:fontRef>
-        </p:style>
-        <p:txBody>
-          <a:bodyPr rtlCol="0" anchor="ctr"/>
-          <a:lstStyle/>
-          <a:p/>
-        </p:txBody>
-      </p:sp>
-      <p:sp>
-        <p:nvSpPr>
-          <p:cNvPr id="47" name="Oval 46"/>
-          <p:cNvSpPr/>
-          <p:nvPr/>
-        </p:nvSpPr>
-        <p:spPr>
-          <a:xfrm>
-            <a:off x="4690170" y="5698331"/>
-            <a:ext cx="152846" cy="152846"/>
-          </a:xfrm>
-          <a:prstGeom prst="ellipse">
-            <a:avLst/>
-          </a:prstGeom>
-          <a:solidFill>
-            <a:srgbClr val="000326"/>
-          </a:solidFill>
-          <a:ln w="9525">
-            <a:solidFill>
-              <a:srgbClr val="000326"/>
-            </a:solidFill>
-          </a:ln>
-        </p:spPr>
-        <p:style>
-          <a:lnRef idx="1">
-            <a:schemeClr val="accent1"/>
-          </a:lnRef>
-          <a:fillRef idx="3">
-            <a:schemeClr val="accent1"/>
-          </a:fillRef>
-          <a:effectRef idx="0">
-            <a:schemeClr val="accent1"/>
-          </a:effectRef>
-          <a:fontRef idx="minor">
-            <a:schemeClr val="lt1"/>
-          </a:fontRef>
-        </p:style>
-        <p:txBody>
-          <a:bodyPr rtlCol="0" anchor="ctr"/>
-          <a:lstStyle/>
-          <a:p/>
-        </p:txBody>
-      </p:sp>
-      <p:sp>
-        <p:nvSpPr>
-          <p:cNvPr id="48" name="Oval 47"/>
-          <p:cNvSpPr/>
-          <p:nvPr/>
-        </p:nvSpPr>
-        <p:spPr>
-          <a:xfrm>
-            <a:off x="4929336" y="5698331"/>
-            <a:ext cx="152846" cy="152846"/>
-          </a:xfrm>
-          <a:prstGeom prst="ellipse">
-            <a:avLst/>
-          </a:prstGeom>
-          <a:solidFill>
-            <a:srgbClr val="000326"/>
-          </a:solidFill>
-          <a:ln w="9525">
-            <a:solidFill>
-              <a:srgbClr val="000326"/>
-            </a:solidFill>
-          </a:ln>
-        </p:spPr>
-        <p:style>
-          <a:lnRef idx="1">
-            <a:schemeClr val="accent1"/>
-          </a:lnRef>
-          <a:fillRef idx="3">
-            <a:schemeClr val="accent1"/>
-          </a:fillRef>
-          <a:effectRef idx="0">
-            <a:schemeClr val="accent1"/>
-          </a:effectRef>
-          <a:fontRef idx="minor">
-            <a:schemeClr val="lt1"/>
-          </a:fontRef>
-        </p:style>
-        <p:txBody>
-          <a:bodyPr rtlCol="0" anchor="ctr"/>
-          <a:lstStyle/>
-          <a:p/>
-        </p:txBody>
-      </p:sp>
-      <p:sp>
-        <p:nvSpPr>
-          <p:cNvPr id="49" name="Oval 48"/>
-          <p:cNvSpPr/>
-          <p:nvPr/>
-        </p:nvSpPr>
-        <p:spPr>
-          <a:xfrm>
-            <a:off x="5168503" y="5698331"/>
-            <a:ext cx="152846" cy="152846"/>
-          </a:xfrm>
-          <a:prstGeom prst="ellipse">
-            <a:avLst/>
-          </a:prstGeom>
-          <a:solidFill>
-            <a:srgbClr val="000326"/>
-          </a:solidFill>
-          <a:ln w="9525">
-            <a:solidFill>
-              <a:srgbClr val="000326"/>
-            </a:solidFill>
-          </a:ln>
-        </p:spPr>
-        <p:style>
-          <a:lnRef idx="1">
-            <a:schemeClr val="accent1"/>
-          </a:lnRef>
-          <a:fillRef idx="3">
-            <a:schemeClr val="accent1"/>
-          </a:fillRef>
-          <a:effectRef idx="0">
-            <a:schemeClr val="accent1"/>
-          </a:effectRef>
-          <a:fontRef idx="minor">
-            <a:schemeClr val="lt1"/>
-          </a:fontRef>
-        </p:style>
-        <p:txBody>
-          <a:bodyPr rtlCol="0" anchor="ctr"/>
-          <a:lstStyle/>
-          <a:p/>
-        </p:txBody>
-      </p:sp>
-      <p:sp>
-        <p:nvSpPr>
-          <p:cNvPr id="50" name="Oval 49"/>
-          <p:cNvSpPr/>
-          <p:nvPr/>
-        </p:nvSpPr>
-        <p:spPr>
-          <a:xfrm>
-            <a:off x="5407670" y="5698331"/>
-            <a:ext cx="152846" cy="152846"/>
-          </a:xfrm>
-          <a:prstGeom prst="ellipse">
-            <a:avLst/>
-          </a:prstGeom>
-          <a:solidFill>
-            <a:srgbClr val="000326"/>
-          </a:solidFill>
-          <a:ln w="9525">
-            <a:solidFill>
-              <a:srgbClr val="000326"/>
-            </a:solidFill>
-          </a:ln>
-        </p:spPr>
-        <p:style>
-          <a:lnRef idx="1">
-            <a:schemeClr val="accent1"/>
-          </a:lnRef>
-          <a:fillRef idx="3">
-            <a:schemeClr val="accent1"/>
-          </a:fillRef>
-          <a:effectRef idx="0">
-            <a:schemeClr val="accent1"/>
-          </a:effectRef>
-          <a:fontRef idx="minor">
-            <a:schemeClr val="lt1"/>
-          </a:fontRef>
-        </p:style>
-        <p:txBody>
-          <a:bodyPr rtlCol="0" anchor="ctr"/>
-          <a:lstStyle/>
-          <a:p/>
-        </p:txBody>
-      </p:sp>
-      <p:sp>
-        <p:nvSpPr>
-          <p:cNvPr id="51" name="Oval 50"/>
-          <p:cNvSpPr/>
-          <p:nvPr/>
-        </p:nvSpPr>
-        <p:spPr>
-          <a:xfrm>
-            <a:off x="5646837" y="5698331"/>
-            <a:ext cx="152846" cy="152846"/>
-          </a:xfrm>
-          <a:prstGeom prst="ellipse">
-            <a:avLst/>
-          </a:prstGeom>
-          <a:solidFill>
-            <a:srgbClr val="000326"/>
-          </a:solidFill>
-          <a:ln w="9525">
-            <a:solidFill>
-              <a:srgbClr val="000326"/>
-            </a:solidFill>
-          </a:ln>
-        </p:spPr>
-        <p:style>
-          <a:lnRef idx="1">
-            <a:schemeClr val="accent1"/>
-          </a:lnRef>
-          <a:fillRef idx="3">
-            <a:schemeClr val="accent1"/>
-          </a:fillRef>
-          <a:effectRef idx="0">
-            <a:schemeClr val="accent1"/>
-          </a:effectRef>
-          <a:fontRef idx="minor">
-            <a:schemeClr val="lt1"/>
-          </a:fontRef>
-        </p:style>
-        <p:txBody>
-          <a:bodyPr rtlCol="0" anchor="ctr"/>
-          <a:lstStyle/>
-          <a:p/>
-        </p:txBody>
-      </p:sp>
-      <p:sp>
-        <p:nvSpPr>
-          <p:cNvPr id="52" name="Oval 51"/>
-          <p:cNvSpPr/>
-          <p:nvPr/>
-        </p:nvSpPr>
-        <p:spPr>
-          <a:xfrm>
-            <a:off x="5886004" y="5698331"/>
-            <a:ext cx="152846" cy="152846"/>
-          </a:xfrm>
-          <a:prstGeom prst="ellipse">
-            <a:avLst/>
-          </a:prstGeom>
-          <a:solidFill>
-            <a:srgbClr val="000326"/>
-          </a:solidFill>
-          <a:ln w="9525">
-            <a:solidFill>
-              <a:srgbClr val="000326"/>
-            </a:solidFill>
-          </a:ln>
-        </p:spPr>
-        <p:style>
-          <a:lnRef idx="1">
-            <a:schemeClr val="accent1"/>
-          </a:lnRef>
-          <a:fillRef idx="3">
-            <a:schemeClr val="accent1"/>
-          </a:fillRef>
-          <a:effectRef idx="0">
-            <a:schemeClr val="accent1"/>
-          </a:effectRef>
-          <a:fontRef idx="minor">
-            <a:schemeClr val="lt1"/>
-          </a:fontRef>
-        </p:style>
-        <p:txBody>
-          <a:bodyPr rtlCol="0" anchor="ctr"/>
-          <a:lstStyle/>
-          <a:p/>
-        </p:txBody>
-      </p:sp>
-      <p:sp>
-        <p:nvSpPr>
-          <p:cNvPr id="53" name="Oval 52"/>
-          <p:cNvSpPr/>
-          <p:nvPr/>
-        </p:nvSpPr>
-        <p:spPr>
-          <a:xfrm>
-            <a:off x="6125170" y="5698331"/>
-            <a:ext cx="152846" cy="152846"/>
-          </a:xfrm>
-          <a:prstGeom prst="ellipse">
-            <a:avLst/>
-          </a:prstGeom>
-          <a:solidFill>
-            <a:srgbClr val="000326"/>
-          </a:solidFill>
-          <a:ln w="9525">
-            <a:solidFill>
-              <a:srgbClr val="000326"/>
-            </a:solidFill>
-          </a:ln>
-        </p:spPr>
-        <p:style>
-          <a:lnRef idx="1">
-            <a:schemeClr val="accent1"/>
-          </a:lnRef>
-          <a:fillRef idx="3">
-            <a:schemeClr val="accent1"/>
-          </a:fillRef>
-          <a:effectRef idx="0">
-            <a:schemeClr val="accent1"/>
-          </a:effectRef>
-          <a:fontRef idx="minor">
-            <a:schemeClr val="lt1"/>
-          </a:fontRef>
-        </p:style>
-        <p:txBody>
-          <a:bodyPr rtlCol="0" anchor="ctr"/>
-          <a:lstStyle/>
-          <a:p/>
-        </p:txBody>
-      </p:sp>
-      <p:sp>
-        <p:nvSpPr>
-          <p:cNvPr id="54" name="Oval 53"/>
-          <p:cNvSpPr/>
-          <p:nvPr/>
-        </p:nvSpPr>
-        <p:spPr>
-          <a:xfrm>
-            <a:off x="6364337" y="5698331"/>
-            <a:ext cx="152846" cy="152846"/>
-          </a:xfrm>
-          <a:prstGeom prst="ellipse">
-            <a:avLst/>
-          </a:prstGeom>
-          <a:solidFill>
-            <a:srgbClr val="000326"/>
-          </a:solidFill>
-          <a:ln w="9525">
-            <a:solidFill>
-              <a:srgbClr val="000326"/>
-            </a:solidFill>
-          </a:ln>
-        </p:spPr>
-        <p:style>
-          <a:lnRef idx="1">
-            <a:schemeClr val="accent1"/>
-          </a:lnRef>
-          <a:fillRef idx="3">
-            <a:schemeClr val="accent1"/>
-          </a:fillRef>
-          <a:effectRef idx="0">
-            <a:schemeClr val="accent1"/>
-          </a:effectRef>
-          <a:fontRef idx="minor">
-            <a:schemeClr val="lt1"/>
-          </a:fontRef>
-        </p:style>
-        <p:txBody>
-          <a:bodyPr rtlCol="0" anchor="ctr"/>
-          <a:lstStyle/>
-          <a:p/>
-        </p:txBody>
-      </p:sp>
+            <a:ext cx="191542" cy="191542"/>
+          </a:xfrm>
+          <a:prstGeom prst="rect">
+            <a:avLst/>
+          </a:prstGeom>
+        </p:spPr>
+      </p:pic>
+      <p:pic>
+        <p:nvPicPr>
+          <p:cNvPr id="36" name="Picture 35" descr="svg-0-21.png"/>
+          <p:cNvPicPr>
+            <a:picLocks noChangeAspect="1"/>
+          </p:cNvPicPr>
+          <p:nvPr/>
+        </p:nvPicPr>
+        <p:blipFill>
+          <a:blip r:embed="rId19"/>
+          <a:stretch>
+            <a:fillRect/>
+          </a:stretch>
+        </p:blipFill>
+        <p:spPr>
+          <a:xfrm>
+            <a:off x="4446538" y="5459164"/>
+            <a:ext cx="191542" cy="191542"/>
+          </a:xfrm>
+          <a:prstGeom prst="rect">
+            <a:avLst/>
+          </a:prstGeom>
+        </p:spPr>
+      </p:pic>
+      <p:pic>
+        <p:nvPicPr>
+          <p:cNvPr id="37" name="Picture 36" descr="svg-0-22.png"/>
+          <p:cNvPicPr>
+            <a:picLocks noChangeAspect="1"/>
+          </p:cNvPicPr>
+          <p:nvPr/>
+        </p:nvPicPr>
+        <p:blipFill>
+          <a:blip r:embed="rId20"/>
+          <a:stretch>
+            <a:fillRect/>
+          </a:stretch>
+        </p:blipFill>
+        <p:spPr>
+          <a:xfrm>
+            <a:off x="4681240" y="5459164"/>
+            <a:ext cx="191542" cy="191542"/>
+          </a:xfrm>
+          <a:prstGeom prst="rect">
+            <a:avLst/>
+          </a:prstGeom>
+        </p:spPr>
+      </p:pic>
+      <p:pic>
+        <p:nvPicPr>
+          <p:cNvPr id="38" name="Picture 37" descr="svg-0-20.png"/>
+          <p:cNvPicPr>
+            <a:picLocks noChangeAspect="1"/>
+          </p:cNvPicPr>
+          <p:nvPr/>
+        </p:nvPicPr>
+        <p:blipFill>
+          <a:blip r:embed="rId18"/>
+          <a:stretch>
+            <a:fillRect/>
+          </a:stretch>
+        </p:blipFill>
+        <p:spPr>
+          <a:xfrm>
+            <a:off x="4915942" y="5459164"/>
+            <a:ext cx="191542" cy="191542"/>
+          </a:xfrm>
+          <a:prstGeom prst="rect">
+            <a:avLst/>
+          </a:prstGeom>
+        </p:spPr>
+      </p:pic>
+      <p:pic>
+        <p:nvPicPr>
+          <p:cNvPr id="39" name="Picture 38" descr="svg-0-21.png"/>
+          <p:cNvPicPr>
+            <a:picLocks noChangeAspect="1"/>
+          </p:cNvPicPr>
+          <p:nvPr/>
+        </p:nvPicPr>
+        <p:blipFill>
+          <a:blip r:embed="rId19"/>
+          <a:stretch>
+            <a:fillRect/>
+          </a:stretch>
+        </p:blipFill>
+        <p:spPr>
+          <a:xfrm>
+            <a:off x="5150644" y="5459164"/>
+            <a:ext cx="191542" cy="191542"/>
+          </a:xfrm>
+          <a:prstGeom prst="rect">
+            <a:avLst/>
+          </a:prstGeom>
+        </p:spPr>
+      </p:pic>
+      <p:pic>
+        <p:nvPicPr>
+          <p:cNvPr id="40" name="Picture 39" descr="svg-0-25.png"/>
+          <p:cNvPicPr>
+            <a:picLocks noChangeAspect="1"/>
+          </p:cNvPicPr>
+          <p:nvPr/>
+        </p:nvPicPr>
+        <p:blipFill>
+          <a:blip r:embed="rId21"/>
+          <a:stretch>
+            <a:fillRect/>
+          </a:stretch>
+        </p:blipFill>
+        <p:spPr>
+          <a:xfrm>
+            <a:off x="5385346" y="5459164"/>
+            <a:ext cx="191691" cy="191691"/>
+          </a:xfrm>
+          <a:prstGeom prst="rect">
+            <a:avLst/>
+          </a:prstGeom>
+        </p:spPr>
+      </p:pic>
+      <p:pic>
+        <p:nvPicPr>
+          <p:cNvPr id="41" name="Picture 40" descr="svg-0-20.png"/>
+          <p:cNvPicPr>
+            <a:picLocks noChangeAspect="1"/>
+          </p:cNvPicPr>
+          <p:nvPr/>
+        </p:nvPicPr>
+        <p:blipFill>
+          <a:blip r:embed="rId18"/>
+          <a:stretch>
+            <a:fillRect/>
+          </a:stretch>
+        </p:blipFill>
+        <p:spPr>
+          <a:xfrm>
+            <a:off x="5620196" y="5459164"/>
+            <a:ext cx="191542" cy="191542"/>
+          </a:xfrm>
+          <a:prstGeom prst="rect">
+            <a:avLst/>
+          </a:prstGeom>
+        </p:spPr>
+      </p:pic>
+      <p:pic>
+        <p:nvPicPr>
+          <p:cNvPr id="42" name="Picture 41" descr="svg-0-21.png"/>
+          <p:cNvPicPr>
+            <a:picLocks noChangeAspect="1"/>
+          </p:cNvPicPr>
+          <p:nvPr/>
+        </p:nvPicPr>
+        <p:blipFill>
+          <a:blip r:embed="rId19"/>
+          <a:stretch>
+            <a:fillRect/>
+          </a:stretch>
+        </p:blipFill>
+        <p:spPr>
+          <a:xfrm>
+            <a:off x="5854898" y="5459164"/>
+            <a:ext cx="191542" cy="191542"/>
+          </a:xfrm>
+          <a:prstGeom prst="rect">
+            <a:avLst/>
+          </a:prstGeom>
+        </p:spPr>
+      </p:pic>
+      <p:pic>
+        <p:nvPicPr>
+          <p:cNvPr id="43" name="Picture 42" descr="svg-0-20.png"/>
+          <p:cNvPicPr>
+            <a:picLocks noChangeAspect="1"/>
+          </p:cNvPicPr>
+          <p:nvPr/>
+        </p:nvPicPr>
+        <p:blipFill>
+          <a:blip r:embed="rId18"/>
+          <a:stretch>
+            <a:fillRect/>
+          </a:stretch>
+        </p:blipFill>
+        <p:spPr>
+          <a:xfrm>
+            <a:off x="6089600" y="5459164"/>
+            <a:ext cx="191542" cy="191542"/>
+          </a:xfrm>
+          <a:prstGeom prst="rect">
+            <a:avLst/>
+          </a:prstGeom>
+        </p:spPr>
+      </p:pic>
+      <p:pic>
+        <p:nvPicPr>
+          <p:cNvPr id="44" name="Picture 43" descr="svg-0-29.png"/>
+          <p:cNvPicPr>
+            <a:picLocks noChangeAspect="1"/>
+          </p:cNvPicPr>
+          <p:nvPr/>
+        </p:nvPicPr>
+        <p:blipFill>
+          <a:blip r:embed="rId22"/>
+          <a:stretch>
+            <a:fillRect/>
+          </a:stretch>
+        </p:blipFill>
+        <p:spPr>
+          <a:xfrm>
+            <a:off x="6324302" y="5459164"/>
+            <a:ext cx="191542" cy="191542"/>
+          </a:xfrm>
+          <a:prstGeom prst="rect">
+            <a:avLst/>
+          </a:prstGeom>
+        </p:spPr>
+      </p:pic>
+      <p:pic>
+        <p:nvPicPr>
+          <p:cNvPr id="45" name="Picture 44" descr="svg-0-20.png"/>
+          <p:cNvPicPr>
+            <a:picLocks noChangeAspect="1"/>
+          </p:cNvPicPr>
+          <p:nvPr/>
+        </p:nvPicPr>
+        <p:blipFill>
+          <a:blip r:embed="rId18"/>
+          <a:stretch>
+            <a:fillRect/>
+          </a:stretch>
+        </p:blipFill>
+        <p:spPr>
+          <a:xfrm>
+            <a:off x="4211836" y="5708452"/>
+            <a:ext cx="191542" cy="191542"/>
+          </a:xfrm>
+          <a:prstGeom prst="rect">
+            <a:avLst/>
+          </a:prstGeom>
+        </p:spPr>
+      </p:pic>
+      <p:pic>
+        <p:nvPicPr>
+          <p:cNvPr id="46" name="Picture 45" descr="svg-0-21.png"/>
+          <p:cNvPicPr>
+            <a:picLocks noChangeAspect="1"/>
+          </p:cNvPicPr>
+          <p:nvPr/>
+        </p:nvPicPr>
+        <p:blipFill>
+          <a:blip r:embed="rId19"/>
+          <a:stretch>
+            <a:fillRect/>
+          </a:stretch>
+        </p:blipFill>
+        <p:spPr>
+          <a:xfrm>
+            <a:off x="4446538" y="5708452"/>
+            <a:ext cx="191542" cy="191542"/>
+          </a:xfrm>
+          <a:prstGeom prst="rect">
+            <a:avLst/>
+          </a:prstGeom>
+        </p:spPr>
+      </p:pic>
+      <p:pic>
+        <p:nvPicPr>
+          <p:cNvPr id="47" name="Picture 46" descr="svg-0-22.png"/>
+          <p:cNvPicPr>
+            <a:picLocks noChangeAspect="1"/>
+          </p:cNvPicPr>
+          <p:nvPr/>
+        </p:nvPicPr>
+        <p:blipFill>
+          <a:blip r:embed="rId20"/>
+          <a:stretch>
+            <a:fillRect/>
+          </a:stretch>
+        </p:blipFill>
+        <p:spPr>
+          <a:xfrm>
+            <a:off x="4681240" y="5708452"/>
+            <a:ext cx="191542" cy="191542"/>
+          </a:xfrm>
+          <a:prstGeom prst="rect">
+            <a:avLst/>
+          </a:prstGeom>
+        </p:spPr>
+      </p:pic>
+      <p:pic>
+        <p:nvPicPr>
+          <p:cNvPr id="48" name="Picture 47" descr="svg-0-20.png"/>
+          <p:cNvPicPr>
+            <a:picLocks noChangeAspect="1"/>
+          </p:cNvPicPr>
+          <p:nvPr/>
+        </p:nvPicPr>
+        <p:blipFill>
+          <a:blip r:embed="rId18"/>
+          <a:stretch>
+            <a:fillRect/>
+          </a:stretch>
+        </p:blipFill>
+        <p:spPr>
+          <a:xfrm>
+            <a:off x="4915942" y="5708452"/>
+            <a:ext cx="191542" cy="191542"/>
+          </a:xfrm>
+          <a:prstGeom prst="rect">
+            <a:avLst/>
+          </a:prstGeom>
+        </p:spPr>
+      </p:pic>
+      <p:pic>
+        <p:nvPicPr>
+          <p:cNvPr id="49" name="Picture 48" descr="svg-0-21.png"/>
+          <p:cNvPicPr>
+            <a:picLocks noChangeAspect="1"/>
+          </p:cNvPicPr>
+          <p:nvPr/>
+        </p:nvPicPr>
+        <p:blipFill>
+          <a:blip r:embed="rId19"/>
+          <a:stretch>
+            <a:fillRect/>
+          </a:stretch>
+        </p:blipFill>
+        <p:spPr>
+          <a:xfrm>
+            <a:off x="5150644" y="5708452"/>
+            <a:ext cx="191542" cy="191542"/>
+          </a:xfrm>
+          <a:prstGeom prst="rect">
+            <a:avLst/>
+          </a:prstGeom>
+        </p:spPr>
+      </p:pic>
+      <p:pic>
+        <p:nvPicPr>
+          <p:cNvPr id="50" name="Picture 49" descr="svg-0-25.png"/>
+          <p:cNvPicPr>
+            <a:picLocks noChangeAspect="1"/>
+          </p:cNvPicPr>
+          <p:nvPr/>
+        </p:nvPicPr>
+        <p:blipFill>
+          <a:blip r:embed="rId21"/>
+          <a:stretch>
+            <a:fillRect/>
+          </a:stretch>
+        </p:blipFill>
+        <p:spPr>
+          <a:xfrm>
+            <a:off x="5385346" y="5708452"/>
+            <a:ext cx="191691" cy="191691"/>
+          </a:xfrm>
+          <a:prstGeom prst="rect">
+            <a:avLst/>
+          </a:prstGeom>
+        </p:spPr>
+      </p:pic>
+      <p:pic>
+        <p:nvPicPr>
+          <p:cNvPr id="51" name="Picture 50" descr="svg-0-20.png"/>
+          <p:cNvPicPr>
+            <a:picLocks noChangeAspect="1"/>
+          </p:cNvPicPr>
+          <p:nvPr/>
+        </p:nvPicPr>
+        <p:blipFill>
+          <a:blip r:embed="rId18"/>
+          <a:stretch>
+            <a:fillRect/>
+          </a:stretch>
+        </p:blipFill>
+        <p:spPr>
+          <a:xfrm>
+            <a:off x="5620196" y="5708452"/>
+            <a:ext cx="191542" cy="191542"/>
+          </a:xfrm>
+          <a:prstGeom prst="rect">
+            <a:avLst/>
+          </a:prstGeom>
+        </p:spPr>
+      </p:pic>
+      <p:pic>
+        <p:nvPicPr>
+          <p:cNvPr id="52" name="Picture 51" descr="svg-0-21.png"/>
+          <p:cNvPicPr>
+            <a:picLocks noChangeAspect="1"/>
+          </p:cNvPicPr>
+          <p:nvPr/>
+        </p:nvPicPr>
+        <p:blipFill>
+          <a:blip r:embed="rId19"/>
+          <a:stretch>
+            <a:fillRect/>
+          </a:stretch>
+        </p:blipFill>
+        <p:spPr>
+          <a:xfrm>
+            <a:off x="5854898" y="5708452"/>
+            <a:ext cx="191542" cy="191542"/>
+          </a:xfrm>
+          <a:prstGeom prst="rect">
+            <a:avLst/>
+          </a:prstGeom>
+        </p:spPr>
+      </p:pic>
+      <p:pic>
+        <p:nvPicPr>
+          <p:cNvPr id="53" name="Picture 52" descr="svg-0-20.png"/>
+          <p:cNvPicPr>
+            <a:picLocks noChangeAspect="1"/>
+          </p:cNvPicPr>
+          <p:nvPr/>
+        </p:nvPicPr>
+        <p:blipFill>
+          <a:blip r:embed="rId18"/>
+          <a:stretch>
+            <a:fillRect/>
+          </a:stretch>
+        </p:blipFill>
+        <p:spPr>
+          <a:xfrm>
+            <a:off x="6089600" y="5708452"/>
+            <a:ext cx="191542" cy="191542"/>
+          </a:xfrm>
+          <a:prstGeom prst="rect">
+            <a:avLst/>
+          </a:prstGeom>
+        </p:spPr>
+      </p:pic>
+      <p:pic>
+        <p:nvPicPr>
+          <p:cNvPr id="54" name="Picture 53" descr="svg-0-29.png"/>
+          <p:cNvPicPr>
+            <a:picLocks noChangeAspect="1"/>
+          </p:cNvPicPr>
+          <p:nvPr/>
+        </p:nvPicPr>
+        <p:blipFill>
+          <a:blip r:embed="rId22"/>
+          <a:stretch>
+            <a:fillRect/>
+          </a:stretch>
+        </p:blipFill>
+        <p:spPr>
+          <a:xfrm>
+            <a:off x="6324302" y="5708452"/>
+            <a:ext cx="191542" cy="191542"/>
+          </a:xfrm>
+          <a:prstGeom prst="rect">
+            <a:avLst/>
+          </a:prstGeom>
+        </p:spPr>
+      </p:pic>
       <p:sp>
         <p:nvSpPr>
           <p:cNvPr id="55" name="TextBox 54"/>
@@ -5318,8 +4578,8 @@
         </p:nvSpPr>
         <p:spPr>
           <a:xfrm>
-            <a:off x="723900" y="6298257"/>
-            <a:ext cx="2055733" cy="142875"/>
+            <a:off x="723900" y="6347222"/>
+            <a:ext cx="2804827" cy="142875"/>
           </a:xfrm>
           <a:prstGeom prst="rect">
             <a:avLst/>
@@ -5344,7 +4604,7 @@
                 </a:solidFill>
                 <a:latin typeface="Inter"/>
               </a:rPr>
-              <a:t>Elke stip is 5% van de studenten.</a:t>
+              <a:t>Elk poppetje staat voor 5% van de studenten.</a:t>
             </a:r>
           </a:p>
         </p:txBody>
@@ -5357,7 +4617,7 @@
         </p:nvSpPr>
         <p:spPr>
           <a:xfrm>
-            <a:off x="719882" y="6674197"/>
+            <a:off x="719882" y="6723162"/>
             <a:ext cx="6120110" cy="1422648"/>
           </a:xfrm>
           <a:prstGeom prst="roundRect">
@@ -5400,7 +4660,7 @@
         </p:nvSpPr>
         <p:spPr>
           <a:xfrm>
-            <a:off x="1043880" y="7007721"/>
+            <a:off x="1043880" y="7056686"/>
             <a:ext cx="3437573" cy="428625"/>
           </a:xfrm>
           <a:prstGeom prst="rect">
@@ -5439,7 +4699,7 @@
         </p:nvSpPr>
         <p:spPr>
           <a:xfrm>
-            <a:off x="1043880" y="7582346"/>
+            <a:off x="1043880" y="7631311"/>
             <a:ext cx="2320766" cy="171450"/>
           </a:xfrm>
           <a:prstGeom prst="rect">
@@ -5479,7 +4739,7 @@
           <p:nvPr/>
         </p:nvPicPr>
         <p:blipFill>
-          <a:blip r:embed="rId2"/>
+          <a:blip r:embed="rId23"/>
           <a:stretch>
             <a:fillRect/>
           </a:stretch>

</xml_diff>

<commit_message>
Voorstel: kader om de lege rij poppetjes
Co-Authored-By: Claude Opus 5.5 <noreply@anthropic.com>
Claude-Session: https://claude.ai/code/session_011t24oNqE5E2i7wh7JuX2xs
</commit_message>
<xml_diff>
--- a/Design/Concepts/document/eduface-document-bewerkbaar.pptx
+++ b/Design/Concepts/document/eduface-document-bewerkbaar.pptx
@@ -3299,11 +3299,11 @@
         <p:spPr>
           <a:xfrm>
             <a:off x="719882" y="3893790"/>
-            <a:ext cx="2952006" cy="2345531"/>
+            <a:ext cx="2952006" cy="2687687"/>
           </a:xfrm>
           <a:prstGeom prst="roundRect">
             <a:avLst>
-              <a:gd name="adj" fmla="val 9209"/>
+              <a:gd name="adj" fmla="val 8036"/>
             </a:avLst>
           </a:prstGeom>
           <a:noFill/>
@@ -3690,9 +3690,52 @@
           </a:prstGeom>
         </p:spPr>
       </p:pic>
+      <p:sp>
+        <p:nvSpPr>
+          <p:cNvPr id="21" name="Rounded Rectangle 20"/>
+          <p:cNvSpPr/>
+          <p:nvPr/>
+        </p:nvSpPr>
+        <p:spPr>
+          <a:xfrm>
+            <a:off x="1053405" y="5730329"/>
+            <a:ext cx="2284958" cy="303758"/>
+          </a:xfrm>
+          <a:prstGeom prst="roundRect">
+            <a:avLst>
+              <a:gd name="adj" fmla="val 23703"/>
+            </a:avLst>
+          </a:prstGeom>
+          <a:noFill/>
+          <a:ln w="9525">
+            <a:solidFill>
+              <a:srgbClr val="555A78"/>
+            </a:solidFill>
+          </a:ln>
+        </p:spPr>
+        <p:style>
+          <a:lnRef idx="1">
+            <a:schemeClr val="accent1"/>
+          </a:lnRef>
+          <a:fillRef idx="3">
+            <a:schemeClr val="accent1"/>
+          </a:fillRef>
+          <a:effectRef idx="0">
+            <a:schemeClr val="accent1"/>
+          </a:effectRef>
+          <a:fontRef idx="minor">
+            <a:schemeClr val="lt1"/>
+          </a:fontRef>
+        </p:style>
+        <p:txBody>
+          <a:bodyPr rtlCol="0" anchor="ctr"/>
+          <a:lstStyle/>
+          <a:p/>
+        </p:txBody>
+      </p:sp>
       <p:pic>
         <p:nvPicPr>
-          <p:cNvPr id="21" name="Picture 20" descr="svg-0-10.png"/>
+          <p:cNvPr id="22" name="Picture 21" descr="svg-0-10.png"/>
           <p:cNvPicPr>
             <a:picLocks noChangeAspect="1"/>
           </p:cNvPicPr>
@@ -3706,8 +3749,8 @@
         </p:blipFill>
         <p:spPr>
           <a:xfrm>
-            <a:off x="1053405" y="5716042"/>
-            <a:ext cx="189607" cy="189607"/>
+            <a:off x="1116806" y="5793730"/>
+            <a:ext cx="176957" cy="176957"/>
           </a:xfrm>
           <a:prstGeom prst="rect">
             <a:avLst/>
@@ -3716,7 +3759,7 @@
       </p:pic>
       <p:pic>
         <p:nvPicPr>
-          <p:cNvPr id="22" name="Picture 21" descr="svg-0-11.png"/>
+          <p:cNvPr id="23" name="Picture 22" descr="svg-0-11.png"/>
           <p:cNvPicPr>
             <a:picLocks noChangeAspect="1"/>
           </p:cNvPicPr>
@@ -3730,8 +3773,8 @@
         </p:blipFill>
         <p:spPr>
           <a:xfrm>
-            <a:off x="1286173" y="5716042"/>
-            <a:ext cx="189607" cy="189607"/>
+            <a:off x="1336923" y="5793730"/>
+            <a:ext cx="176957" cy="176957"/>
           </a:xfrm>
           <a:prstGeom prst="rect">
             <a:avLst/>
@@ -3740,7 +3783,7 @@
       </p:pic>
       <p:pic>
         <p:nvPicPr>
-          <p:cNvPr id="23" name="Picture 22" descr="svg-0-12.png"/>
+          <p:cNvPr id="24" name="Picture 23" descr="svg-0-12.png"/>
           <p:cNvPicPr>
             <a:picLocks noChangeAspect="1"/>
           </p:cNvPicPr>
@@ -3754,8 +3797,8 @@
         </p:blipFill>
         <p:spPr>
           <a:xfrm>
-            <a:off x="1518940" y="5716042"/>
-            <a:ext cx="189607" cy="189607"/>
+            <a:off x="1557040" y="5793730"/>
+            <a:ext cx="176957" cy="176957"/>
           </a:xfrm>
           <a:prstGeom prst="rect">
             <a:avLst/>
@@ -3764,7 +3807,7 @@
       </p:pic>
       <p:pic>
         <p:nvPicPr>
-          <p:cNvPr id="24" name="Picture 23" descr="svg-0-13.png"/>
+          <p:cNvPr id="25" name="Picture 24" descr="svg-0-13.png"/>
           <p:cNvPicPr>
             <a:picLocks noChangeAspect="1"/>
           </p:cNvPicPr>
@@ -3778,8 +3821,8 @@
         </p:blipFill>
         <p:spPr>
           <a:xfrm>
-            <a:off x="1751707" y="5716042"/>
-            <a:ext cx="189756" cy="189756"/>
+            <a:off x="1777157" y="5793730"/>
+            <a:ext cx="176957" cy="176957"/>
           </a:xfrm>
           <a:prstGeom prst="rect">
             <a:avLst/>
@@ -3788,31 +3831,7 @@
       </p:pic>
       <p:pic>
         <p:nvPicPr>
-          <p:cNvPr id="25" name="Picture 24" descr="svg-0-12.png"/>
-          <p:cNvPicPr>
-            <a:picLocks noChangeAspect="1"/>
-          </p:cNvPicPr>
-          <p:nvPr/>
-        </p:nvPicPr>
-        <p:blipFill>
-          <a:blip r:embed="rId12"/>
-          <a:stretch>
-            <a:fillRect/>
-          </a:stretch>
-        </p:blipFill>
-        <p:spPr>
-          <a:xfrm>
-            <a:off x="1984623" y="5716042"/>
-            <a:ext cx="189607" cy="189607"/>
-          </a:xfrm>
-          <a:prstGeom prst="rect">
-            <a:avLst/>
-          </a:prstGeom>
-        </p:spPr>
-      </p:pic>
-      <p:pic>
-        <p:nvPicPr>
-          <p:cNvPr id="26" name="Picture 25" descr="svg-0-15.png"/>
+          <p:cNvPr id="26" name="Picture 25" descr="svg-0-14.png"/>
           <p:cNvPicPr>
             <a:picLocks noChangeAspect="1"/>
           </p:cNvPicPr>
@@ -3826,8 +3845,8 @@
         </p:blipFill>
         <p:spPr>
           <a:xfrm>
-            <a:off x="2217390" y="5716042"/>
-            <a:ext cx="189607" cy="189607"/>
+            <a:off x="1997273" y="5793730"/>
+            <a:ext cx="176957" cy="176957"/>
           </a:xfrm>
           <a:prstGeom prst="rect">
             <a:avLst/>
@@ -3836,7 +3855,79 @@
       </p:pic>
       <p:pic>
         <p:nvPicPr>
-          <p:cNvPr id="27" name="Picture 26" descr="svg-0-16.png"/>
+          <p:cNvPr id="27" name="Picture 26" descr="svg-0-14.png"/>
+          <p:cNvPicPr>
+            <a:picLocks noChangeAspect="1"/>
+          </p:cNvPicPr>
+          <p:nvPr/>
+        </p:nvPicPr>
+        <p:blipFill>
+          <a:blip r:embed="rId14"/>
+          <a:stretch>
+            <a:fillRect/>
+          </a:stretch>
+        </p:blipFill>
+        <p:spPr>
+          <a:xfrm>
+            <a:off x="2217390" y="5793730"/>
+            <a:ext cx="176957" cy="176957"/>
+          </a:xfrm>
+          <a:prstGeom prst="rect">
+            <a:avLst/>
+          </a:prstGeom>
+        </p:spPr>
+      </p:pic>
+      <p:pic>
+        <p:nvPicPr>
+          <p:cNvPr id="28" name="Picture 27" descr="svg-0-14.png"/>
+          <p:cNvPicPr>
+            <a:picLocks noChangeAspect="1"/>
+          </p:cNvPicPr>
+          <p:nvPr/>
+        </p:nvPicPr>
+        <p:blipFill>
+          <a:blip r:embed="rId14"/>
+          <a:stretch>
+            <a:fillRect/>
+          </a:stretch>
+        </p:blipFill>
+        <p:spPr>
+          <a:xfrm>
+            <a:off x="2437507" y="5793730"/>
+            <a:ext cx="176957" cy="176957"/>
+          </a:xfrm>
+          <a:prstGeom prst="rect">
+            <a:avLst/>
+          </a:prstGeom>
+        </p:spPr>
+      </p:pic>
+      <p:pic>
+        <p:nvPicPr>
+          <p:cNvPr id="29" name="Picture 28" descr="svg-0-11.png"/>
+          <p:cNvPicPr>
+            <a:picLocks noChangeAspect="1"/>
+          </p:cNvPicPr>
+          <p:nvPr/>
+        </p:nvPicPr>
+        <p:blipFill>
+          <a:blip r:embed="rId11"/>
+          <a:stretch>
+            <a:fillRect/>
+          </a:stretch>
+        </p:blipFill>
+        <p:spPr>
+          <a:xfrm>
+            <a:off x="2657624" y="5793730"/>
+            <a:ext cx="176957" cy="176957"/>
+          </a:xfrm>
+          <a:prstGeom prst="rect">
+            <a:avLst/>
+          </a:prstGeom>
+        </p:spPr>
+      </p:pic>
+      <p:pic>
+        <p:nvPicPr>
+          <p:cNvPr id="30" name="Picture 29" descr="svg-0-18.png"/>
           <p:cNvPicPr>
             <a:picLocks noChangeAspect="1"/>
           </p:cNvPicPr>
@@ -3850,8 +3941,8 @@
         </p:blipFill>
         <p:spPr>
           <a:xfrm>
-            <a:off x="2450157" y="5716042"/>
-            <a:ext cx="189756" cy="189756"/>
+            <a:off x="2877741" y="5793730"/>
+            <a:ext cx="176957" cy="176957"/>
           </a:xfrm>
           <a:prstGeom prst="rect">
             <a:avLst/>
@@ -3860,31 +3951,230 @@
       </p:pic>
       <p:pic>
         <p:nvPicPr>
-          <p:cNvPr id="28" name="Picture 27" descr="svg-0-15.png"/>
+          <p:cNvPr id="31" name="Picture 30" descr="svg-0-11.png"/>
           <p:cNvPicPr>
             <a:picLocks noChangeAspect="1"/>
           </p:cNvPicPr>
           <p:nvPr/>
         </p:nvPicPr>
         <p:blipFill>
-          <a:blip r:embed="rId14"/>
+          <a:blip r:embed="rId11"/>
           <a:stretch>
             <a:fillRect/>
           </a:stretch>
         </p:blipFill>
         <p:spPr>
           <a:xfrm>
-            <a:off x="2683073" y="5716042"/>
-            <a:ext cx="189607" cy="189607"/>
+            <a:off x="3097857" y="5793730"/>
+            <a:ext cx="176957" cy="176957"/>
           </a:xfrm>
           <a:prstGeom prst="rect">
             <a:avLst/>
           </a:prstGeom>
         </p:spPr>
       </p:pic>
+      <p:sp>
+        <p:nvSpPr>
+          <p:cNvPr id="32" name="TextBox 31"/>
+          <p:cNvSpPr txBox="1"/>
+          <p:nvPr/>
+        </p:nvSpPr>
+        <p:spPr>
+          <a:xfrm>
+            <a:off x="1053405" y="6087963"/>
+            <a:ext cx="1503998" cy="142875"/>
+          </a:xfrm>
+          <a:prstGeom prst="rect">
+            <a:avLst/>
+          </a:prstGeom>
+          <a:noFill/>
+        </p:spPr>
+        <p:txBody>
+          <a:bodyPr wrap="square" anchor="t" lIns="0" rIns="0" tIns="0" bIns="0">
+            <a:noAutofit/>
+          </a:bodyPr>
+          <a:lstStyle/>
+          <a:p>
+            <a:pPr algn="l">
+              <a:lnSpc>
+                <a:spcPts val="1260"/>
+              </a:lnSpc>
+            </a:pPr>
+            <a:r>
+              <a:rPr sz="900" b="0">
+                <a:solidFill>
+                  <a:srgbClr val="555A78"/>
+                </a:solidFill>
+                <a:latin typeface="Inter"/>
+              </a:rPr>
+              <a:t>Krijgt nu geen feedback</a:t>
+            </a:r>
+          </a:p>
+        </p:txBody>
+      </p:sp>
+      <p:sp>
+        <p:nvSpPr>
+          <p:cNvPr id="33" name="Rounded Rectangle 32"/>
+          <p:cNvSpPr/>
+          <p:nvPr/>
+        </p:nvSpPr>
+        <p:spPr>
+          <a:xfrm>
+            <a:off x="3887837" y="3893790"/>
+            <a:ext cx="2952155" cy="2687687"/>
+          </a:xfrm>
+          <a:prstGeom prst="roundRect">
+            <a:avLst>
+              <a:gd name="adj" fmla="val 8036"/>
+            </a:avLst>
+          </a:prstGeom>
+          <a:solidFill>
+            <a:srgbClr val="E3E6F4"/>
+          </a:solidFill>
+          <a:ln>
+            <a:noFill/>
+          </a:ln>
+        </p:spPr>
+        <p:style>
+          <a:lnRef idx="1">
+            <a:schemeClr val="accent1"/>
+          </a:lnRef>
+          <a:fillRef idx="3">
+            <a:schemeClr val="accent1"/>
+          </a:fillRef>
+          <a:effectRef idx="0">
+            <a:schemeClr val="accent1"/>
+          </a:effectRef>
+          <a:fontRef idx="minor">
+            <a:schemeClr val="lt1"/>
+          </a:fontRef>
+        </p:style>
+        <p:txBody>
+          <a:bodyPr rtlCol="0" anchor="ctr"/>
+          <a:lstStyle/>
+          <a:p/>
+        </p:txBody>
+      </p:sp>
+      <p:sp>
+        <p:nvSpPr>
+          <p:cNvPr id="34" name="TextBox 33"/>
+          <p:cNvSpPr txBox="1"/>
+          <p:nvPr/>
+        </p:nvSpPr>
+        <p:spPr>
+          <a:xfrm>
+            <a:off x="4211836" y="4217789"/>
+            <a:ext cx="1069943" cy="142875"/>
+          </a:xfrm>
+          <a:prstGeom prst="rect">
+            <a:avLst/>
+          </a:prstGeom>
+          <a:noFill/>
+        </p:spPr>
+        <p:txBody>
+          <a:bodyPr wrap="square" anchor="t" lIns="0" rIns="0" tIns="0" bIns="0">
+            <a:noAutofit/>
+          </a:bodyPr>
+          <a:lstStyle/>
+          <a:p>
+            <a:pPr algn="l">
+              <a:lnSpc>
+                <a:spcPts val="1080"/>
+              </a:lnSpc>
+            </a:pPr>
+            <a:r>
+              <a:rPr sz="900" b="1">
+                <a:solidFill>
+                  <a:srgbClr val="555A78"/>
+                </a:solidFill>
+                <a:latin typeface="Inter"/>
+              </a:rPr>
+              <a:t>MET EDUFACE</a:t>
+            </a:r>
+          </a:p>
+        </p:txBody>
+      </p:sp>
+      <p:sp>
+        <p:nvSpPr>
+          <p:cNvPr id="35" name="TextBox 34"/>
+          <p:cNvSpPr txBox="1"/>
+          <p:nvPr/>
+        </p:nvSpPr>
+        <p:spPr>
+          <a:xfrm>
+            <a:off x="4211836" y="4478089"/>
+            <a:ext cx="2008894" cy="428625"/>
+          </a:xfrm>
+          <a:prstGeom prst="rect">
+            <a:avLst/>
+          </a:prstGeom>
+          <a:noFill/>
+        </p:spPr>
+        <p:txBody>
+          <a:bodyPr wrap="square" anchor="t" lIns="0" rIns="0" tIns="0" bIns="0">
+            <a:noAutofit/>
+          </a:bodyPr>
+          <a:lstStyle/>
+          <a:p>
+            <a:pPr algn="l">
+              <a:lnSpc>
+                <a:spcPts val="3600"/>
+              </a:lnSpc>
+            </a:pPr>
+            <a:r>
+              <a:rPr sz="3600" b="1">
+                <a:solidFill>
+                  <a:srgbClr val="000326"/>
+                </a:solidFill>
+                <a:latin typeface="League Spartan"/>
+              </a:rPr>
+              <a:t>€ 18.000</a:t>
+            </a:r>
+          </a:p>
+        </p:txBody>
+      </p:sp>
+      <p:sp>
+        <p:nvSpPr>
+          <p:cNvPr id="36" name="TextBox 35"/>
+          <p:cNvSpPr txBox="1"/>
+          <p:nvPr/>
+        </p:nvSpPr>
+        <p:spPr>
+          <a:xfrm>
+            <a:off x="4211836" y="5052715"/>
+            <a:ext cx="2103739" cy="171450"/>
+          </a:xfrm>
+          <a:prstGeom prst="rect">
+            <a:avLst/>
+          </a:prstGeom>
+          <a:noFill/>
+        </p:spPr>
+        <p:txBody>
+          <a:bodyPr wrap="square" anchor="t" lIns="0" rIns="0" tIns="0" bIns="0">
+            <a:noAutofit/>
+          </a:bodyPr>
+          <a:lstStyle/>
+          <a:p>
+            <a:pPr algn="l">
+              <a:lnSpc>
+                <a:spcPts val="1650"/>
+              </a:lnSpc>
+            </a:pPr>
+            <a:r>
+              <a:rPr sz="1100" b="0">
+                <a:solidFill>
+                  <a:srgbClr val="555A78"/>
+                </a:solidFill>
+                <a:latin typeface="Inter"/>
+              </a:rPr>
+              <a:t>Feedback voor elke student</a:t>
+            </a:r>
+          </a:p>
+        </p:txBody>
+      </p:sp>
       <p:pic>
         <p:nvPicPr>
-          <p:cNvPr id="29" name="Picture 28" descr="svg-0-18.png"/>
+          <p:cNvPr id="37" name="Picture 36" descr="svg-0-20.png"/>
           <p:cNvPicPr>
             <a:picLocks noChangeAspect="1"/>
           </p:cNvPicPr>
@@ -3898,8 +4188,8 @@
         </p:blipFill>
         <p:spPr>
           <a:xfrm>
-            <a:off x="2915841" y="5716042"/>
-            <a:ext cx="189607" cy="189607"/>
+            <a:off x="4211836" y="5459164"/>
+            <a:ext cx="191542" cy="191542"/>
           </a:xfrm>
           <a:prstGeom prst="rect">
             <a:avLst/>
@@ -3908,7 +4198,7 @@
       </p:pic>
       <p:pic>
         <p:nvPicPr>
-          <p:cNvPr id="30" name="Picture 29" descr="svg-0-19.png"/>
+          <p:cNvPr id="38" name="Picture 37" descr="svg-0-21.png"/>
           <p:cNvPicPr>
             <a:picLocks noChangeAspect="1"/>
           </p:cNvPicPr>
@@ -3922,177 +4212,17 @@
         </p:blipFill>
         <p:spPr>
           <a:xfrm>
-            <a:off x="3148608" y="5716042"/>
-            <a:ext cx="189756" cy="189756"/>
+            <a:off x="4446538" y="5459164"/>
+            <a:ext cx="191542" cy="191542"/>
           </a:xfrm>
           <a:prstGeom prst="rect">
             <a:avLst/>
           </a:prstGeom>
         </p:spPr>
       </p:pic>
-      <p:sp>
-        <p:nvSpPr>
-          <p:cNvPr id="31" name="Rounded Rectangle 30"/>
-          <p:cNvSpPr/>
-          <p:nvPr/>
-        </p:nvSpPr>
-        <p:spPr>
-          <a:xfrm>
-            <a:off x="3887837" y="3893790"/>
-            <a:ext cx="2952155" cy="2345531"/>
-          </a:xfrm>
-          <a:prstGeom prst="roundRect">
-            <a:avLst>
-              <a:gd name="adj" fmla="val 9209"/>
-            </a:avLst>
-          </a:prstGeom>
-          <a:solidFill>
-            <a:srgbClr val="E3E6F4"/>
-          </a:solidFill>
-          <a:ln>
-            <a:noFill/>
-          </a:ln>
-        </p:spPr>
-        <p:style>
-          <a:lnRef idx="1">
-            <a:schemeClr val="accent1"/>
-          </a:lnRef>
-          <a:fillRef idx="3">
-            <a:schemeClr val="accent1"/>
-          </a:fillRef>
-          <a:effectRef idx="0">
-            <a:schemeClr val="accent1"/>
-          </a:effectRef>
-          <a:fontRef idx="minor">
-            <a:schemeClr val="lt1"/>
-          </a:fontRef>
-        </p:style>
-        <p:txBody>
-          <a:bodyPr rtlCol="0" anchor="ctr"/>
-          <a:lstStyle/>
-          <a:p/>
-        </p:txBody>
-      </p:sp>
-      <p:sp>
-        <p:nvSpPr>
-          <p:cNvPr id="32" name="TextBox 31"/>
-          <p:cNvSpPr txBox="1"/>
-          <p:nvPr/>
-        </p:nvSpPr>
-        <p:spPr>
-          <a:xfrm>
-            <a:off x="4211836" y="4217789"/>
-            <a:ext cx="1069943" cy="142875"/>
-          </a:xfrm>
-          <a:prstGeom prst="rect">
-            <a:avLst/>
-          </a:prstGeom>
-          <a:noFill/>
-        </p:spPr>
-        <p:txBody>
-          <a:bodyPr wrap="square" anchor="t" lIns="0" rIns="0" tIns="0" bIns="0">
-            <a:noAutofit/>
-          </a:bodyPr>
-          <a:lstStyle/>
-          <a:p>
-            <a:pPr algn="l">
-              <a:lnSpc>
-                <a:spcPts val="1080"/>
-              </a:lnSpc>
-            </a:pPr>
-            <a:r>
-              <a:rPr sz="900" b="1">
-                <a:solidFill>
-                  <a:srgbClr val="555A78"/>
-                </a:solidFill>
-                <a:latin typeface="Inter"/>
-              </a:rPr>
-              <a:t>MET EDUFACE</a:t>
-            </a:r>
-          </a:p>
-        </p:txBody>
-      </p:sp>
-      <p:sp>
-        <p:nvSpPr>
-          <p:cNvPr id="33" name="TextBox 32"/>
-          <p:cNvSpPr txBox="1"/>
-          <p:nvPr/>
-        </p:nvSpPr>
-        <p:spPr>
-          <a:xfrm>
-            <a:off x="4211836" y="4478089"/>
-            <a:ext cx="2008894" cy="428625"/>
-          </a:xfrm>
-          <a:prstGeom prst="rect">
-            <a:avLst/>
-          </a:prstGeom>
-          <a:noFill/>
-        </p:spPr>
-        <p:txBody>
-          <a:bodyPr wrap="square" anchor="t" lIns="0" rIns="0" tIns="0" bIns="0">
-            <a:noAutofit/>
-          </a:bodyPr>
-          <a:lstStyle/>
-          <a:p>
-            <a:pPr algn="l">
-              <a:lnSpc>
-                <a:spcPts val="3600"/>
-              </a:lnSpc>
-            </a:pPr>
-            <a:r>
-              <a:rPr sz="3600" b="1">
-                <a:solidFill>
-                  <a:srgbClr val="000326"/>
-                </a:solidFill>
-                <a:latin typeface="League Spartan"/>
-              </a:rPr>
-              <a:t>€ 18.000</a:t>
-            </a:r>
-          </a:p>
-        </p:txBody>
-      </p:sp>
-      <p:sp>
-        <p:nvSpPr>
-          <p:cNvPr id="34" name="TextBox 33"/>
-          <p:cNvSpPr txBox="1"/>
-          <p:nvPr/>
-        </p:nvSpPr>
-        <p:spPr>
-          <a:xfrm>
-            <a:off x="4211836" y="5052715"/>
-            <a:ext cx="2103739" cy="171450"/>
-          </a:xfrm>
-          <a:prstGeom prst="rect">
-            <a:avLst/>
-          </a:prstGeom>
-          <a:noFill/>
-        </p:spPr>
-        <p:txBody>
-          <a:bodyPr wrap="square" anchor="t" lIns="0" rIns="0" tIns="0" bIns="0">
-            <a:noAutofit/>
-          </a:bodyPr>
-          <a:lstStyle/>
-          <a:p>
-            <a:pPr algn="l">
-              <a:lnSpc>
-                <a:spcPts val="1650"/>
-              </a:lnSpc>
-            </a:pPr>
-            <a:r>
-              <a:rPr sz="1100" b="0">
-                <a:solidFill>
-                  <a:srgbClr val="555A78"/>
-                </a:solidFill>
-                <a:latin typeface="Inter"/>
-              </a:rPr>
-              <a:t>Feedback voor elke student</a:t>
-            </a:r>
-          </a:p>
-        </p:txBody>
-      </p:sp>
       <p:pic>
         <p:nvPicPr>
-          <p:cNvPr id="35" name="Picture 34" descr="svg-0-20.png"/>
+          <p:cNvPr id="39" name="Picture 38" descr="svg-0-22.png"/>
           <p:cNvPicPr>
             <a:picLocks noChangeAspect="1"/>
           </p:cNvPicPr>
@@ -4106,7 +4236,7 @@
         </p:blipFill>
         <p:spPr>
           <a:xfrm>
-            <a:off x="4211836" y="5459164"/>
+            <a:off x="4681240" y="5459164"/>
             <a:ext cx="191542" cy="191542"/>
           </a:xfrm>
           <a:prstGeom prst="rect">
@@ -4116,7 +4246,55 @@
       </p:pic>
       <p:pic>
         <p:nvPicPr>
-          <p:cNvPr id="36" name="Picture 35" descr="svg-0-21.png"/>
+          <p:cNvPr id="40" name="Picture 39" descr="svg-0-20.png"/>
+          <p:cNvPicPr>
+            <a:picLocks noChangeAspect="1"/>
+          </p:cNvPicPr>
+          <p:nvPr/>
+        </p:nvPicPr>
+        <p:blipFill>
+          <a:blip r:embed="rId16"/>
+          <a:stretch>
+            <a:fillRect/>
+          </a:stretch>
+        </p:blipFill>
+        <p:spPr>
+          <a:xfrm>
+            <a:off x="4915942" y="5459164"/>
+            <a:ext cx="191542" cy="191542"/>
+          </a:xfrm>
+          <a:prstGeom prst="rect">
+            <a:avLst/>
+          </a:prstGeom>
+        </p:spPr>
+      </p:pic>
+      <p:pic>
+        <p:nvPicPr>
+          <p:cNvPr id="41" name="Picture 40" descr="svg-0-21.png"/>
+          <p:cNvPicPr>
+            <a:picLocks noChangeAspect="1"/>
+          </p:cNvPicPr>
+          <p:nvPr/>
+        </p:nvPicPr>
+        <p:blipFill>
+          <a:blip r:embed="rId17"/>
+          <a:stretch>
+            <a:fillRect/>
+          </a:stretch>
+        </p:blipFill>
+        <p:spPr>
+          <a:xfrm>
+            <a:off x="5150644" y="5459164"/>
+            <a:ext cx="191542" cy="191542"/>
+          </a:xfrm>
+          <a:prstGeom prst="rect">
+            <a:avLst/>
+          </a:prstGeom>
+        </p:spPr>
+      </p:pic>
+      <p:pic>
+        <p:nvPicPr>
+          <p:cNvPr id="42" name="Picture 41" descr="svg-0-25.png"/>
           <p:cNvPicPr>
             <a:picLocks noChangeAspect="1"/>
           </p:cNvPicPr>
@@ -4130,8 +4308,8 @@
         </p:blipFill>
         <p:spPr>
           <a:xfrm>
-            <a:off x="4446538" y="5459164"/>
-            <a:ext cx="191542" cy="191542"/>
+            <a:off x="5385346" y="5459164"/>
+            <a:ext cx="191691" cy="191691"/>
           </a:xfrm>
           <a:prstGeom prst="rect">
             <a:avLst/>
@@ -4140,7 +4318,79 @@
       </p:pic>
       <p:pic>
         <p:nvPicPr>
-          <p:cNvPr id="37" name="Picture 36" descr="svg-0-22.png"/>
+          <p:cNvPr id="43" name="Picture 42" descr="svg-0-20.png"/>
+          <p:cNvPicPr>
+            <a:picLocks noChangeAspect="1"/>
+          </p:cNvPicPr>
+          <p:nvPr/>
+        </p:nvPicPr>
+        <p:blipFill>
+          <a:blip r:embed="rId16"/>
+          <a:stretch>
+            <a:fillRect/>
+          </a:stretch>
+        </p:blipFill>
+        <p:spPr>
+          <a:xfrm>
+            <a:off x="5620196" y="5459164"/>
+            <a:ext cx="191542" cy="191542"/>
+          </a:xfrm>
+          <a:prstGeom prst="rect">
+            <a:avLst/>
+          </a:prstGeom>
+        </p:spPr>
+      </p:pic>
+      <p:pic>
+        <p:nvPicPr>
+          <p:cNvPr id="44" name="Picture 43" descr="svg-0-21.png"/>
+          <p:cNvPicPr>
+            <a:picLocks noChangeAspect="1"/>
+          </p:cNvPicPr>
+          <p:nvPr/>
+        </p:nvPicPr>
+        <p:blipFill>
+          <a:blip r:embed="rId17"/>
+          <a:stretch>
+            <a:fillRect/>
+          </a:stretch>
+        </p:blipFill>
+        <p:spPr>
+          <a:xfrm>
+            <a:off x="5854898" y="5459164"/>
+            <a:ext cx="191542" cy="191542"/>
+          </a:xfrm>
+          <a:prstGeom prst="rect">
+            <a:avLst/>
+          </a:prstGeom>
+        </p:spPr>
+      </p:pic>
+      <p:pic>
+        <p:nvPicPr>
+          <p:cNvPr id="45" name="Picture 44" descr="svg-0-20.png"/>
+          <p:cNvPicPr>
+            <a:picLocks noChangeAspect="1"/>
+          </p:cNvPicPr>
+          <p:nvPr/>
+        </p:nvPicPr>
+        <p:blipFill>
+          <a:blip r:embed="rId16"/>
+          <a:stretch>
+            <a:fillRect/>
+          </a:stretch>
+        </p:blipFill>
+        <p:spPr>
+          <a:xfrm>
+            <a:off x="6089600" y="5459164"/>
+            <a:ext cx="191542" cy="191542"/>
+          </a:xfrm>
+          <a:prstGeom prst="rect">
+            <a:avLst/>
+          </a:prstGeom>
+        </p:spPr>
+      </p:pic>
+      <p:pic>
+        <p:nvPicPr>
+          <p:cNvPr id="46" name="Picture 45" descr="svg-0-29.png"/>
           <p:cNvPicPr>
             <a:picLocks noChangeAspect="1"/>
           </p:cNvPicPr>
@@ -4154,7 +4404,7 @@
         </p:blipFill>
         <p:spPr>
           <a:xfrm>
-            <a:off x="4681240" y="5459164"/>
+            <a:off x="6324302" y="5459164"/>
             <a:ext cx="191542" cy="191542"/>
           </a:xfrm>
           <a:prstGeom prst="rect">
@@ -4164,7 +4414,55 @@
       </p:pic>
       <p:pic>
         <p:nvPicPr>
-          <p:cNvPr id="38" name="Picture 37" descr="svg-0-20.png"/>
+          <p:cNvPr id="47" name="Picture 46" descr="svg-0-20.png"/>
+          <p:cNvPicPr>
+            <a:picLocks noChangeAspect="1"/>
+          </p:cNvPicPr>
+          <p:nvPr/>
+        </p:nvPicPr>
+        <p:blipFill>
+          <a:blip r:embed="rId16"/>
+          <a:stretch>
+            <a:fillRect/>
+          </a:stretch>
+        </p:blipFill>
+        <p:spPr>
+          <a:xfrm>
+            <a:off x="4211836" y="5708452"/>
+            <a:ext cx="191542" cy="191542"/>
+          </a:xfrm>
+          <a:prstGeom prst="rect">
+            <a:avLst/>
+          </a:prstGeom>
+        </p:spPr>
+      </p:pic>
+      <p:pic>
+        <p:nvPicPr>
+          <p:cNvPr id="48" name="Picture 47" descr="svg-0-21.png"/>
+          <p:cNvPicPr>
+            <a:picLocks noChangeAspect="1"/>
+          </p:cNvPicPr>
+          <p:nvPr/>
+        </p:nvPicPr>
+        <p:blipFill>
+          <a:blip r:embed="rId17"/>
+          <a:stretch>
+            <a:fillRect/>
+          </a:stretch>
+        </p:blipFill>
+        <p:spPr>
+          <a:xfrm>
+            <a:off x="4446538" y="5708452"/>
+            <a:ext cx="191542" cy="191542"/>
+          </a:xfrm>
+          <a:prstGeom prst="rect">
+            <a:avLst/>
+          </a:prstGeom>
+        </p:spPr>
+      </p:pic>
+      <p:pic>
+        <p:nvPicPr>
+          <p:cNvPr id="49" name="Picture 48" descr="svg-0-22.png"/>
           <p:cNvPicPr>
             <a:picLocks noChangeAspect="1"/>
           </p:cNvPicPr>
@@ -4178,7 +4476,7 @@
         </p:blipFill>
         <p:spPr>
           <a:xfrm>
-            <a:off x="4915942" y="5459164"/>
+            <a:off x="4681240" y="5708452"/>
             <a:ext cx="191542" cy="191542"/>
           </a:xfrm>
           <a:prstGeom prst="rect">
@@ -4188,7 +4486,55 @@
       </p:pic>
       <p:pic>
         <p:nvPicPr>
-          <p:cNvPr id="39" name="Picture 38" descr="svg-0-21.png"/>
+          <p:cNvPr id="50" name="Picture 49" descr="svg-0-20.png"/>
+          <p:cNvPicPr>
+            <a:picLocks noChangeAspect="1"/>
+          </p:cNvPicPr>
+          <p:nvPr/>
+        </p:nvPicPr>
+        <p:blipFill>
+          <a:blip r:embed="rId16"/>
+          <a:stretch>
+            <a:fillRect/>
+          </a:stretch>
+        </p:blipFill>
+        <p:spPr>
+          <a:xfrm>
+            <a:off x="4915942" y="5708452"/>
+            <a:ext cx="191542" cy="191542"/>
+          </a:xfrm>
+          <a:prstGeom prst="rect">
+            <a:avLst/>
+          </a:prstGeom>
+        </p:spPr>
+      </p:pic>
+      <p:pic>
+        <p:nvPicPr>
+          <p:cNvPr id="51" name="Picture 50" descr="svg-0-21.png"/>
+          <p:cNvPicPr>
+            <a:picLocks noChangeAspect="1"/>
+          </p:cNvPicPr>
+          <p:nvPr/>
+        </p:nvPicPr>
+        <p:blipFill>
+          <a:blip r:embed="rId17"/>
+          <a:stretch>
+            <a:fillRect/>
+          </a:stretch>
+        </p:blipFill>
+        <p:spPr>
+          <a:xfrm>
+            <a:off x="5150644" y="5708452"/>
+            <a:ext cx="191542" cy="191542"/>
+          </a:xfrm>
+          <a:prstGeom prst="rect">
+            <a:avLst/>
+          </a:prstGeom>
+        </p:spPr>
+      </p:pic>
+      <p:pic>
+        <p:nvPicPr>
+          <p:cNvPr id="52" name="Picture 51" descr="svg-0-25.png"/>
           <p:cNvPicPr>
             <a:picLocks noChangeAspect="1"/>
           </p:cNvPicPr>
@@ -4202,8 +4548,8 @@
         </p:blipFill>
         <p:spPr>
           <a:xfrm>
-            <a:off x="5150644" y="5459164"/>
-            <a:ext cx="191542" cy="191542"/>
+            <a:off x="5385346" y="5708452"/>
+            <a:ext cx="191691" cy="191691"/>
           </a:xfrm>
           <a:prstGeom prst="rect">
             <a:avLst/>
@@ -4212,7 +4558,263 @@
       </p:pic>
       <p:pic>
         <p:nvPicPr>
-          <p:cNvPr id="40" name="Picture 39" descr="svg-0-25.png"/>
+          <p:cNvPr id="53" name="Picture 52" descr="svg-0-20.png"/>
+          <p:cNvPicPr>
+            <a:picLocks noChangeAspect="1"/>
+          </p:cNvPicPr>
+          <p:nvPr/>
+        </p:nvPicPr>
+        <p:blipFill>
+          <a:blip r:embed="rId16"/>
+          <a:stretch>
+            <a:fillRect/>
+          </a:stretch>
+        </p:blipFill>
+        <p:spPr>
+          <a:xfrm>
+            <a:off x="5620196" y="5708452"/>
+            <a:ext cx="191542" cy="191542"/>
+          </a:xfrm>
+          <a:prstGeom prst="rect">
+            <a:avLst/>
+          </a:prstGeom>
+        </p:spPr>
+      </p:pic>
+      <p:pic>
+        <p:nvPicPr>
+          <p:cNvPr id="54" name="Picture 53" descr="svg-0-21.png"/>
+          <p:cNvPicPr>
+            <a:picLocks noChangeAspect="1"/>
+          </p:cNvPicPr>
+          <p:nvPr/>
+        </p:nvPicPr>
+        <p:blipFill>
+          <a:blip r:embed="rId17"/>
+          <a:stretch>
+            <a:fillRect/>
+          </a:stretch>
+        </p:blipFill>
+        <p:spPr>
+          <a:xfrm>
+            <a:off x="5854898" y="5708452"/>
+            <a:ext cx="191542" cy="191542"/>
+          </a:xfrm>
+          <a:prstGeom prst="rect">
+            <a:avLst/>
+          </a:prstGeom>
+        </p:spPr>
+      </p:pic>
+      <p:pic>
+        <p:nvPicPr>
+          <p:cNvPr id="55" name="Picture 54" descr="svg-0-20.png"/>
+          <p:cNvPicPr>
+            <a:picLocks noChangeAspect="1"/>
+          </p:cNvPicPr>
+          <p:nvPr/>
+        </p:nvPicPr>
+        <p:blipFill>
+          <a:blip r:embed="rId16"/>
+          <a:stretch>
+            <a:fillRect/>
+          </a:stretch>
+        </p:blipFill>
+        <p:spPr>
+          <a:xfrm>
+            <a:off x="6089600" y="5708452"/>
+            <a:ext cx="191542" cy="191542"/>
+          </a:xfrm>
+          <a:prstGeom prst="rect">
+            <a:avLst/>
+          </a:prstGeom>
+        </p:spPr>
+      </p:pic>
+      <p:pic>
+        <p:nvPicPr>
+          <p:cNvPr id="56" name="Picture 55" descr="svg-0-29.png"/>
+          <p:cNvPicPr>
+            <a:picLocks noChangeAspect="1"/>
+          </p:cNvPicPr>
+          <p:nvPr/>
+        </p:nvPicPr>
+        <p:blipFill>
+          <a:blip r:embed="rId20"/>
+          <a:stretch>
+            <a:fillRect/>
+          </a:stretch>
+        </p:blipFill>
+        <p:spPr>
+          <a:xfrm>
+            <a:off x="6324302" y="5708452"/>
+            <a:ext cx="191542" cy="191542"/>
+          </a:xfrm>
+          <a:prstGeom prst="rect">
+            <a:avLst/>
+          </a:prstGeom>
+        </p:spPr>
+      </p:pic>
+      <p:sp>
+        <p:nvSpPr>
+          <p:cNvPr id="57" name="TextBox 56"/>
+          <p:cNvSpPr txBox="1"/>
+          <p:nvPr/>
+        </p:nvSpPr>
+        <p:spPr>
+          <a:xfrm>
+            <a:off x="723900" y="6689378"/>
+            <a:ext cx="2804827" cy="142875"/>
+          </a:xfrm>
+          <a:prstGeom prst="rect">
+            <a:avLst/>
+          </a:prstGeom>
+          <a:noFill/>
+        </p:spPr>
+        <p:txBody>
+          <a:bodyPr wrap="square" anchor="t" lIns="0" rIns="0" tIns="0" bIns="0">
+            <a:noAutofit/>
+          </a:bodyPr>
+          <a:lstStyle/>
+          <a:p>
+            <a:pPr algn="l">
+              <a:lnSpc>
+                <a:spcPts val="1260"/>
+              </a:lnSpc>
+            </a:pPr>
+            <a:r>
+              <a:rPr sz="900" b="0">
+                <a:solidFill>
+                  <a:srgbClr val="555A78"/>
+                </a:solidFill>
+                <a:latin typeface="Inter"/>
+              </a:rPr>
+              <a:t>Elk poppetje staat voor 5% van de studenten.</a:t>
+            </a:r>
+          </a:p>
+        </p:txBody>
+      </p:sp>
+      <p:sp>
+        <p:nvSpPr>
+          <p:cNvPr id="58" name="Rounded Rectangle 57"/>
+          <p:cNvSpPr/>
+          <p:nvPr/>
+        </p:nvSpPr>
+        <p:spPr>
+          <a:xfrm>
+            <a:off x="719882" y="7065318"/>
+            <a:ext cx="6120110" cy="1422648"/>
+          </a:xfrm>
+          <a:prstGeom prst="roundRect">
+            <a:avLst>
+              <a:gd name="adj" fmla="val 15182"/>
+            </a:avLst>
+          </a:prstGeom>
+          <a:solidFill>
+            <a:srgbClr val="F1F2F9"/>
+          </a:solidFill>
+          <a:ln>
+            <a:noFill/>
+          </a:ln>
+        </p:spPr>
+        <p:style>
+          <a:lnRef idx="1">
+            <a:schemeClr val="accent1"/>
+          </a:lnRef>
+          <a:fillRef idx="3">
+            <a:schemeClr val="accent1"/>
+          </a:fillRef>
+          <a:effectRef idx="0">
+            <a:schemeClr val="accent1"/>
+          </a:effectRef>
+          <a:fontRef idx="minor">
+            <a:schemeClr val="lt1"/>
+          </a:fontRef>
+        </p:style>
+        <p:txBody>
+          <a:bodyPr rtlCol="0" anchor="ctr"/>
+          <a:lstStyle/>
+          <a:p/>
+        </p:txBody>
+      </p:sp>
+      <p:sp>
+        <p:nvSpPr>
+          <p:cNvPr id="59" name="TextBox 58"/>
+          <p:cNvSpPr txBox="1"/>
+          <p:nvPr/>
+        </p:nvSpPr>
+        <p:spPr>
+          <a:xfrm>
+            <a:off x="1043880" y="7398841"/>
+            <a:ext cx="3437573" cy="428625"/>
+          </a:xfrm>
+          <a:prstGeom prst="rect">
+            <a:avLst/>
+          </a:prstGeom>
+          <a:noFill/>
+        </p:spPr>
+        <p:txBody>
+          <a:bodyPr wrap="square" anchor="t" lIns="0" rIns="0" tIns="0" bIns="0">
+            <a:noAutofit/>
+          </a:bodyPr>
+          <a:lstStyle/>
+          <a:p>
+            <a:pPr algn="l">
+              <a:lnSpc>
+                <a:spcPts val="3600"/>
+              </a:lnSpc>
+            </a:pPr>
+            <a:r>
+              <a:rPr sz="3600" b="1">
+                <a:solidFill>
+                  <a:srgbClr val="000326"/>
+                </a:solidFill>
+                <a:latin typeface="League Spartan"/>
+              </a:rPr>
+              <a:t>76% goedkoper</a:t>
+            </a:r>
+          </a:p>
+        </p:txBody>
+      </p:sp>
+      <p:sp>
+        <p:nvSpPr>
+          <p:cNvPr id="60" name="TextBox 59"/>
+          <p:cNvSpPr txBox="1"/>
+          <p:nvPr/>
+        </p:nvSpPr>
+        <p:spPr>
+          <a:xfrm>
+            <a:off x="1043880" y="7973467"/>
+            <a:ext cx="2320766" cy="171450"/>
+          </a:xfrm>
+          <a:prstGeom prst="rect">
+            <a:avLst/>
+          </a:prstGeom>
+          <a:noFill/>
+        </p:spPr>
+        <p:txBody>
+          <a:bodyPr wrap="square" anchor="t" lIns="0" rIns="0" tIns="0" bIns="0">
+            <a:noAutofit/>
+          </a:bodyPr>
+          <a:lstStyle/>
+          <a:p>
+            <a:pPr algn="l">
+              <a:lnSpc>
+                <a:spcPts val="1650"/>
+              </a:lnSpc>
+            </a:pPr>
+            <a:r>
+              <a:rPr sz="1100" b="0">
+                <a:solidFill>
+                  <a:srgbClr val="555A78"/>
+                </a:solidFill>
+                <a:latin typeface="Inter"/>
+              </a:rPr>
+              <a:t>per student die feedback krijgt</a:t>
+            </a:r>
+          </a:p>
+        </p:txBody>
+      </p:sp>
+      <p:pic>
+        <p:nvPicPr>
+          <p:cNvPr id="61" name="Picture 60" descr="academica.png"/>
           <p:cNvPicPr>
             <a:picLocks noChangeAspect="1"/>
           </p:cNvPicPr>
@@ -4226,526 +4828,6 @@
         </p:blipFill>
         <p:spPr>
           <a:xfrm>
-            <a:off x="5385346" y="5459164"/>
-            <a:ext cx="191691" cy="191691"/>
-          </a:xfrm>
-          <a:prstGeom prst="rect">
-            <a:avLst/>
-          </a:prstGeom>
-        </p:spPr>
-      </p:pic>
-      <p:pic>
-        <p:nvPicPr>
-          <p:cNvPr id="41" name="Picture 40" descr="svg-0-20.png"/>
-          <p:cNvPicPr>
-            <a:picLocks noChangeAspect="1"/>
-          </p:cNvPicPr>
-          <p:nvPr/>
-        </p:nvPicPr>
-        <p:blipFill>
-          <a:blip r:embed="rId18"/>
-          <a:stretch>
-            <a:fillRect/>
-          </a:stretch>
-        </p:blipFill>
-        <p:spPr>
-          <a:xfrm>
-            <a:off x="5620196" y="5459164"/>
-            <a:ext cx="191542" cy="191542"/>
-          </a:xfrm>
-          <a:prstGeom prst="rect">
-            <a:avLst/>
-          </a:prstGeom>
-        </p:spPr>
-      </p:pic>
-      <p:pic>
-        <p:nvPicPr>
-          <p:cNvPr id="42" name="Picture 41" descr="svg-0-21.png"/>
-          <p:cNvPicPr>
-            <a:picLocks noChangeAspect="1"/>
-          </p:cNvPicPr>
-          <p:nvPr/>
-        </p:nvPicPr>
-        <p:blipFill>
-          <a:blip r:embed="rId19"/>
-          <a:stretch>
-            <a:fillRect/>
-          </a:stretch>
-        </p:blipFill>
-        <p:spPr>
-          <a:xfrm>
-            <a:off x="5854898" y="5459164"/>
-            <a:ext cx="191542" cy="191542"/>
-          </a:xfrm>
-          <a:prstGeom prst="rect">
-            <a:avLst/>
-          </a:prstGeom>
-        </p:spPr>
-      </p:pic>
-      <p:pic>
-        <p:nvPicPr>
-          <p:cNvPr id="43" name="Picture 42" descr="svg-0-20.png"/>
-          <p:cNvPicPr>
-            <a:picLocks noChangeAspect="1"/>
-          </p:cNvPicPr>
-          <p:nvPr/>
-        </p:nvPicPr>
-        <p:blipFill>
-          <a:blip r:embed="rId18"/>
-          <a:stretch>
-            <a:fillRect/>
-          </a:stretch>
-        </p:blipFill>
-        <p:spPr>
-          <a:xfrm>
-            <a:off x="6089600" y="5459164"/>
-            <a:ext cx="191542" cy="191542"/>
-          </a:xfrm>
-          <a:prstGeom prst="rect">
-            <a:avLst/>
-          </a:prstGeom>
-        </p:spPr>
-      </p:pic>
-      <p:pic>
-        <p:nvPicPr>
-          <p:cNvPr id="44" name="Picture 43" descr="svg-0-29.png"/>
-          <p:cNvPicPr>
-            <a:picLocks noChangeAspect="1"/>
-          </p:cNvPicPr>
-          <p:nvPr/>
-        </p:nvPicPr>
-        <p:blipFill>
-          <a:blip r:embed="rId22"/>
-          <a:stretch>
-            <a:fillRect/>
-          </a:stretch>
-        </p:blipFill>
-        <p:spPr>
-          <a:xfrm>
-            <a:off x="6324302" y="5459164"/>
-            <a:ext cx="191542" cy="191542"/>
-          </a:xfrm>
-          <a:prstGeom prst="rect">
-            <a:avLst/>
-          </a:prstGeom>
-        </p:spPr>
-      </p:pic>
-      <p:pic>
-        <p:nvPicPr>
-          <p:cNvPr id="45" name="Picture 44" descr="svg-0-20.png"/>
-          <p:cNvPicPr>
-            <a:picLocks noChangeAspect="1"/>
-          </p:cNvPicPr>
-          <p:nvPr/>
-        </p:nvPicPr>
-        <p:blipFill>
-          <a:blip r:embed="rId18"/>
-          <a:stretch>
-            <a:fillRect/>
-          </a:stretch>
-        </p:blipFill>
-        <p:spPr>
-          <a:xfrm>
-            <a:off x="4211836" y="5708452"/>
-            <a:ext cx="191542" cy="191542"/>
-          </a:xfrm>
-          <a:prstGeom prst="rect">
-            <a:avLst/>
-          </a:prstGeom>
-        </p:spPr>
-      </p:pic>
-      <p:pic>
-        <p:nvPicPr>
-          <p:cNvPr id="46" name="Picture 45" descr="svg-0-21.png"/>
-          <p:cNvPicPr>
-            <a:picLocks noChangeAspect="1"/>
-          </p:cNvPicPr>
-          <p:nvPr/>
-        </p:nvPicPr>
-        <p:blipFill>
-          <a:blip r:embed="rId19"/>
-          <a:stretch>
-            <a:fillRect/>
-          </a:stretch>
-        </p:blipFill>
-        <p:spPr>
-          <a:xfrm>
-            <a:off x="4446538" y="5708452"/>
-            <a:ext cx="191542" cy="191542"/>
-          </a:xfrm>
-          <a:prstGeom prst="rect">
-            <a:avLst/>
-          </a:prstGeom>
-        </p:spPr>
-      </p:pic>
-      <p:pic>
-        <p:nvPicPr>
-          <p:cNvPr id="47" name="Picture 46" descr="svg-0-22.png"/>
-          <p:cNvPicPr>
-            <a:picLocks noChangeAspect="1"/>
-          </p:cNvPicPr>
-          <p:nvPr/>
-        </p:nvPicPr>
-        <p:blipFill>
-          <a:blip r:embed="rId20"/>
-          <a:stretch>
-            <a:fillRect/>
-          </a:stretch>
-        </p:blipFill>
-        <p:spPr>
-          <a:xfrm>
-            <a:off x="4681240" y="5708452"/>
-            <a:ext cx="191542" cy="191542"/>
-          </a:xfrm>
-          <a:prstGeom prst="rect">
-            <a:avLst/>
-          </a:prstGeom>
-        </p:spPr>
-      </p:pic>
-      <p:pic>
-        <p:nvPicPr>
-          <p:cNvPr id="48" name="Picture 47" descr="svg-0-20.png"/>
-          <p:cNvPicPr>
-            <a:picLocks noChangeAspect="1"/>
-          </p:cNvPicPr>
-          <p:nvPr/>
-        </p:nvPicPr>
-        <p:blipFill>
-          <a:blip r:embed="rId18"/>
-          <a:stretch>
-            <a:fillRect/>
-          </a:stretch>
-        </p:blipFill>
-        <p:spPr>
-          <a:xfrm>
-            <a:off x="4915942" y="5708452"/>
-            <a:ext cx="191542" cy="191542"/>
-          </a:xfrm>
-          <a:prstGeom prst="rect">
-            <a:avLst/>
-          </a:prstGeom>
-        </p:spPr>
-      </p:pic>
-      <p:pic>
-        <p:nvPicPr>
-          <p:cNvPr id="49" name="Picture 48" descr="svg-0-21.png"/>
-          <p:cNvPicPr>
-            <a:picLocks noChangeAspect="1"/>
-          </p:cNvPicPr>
-          <p:nvPr/>
-        </p:nvPicPr>
-        <p:blipFill>
-          <a:blip r:embed="rId19"/>
-          <a:stretch>
-            <a:fillRect/>
-          </a:stretch>
-        </p:blipFill>
-        <p:spPr>
-          <a:xfrm>
-            <a:off x="5150644" y="5708452"/>
-            <a:ext cx="191542" cy="191542"/>
-          </a:xfrm>
-          <a:prstGeom prst="rect">
-            <a:avLst/>
-          </a:prstGeom>
-        </p:spPr>
-      </p:pic>
-      <p:pic>
-        <p:nvPicPr>
-          <p:cNvPr id="50" name="Picture 49" descr="svg-0-25.png"/>
-          <p:cNvPicPr>
-            <a:picLocks noChangeAspect="1"/>
-          </p:cNvPicPr>
-          <p:nvPr/>
-        </p:nvPicPr>
-        <p:blipFill>
-          <a:blip r:embed="rId21"/>
-          <a:stretch>
-            <a:fillRect/>
-          </a:stretch>
-        </p:blipFill>
-        <p:spPr>
-          <a:xfrm>
-            <a:off x="5385346" y="5708452"/>
-            <a:ext cx="191691" cy="191691"/>
-          </a:xfrm>
-          <a:prstGeom prst="rect">
-            <a:avLst/>
-          </a:prstGeom>
-        </p:spPr>
-      </p:pic>
-      <p:pic>
-        <p:nvPicPr>
-          <p:cNvPr id="51" name="Picture 50" descr="svg-0-20.png"/>
-          <p:cNvPicPr>
-            <a:picLocks noChangeAspect="1"/>
-          </p:cNvPicPr>
-          <p:nvPr/>
-        </p:nvPicPr>
-        <p:blipFill>
-          <a:blip r:embed="rId18"/>
-          <a:stretch>
-            <a:fillRect/>
-          </a:stretch>
-        </p:blipFill>
-        <p:spPr>
-          <a:xfrm>
-            <a:off x="5620196" y="5708452"/>
-            <a:ext cx="191542" cy="191542"/>
-          </a:xfrm>
-          <a:prstGeom prst="rect">
-            <a:avLst/>
-          </a:prstGeom>
-        </p:spPr>
-      </p:pic>
-      <p:pic>
-        <p:nvPicPr>
-          <p:cNvPr id="52" name="Picture 51" descr="svg-0-21.png"/>
-          <p:cNvPicPr>
-            <a:picLocks noChangeAspect="1"/>
-          </p:cNvPicPr>
-          <p:nvPr/>
-        </p:nvPicPr>
-        <p:blipFill>
-          <a:blip r:embed="rId19"/>
-          <a:stretch>
-            <a:fillRect/>
-          </a:stretch>
-        </p:blipFill>
-        <p:spPr>
-          <a:xfrm>
-            <a:off x="5854898" y="5708452"/>
-            <a:ext cx="191542" cy="191542"/>
-          </a:xfrm>
-          <a:prstGeom prst="rect">
-            <a:avLst/>
-          </a:prstGeom>
-        </p:spPr>
-      </p:pic>
-      <p:pic>
-        <p:nvPicPr>
-          <p:cNvPr id="53" name="Picture 52" descr="svg-0-20.png"/>
-          <p:cNvPicPr>
-            <a:picLocks noChangeAspect="1"/>
-          </p:cNvPicPr>
-          <p:nvPr/>
-        </p:nvPicPr>
-        <p:blipFill>
-          <a:blip r:embed="rId18"/>
-          <a:stretch>
-            <a:fillRect/>
-          </a:stretch>
-        </p:blipFill>
-        <p:spPr>
-          <a:xfrm>
-            <a:off x="6089600" y="5708452"/>
-            <a:ext cx="191542" cy="191542"/>
-          </a:xfrm>
-          <a:prstGeom prst="rect">
-            <a:avLst/>
-          </a:prstGeom>
-        </p:spPr>
-      </p:pic>
-      <p:pic>
-        <p:nvPicPr>
-          <p:cNvPr id="54" name="Picture 53" descr="svg-0-29.png"/>
-          <p:cNvPicPr>
-            <a:picLocks noChangeAspect="1"/>
-          </p:cNvPicPr>
-          <p:nvPr/>
-        </p:nvPicPr>
-        <p:blipFill>
-          <a:blip r:embed="rId22"/>
-          <a:stretch>
-            <a:fillRect/>
-          </a:stretch>
-        </p:blipFill>
-        <p:spPr>
-          <a:xfrm>
-            <a:off x="6324302" y="5708452"/>
-            <a:ext cx="191542" cy="191542"/>
-          </a:xfrm>
-          <a:prstGeom prst="rect">
-            <a:avLst/>
-          </a:prstGeom>
-        </p:spPr>
-      </p:pic>
-      <p:sp>
-        <p:nvSpPr>
-          <p:cNvPr id="55" name="TextBox 54"/>
-          <p:cNvSpPr txBox="1"/>
-          <p:nvPr/>
-        </p:nvSpPr>
-        <p:spPr>
-          <a:xfrm>
-            <a:off x="723900" y="6347222"/>
-            <a:ext cx="2804827" cy="142875"/>
-          </a:xfrm>
-          <a:prstGeom prst="rect">
-            <a:avLst/>
-          </a:prstGeom>
-          <a:noFill/>
-        </p:spPr>
-        <p:txBody>
-          <a:bodyPr wrap="square" anchor="t" lIns="0" rIns="0" tIns="0" bIns="0">
-            <a:noAutofit/>
-          </a:bodyPr>
-          <a:lstStyle/>
-          <a:p>
-            <a:pPr algn="l">
-              <a:lnSpc>
-                <a:spcPts val="1260"/>
-              </a:lnSpc>
-            </a:pPr>
-            <a:r>
-              <a:rPr sz="900" b="0">
-                <a:solidFill>
-                  <a:srgbClr val="555A78"/>
-                </a:solidFill>
-                <a:latin typeface="Inter"/>
-              </a:rPr>
-              <a:t>Elk poppetje staat voor 5% van de studenten.</a:t>
-            </a:r>
-          </a:p>
-        </p:txBody>
-      </p:sp>
-      <p:sp>
-        <p:nvSpPr>
-          <p:cNvPr id="56" name="Rounded Rectangle 55"/>
-          <p:cNvSpPr/>
-          <p:nvPr/>
-        </p:nvSpPr>
-        <p:spPr>
-          <a:xfrm>
-            <a:off x="719882" y="6723162"/>
-            <a:ext cx="6120110" cy="1422648"/>
-          </a:xfrm>
-          <a:prstGeom prst="roundRect">
-            <a:avLst>
-              <a:gd name="adj" fmla="val 15182"/>
-            </a:avLst>
-          </a:prstGeom>
-          <a:solidFill>
-            <a:srgbClr val="F1F2F9"/>
-          </a:solidFill>
-          <a:ln>
-            <a:noFill/>
-          </a:ln>
-        </p:spPr>
-        <p:style>
-          <a:lnRef idx="1">
-            <a:schemeClr val="accent1"/>
-          </a:lnRef>
-          <a:fillRef idx="3">
-            <a:schemeClr val="accent1"/>
-          </a:fillRef>
-          <a:effectRef idx="0">
-            <a:schemeClr val="accent1"/>
-          </a:effectRef>
-          <a:fontRef idx="minor">
-            <a:schemeClr val="lt1"/>
-          </a:fontRef>
-        </p:style>
-        <p:txBody>
-          <a:bodyPr rtlCol="0" anchor="ctr"/>
-          <a:lstStyle/>
-          <a:p/>
-        </p:txBody>
-      </p:sp>
-      <p:sp>
-        <p:nvSpPr>
-          <p:cNvPr id="57" name="TextBox 56"/>
-          <p:cNvSpPr txBox="1"/>
-          <p:nvPr/>
-        </p:nvSpPr>
-        <p:spPr>
-          <a:xfrm>
-            <a:off x="1043880" y="7056686"/>
-            <a:ext cx="3437573" cy="428625"/>
-          </a:xfrm>
-          <a:prstGeom prst="rect">
-            <a:avLst/>
-          </a:prstGeom>
-          <a:noFill/>
-        </p:spPr>
-        <p:txBody>
-          <a:bodyPr wrap="square" anchor="t" lIns="0" rIns="0" tIns="0" bIns="0">
-            <a:noAutofit/>
-          </a:bodyPr>
-          <a:lstStyle/>
-          <a:p>
-            <a:pPr algn="l">
-              <a:lnSpc>
-                <a:spcPts val="3600"/>
-              </a:lnSpc>
-            </a:pPr>
-            <a:r>
-              <a:rPr sz="3600" b="1">
-                <a:solidFill>
-                  <a:srgbClr val="000326"/>
-                </a:solidFill>
-                <a:latin typeface="League Spartan"/>
-              </a:rPr>
-              <a:t>76% goedkoper</a:t>
-            </a:r>
-          </a:p>
-        </p:txBody>
-      </p:sp>
-      <p:sp>
-        <p:nvSpPr>
-          <p:cNvPr id="58" name="TextBox 57"/>
-          <p:cNvSpPr txBox="1"/>
-          <p:nvPr/>
-        </p:nvSpPr>
-        <p:spPr>
-          <a:xfrm>
-            <a:off x="1043880" y="7631311"/>
-            <a:ext cx="2320766" cy="171450"/>
-          </a:xfrm>
-          <a:prstGeom prst="rect">
-            <a:avLst/>
-          </a:prstGeom>
-          <a:noFill/>
-        </p:spPr>
-        <p:txBody>
-          <a:bodyPr wrap="square" anchor="t" lIns="0" rIns="0" tIns="0" bIns="0">
-            <a:noAutofit/>
-          </a:bodyPr>
-          <a:lstStyle/>
-          <a:p>
-            <a:pPr algn="l">
-              <a:lnSpc>
-                <a:spcPts val="1650"/>
-              </a:lnSpc>
-            </a:pPr>
-            <a:r>
-              <a:rPr sz="1100" b="0">
-                <a:solidFill>
-                  <a:srgbClr val="555A78"/>
-                </a:solidFill>
-                <a:latin typeface="Inter"/>
-              </a:rPr>
-              <a:t>per student die feedback krijgt</a:t>
-            </a:r>
-          </a:p>
-        </p:txBody>
-      </p:sp>
-      <p:pic>
-        <p:nvPicPr>
-          <p:cNvPr id="59" name="Picture 58" descr="academica.png"/>
-          <p:cNvPicPr>
-            <a:picLocks noChangeAspect="1"/>
-          </p:cNvPicPr>
-          <p:nvPr/>
-        </p:nvPicPr>
-        <p:blipFill>
-          <a:blip r:embed="rId23"/>
-          <a:stretch>
-            <a:fillRect/>
-          </a:stretch>
-        </p:blipFill>
-        <p:spPr>
-          <a:xfrm>
             <a:off x="742950" y="10182225"/>
             <a:ext cx="784860" cy="152400"/>
           </a:xfrm>
@@ -4756,7 +4838,7 @@
       </p:pic>
       <p:sp>
         <p:nvSpPr>
-          <p:cNvPr id="60" name="TextBox 59"/>
+          <p:cNvPr id="62" name="TextBox 61"/>
           <p:cNvSpPr txBox="1"/>
           <p:nvPr/>
         </p:nvSpPr>

</xml_diff>